<commit_message>
Style fix: Redesign Slide 3 table with dark-mode theme, vertical alignment, and balanced columns
</commit_message>
<xml_diff>
--- a/output/Presentacion_Final_ELI556_Atacama.pptx
+++ b/output/Presentacion_Final_ELI556_Atacama.pptx
@@ -7122,20 +7122,20 @@
         </p:nvGraphicFramePr>
         <p:xfrm>
           <a:off x="548640" y="1645920"/>
-          <a:ext cx="11430000" cy="4114800"/>
+          <a:ext cx="11064240" cy="4114800"/>
         </p:xfrm>
         <a:graphic>
           <a:graphicData uri="http://schemas.openxmlformats.org/drawingml/2006/table">
             <a:tbl>
               <a:tblPr firstRow="1" bandRow="1">
-                <a:tableStyleId>{5C22544A-7EE6-4342-B048-85BDC9FD1C3A}</a:tableStyleId>
+                <a:tableStyleId>{5940675A-B579-460E-94D1-54222C63F5DA}</a:tableStyleId>
               </a:tblPr>
               <a:tblGrid>
-                <a:gridCol w="2011680"/>
-                <a:gridCol w="1188720"/>
                 <a:gridCol w="1828800"/>
-                <a:gridCol w="4023360"/>
-                <a:gridCol w="2377440"/>
+                <a:gridCol w="1097280"/>
+                <a:gridCol w="1645920"/>
+                <a:gridCol w="3931920"/>
+                <a:gridCol w="2560320"/>
               </a:tblGrid>
               <a:tr h="685800">
                 <a:tc>
@@ -7146,7 +7146,7 @@
                       <a:pPr algn="ctr">
                         <a:defRPr b="1" sz="1300">
                           <a:solidFill>
-                            <a:srgbClr val="FFFFFF"/>
+                            <a:srgbClr val="E8A838"/>
                           </a:solidFill>
                         </a:defRPr>
                       </a:pPr>
@@ -7155,9 +7155,9 @@
                       </a:r>
                     </a:p>
                   </a:txBody>
-                  <a:tcPr>
+                  <a:tcPr anchor="ctr">
                     <a:solidFill>
-                      <a:srgbClr val="007ACC"/>
+                      <a:srgbClr val="2C2C48"/>
                     </a:solidFill>
                   </a:tcPr>
                 </a:tc>
@@ -7169,7 +7169,7 @@
                       <a:pPr algn="ctr">
                         <a:defRPr b="1" sz="1300">
                           <a:solidFill>
-                            <a:srgbClr val="FFFFFF"/>
+                            <a:srgbClr val="E8A838"/>
                           </a:solidFill>
                         </a:defRPr>
                       </a:pPr>
@@ -7178,9 +7178,9 @@
                       </a:r>
                     </a:p>
                   </a:txBody>
-                  <a:tcPr>
+                  <a:tcPr anchor="ctr">
                     <a:solidFill>
-                      <a:srgbClr val="007ACC"/>
+                      <a:srgbClr val="2C2C48"/>
                     </a:solidFill>
                   </a:tcPr>
                 </a:tc>
@@ -7192,7 +7192,7 @@
                       <a:pPr algn="ctr">
                         <a:defRPr b="1" sz="1300">
                           <a:solidFill>
-                            <a:srgbClr val="FFFFFF"/>
+                            <a:srgbClr val="E8A838"/>
                           </a:solidFill>
                         </a:defRPr>
                       </a:pPr>
@@ -7201,9 +7201,9 @@
                       </a:r>
                     </a:p>
                   </a:txBody>
-                  <a:tcPr>
+                  <a:tcPr anchor="ctr">
                     <a:solidFill>
-                      <a:srgbClr val="007ACC"/>
+                      <a:srgbClr val="2C2C48"/>
                     </a:solidFill>
                   </a:tcPr>
                 </a:tc>
@@ -7215,7 +7215,7 @@
                       <a:pPr algn="ctr">
                         <a:defRPr b="1" sz="1300">
                           <a:solidFill>
-                            <a:srgbClr val="FFFFFF"/>
+                            <a:srgbClr val="E8A838"/>
                           </a:solidFill>
                         </a:defRPr>
                       </a:pPr>
@@ -7224,9 +7224,9 @@
                       </a:r>
                     </a:p>
                   </a:txBody>
-                  <a:tcPr>
+                  <a:tcPr anchor="ctr">
                     <a:solidFill>
-                      <a:srgbClr val="007ACC"/>
+                      <a:srgbClr val="2C2C48"/>
                     </a:solidFill>
                   </a:tcPr>
                 </a:tc>
@@ -7238,7 +7238,7 @@
                       <a:pPr algn="ctr">
                         <a:defRPr b="1" sz="1300">
                           <a:solidFill>
-                            <a:srgbClr val="FFFFFF"/>
+                            <a:srgbClr val="E8A838"/>
                           </a:solidFill>
                         </a:defRPr>
                       </a:pPr>
@@ -7247,9 +7247,9 @@
                       </a:r>
                     </a:p>
                   </a:txBody>
-                  <a:tcPr>
+                  <a:tcPr anchor="ctr">
                     <a:solidFill>
-                      <a:srgbClr val="007ACC"/>
+                      <a:srgbClr val="2C2C48"/>
                     </a:solidFill>
                   </a:tcPr>
                 </a:tc>
@@ -7260,8 +7260,8 @@
                     <a:bodyPr/>
                     <a:lstStyle/>
                     <a:p>
-                      <a:pPr>
-                        <a:defRPr sz="1100" b="1">
+                      <a:pPr algn="l">
+                        <a:defRPr sz="1150" b="1">
                           <a:solidFill>
                             <a:srgbClr val="FFFFFF"/>
                           </a:solidFill>
@@ -7272,9 +7272,9 @@
                       </a:r>
                     </a:p>
                   </a:txBody>
-                  <a:tcPr>
+                  <a:tcPr anchor="ctr">
                     <a:solidFill>
-                      <a:srgbClr val="222248"/>
+                      <a:srgbClr val="28284B"/>
                     </a:solidFill>
                   </a:tcPr>
                 </a:tc>
@@ -7284,7 +7284,7 @@
                     <a:lstStyle/>
                     <a:p>
                       <a:pPr algn="ctr">
-                        <a:defRPr sz="1100">
+                        <a:defRPr sz="1150">
                           <a:solidFill>
                             <a:srgbClr val="FFFFFF"/>
                           </a:solidFill>
@@ -7295,9 +7295,9 @@
                       </a:r>
                     </a:p>
                   </a:txBody>
-                  <a:tcPr>
+                  <a:tcPr anchor="ctr">
                     <a:solidFill>
-                      <a:srgbClr val="222248"/>
+                      <a:srgbClr val="28284B"/>
                     </a:solidFill>
                   </a:tcPr>
                 </a:tc>
@@ -7307,7 +7307,7 @@
                     <a:lstStyle/>
                     <a:p>
                       <a:pPr algn="ctr">
-                        <a:defRPr sz="1100">
+                        <a:defRPr sz="1150">
                           <a:solidFill>
                             <a:srgbClr val="FFFFFF"/>
                           </a:solidFill>
@@ -7318,9 +7318,9 @@
                       </a:r>
                     </a:p>
                   </a:txBody>
-                  <a:tcPr>
+                  <a:tcPr anchor="ctr">
                     <a:solidFill>
-                      <a:srgbClr val="222248"/>
+                      <a:srgbClr val="28284B"/>
                     </a:solidFill>
                   </a:tcPr>
                 </a:tc>
@@ -7329,8 +7329,8 @@
                     <a:bodyPr/>
                     <a:lstStyle/>
                     <a:p>
-                      <a:pPr>
-                        <a:defRPr sz="1000">
+                      <a:pPr algn="l">
+                        <a:defRPr sz="1050">
                           <a:solidFill>
                             <a:srgbClr val="FFFFFF"/>
                           </a:solidFill>
@@ -7341,9 +7341,9 @@
                       </a:r>
                     </a:p>
                   </a:txBody>
-                  <a:tcPr>
+                  <a:tcPr anchor="ctr">
                     <a:solidFill>
-                      <a:srgbClr val="222248"/>
+                      <a:srgbClr val="28284B"/>
                     </a:solidFill>
                   </a:tcPr>
                 </a:tc>
@@ -7353,7 +7353,7 @@
                     <a:lstStyle/>
                     <a:p>
                       <a:pPr algn="ctr">
-                        <a:defRPr sz="1100" b="1">
+                        <a:defRPr sz="1150" b="1">
                           <a:solidFill>
                             <a:srgbClr val="E8A838"/>
                           </a:solidFill>
@@ -7364,9 +7364,9 @@
                       </a:r>
                     </a:p>
                   </a:txBody>
-                  <a:tcPr>
+                  <a:tcPr anchor="ctr">
                     <a:solidFill>
-                      <a:srgbClr val="222248"/>
+                      <a:srgbClr val="28284B"/>
                     </a:solidFill>
                   </a:tcPr>
                 </a:tc>
@@ -7377,8 +7377,8 @@
                     <a:bodyPr/>
                     <a:lstStyle/>
                     <a:p>
-                      <a:pPr>
-                        <a:defRPr sz="1100" b="1">
+                      <a:pPr algn="l">
+                        <a:defRPr sz="1150" b="1">
                           <a:solidFill>
                             <a:srgbClr val="FFFFFF"/>
                           </a:solidFill>
@@ -7389,9 +7389,9 @@
                       </a:r>
                     </a:p>
                   </a:txBody>
-                  <a:tcPr>
+                  <a:tcPr anchor="ctr">
                     <a:solidFill>
-                      <a:srgbClr val="222248"/>
+                      <a:srgbClr val="28284B"/>
                     </a:solidFill>
                   </a:tcPr>
                 </a:tc>
@@ -7401,7 +7401,7 @@
                     <a:lstStyle/>
                     <a:p>
                       <a:pPr algn="ctr">
-                        <a:defRPr sz="1100">
+                        <a:defRPr sz="1150">
                           <a:solidFill>
                             <a:srgbClr val="FFFFFF"/>
                           </a:solidFill>
@@ -7412,9 +7412,9 @@
                       </a:r>
                     </a:p>
                   </a:txBody>
-                  <a:tcPr>
+                  <a:tcPr anchor="ctr">
                     <a:solidFill>
-                      <a:srgbClr val="222248"/>
+                      <a:srgbClr val="28284B"/>
                     </a:solidFill>
                   </a:tcPr>
                 </a:tc>
@@ -7424,7 +7424,7 @@
                     <a:lstStyle/>
                     <a:p>
                       <a:pPr algn="ctr">
-                        <a:defRPr sz="1100">
+                        <a:defRPr sz="1150">
                           <a:solidFill>
                             <a:srgbClr val="FFFFFF"/>
                           </a:solidFill>
@@ -7435,9 +7435,9 @@
                       </a:r>
                     </a:p>
                   </a:txBody>
-                  <a:tcPr>
+                  <a:tcPr anchor="ctr">
                     <a:solidFill>
-                      <a:srgbClr val="222248"/>
+                      <a:srgbClr val="28284B"/>
                     </a:solidFill>
                   </a:tcPr>
                 </a:tc>
@@ -7446,8 +7446,8 @@
                     <a:bodyPr/>
                     <a:lstStyle/>
                     <a:p>
-                      <a:pPr>
-                        <a:defRPr sz="1000">
+                      <a:pPr algn="l">
+                        <a:defRPr sz="1050">
                           <a:solidFill>
                             <a:srgbClr val="FFFFFF"/>
                           </a:solidFill>
@@ -7458,9 +7458,9 @@
                       </a:r>
                     </a:p>
                   </a:txBody>
-                  <a:tcPr>
+                  <a:tcPr anchor="ctr">
                     <a:solidFill>
-                      <a:srgbClr val="222248"/>
+                      <a:srgbClr val="28284B"/>
                     </a:solidFill>
                   </a:tcPr>
                 </a:tc>
@@ -7470,7 +7470,7 @@
                     <a:lstStyle/>
                     <a:p>
                       <a:pPr algn="ctr">
-                        <a:defRPr sz="1100" b="1">
+                        <a:defRPr sz="1150" b="1">
                           <a:solidFill>
                             <a:srgbClr val="E8A838"/>
                           </a:solidFill>
@@ -7481,9 +7481,9 @@
                       </a:r>
                     </a:p>
                   </a:txBody>
-                  <a:tcPr>
+                  <a:tcPr anchor="ctr">
                     <a:solidFill>
-                      <a:srgbClr val="222248"/>
+                      <a:srgbClr val="28284B"/>
                     </a:solidFill>
                   </a:tcPr>
                 </a:tc>
@@ -7494,8 +7494,8 @@
                     <a:bodyPr/>
                     <a:lstStyle/>
                     <a:p>
-                      <a:pPr>
-                        <a:defRPr sz="1100" b="1">
+                      <a:pPr algn="l">
+                        <a:defRPr sz="1150" b="1">
                           <a:solidFill>
                             <a:srgbClr val="FFFFFF"/>
                           </a:solidFill>
@@ -7506,9 +7506,9 @@
                       </a:r>
                     </a:p>
                   </a:txBody>
-                  <a:tcPr>
+                  <a:tcPr anchor="ctr">
                     <a:solidFill>
-                      <a:srgbClr val="1B1B2E"/>
+                      <a:srgbClr val="1F1F33"/>
                     </a:solidFill>
                   </a:tcPr>
                 </a:tc>
@@ -7518,7 +7518,7 @@
                     <a:lstStyle/>
                     <a:p>
                       <a:pPr algn="ctr">
-                        <a:defRPr sz="1100">
+                        <a:defRPr sz="1150">
                           <a:solidFill>
                             <a:srgbClr val="FFFFFF"/>
                           </a:solidFill>
@@ -7529,9 +7529,9 @@
                       </a:r>
                     </a:p>
                   </a:txBody>
-                  <a:tcPr>
+                  <a:tcPr anchor="ctr">
                     <a:solidFill>
-                      <a:srgbClr val="1B1B2E"/>
+                      <a:srgbClr val="1F1F33"/>
                     </a:solidFill>
                   </a:tcPr>
                 </a:tc>
@@ -7541,7 +7541,7 @@
                     <a:lstStyle/>
                     <a:p>
                       <a:pPr algn="ctr">
-                        <a:defRPr sz="1100">
+                        <a:defRPr sz="1150">
                           <a:solidFill>
                             <a:srgbClr val="FFFFFF"/>
                           </a:solidFill>
@@ -7552,9 +7552,9 @@
                       </a:r>
                     </a:p>
                   </a:txBody>
-                  <a:tcPr>
+                  <a:tcPr anchor="ctr">
                     <a:solidFill>
-                      <a:srgbClr val="1B1B2E"/>
+                      <a:srgbClr val="1F1F33"/>
                     </a:solidFill>
                   </a:tcPr>
                 </a:tc>
@@ -7563,8 +7563,8 @@
                     <a:bodyPr/>
                     <a:lstStyle/>
                     <a:p>
-                      <a:pPr>
-                        <a:defRPr sz="1000">
+                      <a:pPr algn="l">
+                        <a:defRPr sz="1050">
                           <a:solidFill>
                             <a:srgbClr val="FFFFFF"/>
                           </a:solidFill>
@@ -7575,9 +7575,9 @@
                       </a:r>
                     </a:p>
                   </a:txBody>
-                  <a:tcPr>
+                  <a:tcPr anchor="ctr">
                     <a:solidFill>
-                      <a:srgbClr val="1B1B2E"/>
+                      <a:srgbClr val="1F1F33"/>
                     </a:solidFill>
                   </a:tcPr>
                 </a:tc>
@@ -7587,9 +7587,9 @@
                     <a:lstStyle/>
                     <a:p>
                       <a:pPr algn="ctr">
-                        <a:defRPr sz="1100" b="1">
+                        <a:defRPr sz="1150" b="1">
                           <a:solidFill>
-                            <a:srgbClr val="FFFFFF"/>
+                            <a:srgbClr val="BBBBBB"/>
                           </a:solidFill>
                         </a:defRPr>
                       </a:pPr>
@@ -7598,9 +7598,9 @@
                       </a:r>
                     </a:p>
                   </a:txBody>
-                  <a:tcPr>
+                  <a:tcPr anchor="ctr">
                     <a:solidFill>
-                      <a:srgbClr val="1B1B2E"/>
+                      <a:srgbClr val="1F1F33"/>
                     </a:solidFill>
                   </a:tcPr>
                 </a:tc>
@@ -7611,8 +7611,8 @@
                     <a:bodyPr/>
                     <a:lstStyle/>
                     <a:p>
-                      <a:pPr>
-                        <a:defRPr sz="1100" b="1">
+                      <a:pPr algn="l">
+                        <a:defRPr sz="1150" b="1">
                           <a:solidFill>
                             <a:srgbClr val="FFFFFF"/>
                           </a:solidFill>
@@ -7623,9 +7623,9 @@
                       </a:r>
                     </a:p>
                   </a:txBody>
-                  <a:tcPr>
+                  <a:tcPr anchor="ctr">
                     <a:solidFill>
-                      <a:srgbClr val="1B1B2E"/>
+                      <a:srgbClr val="1F1F33"/>
                     </a:solidFill>
                   </a:tcPr>
                 </a:tc>
@@ -7635,7 +7635,7 @@
                     <a:lstStyle/>
                     <a:p>
                       <a:pPr algn="ctr">
-                        <a:defRPr sz="1100">
+                        <a:defRPr sz="1150">
                           <a:solidFill>
                             <a:srgbClr val="FFFFFF"/>
                           </a:solidFill>
@@ -7646,9 +7646,9 @@
                       </a:r>
                     </a:p>
                   </a:txBody>
-                  <a:tcPr>
+                  <a:tcPr anchor="ctr">
                     <a:solidFill>
-                      <a:srgbClr val="1B1B2E"/>
+                      <a:srgbClr val="1F1F33"/>
                     </a:solidFill>
                   </a:tcPr>
                 </a:tc>
@@ -7658,7 +7658,7 @@
                     <a:lstStyle/>
                     <a:p>
                       <a:pPr algn="ctr">
-                        <a:defRPr sz="1100">
+                        <a:defRPr sz="1150">
                           <a:solidFill>
                             <a:srgbClr val="FFFFFF"/>
                           </a:solidFill>
@@ -7669,9 +7669,9 @@
                       </a:r>
                     </a:p>
                   </a:txBody>
-                  <a:tcPr>
+                  <a:tcPr anchor="ctr">
                     <a:solidFill>
-                      <a:srgbClr val="1B1B2E"/>
+                      <a:srgbClr val="1F1F33"/>
                     </a:solidFill>
                   </a:tcPr>
                 </a:tc>
@@ -7680,8 +7680,8 @@
                     <a:bodyPr/>
                     <a:lstStyle/>
                     <a:p>
-                      <a:pPr>
-                        <a:defRPr sz="1000">
+                      <a:pPr algn="l">
+                        <a:defRPr sz="1050">
                           <a:solidFill>
                             <a:srgbClr val="FFFFFF"/>
                           </a:solidFill>
@@ -7692,9 +7692,9 @@
                       </a:r>
                     </a:p>
                   </a:txBody>
-                  <a:tcPr>
+                  <a:tcPr anchor="ctr">
                     <a:solidFill>
-                      <a:srgbClr val="1B1B2E"/>
+                      <a:srgbClr val="1F1F33"/>
                     </a:solidFill>
                   </a:tcPr>
                 </a:tc>
@@ -7704,9 +7704,9 @@
                     <a:lstStyle/>
                     <a:p>
                       <a:pPr algn="ctr">
-                        <a:defRPr sz="1100" b="1">
+                        <a:defRPr sz="1150" b="1">
                           <a:solidFill>
-                            <a:srgbClr val="FFFFFF"/>
+                            <a:srgbClr val="BBBBBB"/>
                           </a:solidFill>
                         </a:defRPr>
                       </a:pPr>
@@ -7715,9 +7715,9 @@
                       </a:r>
                     </a:p>
                   </a:txBody>
-                  <a:tcPr>
+                  <a:tcPr anchor="ctr">
                     <a:solidFill>
-                      <a:srgbClr val="1B1B2E"/>
+                      <a:srgbClr val="1F1F33"/>
                     </a:solidFill>
                   </a:tcPr>
                 </a:tc>
@@ -7728,8 +7728,8 @@
                     <a:bodyPr/>
                     <a:lstStyle/>
                     <a:p>
-                      <a:pPr>
-                        <a:defRPr sz="1100" b="1">
+                      <a:pPr algn="l">
+                        <a:defRPr sz="1150" b="1">
                           <a:solidFill>
                             <a:srgbClr val="FFFFFF"/>
                           </a:solidFill>
@@ -7740,9 +7740,9 @@
                       </a:r>
                     </a:p>
                   </a:txBody>
-                  <a:tcPr>
+                  <a:tcPr anchor="ctr">
                     <a:solidFill>
-                      <a:srgbClr val="1B1B2E"/>
+                      <a:srgbClr val="1F1F33"/>
                     </a:solidFill>
                   </a:tcPr>
                 </a:tc>
@@ -7752,7 +7752,7 @@
                     <a:lstStyle/>
                     <a:p>
                       <a:pPr algn="ctr">
-                        <a:defRPr sz="1100">
+                        <a:defRPr sz="1150">
                           <a:solidFill>
                             <a:srgbClr val="FFFFFF"/>
                           </a:solidFill>
@@ -7763,9 +7763,9 @@
                       </a:r>
                     </a:p>
                   </a:txBody>
-                  <a:tcPr>
+                  <a:tcPr anchor="ctr">
                     <a:solidFill>
-                      <a:srgbClr val="1B1B2E"/>
+                      <a:srgbClr val="1F1F33"/>
                     </a:solidFill>
                   </a:tcPr>
                 </a:tc>
@@ -7775,7 +7775,7 @@
                     <a:lstStyle/>
                     <a:p>
                       <a:pPr algn="ctr">
-                        <a:defRPr sz="1100">
+                        <a:defRPr sz="1150">
                           <a:solidFill>
                             <a:srgbClr val="FFFFFF"/>
                           </a:solidFill>
@@ -7786,9 +7786,9 @@
                       </a:r>
                     </a:p>
                   </a:txBody>
-                  <a:tcPr>
+                  <a:tcPr anchor="ctr">
                     <a:solidFill>
-                      <a:srgbClr val="1B1B2E"/>
+                      <a:srgbClr val="1F1F33"/>
                     </a:solidFill>
                   </a:tcPr>
                 </a:tc>
@@ -7797,8 +7797,8 @@
                     <a:bodyPr/>
                     <a:lstStyle/>
                     <a:p>
-                      <a:pPr>
-                        <a:defRPr sz="1000">
+                      <a:pPr algn="l">
+                        <a:defRPr sz="1050">
                           <a:solidFill>
                             <a:srgbClr val="FFFFFF"/>
                           </a:solidFill>
@@ -7809,9 +7809,9 @@
                       </a:r>
                     </a:p>
                   </a:txBody>
-                  <a:tcPr>
+                  <a:tcPr anchor="ctr">
                     <a:solidFill>
-                      <a:srgbClr val="1B1B2E"/>
+                      <a:srgbClr val="1F1F33"/>
                     </a:solidFill>
                   </a:tcPr>
                 </a:tc>
@@ -7821,9 +7821,9 @@
                     <a:lstStyle/>
                     <a:p>
                       <a:pPr algn="ctr">
-                        <a:defRPr sz="1100" b="1">
+                        <a:defRPr sz="1150" b="1">
                           <a:solidFill>
-                            <a:srgbClr val="FFFFFF"/>
+                            <a:srgbClr val="BBBBBB"/>
                           </a:solidFill>
                         </a:defRPr>
                       </a:pPr>
@@ -7832,9 +7832,9 @@
                       </a:r>
                     </a:p>
                   </a:txBody>
-                  <a:tcPr>
+                  <a:tcPr anchor="ctr">
                     <a:solidFill>
-                      <a:srgbClr val="1B1B2E"/>
+                      <a:srgbClr val="1F1F33"/>
                     </a:solidFill>
                   </a:tcPr>
                 </a:tc>

</xml_diff>

<commit_message>
style: fix double backslash escaping in LaTeX slides using raw strings
</commit_message>
<xml_diff>
--- a/output/Presentacion_Final_ELI556_Atacama.pptx
+++ b/output/Presentacion_Final_ELI556_Atacama.pptx
@@ -3432,29 +3432,29 @@
           <a:lstStyle/>
           <a:p>
             <a:pPr algn="l">
-              <a:defRPr sz="1500" b="0">
+              <a:defRPr sz="1400" b="0">
                 <a:solidFill>
                   <a:srgbClr val="E8A838"/>
                 </a:solidFill>
               </a:defRPr>
             </a:pPr>
             <a:r>
-              <a:t>El módulo se modela como un circuito de un diodo y resistencias de pérdidas:</a:t>
-            </a:r>
-            <a:br/>
-            <a:br/>
-            <a:r>
-              <a:t>I = I_L − I_0 · [ exp((V + I·R_s) / a) − 1 ] − (V + I·R_s) / R_sh</a:t>
-            </a:r>
-            <a:br/>
-            <a:br/>
-            <a:r>
-              <a:t>El factor de idealidad modificado (a) se define por la física del semiconductor:</a:t>
-            </a:r>
-            <a:br/>
-            <a:br/>
-            <a:r>
-              <a:t>a = (N_s · n_I · k · T_c) / q</a:t>
+              <a:t>El módulo se modela como un circuito equivalente de un diodo y pérdidas óhmicas:</a:t>
+            </a:r>
+            <a:br/>
+            <a:br/>
+            <a:r>
+              <a:t>$$I = I_L - I_0 \cdot \left[ \exp\left(\frac{V + I \cdot R_s}{a}\right) - 1 \right] - \frac{V + I \cdot R_s}{R_{sh}}$$</a:t>
+            </a:r>
+            <a:br/>
+            <a:br/>
+            <a:r>
+              <a:t>El factor de idealidad térmico ($a$) se define formalmente como:</a:t>
+            </a:r>
+            <a:br/>
+            <a:br/>
+            <a:r>
+              <a:t>$$a = \frac{N_s \cdot n_I \cdot k \cdot T_c}{q}$$</a:t>
             </a:r>
           </a:p>
         </p:txBody>
@@ -3562,50 +3562,50 @@
           <a:lstStyle/>
           <a:p>
             <a:pPr algn="l">
-              <a:defRPr sz="1300" b="0">
+              <a:defRPr sz="1200" b="0">
                 <a:solidFill>
                   <a:srgbClr val="FFFFFF"/>
                 </a:solidFill>
               </a:defRPr>
             </a:pPr>
             <a:r>
-              <a:t>• I / V: Corriente y voltaje de salida (A, V).</a:t>
-            </a:r>
-            <a:br/>
-            <a:r>
-              <a:t>• I_L: Corriente fotogenerada por luz (A) (light current).</a:t>
-            </a:r>
-            <a:br/>
-            <a:r>
-              <a:t>• I_0: Corriente de saturación inversa del diodo (A).</a:t>
-            </a:r>
-            <a:br/>
-            <a:r>
-              <a:t>• R_s: Resistencia serie (pérdidas por conducción) (Ω).</a:t>
-            </a:r>
-            <a:br/>
-            <a:r>
-              <a:t>• R_sh: Resistencia paralelo o shunt (corrientes de fuga) (Ω).</a:t>
-            </a:r>
-            <a:br/>
-            <a:r>
-              <a:t>• N_s: Número de celdas conectadas en serie (mSi: 36, HIT: 72).</a:t>
-            </a:r>
-            <a:br/>
-            <a:r>
-              <a:t>• n_I: Factor de idealidad del diodo (adimensional).</a:t>
-            </a:r>
-            <a:br/>
-            <a:r>
-              <a:t>• k: Constante de Boltzmann (1.3806e-23 J/K).</a:t>
-            </a:r>
-            <a:br/>
-            <a:r>
-              <a:t>• q: Carga del electrón (1.6022e-19 C).</a:t>
-            </a:r>
-            <a:br/>
-            <a:r>
-              <a:t>• T_c: Temperatura de la celda (K).</a:t>
+              <a:t>• $I \; / \; V$: Corriente y voltaje de salida (A, V).</a:t>
+            </a:r>
+            <a:br/>
+            <a:r>
+              <a:t>• $I_L$: Corriente fotogenerada por irradiancia (A).</a:t>
+            </a:r>
+            <a:br/>
+            <a:r>
+              <a:t>• $I_0$: Corriente de saturación inversa del diodo (A).</a:t>
+            </a:r>
+            <a:br/>
+            <a:r>
+              <a:t>• $R_s$: Resistencia serie de pérdidas ($\Omega$).</a:t>
+            </a:r>
+            <a:br/>
+            <a:r>
+              <a:t>• $R_{sh}$: Resistencia paralelo o shunt de fugas ($\Omega$).</a:t>
+            </a:r>
+            <a:br/>
+            <a:r>
+              <a:t>• $N_s$: Número de celdas en serie (m-Si: 36, HIT: 72).</a:t>
+            </a:r>
+            <a:br/>
+            <a:r>
+              <a:t>• $n_I$: Factor de idealidad del diodo.</a:t>
+            </a:r>
+            <a:br/>
+            <a:r>
+              <a:t>• $k$: Constante de Boltzmann ($1.3806 \times 10^{-23}\text{ J/K}$).</a:t>
+            </a:r>
+            <a:br/>
+            <a:r>
+              <a:t>• $q$: Carga elemental del electrón ($1.6022 \times 10^{-19}\text{ C}$).</a:t>
+            </a:r>
+            <a:br/>
+            <a:r>
+              <a:t>• $T_c$: Temperatura de celda absoluta (K).</a:t>
             </a:r>
           </a:p>
         </p:txBody>
@@ -3809,39 +3809,39 @@
           <a:lstStyle/>
           <a:p>
             <a:pPr algn="l">
-              <a:defRPr sz="1400" b="0">
+              <a:defRPr sz="1300" b="0">
                 <a:solidFill>
                   <a:srgbClr val="E8A838"/>
                 </a:solidFill>
               </a:defRPr>
             </a:pPr>
             <a:r>
-              <a:t>Se extraen aref, IL,ref, I0,ref, Rs,ref, Rsh,ref en STC (1000 W/m², 25°C):</a:t>
-            </a:r>
-            <a:br/>
-            <a:br/>
-            <a:r>
-              <a:t>1. Cortocircuito (Isc): V = 0, I = Isc,ref</a:t>
-            </a:r>
-            <a:br/>
-            <a:r>
-              <a:t>2. Circuito Abierto (Voc): I = 0, V = Voc,ref</a:t>
-            </a:r>
-            <a:br/>
-            <a:r>
-              <a:t>3. Máxima Potencia (MPP): I = Imp,ref, V = Vmp,ref</a:t>
-            </a:r>
-            <a:br/>
-            <a:r>
-              <a:t>4. Pendiente en MPP (dP/dV = 0):</a:t>
-            </a:r>
-            <a:br/>
-            <a:r>
-              <a:t>   dI/dV|_mp = -Imp,ref / Vmp,ref</a:t>
-            </a:r>
-            <a:br/>
-            <a:r>
-              <a:t>5. Coeficiente térmico de Voc: β_Voc = ∂Voc/∂Tc</a:t>
+              <a:t>Se extraen $a_{ref}$, $I_{L,ref}$, $I_{0,ref}$, $R_{s,ref}$, $R_{sh,ref}$ en STC:</a:t>
+            </a:r>
+            <a:br/>
+            <a:br/>
+            <a:r>
+              <a:t>1. Cortocircuito ($I_{sc}$): $V = 0$, $I = I_{sc,ref}$</a:t>
+            </a:r>
+            <a:br/>
+            <a:r>
+              <a:t>2. Circuito Abierto ($V_{oc}$): $I = 0$, $V = V_{oc,ref}$</a:t>
+            </a:r>
+            <a:br/>
+            <a:r>
+              <a:t>3. Máxima Potencia (MPP): $I = I_{mp,ref}$, $V = V_{mp,ref}$</a:t>
+            </a:r>
+            <a:br/>
+            <a:r>
+              <a:t>4. Pendiente en MPP ($\frac{dP}{dV} = 0$):</a:t>
+            </a:r>
+            <a:br/>
+            <a:r>
+              <a:t>   $$\left.\frac{dI}{dV}\right|_{mp} = -\frac{I_{mp,ref}}{V_{mp,ref}}$$</a:t>
+            </a:r>
+            <a:br/>
+            <a:r>
+              <a:t>5. Coeficiente térmico de $V_{oc}$: $\beta_{Voc} = \frac{\partial V_{oc}}{\partial T_c}$</a:t>
             </a:r>
           </a:p>
         </p:txBody>
@@ -3949,19 +3949,19 @@
           <a:lstStyle/>
           <a:p>
             <a:pPr algn="l">
-              <a:defRPr sz="1300" b="0">
+              <a:defRPr sz="1200" b="0">
                 <a:solidFill>
                   <a:srgbClr val="FFFFFF"/>
                 </a:solidFill>
               </a:defRPr>
             </a:pPr>
             <a:r>
-              <a:t>Para acoplar Rs y el factor de idealidad, se implementa la derivada analítica obtenida del circuito:</a:t>
-            </a:r>
-            <a:br/>
-            <a:br/>
-            <a:r>
-              <a:t>dI/dV|_mp = - [ A + B ] / [ 1 + Rs · A + Rs · B ]</a:t>
+              <a:t>Para acoplar $R_s$ y el factor de idealidad, se implementa la derivada analítica obtenida del circuito:</a:t>
+            </a:r>
+            <a:br/>
+            <a:br/>
+            <a:r>
+              <a:t>$$\left.\frac{dI}{dV}\right|_{mp} = -\frac{A + B}{1 + R_s \cdot A + R_s \cdot B}$$</a:t>
             </a:r>
             <a:br/>
             <a:br/>
@@ -3970,16 +3970,16 @@
             </a:r>
             <a:br/>
             <a:r>
-              <a:t>  A = (I_0 / a) · exp((V_mp + I_mp · Rs) / a)</a:t>
-            </a:r>
-            <a:br/>
-            <a:r>
-              <a:t>  B = 1 / R_sh</a:t>
-            </a:r>
-            <a:br/>
-            <a:br/>
-            <a:r>
-              <a:t>La optimización se realiza mediante ajuste de mínimos cuadrados con bounds físicos (Rs &gt; 0, n_I ∈ [1, 2]).</a:t>
+              <a:t>  $$A = \frac{I_0}{a} \cdot e^{\frac{V_{mp} + I_{mp} \cdot R_s}{a}}$$</a:t>
+            </a:r>
+            <a:br/>
+            <a:r>
+              <a:t>  $$B = \frac{1}{R_{sh}}$$</a:t>
+            </a:r>
+            <a:br/>
+            <a:br/>
+            <a:r>
+              <a:t>La optimización se realiza mediante ajuste de mínimos cuadrados con bounds físicos ($R_s &gt; 0, n_I \in [1, 2]$).</a:t>
             </a:r>
           </a:p>
         </p:txBody>
@@ -4183,50 +4183,54 @@
           <a:lstStyle/>
           <a:p>
             <a:pPr algn="l">
-              <a:defRPr sz="1300" b="0">
+              <a:defRPr sz="1200" b="0">
                 <a:solidFill>
                   <a:srgbClr val="E8A838"/>
                 </a:solidFill>
               </a:defRPr>
             </a:pPr>
             <a:r>
-              <a:t>1. Factor de Idealidad: a / a_ref = T_c / T_ref</a:t>
-            </a:r>
-            <a:br/>
-            <a:br/>
-            <a:r>
-              <a:t>2. Corriente de Saturación Inversa (Io):</a:t>
-            </a:r>
-            <a:br/>
-            <a:r>
-              <a:t>Io / Io,ref = (T_c/T_ref)³ · exp[(E_g,ref/(k·T_ref)) − (E_g/(k·T_c))]</a:t>
-            </a:r>
-            <a:br/>
-            <a:br/>
-            <a:r>
-              <a:t>3. Energía de Bandgap (Eg) del Silicio:</a:t>
-            </a:r>
-            <a:br/>
-            <a:r>
-              <a:t>E_g / E_g,ref = 1 − 0.0002677 · (T_c − T_ref)</a:t>
-            </a:r>
-            <a:br/>
-            <a:r>
-              <a:t>(E_g,ref = 1.121 eV para Si cristalino a 25°C)</a:t>
-            </a:r>
-            <a:br/>
-            <a:br/>
-            <a:r>
-              <a:t>4. Corriente Fotogenerada (IL):</a:t>
-            </a:r>
-            <a:br/>
-            <a:r>
-              <a:t>I_L = (S/S_ref) · (M/M_ref) · [I_L,ref + α_Isc · (T_c − T_ref)]</a:t>
-            </a:r>
-            <a:br/>
-            <a:br/>
-            <a:r>
-              <a:t>5. Resistencia Shunt: R_sh = R_sh,ref · (S_ref / S)</a:t>
+              <a:t>1. Factor de Idealidad:</a:t>
+            </a:r>
+            <a:br/>
+            <a:r>
+              <a:t>$$\frac{a}{a_{ref}} = \frac{T_c}{T_{ref}}$$</a:t>
+            </a:r>
+            <a:br/>
+            <a:br/>
+            <a:r>
+              <a:t>2. Corriente de Saturación Inversa ($I_0$):</a:t>
+            </a:r>
+            <a:br/>
+            <a:r>
+              <a:t>$$\frac{I_0}{I_{0,ref}} = \left(\frac{T_c}{T_{ref}}\right)^3 \cdot \exp\left[ \frac{E_{g,ref}}{k \cdot T_{ref}} - \frac{E_g}{k \cdot T_c} \right]$$</a:t>
+            </a:r>
+            <a:br/>
+            <a:br/>
+            <a:r>
+              <a:t>3. Energía de Bandgap ($E_g$):</a:t>
+            </a:r>
+            <a:br/>
+            <a:r>
+              <a:t>$$\frac{E_g}{E_{g,ref}} = 1 - 0.0002677 \cdot (T_c - T_{ref})$$</a:t>
+            </a:r>
+            <a:br/>
+            <a:r>
+              <a:t>Donde $E_{g,ref} = 1.121\text{ eV}$ para Silicio a 25°C.</a:t>
+            </a:r>
+            <a:br/>
+            <a:br/>
+            <a:r>
+              <a:t>4. Corriente Fotogenerada ($I_L$):</a:t>
+            </a:r>
+            <a:br/>
+            <a:r>
+              <a:t>$$I_L = \left(\frac{S}{S_{ref}}\right) \cdot \left(\frac{M}{M_{ref}}\right) \cdot \left[ I_{L,ref} + \alpha_{Isc} \cdot (T_c - T_{ref}) \right]$$</a:t>
+            </a:r>
+            <a:br/>
+            <a:br/>
+            <a:r>
+              <a:t>5. Resistencia Shunt: $$R_{sh} = R_{sh,ref} \cdot \left(\frac{S_{ref}}{S}\right)$$$</a:t>
             </a:r>
           </a:p>
         </p:txBody>
@@ -5055,7 +5059,7 @@
           <a:lstStyle/>
           <a:p>
             <a:pPr algn="l">
-              <a:defRPr sz="1500" b="0">
+              <a:defRPr sz="1400" b="0">
                 <a:solidFill>
                   <a:srgbClr val="E8A838"/>
                 </a:solidFill>
@@ -5067,28 +5071,28 @@
             <a:br/>
             <a:br/>
             <a:r>
-              <a:t>PR = Σ P_mp,SDM(G, T_c) / Σ [ P_STC · (G_poa / 1000) ]</a:t>
-            </a:r>
-            <a:br/>
-            <a:br/>
-            <a:r>
-              <a:t>Glosario de Términos:</a:t>
-            </a:r>
-            <a:br/>
-            <a:r>
-              <a:t>• P_mp,SDM: Potencia en el MPP simulada minuciosamente hora a hora usando el modelo De Soto (W).</a:t>
-            </a:r>
-            <a:br/>
-            <a:r>
-              <a:t>• P_STC: Potencia nominal del panel a STC (m-Si: 46.68 W | HIT: 217.52 W).</a:t>
-            </a:r>
-            <a:br/>
-            <a:r>
-              <a:t>• G_poa: Irradiancia calculada en el plano del panel (W/m²).</a:t>
-            </a:r>
-            <a:br/>
-            <a:r>
-              <a:t>• 1000: Irradiancia de referencia a STC (W/m²).</a:t>
+              <a:t>$$PR = \frac{\sum P_{mp,SDM}(G, T_c)}{\sum \left[ P_{STC} \cdot \left(\frac{G_{poa}}{1000}\right) \right]}$$</a:t>
+            </a:r>
+            <a:br/>
+            <a:br/>
+            <a:r>
+              <a:t>Donde:</a:t>
+            </a:r>
+            <a:br/>
+            <a:r>
+              <a:t>• $P_{mp,SDM}$: Potencia MPP simulada hora a hora con De Soto (W).</a:t>
+            </a:r>
+            <a:br/>
+            <a:r>
+              <a:t>• $P_{STC}$: Potencia nominal a STC (m-Si: 46.68 W | HIT: 217.52 W).</a:t>
+            </a:r>
+            <a:br/>
+            <a:r>
+              <a:t>• $G_{poa}$: Irradiancia calculada en el plano del panel ($\text{W/m}^2$).</a:t>
+            </a:r>
+            <a:br/>
+            <a:r>
+              <a:t>• $1000$: Irradiancia de referencia a STC ($\text{W/m}^2$).</a:t>
             </a:r>
           </a:p>
         </p:txBody>
@@ -8273,7 +8277,7 @@
           <a:lstStyle/>
           <a:p>
             <a:pPr algn="l">
-              <a:defRPr sz="1500" b="0">
+              <a:defRPr sz="1300" b="0">
                 <a:solidFill>
                   <a:srgbClr val="E8A838"/>
                 </a:solidFill>
@@ -8284,11 +8288,7 @@
             </a:r>
             <a:br/>
             <a:r>
-              <a:t>G_poa = G_b · R_beam + G_d · [(1 + cos(β)) / 2] +</a:t>
-            </a:r>
-            <a:br/>
-            <a:r>
-              <a:t>        G · ρ · [(1 - cos(β)) / 2]</a:t>
+              <a:t>$$G_{poa} = G_b \cdot R_{beam} + G_d \cdot \left(\frac{1 + \cos(\beta)}{2}\right) + G \cdot \rho \cdot \left(\frac{1 - \cos(\beta)}{2}\right)$$</a:t>
             </a:r>
             <a:br/>
             <a:br/>
@@ -8297,20 +8297,12 @@
             </a:r>
             <a:br/>
             <a:r>
-              <a:t>S / S_ref = (G_b/G_ref) · R_beam · K_τα,b +</a:t>
-            </a:r>
-            <a:br/>
-            <a:r>
-              <a:t>            (G_d/G_ref) · K_τα,d · [(1 + cos(β)) / 2] +</a:t>
-            </a:r>
-            <a:br/>
-            <a:r>
-              <a:t>            (G/G_ref) · ρ · K_τα,g · [(1 - cos(β)) / 2]</a:t>
-            </a:r>
-            <a:br/>
-            <a:br/>
-            <a:r>
-              <a:t>Donde S_ref = G_ref = 1000 W/m² (SRC).</a:t>
+              <a:t>$$\frac{S}{S_{ref}} = \frac{G_b}{G_{ref}} \cdot R_{beam} \cdot K_{\tau\alpha,b} + \frac{G_d}{G_{ref}} \cdot K_{\tau\alpha,d} \cdot \left(\frac{1 + \cos(\beta)}{2}\right) + \frac{G}{G_{ref}} \cdot \rho \cdot K_{\tau\alpha,g} \cdot \left(\frac{1 - \cos(\beta)}{2}\right)$$</a:t>
+            </a:r>
+            <a:br/>
+            <a:br/>
+            <a:r>
+              <a:t>Donde $S_{ref} = G_{ref} = 1000\text{ W/m}^2$ en condiciones SRC.</a:t>
             </a:r>
           </a:p>
         </p:txBody>
@@ -8418,30 +8410,30 @@
           <a:lstStyle/>
           <a:p>
             <a:pPr algn="l">
-              <a:defRPr sz="1400" b="0">
+              <a:defRPr sz="1300" b="0">
                 <a:solidFill>
                   <a:srgbClr val="FFFFFF"/>
                 </a:solidFill>
               </a:defRPr>
             </a:pPr>
             <a:r>
-              <a:t>• G_b / G_d / G: Irradiancia directa, difusa y global horizontal (W/m²).</a:t>
-            </a:r>
-            <a:br/>
-            <a:r>
-              <a:t>• β (Tilt): Ángulo de inclinación del panel (22.91° optimizado).</a:t>
-            </a:r>
-            <a:br/>
-            <a:r>
-              <a:t>• ρ (Albedo): Reflectancia del suelo árido desértico (~0.20).</a:t>
-            </a:r>
-            <a:br/>
-            <a:r>
-              <a:t>• R_beam: Factor de transposición geométrica para radiación directa.</a:t>
-            </a:r>
-            <a:br/>
-            <a:r>
-              <a:t>• K_τα,b / K_τα,d / K_τα,g: Modificadores por ángulo de incidencia (IAM) para componente directa, difusa y del suelo.</a:t>
+              <a:t>• $G_b \; / \; G_d \; / \; G$: Irradiancia directa, difusa y global horizontal ($\text{W/m}^2$).</a:t>
+            </a:r>
+            <a:br/>
+            <a:r>
+              <a:t>• $\beta$ (Tilt): Ángulo de inclinación del panel ($22.91^\circ$ optimizado).</a:t>
+            </a:r>
+            <a:br/>
+            <a:r>
+              <a:t>• $\rho$ (Albedo): Reflectancia del suelo árido desértico ($\sim 0.20$).</a:t>
+            </a:r>
+            <a:br/>
+            <a:r>
+              <a:t>• $R_{beam}$: Factor de transposición geométrica para radiación directa.</a:t>
+            </a:r>
+            <a:br/>
+            <a:r>
+              <a:t>• $K_{\tau\alpha,b} \; / \; K_{\tau\alpha,d} \; / \; K_{\tau\alpha,g}$: Modificadores por ángulo de incidencia (IAM) para componente directa, difusa y del suelo.</a:t>
             </a:r>
           </a:p>
         </p:txBody>
@@ -8645,7 +8637,7 @@
           <a:lstStyle/>
           <a:p>
             <a:pPr algn="l">
-              <a:defRPr sz="1300" b="0">
+              <a:defRPr sz="1100" b="0">
                 <a:solidFill>
                   <a:srgbClr val="E8A838"/>
                 </a:solidFill>
@@ -8656,46 +8648,38 @@
             </a:r>
             <a:br/>
             <a:r>
-              <a:t>K_τα(θ) = τ(θ) / τ(0)</a:t>
-            </a:r>
-            <a:br/>
-            <a:br/>
-            <a:r>
-              <a:t>τ(θ) = exp(-K·L / cos(θ_r)) · [1 - 0.5 · (</a:t>
-            </a:r>
-            <a:br/>
-            <a:r>
-              <a:t>       sin²(θ_r − θ)/sin²(θ_r + θ) + </a:t>
-            </a:r>
-            <a:br/>
-            <a:r>
-              <a:t>       tan²(θ_r − θ)/tan²(θ_r + θ) )]</a:t>
-            </a:r>
-            <a:br/>
-            <a:br/>
-            <a:r>
-              <a:t>θ_r = arcsin(sin(θ) / n)</a:t>
-            </a:r>
-            <a:br/>
-            <a:br/>
-            <a:r>
-              <a:t>Glosario:</a:t>
-            </a:r>
-            <a:br/>
-            <a:r>
-              <a:t>• θ: Ángulo de incidencia solar respecto a la normal del panel.</a:t>
-            </a:r>
-            <a:br/>
-            <a:r>
-              <a:t>• n = 1.526 (Índice de refracción del vidrio templado).</a:t>
-            </a:r>
-            <a:br/>
-            <a:r>
-              <a:t>• K = 4 m⁻¹ (Coeficiente de absorción del vidrio).</a:t>
-            </a:r>
-            <a:br/>
-            <a:r>
-              <a:t>• L = 2 mm (Espesor típico del vidrio del panel).</a:t>
+              <a:t>$$K_{\tau\alpha}(\theta) = \frac{\tau(\theta)}{\tau(0)}$$</a:t>
+            </a:r>
+            <a:br/>
+            <a:br/>
+            <a:r>
+              <a:t>$$\tau(\theta) = e^{-\frac{K \cdot L}{\cos(\theta_r)}} \cdot \left[ 1 - \frac{1}{2} \left( \frac{\sin^2(\theta_r - \theta)}{\sin^2(\theta_r + \theta)} + \frac{\tan^2(\theta_r - \theta)}{\tan^2(\theta_r + \theta)} \right) \right]$$</a:t>
+            </a:r>
+            <a:br/>
+            <a:br/>
+            <a:r>
+              <a:t>$$\theta_r = \arcsin\left(\frac{\sin(\theta)}{n}\right)$$</a:t>
+            </a:r>
+            <a:br/>
+            <a:br/>
+            <a:r>
+              <a:t>Donde:</a:t>
+            </a:r>
+            <a:br/>
+            <a:r>
+              <a:t>• $\theta$: Ángulo de incidencia solar.</a:t>
+            </a:r>
+            <a:br/>
+            <a:r>
+              <a:t>• $n = 1.526$ (Índice de refracción del vidrio templado).</a:t>
+            </a:r>
+            <a:br/>
+            <a:r>
+              <a:t>• $K = 4\text{ m}^{-1}$ (Absorción del vidrio).</a:t>
+            </a:r>
+            <a:br/>
+            <a:r>
+              <a:t>• $L = 2\text{ mm}$ (Espesor típico del vidrio).</a:t>
             </a:r>
           </a:p>
         </p:txBody>
@@ -8803,7 +8787,7 @@
           <a:lstStyle/>
           <a:p>
             <a:pPr algn="l">
-              <a:defRPr sz="1300" b="0">
+              <a:defRPr sz="1200" b="0">
                 <a:solidFill>
                   <a:srgbClr val="FFFFFF"/>
                 </a:solidFill>
@@ -8814,33 +8798,33 @@
             </a:r>
             <a:br/>
             <a:r>
-              <a:t>M / M_ref = a_0 + a_1 · AM + a_2 · AM² + a_3 · AM³ + a_4 · AM⁴</a:t>
-            </a:r>
-            <a:br/>
-            <a:br/>
-            <a:r>
-              <a:t>AM = 1 / [cos(θ_z) + 0.5057 · (96.08 − θ_z)⁻¹·⁶³⁴]</a:t>
-            </a:r>
-            <a:br/>
-            <a:br/>
-            <a:r>
-              <a:t>Glosario:</a:t>
-            </a:r>
-            <a:br/>
-            <a:r>
-              <a:t>• AM: Masa de aire absoluta (corregida por presión atmosférica local).</a:t>
-            </a:r>
-            <a:br/>
-            <a:r>
-              <a:t>• θ_z: Ángulo cenital del sol.</a:t>
-            </a:r>
-            <a:br/>
-            <a:r>
-              <a:t>• a_0 a a_4: Coeficientes empíricos espectrales según el tipo de semiconductor (establecidos por De Soto).</a:t>
-            </a:r>
-            <a:br/>
-            <a:r>
-              <a:t>• M_ref: Transmitancia del espectro solar en STC (AM 1.5g).</a:t>
+              <a:t>$$\frac{M}{M_{ref}} = a_0 + a_1 \cdot AM + a_2 \cdot AM^2 + a_3 \cdot AM^3 + a_4 \cdot AM^4$$</a:t>
+            </a:r>
+            <a:br/>
+            <a:br/>
+            <a:r>
+              <a:t>$$AM = \frac{1}{\cos(\theta_z) + 0.5057 \cdot (96.08 - \theta_z)^{-1.634}}$$</a:t>
+            </a:r>
+            <a:br/>
+            <a:br/>
+            <a:r>
+              <a:t>Donde:</a:t>
+            </a:r>
+            <a:br/>
+            <a:r>
+              <a:t>• $AM$: Masa de aire absoluta.</a:t>
+            </a:r>
+            <a:br/>
+            <a:r>
+              <a:t>• $\theta_z$: Ángulo cenital del sol.</a:t>
+            </a:r>
+            <a:br/>
+            <a:r>
+              <a:t>• $a_0, a_1, a_2, a_3, a_4$: Coeficientes empíricos espectrales.</a:t>
+            </a:r>
+            <a:br/>
+            <a:r>
+              <a:t>• $M_{ref}$: Transmitancia espectral a STC ($AM\;1.5g$).</a:t>
             </a:r>
           </a:p>
         </p:txBody>
@@ -9209,40 +9193,40 @@
           <a:lstStyle/>
           <a:p>
             <a:pPr algn="l">
-              <a:defRPr sz="1500" b="0">
+              <a:defRPr sz="1400" b="0">
                 <a:solidFill>
                   <a:srgbClr val="E8A838"/>
                 </a:solidFill>
               </a:defRPr>
             </a:pPr>
             <a:r>
-              <a:t>La temperatura interna de la celda (Tc) depende de la irradiancia, temperatura ambiente y viento:</a:t>
-            </a:r>
-            <a:br/>
-            <a:br/>
-            <a:r>
-              <a:t>T_c = G_poa · exp(a + b · v_w) + T_a + (G_poa / 1000) · ΔT</a:t>
-            </a:r>
-            <a:br/>
-            <a:br/>
-            <a:r>
-              <a:t>Glosario de Términos:</a:t>
-            </a:r>
-            <a:br/>
-            <a:r>
-              <a:t>• T_c / T_a: Temperatura de celda y ambiental (°C).</a:t>
-            </a:r>
-            <a:br/>
-            <a:r>
-              <a:t>• G_poa: Irradiancia en el plano del panel (W/m²).</a:t>
-            </a:r>
-            <a:br/>
-            <a:r>
-              <a:t>• v_w: Velocidad del viento (asumida 1 m/s constante).</a:t>
-            </a:r>
-            <a:br/>
-            <a:r>
-              <a:t>• a, b, ΔT: Parámetros empíricos según encapsulado físico.</a:t>
+              <a:t>La temperatura interna de la celda ($T_c$) depende del recurso solar y del viento:</a:t>
+            </a:r>
+            <a:br/>
+            <a:br/>
+            <a:r>
+              <a:t>$$T_c = G_{poa} \cdot e^{a + b \cdot v_w} + T_a + \left(\frac{G_{poa}}{1000}\right) \cdot \Delta T$$</a:t>
+            </a:r>
+            <a:br/>
+            <a:br/>
+            <a:r>
+              <a:t>Donde:</a:t>
+            </a:r>
+            <a:br/>
+            <a:r>
+              <a:t>• $T_c \; / \; T_a$: Temperatura de celda y ambiental ($^\circ\text{C}$).</a:t>
+            </a:r>
+            <a:br/>
+            <a:r>
+              <a:t>• $G_{poa}$: Irradiancia en el plano del panel ($\text{W/m}^2$).</a:t>
+            </a:r>
+            <a:br/>
+            <a:r>
+              <a:t>• $v_w$: Velocidad del viento ($\text{m/s}$).</a:t>
+            </a:r>
+            <a:br/>
+            <a:r>
+              <a:t>• $a, b, \Delta T$: Parámetros empíricos del encapsulado.</a:t>
             </a:r>
           </a:p>
         </p:txBody>

</xml_diff>

<commit_message>
style: replace raw LaTeX strings with clean unicode math equations
</commit_message>
<xml_diff>
--- a/output/Presentacion_Final_ELI556_Atacama.pptx
+++ b/output/Presentacion_Final_ELI556_Atacama.pptx
@@ -3444,17 +3444,17 @@
             <a:br/>
             <a:br/>
             <a:r>
-              <a:t>$$I = I_L - I_0 \cdot \left[ \exp\left(\frac{V + I \cdot R_s}{a}\right) - 1 \right] - \frac{V + I \cdot R_s}{R_{sh}}$$</a:t>
-            </a:r>
-            <a:br/>
-            <a:br/>
-            <a:r>
-              <a:t>El factor de idealidad térmico ($a$) se define formalmente como:</a:t>
-            </a:r>
-            <a:br/>
-            <a:br/>
-            <a:r>
-              <a:t>$$a = \frac{N_s \cdot n_I \cdot k \cdot T_c}{q}$$</a:t>
+              <a:t>   I = I_L - I_₀ · [ exp((V + I·R_s) / a) - 1 ] - (V + I·R_s) / R_sh</a:t>
+            </a:r>
+            <a:br/>
+            <a:br/>
+            <a:r>
+              <a:t>El factor de idealidad térmico (a) se define formalmente como:</a:t>
+            </a:r>
+            <a:br/>
+            <a:br/>
+            <a:r>
+              <a:t>   a = (N_s · n_I · k · T_c) / q</a:t>
             </a:r>
           </a:p>
         </p:txBody>
@@ -3569,43 +3569,43 @@
               </a:defRPr>
             </a:pPr>
             <a:r>
-              <a:t>• $I \; / \; V$: Corriente y voltaje de salida (A, V).</a:t>
-            </a:r>
-            <a:br/>
-            <a:r>
-              <a:t>• $I_L$: Corriente fotogenerada por irradiancia (A).</a:t>
-            </a:r>
-            <a:br/>
-            <a:r>
-              <a:t>• $I_0$: Corriente de saturación inversa del diodo (A).</a:t>
-            </a:r>
-            <a:br/>
-            <a:r>
-              <a:t>• $R_s$: Resistencia serie de pérdidas ($\Omega$).</a:t>
-            </a:r>
-            <a:br/>
-            <a:r>
-              <a:t>• $R_{sh}$: Resistencia paralelo o shunt de fugas ($\Omega$).</a:t>
-            </a:r>
-            <a:br/>
-            <a:r>
-              <a:t>• $N_s$: Número de celdas en serie (m-Si: 36, HIT: 72).</a:t>
-            </a:r>
-            <a:br/>
-            <a:r>
-              <a:t>• $n_I$: Factor de idealidad del diodo.</a:t>
-            </a:r>
-            <a:br/>
-            <a:r>
-              <a:t>• $k$: Constante de Boltzmann ($1.3806 \times 10^{-23}\text{ J/K}$).</a:t>
-            </a:r>
-            <a:br/>
-            <a:r>
-              <a:t>• $q$: Carga elemental del electrón ($1.6022 \times 10^{-19}\text{ C}$).</a:t>
-            </a:r>
-            <a:br/>
-            <a:r>
-              <a:t>• $T_c$: Temperatura de celda absoluta (K).</a:t>
+              <a:t>• I / V: Corriente y voltaje de salida (A, V).</a:t>
+            </a:r>
+            <a:br/>
+            <a:r>
+              <a:t>• I_L: Corriente fotogenerada por irradiancia (A).</a:t>
+            </a:r>
+            <a:br/>
+            <a:r>
+              <a:t>• I_₀: Corriente de saturación inversa del diodo (A).</a:t>
+            </a:r>
+            <a:br/>
+            <a:r>
+              <a:t>• R_s: Resistencia serie de pérdidas (Ω).</a:t>
+            </a:r>
+            <a:br/>
+            <a:r>
+              <a:t>• R_sh: Resistencia paralelo o shunt de fugas (Ω).</a:t>
+            </a:r>
+            <a:br/>
+            <a:r>
+              <a:t>• N_s: Número de celdas en serie (m-Si: 36, HIT: 72).</a:t>
+            </a:r>
+            <a:br/>
+            <a:r>
+              <a:t>• n_I: Factor de idealidad del diodo.</a:t>
+            </a:r>
+            <a:br/>
+            <a:r>
+              <a:t>• k: Constante de Boltzmann (1.3806 × 10⁻²³ J/K).</a:t>
+            </a:r>
+            <a:br/>
+            <a:r>
+              <a:t>• q: Carga elemental del electrón (1.6022 × 10⁻¹⁹ C).</a:t>
+            </a:r>
+            <a:br/>
+            <a:r>
+              <a:t>• T_c: Temperatura de celda absoluta (K).</a:t>
             </a:r>
           </a:p>
         </p:txBody>
@@ -3816,32 +3816,32 @@
               </a:defRPr>
             </a:pPr>
             <a:r>
-              <a:t>Se extraen $a_{ref}$, $I_{L,ref}$, $I_{0,ref}$, $R_{s,ref}$, $R_{sh,ref}$ en STC:</a:t>
-            </a:r>
-            <a:br/>
-            <a:br/>
-            <a:r>
-              <a:t>1. Cortocircuito ($I_{sc}$): $V = 0$, $I = I_{sc,ref}$</a:t>
-            </a:r>
-            <a:br/>
-            <a:r>
-              <a:t>2. Circuito Abierto ($V_{oc}$): $I = 0$, $V = V_{oc,ref}$</a:t>
-            </a:r>
-            <a:br/>
-            <a:r>
-              <a:t>3. Máxima Potencia (MPP): $I = I_{mp,ref}$, $V = V_{mp,ref}$</a:t>
-            </a:r>
-            <a:br/>
-            <a:r>
-              <a:t>4. Pendiente en MPP ($\frac{dP}{dV} = 0$):</a:t>
-            </a:r>
-            <a:br/>
-            <a:r>
-              <a:t>   $$\left.\frac{dI}{dV}\right|_{mp} = -\frac{I_{mp,ref}}{V_{mp,ref}}$$</a:t>
-            </a:r>
-            <a:br/>
-            <a:r>
-              <a:t>5. Coeficiente térmico de $V_{oc}$: $\beta_{Voc} = \frac{\partial V_{oc}}{\partial T_c}$</a:t>
+              <a:t>Se extraen a_ref, I_L,ref, I_₀,ref, R_s,ref, R_sh,ref en STC:</a:t>
+            </a:r>
+            <a:br/>
+            <a:br/>
+            <a:r>
+              <a:t>1. Cortocircuito (I_sc): V = 0, I = I_sc,ref</a:t>
+            </a:r>
+            <a:br/>
+            <a:r>
+              <a:t>2. Circuito Abierto (V_oc): I = 0, V = V_oc,ref</a:t>
+            </a:r>
+            <a:br/>
+            <a:r>
+              <a:t>3. Máxima Potencia (MPP): I = I_mp,ref, V = V_mp,ref</a:t>
+            </a:r>
+            <a:br/>
+            <a:r>
+              <a:t>4. Pendiente en MPP (dP/dV = 0):</a:t>
+            </a:r>
+            <a:br/>
+            <a:r>
+              <a:t>   dI/dV|_mpp = -I_mp,ref / V_mp,ref</a:t>
+            </a:r>
+            <a:br/>
+            <a:r>
+              <a:t>5. Coeficiente térmico de V_oc: β_Voc = ∂V_oc / ∂T_c</a:t>
             </a:r>
           </a:p>
         </p:txBody>
@@ -3956,12 +3956,12 @@
               </a:defRPr>
             </a:pPr>
             <a:r>
-              <a:t>Para acoplar $R_s$ y el factor de idealidad, se implementa la derivada analítica obtenida del circuito:</a:t>
-            </a:r>
-            <a:br/>
-            <a:br/>
-            <a:r>
-              <a:t>$$\left.\frac{dI}{dV}\right|_{mp} = -\frac{A + B}{1 + R_s \cdot A + R_s \cdot B}$$</a:t>
+              <a:t>Para acoplar R_s y el factor de idealidad, se implementa la derivada analítica obtenida del circuito:</a:t>
+            </a:r>
+            <a:br/>
+            <a:br/>
+            <a:r>
+              <a:t>   dI/dV|_mpp = -(A + B) / (1 + R_s · A + R_s · B)</a:t>
             </a:r>
             <a:br/>
             <a:br/>
@@ -3970,16 +3970,16 @@
             </a:r>
             <a:br/>
             <a:r>
-              <a:t>  $$A = \frac{I_0}{a} \cdot e^{\frac{V_{mp} + I_{mp} \cdot R_s}{a}}$$</a:t>
-            </a:r>
-            <a:br/>
-            <a:r>
-              <a:t>  $$B = \frac{1}{R_{sh}}$$</a:t>
-            </a:r>
-            <a:br/>
-            <a:br/>
-            <a:r>
-              <a:t>La optimización se realiza mediante ajuste de mínimos cuadrados con bounds físicos ($R_s &gt; 0, n_I \in [1, 2]$).</a:t>
+              <a:t>   A = (I_₀ / a) · exp((V_mp + I_mp · R_s) / a)</a:t>
+            </a:r>
+            <a:br/>
+            <a:r>
+              <a:t>   B = 1 / R_sh</a:t>
+            </a:r>
+            <a:br/>
+            <a:br/>
+            <a:r>
+              <a:t>La optimización se realiza mediante ajuste de mínimos cuadrados con bounds físicos (R_s &gt; 0, n_I ∈ [1, 2]).</a:t>
             </a:r>
           </a:p>
         </p:txBody>
@@ -4194,43 +4194,47 @@
             </a:r>
             <a:br/>
             <a:r>
-              <a:t>$$\frac{a}{a_{ref}} = \frac{T_c}{T_{ref}}$$</a:t>
-            </a:r>
-            <a:br/>
-            <a:br/>
-            <a:r>
-              <a:t>2. Corriente de Saturación Inversa ($I_0$):</a:t>
-            </a:r>
-            <a:br/>
-            <a:r>
-              <a:t>$$\frac{I_0}{I_{0,ref}} = \left(\frac{T_c}{T_{ref}}\right)^3 \cdot \exp\left[ \frac{E_{g,ref}}{k \cdot T_{ref}} - \frac{E_g}{k \cdot T_c} \right]$$</a:t>
-            </a:r>
-            <a:br/>
-            <a:br/>
-            <a:r>
-              <a:t>3. Energía de Bandgap ($E_g$):</a:t>
-            </a:r>
-            <a:br/>
-            <a:r>
-              <a:t>$$\frac{E_g}{E_{g,ref}} = 1 - 0.0002677 \cdot (T_c - T_{ref})$$</a:t>
-            </a:r>
-            <a:br/>
-            <a:r>
-              <a:t>Donde $E_{g,ref} = 1.121\text{ eV}$ para Silicio a 25°C.</a:t>
-            </a:r>
-            <a:br/>
-            <a:br/>
-            <a:r>
-              <a:t>4. Corriente Fotogenerada ($I_L$):</a:t>
-            </a:r>
-            <a:br/>
-            <a:r>
-              <a:t>$$I_L = \left(\frac{S}{S_{ref}}\right) \cdot \left(\frac{M}{M_{ref}}\right) \cdot \left[ I_{L,ref} + \alpha_{Isc} \cdot (T_c - T_{ref}) \right]$$</a:t>
-            </a:r>
-            <a:br/>
-            <a:br/>
-            <a:r>
-              <a:t>5. Resistencia Shunt: $$R_{sh} = R_{sh,ref} \cdot \left(\frac{S_{ref}}{S}\right)$$$</a:t>
+              <a:t>   a / a_ref = T_c / T_ref</a:t>
+            </a:r>
+            <a:br/>
+            <a:br/>
+            <a:r>
+              <a:t>2. Corriente de Saturación Inversa (I_₀):</a:t>
+            </a:r>
+            <a:br/>
+            <a:r>
+              <a:t>   I_₀ / I_₀,ref = (T_c / T_ref)³ · exp[ E_g,ref / (k · T_ref) - E_g / (k · T_c) ]</a:t>
+            </a:r>
+            <a:br/>
+            <a:br/>
+            <a:r>
+              <a:t>3. Energía de Bandgap (E_g):</a:t>
+            </a:r>
+            <a:br/>
+            <a:r>
+              <a:t>   E_g / E_g,ref = 1 - 0.0002677 · (T_c - T_ref)</a:t>
+            </a:r>
+            <a:br/>
+            <a:r>
+              <a:t>   Donde E_g,ref = 1.121 eV para Silicio a 25°C.</a:t>
+            </a:r>
+            <a:br/>
+            <a:br/>
+            <a:r>
+              <a:t>4. Corriente Fotogenerada (I_L):</a:t>
+            </a:r>
+            <a:br/>
+            <a:r>
+              <a:t>   I_L = (S / S_ref) · (M / M_ref) · [ I_L,ref + α_Isc · (T_c - T_ref) ]</a:t>
+            </a:r>
+            <a:br/>
+            <a:br/>
+            <a:r>
+              <a:t>5. Resistencia Shunt:</a:t>
+            </a:r>
+            <a:br/>
+            <a:r>
+              <a:t>   R_sh = R_sh,ref · (S_ref / S)</a:t>
             </a:r>
           </a:p>
         </p:txBody>
@@ -5071,7 +5075,7 @@
             <a:br/>
             <a:br/>
             <a:r>
-              <a:t>$$PR = \frac{\sum P_{mp,SDM}(G, T_c)}{\sum \left[ P_{STC} \cdot \left(\frac{G_{poa}}{1000}\right) \right]}$$</a:t>
+              <a:t>   PR = Σ P_mp,SDM(G, T_c) / Σ [ P_STC · (G_poa / 1000) ]</a:t>
             </a:r>
             <a:br/>
             <a:br/>
@@ -5080,19 +5084,19 @@
             </a:r>
             <a:br/>
             <a:r>
-              <a:t>• $P_{mp,SDM}$: Potencia MPP simulada hora a hora con De Soto (W).</a:t>
-            </a:r>
-            <a:br/>
-            <a:r>
-              <a:t>• $P_{STC}$: Potencia nominal a STC (m-Si: 46.68 W | HIT: 217.52 W).</a:t>
-            </a:r>
-            <a:br/>
-            <a:r>
-              <a:t>• $G_{poa}$: Irradiancia calculada en el plano del panel ($\text{W/m}^2$).</a:t>
-            </a:r>
-            <a:br/>
-            <a:r>
-              <a:t>• $1000$: Irradiancia de referencia a STC ($\text{W/m}^2$).</a:t>
+              <a:t>• P_mp,SDM: Potencia MPP simulada hora a hora con De Soto (W).</a:t>
+            </a:r>
+            <a:br/>
+            <a:r>
+              <a:t>• P_STC: Potencia nominal a STC (m-Si: 46.68 W | HIT: 217.52 W).</a:t>
+            </a:r>
+            <a:br/>
+            <a:r>
+              <a:t>• G_poa: Irradiancia calculada en el plano del panel (W/m²).</a:t>
+            </a:r>
+            <a:br/>
+            <a:r>
+              <a:t>• 1000: Irradiancia de referencia a STC (W/m²).</a:t>
             </a:r>
           </a:p>
         </p:txBody>
@@ -8288,7 +8292,7 @@
             </a:r>
             <a:br/>
             <a:r>
-              <a:t>$$G_{poa} = G_b \cdot R_{beam} + G_d \cdot \left(\frac{1 + \cos(\beta)}{2}\right) + G \cdot \rho \cdot \left(\frac{1 - \cos(\beta)}{2}\right)$$</a:t>
+              <a:t>   G_poa = G_b · R_beam + G_d · [(1 + cos(β)) / 2] + G · ρ · [(1 - cos(β)) / 2]</a:t>
             </a:r>
             <a:br/>
             <a:br/>
@@ -8297,12 +8301,12 @@
             </a:r>
             <a:br/>
             <a:r>
-              <a:t>$$\frac{S}{S_{ref}} = \frac{G_b}{G_{ref}} \cdot R_{beam} \cdot K_{\tau\alpha,b} + \frac{G_d}{G_{ref}} \cdot K_{\tau\alpha,d} \cdot \left(\frac{1 + \cos(\beta)}{2}\right) + \frac{G}{G_{ref}} \cdot \rho \cdot K_{\tau\alpha,g} \cdot \left(\frac{1 - \cos(\beta)}{2}\right)$$</a:t>
-            </a:r>
-            <a:br/>
-            <a:br/>
-            <a:r>
-              <a:t>Donde $S_{ref} = G_{ref} = 1000\text{ W/m}^2$ en condiciones SRC.</a:t>
+              <a:t>   S / S_ref = (G_b / G_ref) · R_beam · K_τα,b + (G_d / G_ref) · K_τα,d · [(1 + cos(β)) / 2] + (G / G_ref) · ρ · K_τα,g · [(1 - cos(β)) / 2]</a:t>
+            </a:r>
+            <a:br/>
+            <a:br/>
+            <a:r>
+              <a:t>Donde S_ref = G_ref = 1000 W/m² en condiciones de referencia (SRC).</a:t>
             </a:r>
           </a:p>
         </p:txBody>
@@ -8417,23 +8421,23 @@
               </a:defRPr>
             </a:pPr>
             <a:r>
-              <a:t>• $G_b \; / \; G_d \; / \; G$: Irradiancia directa, difusa y global horizontal ($\text{W/m}^2$).</a:t>
-            </a:r>
-            <a:br/>
-            <a:r>
-              <a:t>• $\beta$ (Tilt): Ángulo de inclinación del panel ($22.91^\circ$ optimizado).</a:t>
-            </a:r>
-            <a:br/>
-            <a:r>
-              <a:t>• $\rho$ (Albedo): Reflectancia del suelo árido desértico ($\sim 0.20$).</a:t>
-            </a:r>
-            <a:br/>
-            <a:r>
-              <a:t>• $R_{beam}$: Factor de transposición geométrica para radiación directa.</a:t>
-            </a:r>
-            <a:br/>
-            <a:r>
-              <a:t>• $K_{\tau\alpha,b} \; / \; K_{\tau\alpha,d} \; / \; K_{\tau\alpha,g}$: Modificadores por ángulo de incidencia (IAM) para componente directa, difusa y del suelo.</a:t>
+              <a:t>• G_b / G_d / G: Irradiancia directa, difusa y global horizontal (W/m²).</a:t>
+            </a:r>
+            <a:br/>
+            <a:r>
+              <a:t>• β (Tilt): Ángulo de inclinación del panel (22.91° optimizado).</a:t>
+            </a:r>
+            <a:br/>
+            <a:r>
+              <a:t>• ρ (Albedo): Reflectancia del suelo árido desértico (~0.20).</a:t>
+            </a:r>
+            <a:br/>
+            <a:r>
+              <a:t>• R_beam: Factor de transposición geométrica para radiación directa.</a:t>
+            </a:r>
+            <a:br/>
+            <a:r>
+              <a:t>• K_τα,b / K_τα,d / K_τα,g: Modificadores por ángulo de incidencia (IAM) para componente directa, difusa y del suelo.</a:t>
             </a:r>
           </a:p>
         </p:txBody>
@@ -8647,18 +8651,19 @@
               <a:t>Ecuación física basada en Ley de Snell y Bouguer:</a:t>
             </a:r>
             <a:br/>
-            <a:r>
-              <a:t>$$K_{\tau\alpha}(\theta) = \frac{\tau(\theta)}{\tau(0)}$$</a:t>
-            </a:r>
-            <a:br/>
-            <a:br/>
-            <a:r>
-              <a:t>$$\tau(\theta) = e^{-\frac{K \cdot L}{\cos(\theta_r)}} \cdot \left[ 1 - \frac{1}{2} \left( \frac{\sin^2(\theta_r - \theta)}{\sin^2(\theta_r + \theta)} + \frac{\tan^2(\theta_r - \theta)}{\tan^2(\theta_r + \theta)} \right) \right]$$</a:t>
-            </a:r>
-            <a:br/>
-            <a:br/>
-            <a:r>
-              <a:t>$$\theta_r = \arcsin\left(\frac{\sin(\theta)}{n}\right)$$</a:t>
+            <a:br/>
+            <a:r>
+              <a:t>   K_τα(θ) = τ(θ) / τ(0)</a:t>
+            </a:r>
+            <a:br/>
+            <a:br/>
+            <a:r>
+              <a:t>   τ(θ) = e^(-K·L / cos(θ_r)) · [ 1 - 0.5 · ( sin²(θ_r - θ)/sin²(θ_r + θ) + tan²(θ_r - θ)/tan²(θ_r + θ) ) ]</a:t>
+            </a:r>
+            <a:br/>
+            <a:br/>
+            <a:r>
+              <a:t>   θ_r = arcsin( sin(θ) / n )</a:t>
             </a:r>
             <a:br/>
             <a:br/>
@@ -8667,19 +8672,19 @@
             </a:r>
             <a:br/>
             <a:r>
-              <a:t>• $\theta$: Ángulo de incidencia solar.</a:t>
-            </a:r>
-            <a:br/>
-            <a:r>
-              <a:t>• $n = 1.526$ (Índice de refracción del vidrio templado).</a:t>
-            </a:r>
-            <a:br/>
-            <a:r>
-              <a:t>• $K = 4\text{ m}^{-1}$ (Absorción del vidrio).</a:t>
-            </a:r>
-            <a:br/>
-            <a:r>
-              <a:t>• $L = 2\text{ mm}$ (Espesor típico del vidrio).</a:t>
+              <a:t>• θ: Ángulo de incidencia solar.</a:t>
+            </a:r>
+            <a:br/>
+            <a:r>
+              <a:t>• n = 1.526 (Índice de refracción del vidrio templado).</a:t>
+            </a:r>
+            <a:br/>
+            <a:r>
+              <a:t>• K = 4 m⁻¹ (Absorción del vidrio).</a:t>
+            </a:r>
+            <a:br/>
+            <a:r>
+              <a:t>• L = 2 mm (Espesor típico del vidrio).</a:t>
             </a:r>
           </a:p>
         </p:txBody>
@@ -8797,13 +8802,14 @@
               <a:t>Corrige el desajuste del espectro solar según el espesor de la atmósfera atravesada:</a:t>
             </a:r>
             <a:br/>
-            <a:r>
-              <a:t>$$\frac{M}{M_{ref}} = a_0 + a_1 \cdot AM + a_2 \cdot AM^2 + a_3 \cdot AM^3 + a_4 \cdot AM^4$$</a:t>
-            </a:r>
-            <a:br/>
-            <a:br/>
-            <a:r>
-              <a:t>$$AM = \frac{1}{\cos(\theta_z) + 0.5057 \cdot (96.08 - \theta_z)^{-1.634}}$$</a:t>
+            <a:br/>
+            <a:r>
+              <a:t>   M / M_ref = a₀ + a₁·AM + a₂·AM² + a₃·AM³ + a₄·AM⁴</a:t>
+            </a:r>
+            <a:br/>
+            <a:br/>
+            <a:r>
+              <a:t>   AM = 1 / [ cos(θ_z) + 0.5057 · (96.08 - θ_z)⁻¹.⁶³⁴ ]</a:t>
             </a:r>
             <a:br/>
             <a:br/>
@@ -8812,19 +8818,19 @@
             </a:r>
             <a:br/>
             <a:r>
-              <a:t>• $AM$: Masa de aire absoluta.</a:t>
-            </a:r>
-            <a:br/>
-            <a:r>
-              <a:t>• $\theta_z$: Ángulo cenital del sol.</a:t>
-            </a:r>
-            <a:br/>
-            <a:r>
-              <a:t>• $a_0, a_1, a_2, a_3, a_4$: Coeficientes empíricos espectrales.</a:t>
-            </a:r>
-            <a:br/>
-            <a:r>
-              <a:t>• $M_{ref}$: Transmitancia espectral a STC ($AM\;1.5g$).</a:t>
+              <a:t>• AM: Masa de aire absoluta.</a:t>
+            </a:r>
+            <a:br/>
+            <a:r>
+              <a:t>• θ_z: Ángulo cenital del sol.</a:t>
+            </a:r>
+            <a:br/>
+            <a:r>
+              <a:t>• a₀, a₁, a₂, a₃, a₄: Coeficientes empíricos espectrales.</a:t>
+            </a:r>
+            <a:br/>
+            <a:r>
+              <a:t>• M_ref: Transmitancia espectral a STC (AM 1.5g).</a:t>
             </a:r>
           </a:p>
         </p:txBody>
@@ -9200,12 +9206,12 @@
               </a:defRPr>
             </a:pPr>
             <a:r>
-              <a:t>La temperatura interna de la celda ($T_c$) depende del recurso solar y del viento:</a:t>
-            </a:r>
-            <a:br/>
-            <a:br/>
-            <a:r>
-              <a:t>$$T_c = G_{poa} \cdot e^{a + b \cdot v_w} + T_a + \left(\frac{G_{poa}}{1000}\right) \cdot \Delta T$$</a:t>
+              <a:t>La temperatura interna de la celda (T_c) depende del recurso solar y del viento:</a:t>
+            </a:r>
+            <a:br/>
+            <a:br/>
+            <a:r>
+              <a:t>   T_c = G_poa · e^(a + b · v_w) + T_a + (G_poa / 1000) · ΔT</a:t>
             </a:r>
             <a:br/>
             <a:br/>
@@ -9214,19 +9220,19 @@
             </a:r>
             <a:br/>
             <a:r>
-              <a:t>• $T_c \; / \; T_a$: Temperatura de celda y ambiental ($^\circ\text{C}$).</a:t>
-            </a:r>
-            <a:br/>
-            <a:r>
-              <a:t>• $G_{poa}$: Irradiancia en el plano del panel ($\text{W/m}^2$).</a:t>
-            </a:r>
-            <a:br/>
-            <a:r>
-              <a:t>• $v_w$: Velocidad del viento ($\text{m/s}$).</a:t>
-            </a:r>
-            <a:br/>
-            <a:r>
-              <a:t>• $a, b, \Delta T$: Parámetros empíricos del encapsulado.</a:t>
+              <a:t>• T_c / T_a: Temperatura de celda y ambiental (°C).</a:t>
+            </a:r>
+            <a:br/>
+            <a:r>
+              <a:t>• G_poa: Irradiancia en el plano del panel (W/m²).</a:t>
+            </a:r>
+            <a:br/>
+            <a:r>
+              <a:t>• v_w: Velocidad del viento (m/s).</a:t>
+            </a:r>
+            <a:br/>
+            <a:r>
+              <a:t>• a, b, ΔT: Parámetros empíricos del encapsulado.</a:t>
             </a:r>
           </a:p>
         </p:txBody>

</xml_diff>

<commit_message>
feat: implement high-fidelity LaTeX equations rendering and optimize slide layouts to prevent overlap and clipping
</commit_message>
<xml_diff>
--- a/output/Presentacion_Final_ELI556_Atacama.pptx
+++ b/output/Presentacion_Final_ELI556_Atacama.pptx
@@ -3417,8 +3417,8 @@
         </p:nvSpPr>
         <p:spPr>
           <a:xfrm>
-            <a:off x="548640" y="1645920"/>
-            <a:ext cx="5181447" cy="4114800"/>
+            <a:off x="548640" y="1554480"/>
+            <a:ext cx="5181447" cy="320040"/>
           </a:xfrm>
           <a:prstGeom prst="rect">
             <a:avLst/>
@@ -3432,36 +3432,104 @@
           <a:lstStyle/>
           <a:p>
             <a:pPr algn="l">
-              <a:defRPr sz="1400" b="0">
-                <a:solidFill>
-                  <a:srgbClr val="E8A838"/>
+              <a:defRPr sz="1300" b="0">
+                <a:solidFill>
+                  <a:srgbClr val="FFFFFF"/>
                 </a:solidFill>
               </a:defRPr>
             </a:pPr>
             <a:r>
               <a:t>El módulo se modela como un circuito equivalente de un diodo y pérdidas óhmicas:</a:t>
             </a:r>
-            <a:br/>
-            <a:br/>
-            <a:r>
-              <a:t>   I = I_L - I_₀ · [ exp((V + I·R_s) / a) - 1 ] - (V + I·R_s) / R_sh</a:t>
-            </a:r>
-            <a:br/>
-            <a:br/>
+          </a:p>
+        </p:txBody>
+      </p:sp>
+      <p:pic>
+        <p:nvPicPr>
+          <p:cNvPr id="6" name="Picture 5" descr="eq_0f6e22b8305268a9b05c626661276e2a.png"/>
+          <p:cNvPicPr>
+            <a:picLocks noChangeAspect="1"/>
+          </p:cNvPicPr>
+          <p:nvPr/>
+        </p:nvPicPr>
+        <p:blipFill>
+          <a:blip r:embed="rId2"/>
+          <a:stretch>
+            <a:fillRect/>
+          </a:stretch>
+        </p:blipFill>
+        <p:spPr>
+          <a:xfrm>
+            <a:off x="640080" y="2011680"/>
+            <a:ext cx="3448304" cy="310896"/>
+          </a:xfrm>
+          <a:prstGeom prst="rect">
+            <a:avLst/>
+          </a:prstGeom>
+        </p:spPr>
+      </p:pic>
+      <p:sp>
+        <p:nvSpPr>
+          <p:cNvPr id="7" name="TextBox 6"/>
+          <p:cNvSpPr txBox="1"/>
+          <p:nvPr/>
+        </p:nvSpPr>
+        <p:spPr>
+          <a:xfrm>
+            <a:off x="548640" y="2651760"/>
+            <a:ext cx="5181447" cy="320040"/>
+          </a:xfrm>
+          <a:prstGeom prst="rect">
+            <a:avLst/>
+          </a:prstGeom>
+          <a:noFill/>
+        </p:spPr>
+        <p:txBody>
+          <a:bodyPr wrap="square">
+            <a:spAutoFit/>
+          </a:bodyPr>
+          <a:lstStyle/>
+          <a:p>
+            <a:pPr algn="l">
+              <a:defRPr sz="1300" b="0">
+                <a:solidFill>
+                  <a:srgbClr val="FFFFFF"/>
+                </a:solidFill>
+              </a:defRPr>
+            </a:pPr>
             <a:r>
               <a:t>El factor de idealidad térmico (a) se define formalmente como:</a:t>
             </a:r>
-            <a:br/>
-            <a:br/>
-            <a:r>
-              <a:t>   a = (N_s · n_I · k · T_c) / q</a:t>
-            </a:r>
-          </a:p>
-        </p:txBody>
-      </p:sp>
-      <p:sp>
-        <p:nvSpPr>
-          <p:cNvPr id="6" name="Rectangle 5"/>
+          </a:p>
+        </p:txBody>
+      </p:sp>
+      <p:pic>
+        <p:nvPicPr>
+          <p:cNvPr id="8" name="Picture 7" descr="eq_81b193729b5e8ca3d3141349bc52cf9d.png"/>
+          <p:cNvPicPr>
+            <a:picLocks noChangeAspect="1"/>
+          </p:cNvPicPr>
+          <p:nvPr/>
+        </p:nvPicPr>
+        <p:blipFill>
+          <a:blip r:embed="rId3"/>
+          <a:stretch>
+            <a:fillRect/>
+          </a:stretch>
+        </p:blipFill>
+        <p:spPr>
+          <a:xfrm>
+            <a:off x="640080" y="3108960"/>
+            <a:ext cx="1541798" cy="384048"/>
+          </a:xfrm>
+          <a:prstGeom prst="rect">
+            <a:avLst/>
+          </a:prstGeom>
+        </p:spPr>
+      </p:pic>
+      <p:sp>
+        <p:nvSpPr>
+          <p:cNvPr id="9" name="Rectangle 8"/>
           <p:cNvSpPr/>
           <p:nvPr/>
         </p:nvSpPr>
@@ -3506,7 +3574,7 @@
       </p:sp>
       <p:sp>
         <p:nvSpPr>
-          <p:cNvPr id="7" name="TextBox 6"/>
+          <p:cNvPr id="10" name="TextBox 9"/>
           <p:cNvSpPr txBox="1"/>
           <p:nvPr/>
         </p:nvSpPr>
@@ -3541,7 +3609,7 @@
       </p:sp>
       <p:sp>
         <p:nvSpPr>
-          <p:cNvPr id="8" name="TextBox 7"/>
+          <p:cNvPr id="11" name="TextBox 10"/>
           <p:cNvSpPr txBox="1"/>
           <p:nvPr/>
         </p:nvSpPr>
@@ -3612,7 +3680,7 @@
       </p:sp>
       <p:sp>
         <p:nvSpPr>
-          <p:cNvPr id="9" name="TextBox 8"/>
+          <p:cNvPr id="12" name="TextBox 11"/>
           <p:cNvSpPr txBox="1"/>
           <p:nvPr/>
         </p:nvSpPr>
@@ -3794,8 +3862,8 @@
         </p:nvSpPr>
         <p:spPr>
           <a:xfrm>
-            <a:off x="548640" y="1645920"/>
-            <a:ext cx="5181447" cy="4114800"/>
+            <a:off x="548640" y="1554480"/>
+            <a:ext cx="5181447" cy="1188720"/>
           </a:xfrm>
           <a:prstGeom prst="rect">
             <a:avLst/>
@@ -3809,14 +3877,14 @@
           <a:lstStyle/>
           <a:p>
             <a:pPr algn="l">
-              <a:defRPr sz="1300" b="0">
-                <a:solidFill>
-                  <a:srgbClr val="E8A838"/>
+              <a:defRPr sz="1200" b="0">
+                <a:solidFill>
+                  <a:srgbClr val="FFFFFF"/>
                 </a:solidFill>
               </a:defRPr>
             </a:pPr>
             <a:r>
-              <a:t>Se extraen a_ref, I_L,ref, I_₀,ref, R_s,ref, R_sh,ref en STC:</a:t>
+              <a:t>Se extraen a_ref, I_L,ref, I_0,ref, R_s,ref, R_sh,ref en STC:</a:t>
             </a:r>
             <a:br/>
             <a:br/>
@@ -3835,20 +3903,95 @@
             <a:r>
               <a:t>4. Pendiente en MPP (dP/dV = 0):</a:t>
             </a:r>
-            <a:br/>
-            <a:r>
-              <a:t>   dI/dV|_mpp = -I_mp,ref / V_mp,ref</a:t>
-            </a:r>
-            <a:br/>
-            <a:r>
-              <a:t>5. Coeficiente térmico de V_oc: β_Voc = ∂V_oc / ∂T_c</a:t>
-            </a:r>
-          </a:p>
-        </p:txBody>
-      </p:sp>
-      <p:sp>
-        <p:nvSpPr>
-          <p:cNvPr id="6" name="Rectangle 5"/>
+          </a:p>
+        </p:txBody>
+      </p:sp>
+      <p:pic>
+        <p:nvPicPr>
+          <p:cNvPr id="6" name="Picture 5" descr="eq_cc2b86fbacba503d5f0c9a0e295f4a34.png"/>
+          <p:cNvPicPr>
+            <a:picLocks noChangeAspect="1"/>
+          </p:cNvPicPr>
+          <p:nvPr/>
+        </p:nvPicPr>
+        <p:blipFill>
+          <a:blip r:embed="rId2"/>
+          <a:stretch>
+            <a:fillRect/>
+          </a:stretch>
+        </p:blipFill>
+        <p:spPr>
+          <a:xfrm>
+            <a:off x="640080" y="2834640"/>
+            <a:ext cx="1337575" cy="365760"/>
+          </a:xfrm>
+          <a:prstGeom prst="rect">
+            <a:avLst/>
+          </a:prstGeom>
+        </p:spPr>
+      </p:pic>
+      <p:sp>
+        <p:nvSpPr>
+          <p:cNvPr id="7" name="TextBox 6"/>
+          <p:cNvSpPr txBox="1"/>
+          <p:nvPr/>
+        </p:nvSpPr>
+        <p:spPr>
+          <a:xfrm>
+            <a:off x="548640" y="3383280"/>
+            <a:ext cx="5181447" cy="320040"/>
+          </a:xfrm>
+          <a:prstGeom prst="rect">
+            <a:avLst/>
+          </a:prstGeom>
+          <a:noFill/>
+        </p:spPr>
+        <p:txBody>
+          <a:bodyPr wrap="square">
+            <a:spAutoFit/>
+          </a:bodyPr>
+          <a:lstStyle/>
+          <a:p>
+            <a:pPr algn="l">
+              <a:defRPr sz="1200" b="0">
+                <a:solidFill>
+                  <a:srgbClr val="FFFFFF"/>
+                </a:solidFill>
+              </a:defRPr>
+            </a:pPr>
+            <a:r>
+              <a:t>5. Coeficiente térmico de V_oc:</a:t>
+            </a:r>
+          </a:p>
+        </p:txBody>
+      </p:sp>
+      <p:pic>
+        <p:nvPicPr>
+          <p:cNvPr id="8" name="Picture 7" descr="eq_f96c26b5e5df4b01883ec3fa71a97116.png"/>
+          <p:cNvPicPr>
+            <a:picLocks noChangeAspect="1"/>
+          </p:cNvPicPr>
+          <p:nvPr/>
+        </p:nvPicPr>
+        <p:blipFill>
+          <a:blip r:embed="rId3"/>
+          <a:stretch>
+            <a:fillRect/>
+          </a:stretch>
+        </p:blipFill>
+        <p:spPr>
+          <a:xfrm>
+            <a:off x="640080" y="3749039"/>
+            <a:ext cx="874936" cy="329184"/>
+          </a:xfrm>
+          <a:prstGeom prst="rect">
+            <a:avLst/>
+          </a:prstGeom>
+        </p:spPr>
+      </p:pic>
+      <p:sp>
+        <p:nvSpPr>
+          <p:cNvPr id="9" name="Rectangle 8"/>
           <p:cNvSpPr/>
           <p:nvPr/>
         </p:nvSpPr>
@@ -3893,7 +4036,7 @@
       </p:sp>
       <p:sp>
         <p:nvSpPr>
-          <p:cNvPr id="7" name="TextBox 6"/>
+          <p:cNvPr id="10" name="TextBox 9"/>
           <p:cNvSpPr txBox="1"/>
           <p:nvPr/>
         </p:nvSpPr>
@@ -3928,14 +4071,14 @@
       </p:sp>
       <p:sp>
         <p:nvSpPr>
-          <p:cNvPr id="8" name="TextBox 7"/>
+          <p:cNvPr id="11" name="TextBox 10"/>
           <p:cNvSpPr txBox="1"/>
           <p:nvPr/>
         </p:nvSpPr>
         <p:spPr>
           <a:xfrm>
-            <a:off x="6370167" y="1645920"/>
-            <a:ext cx="5181447" cy="4114800"/>
+            <a:off x="6370167" y="1554480"/>
+            <a:ext cx="5181447" cy="320040"/>
           </a:xfrm>
           <a:prstGeom prst="rect">
             <a:avLst/>
@@ -3956,28 +4099,147 @@
               </a:defRPr>
             </a:pPr>
             <a:r>
-              <a:t>Para acoplar R_s y el factor de idealidad, se implementa la derivada analítica obtenida del circuito:</a:t>
-            </a:r>
-            <a:br/>
-            <a:br/>
-            <a:r>
-              <a:t>   dI/dV|_mpp = -(A + B) / (1 + R_s · A + R_s · B)</a:t>
-            </a:r>
-            <a:br/>
-            <a:br/>
+              <a:t>Para acoplar Rs y el factor de idealidad, se implementa la derivada analítica obtenida del circuito:</a:t>
+            </a:r>
+          </a:p>
+        </p:txBody>
+      </p:sp>
+      <p:pic>
+        <p:nvPicPr>
+          <p:cNvPr id="12" name="Picture 11" descr="eq_a76554b1ee03916d0fb4d4b17eb59988.png"/>
+          <p:cNvPicPr>
+            <a:picLocks noChangeAspect="1"/>
+          </p:cNvPicPr>
+          <p:nvPr/>
+        </p:nvPicPr>
+        <p:blipFill>
+          <a:blip r:embed="rId4"/>
+          <a:stretch>
+            <a:fillRect/>
+          </a:stretch>
+        </p:blipFill>
+        <p:spPr>
+          <a:xfrm>
+            <a:off x="6461607" y="2011680"/>
+            <a:ext cx="2707592" cy="420624"/>
+          </a:xfrm>
+          <a:prstGeom prst="rect">
+            <a:avLst/>
+          </a:prstGeom>
+        </p:spPr>
+      </p:pic>
+      <p:sp>
+        <p:nvSpPr>
+          <p:cNvPr id="13" name="TextBox 12"/>
+          <p:cNvSpPr txBox="1"/>
+          <p:nvPr/>
+        </p:nvSpPr>
+        <p:spPr>
+          <a:xfrm>
+            <a:off x="6370167" y="2606040"/>
+            <a:ext cx="5181447" cy="320040"/>
+          </a:xfrm>
+          <a:prstGeom prst="rect">
+            <a:avLst/>
+          </a:prstGeom>
+          <a:noFill/>
+        </p:spPr>
+        <p:txBody>
+          <a:bodyPr wrap="square">
+            <a:spAutoFit/>
+          </a:bodyPr>
+          <a:lstStyle/>
+          <a:p>
+            <a:pPr algn="l">
+              <a:defRPr sz="1200" b="0">
+                <a:solidFill>
+                  <a:srgbClr val="FFFFFF"/>
+                </a:solidFill>
+              </a:defRPr>
+            </a:pPr>
             <a:r>
               <a:t>Donde:</a:t>
             </a:r>
-            <a:br/>
-            <a:r>
-              <a:t>   A = (I_₀ / a) · exp((V_mp + I_mp · R_s) / a)</a:t>
-            </a:r>
-            <a:br/>
-            <a:r>
-              <a:t>   B = 1 / R_sh</a:t>
-            </a:r>
-            <a:br/>
-            <a:br/>
+          </a:p>
+        </p:txBody>
+      </p:sp>
+      <p:pic>
+        <p:nvPicPr>
+          <p:cNvPr id="14" name="Picture 13" descr="eq_d3cc56a0e87a29528d48690a85598da7.png"/>
+          <p:cNvPicPr>
+            <a:picLocks noChangeAspect="1"/>
+          </p:cNvPicPr>
+          <p:nvPr/>
+        </p:nvPicPr>
+        <p:blipFill>
+          <a:blip r:embed="rId5"/>
+          <a:stretch>
+            <a:fillRect/>
+          </a:stretch>
+        </p:blipFill>
+        <p:spPr>
+          <a:xfrm>
+            <a:off x="6461607" y="2880360"/>
+            <a:ext cx="1842877" cy="384048"/>
+          </a:xfrm>
+          <a:prstGeom prst="rect">
+            <a:avLst/>
+          </a:prstGeom>
+        </p:spPr>
+      </p:pic>
+      <p:pic>
+        <p:nvPicPr>
+          <p:cNvPr id="15" name="Picture 14" descr="eq_383431ee7cb363d006acacfdbffa99d2.png"/>
+          <p:cNvPicPr>
+            <a:picLocks noChangeAspect="1"/>
+          </p:cNvPicPr>
+          <p:nvPr/>
+        </p:nvPicPr>
+        <p:blipFill>
+          <a:blip r:embed="rId6"/>
+          <a:stretch>
+            <a:fillRect/>
+          </a:stretch>
+        </p:blipFill>
+        <p:spPr>
+          <a:xfrm>
+            <a:off x="6461607" y="3429000"/>
+            <a:ext cx="578031" cy="274320"/>
+          </a:xfrm>
+          <a:prstGeom prst="rect">
+            <a:avLst/>
+          </a:prstGeom>
+        </p:spPr>
+      </p:pic>
+      <p:sp>
+        <p:nvSpPr>
+          <p:cNvPr id="16" name="TextBox 15"/>
+          <p:cNvSpPr txBox="1"/>
+          <p:nvPr/>
+        </p:nvSpPr>
+        <p:spPr>
+          <a:xfrm>
+            <a:off x="6370167" y="3886200"/>
+            <a:ext cx="5181447" cy="1371600"/>
+          </a:xfrm>
+          <a:prstGeom prst="rect">
+            <a:avLst/>
+          </a:prstGeom>
+          <a:noFill/>
+        </p:spPr>
+        <p:txBody>
+          <a:bodyPr wrap="square">
+            <a:spAutoFit/>
+          </a:bodyPr>
+          <a:lstStyle/>
+          <a:p>
+            <a:pPr algn="l">
+              <a:defRPr sz="1200" b="0">
+                <a:solidFill>
+                  <a:srgbClr val="E8A838"/>
+                </a:solidFill>
+              </a:defRPr>
+            </a:pPr>
             <a:r>
               <a:t>La optimización se realiza mediante ajuste de mínimos cuadrados con bounds físicos (R_s &gt; 0, n_I ∈ [1, 2]).</a:t>
             </a:r>
@@ -3986,7 +4248,7 @@
       </p:sp>
       <p:sp>
         <p:nvSpPr>
-          <p:cNvPr id="9" name="TextBox 8"/>
+          <p:cNvPr id="17" name="TextBox 16"/>
           <p:cNvSpPr txBox="1"/>
           <p:nvPr/>
         </p:nvSpPr>
@@ -4168,8 +4430,8 @@
         </p:nvSpPr>
         <p:spPr>
           <a:xfrm>
-            <a:off x="548640" y="1645920"/>
-            <a:ext cx="5181447" cy="4114800"/>
+            <a:off x="548640" y="1554480"/>
+            <a:ext cx="5181447" cy="274320"/>
           </a:xfrm>
           <a:prstGeom prst="rect">
             <a:avLst/>
@@ -4185,63 +4447,314 @@
             <a:pPr algn="l">
               <a:defRPr sz="1200" b="0">
                 <a:solidFill>
+                  <a:srgbClr val="FFFFFF"/>
+                </a:solidFill>
+              </a:defRPr>
+            </a:pPr>
+            <a:r>
+              <a:t>1. Factor de Idealidad:</a:t>
+            </a:r>
+          </a:p>
+        </p:txBody>
+      </p:sp>
+      <p:pic>
+        <p:nvPicPr>
+          <p:cNvPr id="6" name="Picture 5" descr="eq_4d3e1415cb08b8bc20f12f74abe8552d.png"/>
+          <p:cNvPicPr>
+            <a:picLocks noChangeAspect="1"/>
+          </p:cNvPicPr>
+          <p:nvPr/>
+        </p:nvPicPr>
+        <p:blipFill>
+          <a:blip r:embed="rId2"/>
+          <a:stretch>
+            <a:fillRect/>
+          </a:stretch>
+        </p:blipFill>
+        <p:spPr>
+          <a:xfrm>
+            <a:off x="640080" y="1828800"/>
+            <a:ext cx="554736" cy="256032"/>
+          </a:xfrm>
+          <a:prstGeom prst="rect">
+            <a:avLst/>
+          </a:prstGeom>
+        </p:spPr>
+      </p:pic>
+      <p:sp>
+        <p:nvSpPr>
+          <p:cNvPr id="7" name="TextBox 6"/>
+          <p:cNvSpPr txBox="1"/>
+          <p:nvPr/>
+        </p:nvSpPr>
+        <p:spPr>
+          <a:xfrm>
+            <a:off x="548640" y="2148840"/>
+            <a:ext cx="5181447" cy="274320"/>
+          </a:xfrm>
+          <a:prstGeom prst="rect">
+            <a:avLst/>
+          </a:prstGeom>
+          <a:noFill/>
+        </p:spPr>
+        <p:txBody>
+          <a:bodyPr wrap="square">
+            <a:spAutoFit/>
+          </a:bodyPr>
+          <a:lstStyle/>
+          <a:p>
+            <a:pPr algn="l">
+              <a:defRPr sz="1200" b="0">
+                <a:solidFill>
+                  <a:srgbClr val="FFFFFF"/>
+                </a:solidFill>
+              </a:defRPr>
+            </a:pPr>
+            <a:r>
+              <a:t>2. Corriente de Saturación Inversa (Io):</a:t>
+            </a:r>
+          </a:p>
+        </p:txBody>
+      </p:sp>
+      <p:pic>
+        <p:nvPicPr>
+          <p:cNvPr id="8" name="Picture 7" descr="eq_147b7f3a535fae0ea51286e3e32c141f.png"/>
+          <p:cNvPicPr>
+            <a:picLocks noChangeAspect="1"/>
+          </p:cNvPicPr>
+          <p:nvPr/>
+        </p:nvPicPr>
+        <p:blipFill>
+          <a:blip r:embed="rId3"/>
+          <a:stretch>
+            <a:fillRect/>
+          </a:stretch>
+        </p:blipFill>
+        <p:spPr>
+          <a:xfrm>
+            <a:off x="640080" y="2423160"/>
+            <a:ext cx="2464123" cy="320040"/>
+          </a:xfrm>
+          <a:prstGeom prst="rect">
+            <a:avLst/>
+          </a:prstGeom>
+        </p:spPr>
+      </p:pic>
+      <p:sp>
+        <p:nvSpPr>
+          <p:cNvPr id="9" name="TextBox 8"/>
+          <p:cNvSpPr txBox="1"/>
+          <p:nvPr/>
+        </p:nvSpPr>
+        <p:spPr>
+          <a:xfrm>
+            <a:off x="548640" y="2834640"/>
+            <a:ext cx="5181447" cy="274320"/>
+          </a:xfrm>
+          <a:prstGeom prst="rect">
+            <a:avLst/>
+          </a:prstGeom>
+          <a:noFill/>
+        </p:spPr>
+        <p:txBody>
+          <a:bodyPr wrap="square">
+            <a:spAutoFit/>
+          </a:bodyPr>
+          <a:lstStyle/>
+          <a:p>
+            <a:pPr algn="l">
+              <a:defRPr sz="1200" b="0">
+                <a:solidFill>
+                  <a:srgbClr val="FFFFFF"/>
+                </a:solidFill>
+              </a:defRPr>
+            </a:pPr>
+            <a:r>
+              <a:t>3. Energía de Bandgap (Eg):</a:t>
+            </a:r>
+          </a:p>
+        </p:txBody>
+      </p:sp>
+      <p:pic>
+        <p:nvPicPr>
+          <p:cNvPr id="10" name="Picture 9" descr="eq_0ed50450f33c4ace764411b1918723c3.png"/>
+          <p:cNvPicPr>
+            <a:picLocks noChangeAspect="1"/>
+          </p:cNvPicPr>
+          <p:nvPr/>
+        </p:nvPicPr>
+        <p:blipFill>
+          <a:blip r:embed="rId4"/>
+          <a:stretch>
+            <a:fillRect/>
+          </a:stretch>
+        </p:blipFill>
+        <p:spPr>
+          <a:xfrm>
+            <a:off x="640080" y="3108960"/>
+            <a:ext cx="2078201" cy="256032"/>
+          </a:xfrm>
+          <a:prstGeom prst="rect">
+            <a:avLst/>
+          </a:prstGeom>
+        </p:spPr>
+      </p:pic>
+      <p:sp>
+        <p:nvSpPr>
+          <p:cNvPr id="11" name="TextBox 10"/>
+          <p:cNvSpPr txBox="1"/>
+          <p:nvPr/>
+        </p:nvSpPr>
+        <p:spPr>
+          <a:xfrm>
+            <a:off x="548640" y="3429000"/>
+            <a:ext cx="5181447" cy="274320"/>
+          </a:xfrm>
+          <a:prstGeom prst="rect">
+            <a:avLst/>
+          </a:prstGeom>
+          <a:noFill/>
+        </p:spPr>
+        <p:txBody>
+          <a:bodyPr wrap="square">
+            <a:spAutoFit/>
+          </a:bodyPr>
+          <a:lstStyle/>
+          <a:p>
+            <a:pPr algn="l">
+              <a:defRPr sz="1200" b="0">
+                <a:solidFill>
+                  <a:srgbClr val="FFFFFF"/>
+                </a:solidFill>
+              </a:defRPr>
+            </a:pPr>
+            <a:r>
+              <a:t>4. Corriente Fotogenerada (IL):</a:t>
+            </a:r>
+          </a:p>
+        </p:txBody>
+      </p:sp>
+      <p:pic>
+        <p:nvPicPr>
+          <p:cNvPr id="12" name="Picture 11" descr="eq_ff8bf6d291204b91b8f99a74fbb13960.png"/>
+          <p:cNvPicPr>
+            <a:picLocks noChangeAspect="1"/>
+          </p:cNvPicPr>
+          <p:nvPr/>
+        </p:nvPicPr>
+        <p:blipFill>
+          <a:blip r:embed="rId5"/>
+          <a:stretch>
+            <a:fillRect/>
+          </a:stretch>
+        </p:blipFill>
+        <p:spPr>
+          <a:xfrm>
+            <a:off x="640080" y="3703320"/>
+            <a:ext cx="3587794" cy="292608"/>
+          </a:xfrm>
+          <a:prstGeom prst="rect">
+            <a:avLst/>
+          </a:prstGeom>
+        </p:spPr>
+      </p:pic>
+      <p:sp>
+        <p:nvSpPr>
+          <p:cNvPr id="13" name="TextBox 12"/>
+          <p:cNvSpPr txBox="1"/>
+          <p:nvPr/>
+        </p:nvSpPr>
+        <p:spPr>
+          <a:xfrm>
+            <a:off x="548640" y="4069080"/>
+            <a:ext cx="5181447" cy="274320"/>
+          </a:xfrm>
+          <a:prstGeom prst="rect">
+            <a:avLst/>
+          </a:prstGeom>
+          <a:noFill/>
+        </p:spPr>
+        <p:txBody>
+          <a:bodyPr wrap="square">
+            <a:spAutoFit/>
+          </a:bodyPr>
+          <a:lstStyle/>
+          <a:p>
+            <a:pPr algn="l">
+              <a:defRPr sz="1200" b="0">
+                <a:solidFill>
+                  <a:srgbClr val="FFFFFF"/>
+                </a:solidFill>
+              </a:defRPr>
+            </a:pPr>
+            <a:r>
+              <a:t>5. Resistencia Shunt:</a:t>
+            </a:r>
+          </a:p>
+        </p:txBody>
+      </p:sp>
+      <p:pic>
+        <p:nvPicPr>
+          <p:cNvPr id="14" name="Picture 13" descr="eq_41b6b711a3ee54ec226a0ceb62a105c8.png"/>
+          <p:cNvPicPr>
+            <a:picLocks noChangeAspect="1"/>
+          </p:cNvPicPr>
+          <p:nvPr/>
+        </p:nvPicPr>
+        <p:blipFill>
+          <a:blip r:embed="rId6"/>
+          <a:stretch>
+            <a:fillRect/>
+          </a:stretch>
+        </p:blipFill>
+        <p:spPr>
+          <a:xfrm>
+            <a:off x="640080" y="4343400"/>
+            <a:ext cx="1393016" cy="256032"/>
+          </a:xfrm>
+          <a:prstGeom prst="rect">
+            <a:avLst/>
+          </a:prstGeom>
+        </p:spPr>
+      </p:pic>
+      <p:sp>
+        <p:nvSpPr>
+          <p:cNvPr id="15" name="TextBox 14"/>
+          <p:cNvSpPr txBox="1"/>
+          <p:nvPr/>
+        </p:nvSpPr>
+        <p:spPr>
+          <a:xfrm>
+            <a:off x="548640" y="4709160"/>
+            <a:ext cx="5181447" cy="274320"/>
+          </a:xfrm>
+          <a:prstGeom prst="rect">
+            <a:avLst/>
+          </a:prstGeom>
+          <a:noFill/>
+        </p:spPr>
+        <p:txBody>
+          <a:bodyPr wrap="square">
+            <a:spAutoFit/>
+          </a:bodyPr>
+          <a:lstStyle/>
+          <a:p>
+            <a:pPr algn="l">
+              <a:defRPr sz="1200" b="0">
+                <a:solidFill>
                   <a:srgbClr val="E8A838"/>
                 </a:solidFill>
               </a:defRPr>
             </a:pPr>
             <a:r>
-              <a:t>1. Factor de Idealidad:</a:t>
-            </a:r>
-            <a:br/>
-            <a:r>
-              <a:t>   a / a_ref = T_c / T_ref</a:t>
-            </a:r>
-            <a:br/>
-            <a:br/>
-            <a:r>
-              <a:t>2. Corriente de Saturación Inversa (I_₀):</a:t>
-            </a:r>
-            <a:br/>
-            <a:r>
-              <a:t>   I_₀ / I_₀,ref = (T_c / T_ref)³ · exp[ E_g,ref / (k · T_ref) - E_g / (k · T_c) ]</a:t>
-            </a:r>
-            <a:br/>
-            <a:br/>
-            <a:r>
-              <a:t>3. Energía de Bandgap (E_g):</a:t>
-            </a:r>
-            <a:br/>
-            <a:r>
-              <a:t>   E_g / E_g,ref = 1 - 0.0002677 · (T_c - T_ref)</a:t>
-            </a:r>
-            <a:br/>
-            <a:r>
-              <a:t>   Donde E_g,ref = 1.121 eV para Silicio a 25°C.</a:t>
-            </a:r>
-            <a:br/>
-            <a:br/>
-            <a:r>
-              <a:t>4. Corriente Fotogenerada (I_L):</a:t>
-            </a:r>
-            <a:br/>
-            <a:r>
-              <a:t>   I_L = (S / S_ref) · (M / M_ref) · [ I_L,ref + α_Isc · (T_c - T_ref) ]</a:t>
-            </a:r>
-            <a:br/>
-            <a:br/>
-            <a:r>
-              <a:t>5. Resistencia Shunt:</a:t>
-            </a:r>
-            <a:br/>
-            <a:r>
-              <a:t>   R_sh = R_sh,ref · (S_ref / S)</a:t>
-            </a:r>
-          </a:p>
-        </p:txBody>
-      </p:sp>
-      <p:sp>
-        <p:nvSpPr>
-          <p:cNvPr id="6" name="Rectangle 5"/>
+              <a:t>Donde Eg,ref = 1.121 eV para Silicio a 25°C.</a:t>
+            </a:r>
+          </a:p>
+        </p:txBody>
+      </p:sp>
+      <p:sp>
+        <p:nvSpPr>
+          <p:cNvPr id="16" name="Rectangle 15"/>
           <p:cNvSpPr/>
           <p:nvPr/>
         </p:nvSpPr>
@@ -4286,7 +4799,7 @@
       </p:sp>
       <p:sp>
         <p:nvSpPr>
-          <p:cNvPr id="7" name="TextBox 6"/>
+          <p:cNvPr id="17" name="TextBox 16"/>
           <p:cNvSpPr txBox="1"/>
           <p:nvPr/>
         </p:nvSpPr>
@@ -4321,7 +4834,7 @@
       </p:sp>
       <p:sp>
         <p:nvSpPr>
-          <p:cNvPr id="8" name="TextBox 7"/>
+          <p:cNvPr id="18" name="TextBox 17"/>
           <p:cNvSpPr txBox="1"/>
           <p:nvPr/>
         </p:nvSpPr>
@@ -4374,7 +4887,7 @@
       </p:sp>
       <p:sp>
         <p:nvSpPr>
-          <p:cNvPr id="9" name="TextBox 8"/>
+          <p:cNvPr id="19" name="TextBox 18"/>
           <p:cNvSpPr txBox="1"/>
           <p:nvPr/>
         </p:nvSpPr>
@@ -5048,8 +5561,8 @@
         </p:nvSpPr>
         <p:spPr>
           <a:xfrm>
-            <a:off x="548640" y="1645920"/>
-            <a:ext cx="5181447" cy="4114800"/>
+            <a:off x="548640" y="1554480"/>
+            <a:ext cx="5181447" cy="320040"/>
           </a:xfrm>
           <a:prstGeom prst="rect">
             <a:avLst/>
@@ -5063,23 +5576,72 @@
           <a:lstStyle/>
           <a:p>
             <a:pPr algn="l">
-              <a:defRPr sz="1400" b="0">
+              <a:defRPr sz="1300" b="0">
+                <a:solidFill>
+                  <a:srgbClr val="FFFFFF"/>
+                </a:solidFill>
+              </a:defRPr>
+            </a:pPr>
+            <a:r>
+              <a:t>El Performance Ratio (PR) evalúa la eficiencia neta del sistema fotovoltaico:</a:t>
+            </a:r>
+          </a:p>
+        </p:txBody>
+      </p:sp>
+      <p:pic>
+        <p:nvPicPr>
+          <p:cNvPr id="6" name="Picture 5" descr="eq_a7cd84c1dfc4bbc488901a2df13705be.png"/>
+          <p:cNvPicPr>
+            <a:picLocks noChangeAspect="1"/>
+          </p:cNvPicPr>
+          <p:nvPr/>
+        </p:nvPicPr>
+        <p:blipFill>
+          <a:blip r:embed="rId2"/>
+          <a:stretch>
+            <a:fillRect/>
+          </a:stretch>
+        </p:blipFill>
+        <p:spPr>
+          <a:xfrm>
+            <a:off x="640080" y="2011680"/>
+            <a:ext cx="1506685" cy="438912"/>
+          </a:xfrm>
+          <a:prstGeom prst="rect">
+            <a:avLst/>
+          </a:prstGeom>
+        </p:spPr>
+      </p:pic>
+      <p:sp>
+        <p:nvSpPr>
+          <p:cNvPr id="7" name="TextBox 6"/>
+          <p:cNvSpPr txBox="1"/>
+          <p:nvPr/>
+        </p:nvSpPr>
+        <p:spPr>
+          <a:xfrm>
+            <a:off x="548640" y="2651760"/>
+            <a:ext cx="5181447" cy="2743200"/>
+          </a:xfrm>
+          <a:prstGeom prst="rect">
+            <a:avLst/>
+          </a:prstGeom>
+          <a:noFill/>
+        </p:spPr>
+        <p:txBody>
+          <a:bodyPr wrap="square">
+            <a:spAutoFit/>
+          </a:bodyPr>
+          <a:lstStyle/>
+          <a:p>
+            <a:pPr algn="l">
+              <a:defRPr sz="1300" b="0">
                 <a:solidFill>
                   <a:srgbClr val="E8A838"/>
                 </a:solidFill>
               </a:defRPr>
             </a:pPr>
             <a:r>
-              <a:t>El Performance Ratio (PR) evalúa la eficiencia neta del sistema fotovoltaico:</a:t>
-            </a:r>
-            <a:br/>
-            <a:br/>
-            <a:r>
-              <a:t>   PR = Σ P_mp,SDM(G, T_c) / Σ [ P_STC · (G_poa / 1000) ]</a:t>
-            </a:r>
-            <a:br/>
-            <a:br/>
-            <a:r>
               <a:t>Donde:</a:t>
             </a:r>
             <a:br/>
@@ -5103,7 +5665,7 @@
       </p:sp>
       <p:sp>
         <p:nvSpPr>
-          <p:cNvPr id="6" name="Rectangle 5"/>
+          <p:cNvPr id="8" name="Rectangle 7"/>
           <p:cNvSpPr/>
           <p:nvPr/>
         </p:nvSpPr>
@@ -5148,7 +5710,7 @@
       </p:sp>
       <p:sp>
         <p:nvSpPr>
-          <p:cNvPr id="7" name="TextBox 6"/>
+          <p:cNvPr id="9" name="TextBox 8"/>
           <p:cNvSpPr txBox="1"/>
           <p:nvPr/>
         </p:nvSpPr>
@@ -5183,7 +5745,7 @@
       </p:sp>
       <p:sp>
         <p:nvSpPr>
-          <p:cNvPr id="8" name="TextBox 7"/>
+          <p:cNvPr id="10" name="TextBox 9"/>
           <p:cNvSpPr txBox="1"/>
           <p:nvPr/>
         </p:nvSpPr>
@@ -5244,7 +5806,7 @@
       </p:sp>
       <p:sp>
         <p:nvSpPr>
-          <p:cNvPr id="9" name="TextBox 8"/>
+          <p:cNvPr id="11" name="TextBox 10"/>
           <p:cNvSpPr txBox="1"/>
           <p:nvPr/>
         </p:nvSpPr>
@@ -8266,8 +8828,8 @@
         </p:nvSpPr>
         <p:spPr>
           <a:xfrm>
-            <a:off x="548640" y="1645920"/>
-            <a:ext cx="5181447" cy="4114800"/>
+            <a:off x="548640" y="1554480"/>
+            <a:ext cx="5181447" cy="320040"/>
           </a:xfrm>
           <a:prstGeom prst="rect">
             <a:avLst/>
@@ -8283,29 +8845,129 @@
             <a:pPr algn="l">
               <a:defRPr sz="1300" b="0">
                 <a:solidFill>
+                  <a:srgbClr val="FFFFFF"/>
+                </a:solidFill>
+              </a:defRPr>
+            </a:pPr>
+            <a:r>
+              <a:t>1. Irradiancia en Plano de Arreglo (POA):</a:t>
+            </a:r>
+          </a:p>
+        </p:txBody>
+      </p:sp>
+      <p:pic>
+        <p:nvPicPr>
+          <p:cNvPr id="6" name="Picture 5" descr="eq_a8e4ce8b7b155acb59ba2491ed70f40b.png"/>
+          <p:cNvPicPr>
+            <a:picLocks noChangeAspect="1"/>
+          </p:cNvPicPr>
+          <p:nvPr/>
+        </p:nvPicPr>
+        <p:blipFill>
+          <a:blip r:embed="rId2"/>
+          <a:stretch>
+            <a:fillRect/>
+          </a:stretch>
+        </p:blipFill>
+        <p:spPr>
+          <a:xfrm>
+            <a:off x="640080" y="1920240"/>
+            <a:ext cx="5086990" cy="347472"/>
+          </a:xfrm>
+          <a:prstGeom prst="rect">
+            <a:avLst/>
+          </a:prstGeom>
+        </p:spPr>
+      </p:pic>
+      <p:sp>
+        <p:nvSpPr>
+          <p:cNvPr id="7" name="TextBox 6"/>
+          <p:cNvSpPr txBox="1"/>
+          <p:nvPr/>
+        </p:nvSpPr>
+        <p:spPr>
+          <a:xfrm>
+            <a:off x="548640" y="2560320"/>
+            <a:ext cx="5181447" cy="320040"/>
+          </a:xfrm>
+          <a:prstGeom prst="rect">
+            <a:avLst/>
+          </a:prstGeom>
+          <a:noFill/>
+        </p:spPr>
+        <p:txBody>
+          <a:bodyPr wrap="square">
+            <a:spAutoFit/>
+          </a:bodyPr>
+          <a:lstStyle/>
+          <a:p>
+            <a:pPr algn="l">
+              <a:defRPr sz="1300" b="0">
+                <a:solidFill>
+                  <a:srgbClr val="FFFFFF"/>
+                </a:solidFill>
+              </a:defRPr>
+            </a:pPr>
+            <a:r>
+              <a:t>2. Irradiancia Absorbida por Celdas (S):</a:t>
+            </a:r>
+          </a:p>
+        </p:txBody>
+      </p:sp>
+      <p:pic>
+        <p:nvPicPr>
+          <p:cNvPr id="8" name="Picture 7" descr="eq_84c6ff8f0a6225d1da45a3b2826e84f0.png"/>
+          <p:cNvPicPr>
+            <a:picLocks noChangeAspect="1"/>
+          </p:cNvPicPr>
+          <p:nvPr/>
+        </p:nvPicPr>
+        <p:blipFill>
+          <a:blip r:embed="rId3"/>
+          <a:stretch>
+            <a:fillRect/>
+          </a:stretch>
+        </p:blipFill>
+        <p:spPr>
+          <a:xfrm>
+            <a:off x="640080" y="2926080"/>
+            <a:ext cx="4878531" cy="274320"/>
+          </a:xfrm>
+          <a:prstGeom prst="rect">
+            <a:avLst/>
+          </a:prstGeom>
+        </p:spPr>
+      </p:pic>
+      <p:sp>
+        <p:nvSpPr>
+          <p:cNvPr id="9" name="TextBox 8"/>
+          <p:cNvSpPr txBox="1"/>
+          <p:nvPr/>
+        </p:nvSpPr>
+        <p:spPr>
+          <a:xfrm>
+            <a:off x="548640" y="3749039"/>
+            <a:ext cx="5181447" cy="1828800"/>
+          </a:xfrm>
+          <a:prstGeom prst="rect">
+            <a:avLst/>
+          </a:prstGeom>
+          <a:noFill/>
+        </p:spPr>
+        <p:txBody>
+          <a:bodyPr wrap="square">
+            <a:spAutoFit/>
+          </a:bodyPr>
+          <a:lstStyle/>
+          <a:p>
+            <a:pPr algn="l">
+              <a:defRPr sz="1300" b="0">
+                <a:solidFill>
                   <a:srgbClr val="E8A838"/>
                 </a:solidFill>
               </a:defRPr>
             </a:pPr>
             <a:r>
-              <a:t>1. Irradiancia en Plano de Arreglo (POA):</a:t>
-            </a:r>
-            <a:br/>
-            <a:r>
-              <a:t>   G_poa = G_b · R_beam + G_d · [(1 + cos(β)) / 2] + G · ρ · [(1 - cos(β)) / 2]</a:t>
-            </a:r>
-            <a:br/>
-            <a:br/>
-            <a:r>
-              <a:t>2. Irradiancia Absorbida por Celdas (S):</a:t>
-            </a:r>
-            <a:br/>
-            <a:r>
-              <a:t>   S / S_ref = (G_b / G_ref) · R_beam · K_τα,b + (G_d / G_ref) · K_τα,d · [(1 + cos(β)) / 2] + (G / G_ref) · ρ · K_τα,g · [(1 - cos(β)) / 2]</a:t>
-            </a:r>
-            <a:br/>
-            <a:br/>
-            <a:r>
               <a:t>Donde S_ref = G_ref = 1000 W/m² en condiciones de referencia (SRC).</a:t>
             </a:r>
           </a:p>
@@ -8313,7 +8975,7 @@
       </p:sp>
       <p:sp>
         <p:nvSpPr>
-          <p:cNvPr id="6" name="Rectangle 5"/>
+          <p:cNvPr id="10" name="Rectangle 9"/>
           <p:cNvSpPr/>
           <p:nvPr/>
         </p:nvSpPr>
@@ -8358,7 +9020,7 @@
       </p:sp>
       <p:sp>
         <p:nvSpPr>
-          <p:cNvPr id="7" name="TextBox 6"/>
+          <p:cNvPr id="11" name="TextBox 10"/>
           <p:cNvSpPr txBox="1"/>
           <p:nvPr/>
         </p:nvSpPr>
@@ -8393,7 +9055,7 @@
       </p:sp>
       <p:sp>
         <p:nvSpPr>
-          <p:cNvPr id="8" name="TextBox 7"/>
+          <p:cNvPr id="12" name="TextBox 11"/>
           <p:cNvSpPr txBox="1"/>
           <p:nvPr/>
         </p:nvSpPr>
@@ -8444,7 +9106,7 @@
       </p:sp>
       <p:sp>
         <p:nvSpPr>
-          <p:cNvPr id="9" name="TextBox 8"/>
+          <p:cNvPr id="13" name="TextBox 12"/>
           <p:cNvSpPr txBox="1"/>
           <p:nvPr/>
         </p:nvSpPr>
@@ -8626,8 +9288,8 @@
         </p:nvSpPr>
         <p:spPr>
           <a:xfrm>
-            <a:off x="548640" y="1645920"/>
-            <a:ext cx="5181447" cy="4114800"/>
+            <a:off x="548640" y="1554480"/>
+            <a:ext cx="5181447" cy="320040"/>
           </a:xfrm>
           <a:prstGeom prst="rect">
             <a:avLst/>
@@ -8641,6 +9303,113 @@
           <a:lstStyle/>
           <a:p>
             <a:pPr algn="l">
+              <a:defRPr sz="1200" b="0">
+                <a:solidFill>
+                  <a:srgbClr val="FFFFFF"/>
+                </a:solidFill>
+              </a:defRPr>
+            </a:pPr>
+            <a:r>
+              <a:t>Ecuación física basada en Ley de Snell y Bouguer:</a:t>
+            </a:r>
+          </a:p>
+        </p:txBody>
+      </p:sp>
+      <p:pic>
+        <p:nvPicPr>
+          <p:cNvPr id="6" name="Picture 5" descr="eq_8a7d35cd9feb6147f12570daab65475e.png"/>
+          <p:cNvPicPr>
+            <a:picLocks noChangeAspect="1"/>
+          </p:cNvPicPr>
+          <p:nvPr/>
+        </p:nvPicPr>
+        <p:blipFill>
+          <a:blip r:embed="rId2"/>
+          <a:stretch>
+            <a:fillRect/>
+          </a:stretch>
+        </p:blipFill>
+        <p:spPr>
+          <a:xfrm>
+            <a:off x="640080" y="1920240"/>
+            <a:ext cx="932688" cy="310896"/>
+          </a:xfrm>
+          <a:prstGeom prst="rect">
+            <a:avLst/>
+          </a:prstGeom>
+        </p:spPr>
+      </p:pic>
+      <p:pic>
+        <p:nvPicPr>
+          <p:cNvPr id="7" name="Picture 6" descr="eq_a96da545a4088927f7bf0f7dbce729ea.png"/>
+          <p:cNvPicPr>
+            <a:picLocks noChangeAspect="1"/>
+          </p:cNvPicPr>
+          <p:nvPr/>
+        </p:nvPicPr>
+        <p:blipFill>
+          <a:blip r:embed="rId3"/>
+          <a:stretch>
+            <a:fillRect/>
+          </a:stretch>
+        </p:blipFill>
+        <p:spPr>
+          <a:xfrm>
+            <a:off x="640080" y="2377440"/>
+            <a:ext cx="3103998" cy="310896"/>
+          </a:xfrm>
+          <a:prstGeom prst="rect">
+            <a:avLst/>
+          </a:prstGeom>
+        </p:spPr>
+      </p:pic>
+      <p:pic>
+        <p:nvPicPr>
+          <p:cNvPr id="8" name="Picture 7" descr="eq_cd4ce63955ff79583978e1e85e9828d5.png"/>
+          <p:cNvPicPr>
+            <a:picLocks noChangeAspect="1"/>
+          </p:cNvPicPr>
+          <p:nvPr/>
+        </p:nvPicPr>
+        <p:blipFill>
+          <a:blip r:embed="rId4"/>
+          <a:stretch>
+            <a:fillRect/>
+          </a:stretch>
+        </p:blipFill>
+        <p:spPr>
+          <a:xfrm>
+            <a:off x="640080" y="2971800"/>
+            <a:ext cx="1480521" cy="274320"/>
+          </a:xfrm>
+          <a:prstGeom prst="rect">
+            <a:avLst/>
+          </a:prstGeom>
+        </p:spPr>
+      </p:pic>
+      <p:sp>
+        <p:nvSpPr>
+          <p:cNvPr id="9" name="TextBox 8"/>
+          <p:cNvSpPr txBox="1"/>
+          <p:nvPr/>
+        </p:nvSpPr>
+        <p:spPr>
+          <a:xfrm>
+            <a:off x="548640" y="3383280"/>
+            <a:ext cx="5181447" cy="2286000"/>
+          </a:xfrm>
+          <a:prstGeom prst="rect">
+            <a:avLst/>
+          </a:prstGeom>
+          <a:noFill/>
+        </p:spPr>
+        <p:txBody>
+          <a:bodyPr wrap="square">
+            <a:spAutoFit/>
+          </a:bodyPr>
+          <a:lstStyle/>
+          <a:p>
+            <a:pPr algn="l">
               <a:defRPr sz="1100" b="0">
                 <a:solidFill>
                   <a:srgbClr val="E8A838"/>
@@ -8648,26 +9417,6 @@
               </a:defRPr>
             </a:pPr>
             <a:r>
-              <a:t>Ecuación física basada en Ley de Snell y Bouguer:</a:t>
-            </a:r>
-            <a:br/>
-            <a:br/>
-            <a:r>
-              <a:t>   K_τα(θ) = τ(θ) / τ(0)</a:t>
-            </a:r>
-            <a:br/>
-            <a:br/>
-            <a:r>
-              <a:t>   τ(θ) = e^(-K·L / cos(θ_r)) · [ 1 - 0.5 · ( sin²(θ_r - θ)/sin²(θ_r + θ) + tan²(θ_r - θ)/tan²(θ_r + θ) ) ]</a:t>
-            </a:r>
-            <a:br/>
-            <a:br/>
-            <a:r>
-              <a:t>   θ_r = arcsin( sin(θ) / n )</a:t>
-            </a:r>
-            <a:br/>
-            <a:br/>
-            <a:r>
               <a:t>Donde:</a:t>
             </a:r>
             <a:br/>
@@ -8691,7 +9440,7 @@
       </p:sp>
       <p:sp>
         <p:nvSpPr>
-          <p:cNvPr id="6" name="Rectangle 5"/>
+          <p:cNvPr id="10" name="Rectangle 9"/>
           <p:cNvSpPr/>
           <p:nvPr/>
         </p:nvSpPr>
@@ -8736,7 +9485,7 @@
       </p:sp>
       <p:sp>
         <p:nvSpPr>
-          <p:cNvPr id="7" name="TextBox 6"/>
+          <p:cNvPr id="11" name="TextBox 10"/>
           <p:cNvSpPr txBox="1"/>
           <p:nvPr/>
         </p:nvSpPr>
@@ -8771,14 +9520,14 @@
       </p:sp>
       <p:sp>
         <p:nvSpPr>
-          <p:cNvPr id="8" name="TextBox 7"/>
+          <p:cNvPr id="12" name="TextBox 11"/>
           <p:cNvSpPr txBox="1"/>
           <p:nvPr/>
         </p:nvSpPr>
         <p:spPr>
           <a:xfrm>
-            <a:off x="6370167" y="1645920"/>
-            <a:ext cx="5181447" cy="4114800"/>
+            <a:off x="6370167" y="1554480"/>
+            <a:ext cx="5181447" cy="320040"/>
           </a:xfrm>
           <a:prstGeom prst="rect">
             <a:avLst/>
@@ -8799,20 +9548,88 @@
               </a:defRPr>
             </a:pPr>
             <a:r>
-              <a:t>Corrige el desajuste del espectro solar según el espesor de la atmósfera atravesada:</a:t>
-            </a:r>
-            <a:br/>
-            <a:br/>
-            <a:r>
-              <a:t>   M / M_ref = a₀ + a₁·AM + a₂·AM² + a₃·AM³ + a₄·AM⁴</a:t>
-            </a:r>
-            <a:br/>
-            <a:br/>
-            <a:r>
-              <a:t>   AM = 1 / [ cos(θ_z) + 0.5057 · (96.08 - θ_z)⁻¹.⁶³⁴ ]</a:t>
-            </a:r>
-            <a:br/>
-            <a:br/>
+              <a:t>Corrige el desajuste del espectro solar según la atmósfera atravesada:</a:t>
+            </a:r>
+          </a:p>
+        </p:txBody>
+      </p:sp>
+      <p:pic>
+        <p:nvPicPr>
+          <p:cNvPr id="13" name="Picture 12" descr="eq_d906b2c1975077e1fc2fda1e56aae0c4.png"/>
+          <p:cNvPicPr>
+            <a:picLocks noChangeAspect="1"/>
+          </p:cNvPicPr>
+          <p:nvPr/>
+        </p:nvPicPr>
+        <p:blipFill>
+          <a:blip r:embed="rId5"/>
+          <a:stretch>
+            <a:fillRect/>
+          </a:stretch>
+        </p:blipFill>
+        <p:spPr>
+          <a:xfrm>
+            <a:off x="6461607" y="2011680"/>
+            <a:ext cx="4688146" cy="310896"/>
+          </a:xfrm>
+          <a:prstGeom prst="rect">
+            <a:avLst/>
+          </a:prstGeom>
+        </p:spPr>
+      </p:pic>
+      <p:pic>
+        <p:nvPicPr>
+          <p:cNvPr id="14" name="Picture 13" descr="eq_a92345a0e73bcc5feb98374753acda41.png"/>
+          <p:cNvPicPr>
+            <a:picLocks noChangeAspect="1"/>
+          </p:cNvPicPr>
+          <p:nvPr/>
+        </p:nvPicPr>
+        <p:blipFill>
+          <a:blip r:embed="rId6"/>
+          <a:stretch>
+            <a:fillRect/>
+          </a:stretch>
+        </p:blipFill>
+        <p:spPr>
+          <a:xfrm>
+            <a:off x="6461607" y="2514600"/>
+            <a:ext cx="3072849" cy="365760"/>
+          </a:xfrm>
+          <a:prstGeom prst="rect">
+            <a:avLst/>
+          </a:prstGeom>
+        </p:spPr>
+      </p:pic>
+      <p:sp>
+        <p:nvSpPr>
+          <p:cNvPr id="15" name="TextBox 14"/>
+          <p:cNvSpPr txBox="1"/>
+          <p:nvPr/>
+        </p:nvSpPr>
+        <p:spPr>
+          <a:xfrm>
+            <a:off x="6370167" y="3108960"/>
+            <a:ext cx="5181447" cy="2743200"/>
+          </a:xfrm>
+          <a:prstGeom prst="rect">
+            <a:avLst/>
+          </a:prstGeom>
+          <a:noFill/>
+        </p:spPr>
+        <p:txBody>
+          <a:bodyPr wrap="square">
+            <a:spAutoFit/>
+          </a:bodyPr>
+          <a:lstStyle/>
+          <a:p>
+            <a:pPr algn="l">
+              <a:defRPr sz="1200" b="0">
+                <a:solidFill>
+                  <a:srgbClr val="FFFFFF"/>
+                </a:solidFill>
+              </a:defRPr>
+            </a:pPr>
             <a:r>
               <a:t>Donde:</a:t>
             </a:r>
@@ -8837,7 +9654,7 @@
       </p:sp>
       <p:sp>
         <p:nvSpPr>
-          <p:cNvPr id="9" name="TextBox 8"/>
+          <p:cNvPr id="16" name="TextBox 15"/>
           <p:cNvSpPr txBox="1"/>
           <p:nvPr/>
         </p:nvSpPr>
@@ -9184,8 +10001,8 @@
         </p:nvSpPr>
         <p:spPr>
           <a:xfrm>
-            <a:off x="548640" y="1645920"/>
-            <a:ext cx="5181447" cy="4114800"/>
+            <a:off x="548640" y="1554480"/>
+            <a:ext cx="5181447" cy="320040"/>
           </a:xfrm>
           <a:prstGeom prst="rect">
             <a:avLst/>
@@ -9199,23 +10016,72 @@
           <a:lstStyle/>
           <a:p>
             <a:pPr algn="l">
-              <a:defRPr sz="1400" b="0">
+              <a:defRPr sz="1300" b="0">
+                <a:solidFill>
+                  <a:srgbClr val="FFFFFF"/>
+                </a:solidFill>
+              </a:defRPr>
+            </a:pPr>
+            <a:r>
+              <a:t>La temperatura interna de la celda (Tc) depende del recurso solar y del viento:</a:t>
+            </a:r>
+          </a:p>
+        </p:txBody>
+      </p:sp>
+      <p:pic>
+        <p:nvPicPr>
+          <p:cNvPr id="6" name="Picture 5" descr="eq_6df31a59eeb699d8d30eef1fac483410.png"/>
+          <p:cNvPicPr>
+            <a:picLocks noChangeAspect="1"/>
+          </p:cNvPicPr>
+          <p:nvPr/>
+        </p:nvPicPr>
+        <p:blipFill>
+          <a:blip r:embed="rId2"/>
+          <a:stretch>
+            <a:fillRect/>
+          </a:stretch>
+        </p:blipFill>
+        <p:spPr>
+          <a:xfrm>
+            <a:off x="640080" y="2011680"/>
+            <a:ext cx="4300102" cy="411480"/>
+          </a:xfrm>
+          <a:prstGeom prst="rect">
+            <a:avLst/>
+          </a:prstGeom>
+        </p:spPr>
+      </p:pic>
+      <p:sp>
+        <p:nvSpPr>
+          <p:cNvPr id="7" name="TextBox 6"/>
+          <p:cNvSpPr txBox="1"/>
+          <p:nvPr/>
+        </p:nvSpPr>
+        <p:spPr>
+          <a:xfrm>
+            <a:off x="548640" y="2651760"/>
+            <a:ext cx="5181447" cy="2743200"/>
+          </a:xfrm>
+          <a:prstGeom prst="rect">
+            <a:avLst/>
+          </a:prstGeom>
+          <a:noFill/>
+        </p:spPr>
+        <p:txBody>
+          <a:bodyPr wrap="square">
+            <a:spAutoFit/>
+          </a:bodyPr>
+          <a:lstStyle/>
+          <a:p>
+            <a:pPr algn="l">
+              <a:defRPr sz="1300" b="0">
                 <a:solidFill>
                   <a:srgbClr val="E8A838"/>
                 </a:solidFill>
               </a:defRPr>
             </a:pPr>
             <a:r>
-              <a:t>La temperatura interna de la celda (T_c) depende del recurso solar y del viento:</a:t>
-            </a:r>
-            <a:br/>
-            <a:br/>
-            <a:r>
-              <a:t>   T_c = G_poa · e^(a + b · v_w) + T_a + (G_poa / 1000) · ΔT</a:t>
-            </a:r>
-            <a:br/>
-            <a:br/>
-            <a:r>
               <a:t>Donde:</a:t>
             </a:r>
             <a:br/>
@@ -9239,7 +10105,7 @@
       </p:sp>
       <p:sp>
         <p:nvSpPr>
-          <p:cNvPr id="6" name="Rectangle 5"/>
+          <p:cNvPr id="8" name="Rectangle 7"/>
           <p:cNvSpPr/>
           <p:nvPr/>
         </p:nvSpPr>
@@ -9284,7 +10150,7 @@
       </p:sp>
       <p:sp>
         <p:nvSpPr>
-          <p:cNvPr id="7" name="TextBox 6"/>
+          <p:cNvPr id="9" name="TextBox 8"/>
           <p:cNvSpPr txBox="1"/>
           <p:nvPr/>
         </p:nvSpPr>
@@ -9319,7 +10185,7 @@
       </p:sp>
       <p:sp>
         <p:nvSpPr>
-          <p:cNvPr id="8" name="TextBox 7"/>
+          <p:cNvPr id="10" name="TextBox 9"/>
           <p:cNvSpPr txBox="1"/>
           <p:nvPr/>
         </p:nvSpPr>
@@ -9388,7 +10254,7 @@
       </p:sp>
       <p:sp>
         <p:nvSpPr>
-          <p:cNvPr id="9" name="TextBox 8"/>
+          <p:cNvPr id="11" name="TextBox 10"/>
           <p:cNvSpPr txBox="1"/>
           <p:nvPr/>
         </p:nvSpPr>

</xml_diff>

<commit_message>
style: maximize typography size, table cells, and implement dynamic column-width auto-scaling constraint for all equations
</commit_message>
<xml_diff>
--- a/output/Presentacion_Final_ELI556_Atacama.pptx
+++ b/output/Presentacion_Final_ELI556_Atacama.pptx
@@ -3173,7 +3173,7 @@
           <a:lstStyle/>
           <a:p>
             <a:pPr algn="ctr">
-              <a:defRPr sz="2000" b="0">
+              <a:defRPr sz="2200" b="0">
                 <a:solidFill>
                   <a:srgbClr val="FFFFFF"/>
                 </a:solidFill>
@@ -3208,7 +3208,7 @@
           <a:lstStyle/>
           <a:p>
             <a:pPr algn="ctr">
-              <a:defRPr sz="1500" b="0">
+              <a:defRPr sz="1600" b="0">
                 <a:solidFill>
                   <a:srgbClr val="FFFFFF"/>
                 </a:solidFill>
@@ -3397,7 +3397,7 @@
           <a:lstStyle/>
           <a:p>
             <a:pPr>
-              <a:defRPr b="1" sz="1400">
+              <a:defRPr b="1" sz="1800">
                 <a:solidFill>
                   <a:srgbClr val="E8A838"/>
                 </a:solidFill>
@@ -3432,7 +3432,7 @@
           <a:lstStyle/>
           <a:p>
             <a:pPr algn="l">
-              <a:defRPr sz="1300" b="0">
+              <a:defRPr sz="1600" b="0">
                 <a:solidFill>
                   <a:srgbClr val="FFFFFF"/>
                 </a:solidFill>
@@ -3460,8 +3460,8 @@
         </p:blipFill>
         <p:spPr>
           <a:xfrm>
-            <a:off x="640080" y="2011680"/>
-            <a:ext cx="3448304" cy="310896"/>
+            <a:off x="640080" y="1965960"/>
+            <a:ext cx="3853986" cy="347472"/>
           </a:xfrm>
           <a:prstGeom prst="rect">
             <a:avLst/>
@@ -3476,7 +3476,7 @@
         </p:nvSpPr>
         <p:spPr>
           <a:xfrm>
-            <a:off x="548640" y="2651760"/>
+            <a:off x="548640" y="2606040"/>
             <a:ext cx="5181447" cy="320040"/>
           </a:xfrm>
           <a:prstGeom prst="rect">
@@ -3491,7 +3491,7 @@
           <a:lstStyle/>
           <a:p>
             <a:pPr algn="l">
-              <a:defRPr sz="1300" b="0">
+              <a:defRPr sz="1600" b="0">
                 <a:solidFill>
                   <a:srgbClr val="FFFFFF"/>
                 </a:solidFill>
@@ -3519,8 +3519,8 @@
         </p:blipFill>
         <p:spPr>
           <a:xfrm>
-            <a:off x="640080" y="3108960"/>
-            <a:ext cx="1541798" cy="384048"/>
+            <a:off x="640080" y="3017520"/>
+            <a:ext cx="1835474" cy="457200"/>
           </a:xfrm>
           <a:prstGeom prst="rect">
             <a:avLst/>
@@ -3595,7 +3595,7 @@
           <a:lstStyle/>
           <a:p>
             <a:pPr>
-              <a:defRPr b="1" sz="1400">
+              <a:defRPr b="1" sz="1800">
                 <a:solidFill>
                   <a:srgbClr val="E8A838"/>
                 </a:solidFill>
@@ -3615,7 +3615,7 @@
         </p:nvSpPr>
         <p:spPr>
           <a:xfrm>
-            <a:off x="6370167" y="1645920"/>
+            <a:off x="6370167" y="1554480"/>
             <a:ext cx="5181447" cy="4114800"/>
           </a:xfrm>
           <a:prstGeom prst="rect">
@@ -3630,7 +3630,7 @@
           <a:lstStyle/>
           <a:p>
             <a:pPr algn="l">
-              <a:defRPr sz="1200" b="0">
+              <a:defRPr sz="1500" b="0">
                 <a:solidFill>
                   <a:srgbClr val="FFFFFF"/>
                 </a:solidFill>
@@ -3645,7 +3645,7 @@
             </a:r>
             <a:br/>
             <a:r>
-              <a:t>• I_₀: Corriente de saturación inversa del diodo (A).</a:t>
+              <a:t>• I_0: Corriente de saturación inversa del diodo (A).</a:t>
             </a:r>
             <a:br/>
             <a:r>
@@ -3842,7 +3842,7 @@
           <a:lstStyle/>
           <a:p>
             <a:pPr>
-              <a:defRPr b="1" sz="1400">
+              <a:defRPr b="1" sz="1800">
                 <a:solidFill>
                   <a:srgbClr val="E8A838"/>
                 </a:solidFill>
@@ -3877,7 +3877,7 @@
           <a:lstStyle/>
           <a:p>
             <a:pPr algn="l">
-              <a:defRPr sz="1200" b="0">
+              <a:defRPr sz="1500" b="0">
                 <a:solidFill>
                   <a:srgbClr val="FFFFFF"/>
                 </a:solidFill>
@@ -3922,8 +3922,8 @@
         </p:blipFill>
         <p:spPr>
           <a:xfrm>
-            <a:off x="640080" y="2834640"/>
-            <a:ext cx="1337575" cy="365760"/>
+            <a:off x="640080" y="2788920"/>
+            <a:ext cx="1671969" cy="457200"/>
           </a:xfrm>
           <a:prstGeom prst="rect">
             <a:avLst/>
@@ -3938,7 +3938,7 @@
         </p:nvSpPr>
         <p:spPr>
           <a:xfrm>
-            <a:off x="548640" y="3383280"/>
+            <a:off x="548640" y="3337560"/>
             <a:ext cx="5181447" cy="320040"/>
           </a:xfrm>
           <a:prstGeom prst="rect">
@@ -3953,7 +3953,7 @@
           <a:lstStyle/>
           <a:p>
             <a:pPr algn="l">
-              <a:defRPr sz="1200" b="0">
+              <a:defRPr sz="1500" b="0">
                 <a:solidFill>
                   <a:srgbClr val="FFFFFF"/>
                 </a:solidFill>
@@ -3981,8 +3981,8 @@
         </p:blipFill>
         <p:spPr>
           <a:xfrm>
-            <a:off x="640080" y="3749039"/>
-            <a:ext cx="874936" cy="329184"/>
+            <a:off x="640080" y="3703320"/>
+            <a:ext cx="1093670" cy="411480"/>
           </a:xfrm>
           <a:prstGeom prst="rect">
             <a:avLst/>
@@ -4057,7 +4057,7 @@
           <a:lstStyle/>
           <a:p>
             <a:pPr>
-              <a:defRPr b="1" sz="1400">
+              <a:defRPr b="1" sz="1800">
                 <a:solidFill>
                   <a:srgbClr val="E8A838"/>
                 </a:solidFill>
@@ -4092,7 +4092,7 @@
           <a:lstStyle/>
           <a:p>
             <a:pPr algn="l">
-              <a:defRPr sz="1200" b="0">
+              <a:defRPr sz="1500" b="0">
                 <a:solidFill>
                   <a:srgbClr val="FFFFFF"/>
                 </a:solidFill>
@@ -4120,8 +4120,8 @@
         </p:blipFill>
         <p:spPr>
           <a:xfrm>
-            <a:off x="6461607" y="2011680"/>
-            <a:ext cx="2707592" cy="420624"/>
+            <a:off x="6461607" y="1920240"/>
+            <a:ext cx="3060757" cy="475488"/>
           </a:xfrm>
           <a:prstGeom prst="rect">
             <a:avLst/>
@@ -4136,7 +4136,7 @@
         </p:nvSpPr>
         <p:spPr>
           <a:xfrm>
-            <a:off x="6370167" y="2606040"/>
+            <a:off x="6370167" y="2514600"/>
             <a:ext cx="5181447" cy="320040"/>
           </a:xfrm>
           <a:prstGeom prst="rect">
@@ -4151,7 +4151,7 @@
           <a:lstStyle/>
           <a:p>
             <a:pPr algn="l">
-              <a:defRPr sz="1200" b="0">
+              <a:defRPr sz="1500" b="0">
                 <a:solidFill>
                   <a:srgbClr val="FFFFFF"/>
                 </a:solidFill>
@@ -4180,7 +4180,7 @@
         <p:spPr>
           <a:xfrm>
             <a:off x="6461607" y="2880360"/>
-            <a:ext cx="1842877" cy="384048"/>
+            <a:ext cx="2193902" cy="457200"/>
           </a:xfrm>
           <a:prstGeom prst="rect">
             <a:avLst/>
@@ -4204,7 +4204,7 @@
         <p:spPr>
           <a:xfrm>
             <a:off x="6461607" y="3429000"/>
-            <a:ext cx="578031" cy="274320"/>
+            <a:ext cx="770708" cy="365760"/>
           </a:xfrm>
           <a:prstGeom prst="rect">
             <a:avLst/>
@@ -4234,7 +4234,7 @@
           <a:lstStyle/>
           <a:p>
             <a:pPr algn="l">
-              <a:defRPr sz="1200" b="0">
+              <a:defRPr sz="1400" b="0">
                 <a:solidFill>
                   <a:srgbClr val="E8A838"/>
                 </a:solidFill>
@@ -4410,7 +4410,7 @@
           <a:lstStyle/>
           <a:p>
             <a:pPr>
-              <a:defRPr b="1" sz="1400">
+              <a:defRPr b="1" sz="1800">
                 <a:solidFill>
                   <a:srgbClr val="E8A838"/>
                 </a:solidFill>
@@ -4445,7 +4445,7 @@
           <a:lstStyle/>
           <a:p>
             <a:pPr algn="l">
-              <a:defRPr sz="1200" b="0">
+              <a:defRPr sz="1500" b="0">
                 <a:solidFill>
                   <a:srgbClr val="FFFFFF"/>
                 </a:solidFill>
@@ -4473,8 +4473,8 @@
         </p:blipFill>
         <p:spPr>
           <a:xfrm>
-            <a:off x="640080" y="1828800"/>
-            <a:ext cx="554736" cy="256032"/>
+            <a:off x="640080" y="1874519"/>
+            <a:ext cx="693420" cy="320040"/>
           </a:xfrm>
           <a:prstGeom prst="rect">
             <a:avLst/>
@@ -4489,7 +4489,7 @@
         </p:nvSpPr>
         <p:spPr>
           <a:xfrm>
-            <a:off x="548640" y="2148840"/>
+            <a:off x="548640" y="2240280"/>
             <a:ext cx="5181447" cy="274320"/>
           </a:xfrm>
           <a:prstGeom prst="rect">
@@ -4504,7 +4504,7 @@
           <a:lstStyle/>
           <a:p>
             <a:pPr algn="l">
-              <a:defRPr sz="1200" b="0">
+              <a:defRPr sz="1500" b="0">
                 <a:solidFill>
                   <a:srgbClr val="FFFFFF"/>
                 </a:solidFill>
@@ -4532,8 +4532,8 @@
         </p:blipFill>
         <p:spPr>
           <a:xfrm>
-            <a:off x="640080" y="2423160"/>
-            <a:ext cx="2464123" cy="320040"/>
+            <a:off x="640080" y="2560320"/>
+            <a:ext cx="2956947" cy="384048"/>
           </a:xfrm>
           <a:prstGeom prst="rect">
             <a:avLst/>
@@ -4548,7 +4548,7 @@
         </p:nvSpPr>
         <p:spPr>
           <a:xfrm>
-            <a:off x="548640" y="2834640"/>
+            <a:off x="548640" y="3017520"/>
             <a:ext cx="5181447" cy="274320"/>
           </a:xfrm>
           <a:prstGeom prst="rect">
@@ -4563,7 +4563,7 @@
           <a:lstStyle/>
           <a:p>
             <a:pPr algn="l">
-              <a:defRPr sz="1200" b="0">
+              <a:defRPr sz="1500" b="0">
                 <a:solidFill>
                   <a:srgbClr val="FFFFFF"/>
                 </a:solidFill>
@@ -4591,8 +4591,8 @@
         </p:blipFill>
         <p:spPr>
           <a:xfrm>
-            <a:off x="640080" y="3108960"/>
-            <a:ext cx="2078201" cy="256032"/>
+            <a:off x="640080" y="3337560"/>
+            <a:ext cx="2671973" cy="329184"/>
           </a:xfrm>
           <a:prstGeom prst="rect">
             <a:avLst/>
@@ -4607,7 +4607,7 @@
         </p:nvSpPr>
         <p:spPr>
           <a:xfrm>
-            <a:off x="548640" y="3429000"/>
+            <a:off x="548640" y="3749039"/>
             <a:ext cx="5181447" cy="274320"/>
           </a:xfrm>
           <a:prstGeom prst="rect">
@@ -4622,7 +4622,7 @@
           <a:lstStyle/>
           <a:p>
             <a:pPr algn="l">
-              <a:defRPr sz="1200" b="0">
+              <a:defRPr sz="1500" b="0">
                 <a:solidFill>
                   <a:srgbClr val="FFFFFF"/>
                 </a:solidFill>
@@ -4650,8 +4650,8 @@
         </p:blipFill>
         <p:spPr>
           <a:xfrm>
-            <a:off x="640080" y="3703320"/>
-            <a:ext cx="3587794" cy="292608"/>
+            <a:off x="640080" y="4069080"/>
+            <a:ext cx="4260506" cy="347472"/>
           </a:xfrm>
           <a:prstGeom prst="rect">
             <a:avLst/>
@@ -4666,7 +4666,7 @@
         </p:nvSpPr>
         <p:spPr>
           <a:xfrm>
-            <a:off x="548640" y="4069080"/>
+            <a:off x="548640" y="4480560"/>
             <a:ext cx="5181447" cy="274320"/>
           </a:xfrm>
           <a:prstGeom prst="rect">
@@ -4681,7 +4681,7 @@
           <a:lstStyle/>
           <a:p>
             <a:pPr algn="l">
-              <a:defRPr sz="1200" b="0">
+              <a:defRPr sz="1500" b="0">
                 <a:solidFill>
                   <a:srgbClr val="FFFFFF"/>
                 </a:solidFill>
@@ -4709,8 +4709,8 @@
         </p:blipFill>
         <p:spPr>
           <a:xfrm>
-            <a:off x="640080" y="4343400"/>
-            <a:ext cx="1393016" cy="256032"/>
+            <a:off x="640080" y="4800600"/>
+            <a:ext cx="1741270" cy="320040"/>
           </a:xfrm>
           <a:prstGeom prst="rect">
             <a:avLst/>
@@ -4725,7 +4725,7 @@
         </p:nvSpPr>
         <p:spPr>
           <a:xfrm>
-            <a:off x="548640" y="4709160"/>
+            <a:off x="548640" y="5212080"/>
             <a:ext cx="5181447" cy="274320"/>
           </a:xfrm>
           <a:prstGeom prst="rect">
@@ -4740,7 +4740,7 @@
           <a:lstStyle/>
           <a:p>
             <a:pPr algn="l">
-              <a:defRPr sz="1200" b="0">
+              <a:defRPr sz="1400" b="0">
                 <a:solidFill>
                   <a:srgbClr val="E8A838"/>
                 </a:solidFill>
@@ -4820,14 +4820,14 @@
           <a:lstStyle/>
           <a:p>
             <a:pPr>
-              <a:defRPr b="1" sz="1400">
+              <a:defRPr b="1" sz="1800">
                 <a:solidFill>
                   <a:srgbClr val="E8A838"/>
                 </a:solidFill>
               </a:defRPr>
             </a:pPr>
             <a:r>
-              <a:t>Suposiciones Físicas Justificadas</a:t>
+              <a:t>Suposiciones Ficas Justificadas</a:t>
             </a:r>
           </a:p>
         </p:txBody>
@@ -4855,7 +4855,7 @@
           <a:lstStyle/>
           <a:p>
             <a:pPr algn="l">
-              <a:defRPr sz="1300" b="0">
+              <a:defRPr sz="1500" b="0">
                 <a:solidFill>
                   <a:srgbClr val="FFFFFF"/>
                 </a:solidFill>
@@ -5214,7 +5214,7 @@
           <a:lstStyle/>
           <a:p>
             <a:pPr>
-              <a:defRPr b="1" sz="1400">
+              <a:defRPr b="1" sz="1800">
                 <a:solidFill>
                   <a:srgbClr val="E8A838"/>
                 </a:solidFill>
@@ -5318,7 +5318,7 @@
           <a:lstStyle/>
           <a:p>
             <a:pPr>
-              <a:defRPr b="1" sz="1400">
+              <a:defRPr b="1" sz="1800">
                 <a:solidFill>
                   <a:srgbClr val="E8A838"/>
                 </a:solidFill>
@@ -5353,7 +5353,7 @@
           <a:lstStyle/>
           <a:p>
             <a:pPr algn="l">
-              <a:defRPr sz="1600" b="0">
+              <a:defRPr sz="1700" b="0">
                 <a:solidFill>
                   <a:srgbClr val="FFFFFF"/>
                 </a:solidFill>
@@ -5363,13 +5363,16 @@
               <a:t>• Coeficiente de determinación R² &gt; 0.99 para ambas tecnologías.</a:t>
             </a:r>
             <a:br/>
+            <a:br/>
             <a:r>
               <a:t>• RMSE &lt; 5W en condiciones estándar.</a:t>
             </a:r>
             <a:br/>
+            <a:br/>
             <a:r>
               <a:t>• Validación cruzada: El modelo de De Soto reproduce con alta fidelidad las pérdidas por temperatura en celdas de silicio.</a:t>
             </a:r>
+            <a:br/>
             <a:br/>
             <a:r>
               <a:t>• Error máximo concentrado en la zona de codo a baja irradiancia.</a:t>
@@ -5541,7 +5544,7 @@
           <a:lstStyle/>
           <a:p>
             <a:pPr>
-              <a:defRPr b="1" sz="1400">
+              <a:defRPr b="1" sz="1800">
                 <a:solidFill>
                   <a:srgbClr val="E8A838"/>
                 </a:solidFill>
@@ -5576,7 +5579,7 @@
           <a:lstStyle/>
           <a:p>
             <a:pPr algn="l">
-              <a:defRPr sz="1300" b="0">
+              <a:defRPr sz="1600" b="0">
                 <a:solidFill>
                   <a:srgbClr val="FFFFFF"/>
                 </a:solidFill>
@@ -5604,8 +5607,8 @@
         </p:blipFill>
         <p:spPr>
           <a:xfrm>
-            <a:off x="640080" y="2011680"/>
-            <a:ext cx="1506685" cy="438912"/>
+            <a:off x="640080" y="1965960"/>
+            <a:ext cx="1726410" cy="502920"/>
           </a:xfrm>
           <a:prstGeom prst="rect">
             <a:avLst/>
@@ -5635,7 +5638,7 @@
           <a:lstStyle/>
           <a:p>
             <a:pPr algn="l">
-              <a:defRPr sz="1300" b="0">
+              <a:defRPr sz="1500" b="0">
                 <a:solidFill>
                   <a:srgbClr val="E8A838"/>
                 </a:solidFill>
@@ -5731,7 +5734,7 @@
           <a:lstStyle/>
           <a:p>
             <a:pPr>
-              <a:defRPr b="1" sz="1400">
+              <a:defRPr b="1" sz="1800">
                 <a:solidFill>
                   <a:srgbClr val="E8A838"/>
                 </a:solidFill>
@@ -5751,7 +5754,7 @@
         </p:nvSpPr>
         <p:spPr>
           <a:xfrm>
-            <a:off x="6370167" y="1645920"/>
+            <a:off x="6370167" y="1554480"/>
             <a:ext cx="5181447" cy="4114800"/>
           </a:xfrm>
           <a:prstGeom prst="rect">
@@ -5766,7 +5769,7 @@
           <a:lstStyle/>
           <a:p>
             <a:pPr algn="l">
-              <a:defRPr sz="1400" b="0">
+              <a:defRPr sz="1600" b="0">
                 <a:solidFill>
                   <a:srgbClr val="FFFFFF"/>
                 </a:solidFill>
@@ -6133,7 +6136,7 @@
           <a:lstStyle/>
           <a:p>
             <a:pPr>
-              <a:defRPr b="1" sz="1400">
+              <a:defRPr b="1" sz="1800">
                 <a:solidFill>
                   <a:srgbClr val="E8A838"/>
                 </a:solidFill>
@@ -6237,7 +6240,7 @@
           <a:lstStyle/>
           <a:p>
             <a:pPr>
-              <a:defRPr b="1" sz="1400">
+              <a:defRPr b="1" sz="1800">
                 <a:solidFill>
                   <a:srgbClr val="E8A838"/>
                 </a:solidFill>
@@ -6272,7 +6275,7 @@
           <a:lstStyle/>
           <a:p>
             <a:pPr algn="l">
-              <a:defRPr sz="1500" b="0">
+              <a:defRPr sz="1700" b="0">
                 <a:solidFill>
                   <a:srgbClr val="FFFFFF"/>
                 </a:solidFill>
@@ -6453,7 +6456,7 @@
           <a:lstStyle/>
           <a:p>
             <a:pPr>
-              <a:defRPr b="1" sz="1400">
+              <a:defRPr b="1" sz="1800">
                 <a:solidFill>
                   <a:srgbClr val="E8A838"/>
                 </a:solidFill>
@@ -6488,7 +6491,7 @@
           <a:lstStyle/>
           <a:p>
             <a:pPr algn="l">
-              <a:defRPr sz="1700" b="1">
+              <a:defRPr sz="1800" b="1">
                 <a:solidFill>
                   <a:srgbClr val="E8A838"/>
                 </a:solidFill>
@@ -6497,6 +6500,7 @@
             <a:r>
               <a:t>• Performance Ratio Anual m-Si: 84.53%</a:t>
             </a:r>
+            <a:br/>
             <a:br/>
             <a:r>
               <a:t>• Performance Ratio Anual HIT: 86.92%</a:t>
@@ -6582,7 +6586,7 @@
           <a:lstStyle/>
           <a:p>
             <a:pPr>
-              <a:defRPr b="1" sz="1400">
+              <a:defRPr b="1" sz="1800">
                 <a:solidFill>
                   <a:srgbClr val="E8A838"/>
                 </a:solidFill>
@@ -6617,7 +6621,7 @@
           <a:lstStyle/>
           <a:p>
             <a:pPr algn="l">
-              <a:defRPr sz="1500" b="0">
+              <a:defRPr sz="1700" b="0">
                 <a:solidFill>
                   <a:srgbClr val="FFFFFF"/>
                 </a:solidFill>
@@ -6808,7 +6812,7 @@
           <a:lstStyle/>
           <a:p>
             <a:pPr>
-              <a:defRPr b="1" sz="1400">
+              <a:defRPr b="1" sz="1800">
                 <a:solidFill>
                   <a:srgbClr val="E8A838"/>
                 </a:solidFill>
@@ -6843,7 +6847,7 @@
           <a:lstStyle/>
           <a:p>
             <a:pPr algn="l">
-              <a:defRPr sz="1500" b="0">
+              <a:defRPr sz="1700" b="0">
                 <a:solidFill>
                   <a:srgbClr val="E8A838"/>
                 </a:solidFill>
@@ -6938,7 +6942,7 @@
           <a:lstStyle/>
           <a:p>
             <a:pPr>
-              <a:defRPr b="1" sz="1400">
+              <a:defRPr b="1" sz="1800">
                 <a:solidFill>
                   <a:srgbClr val="E8A838"/>
                 </a:solidFill>
@@ -6973,7 +6977,7 @@
           <a:lstStyle/>
           <a:p>
             <a:pPr algn="l">
-              <a:defRPr sz="1400" b="0">
+              <a:defRPr sz="1600" b="0">
                 <a:solidFill>
                   <a:srgbClr val="FFFFFF"/>
                 </a:solidFill>
@@ -7164,7 +7168,7 @@
           <a:lstStyle/>
           <a:p>
             <a:pPr>
-              <a:defRPr b="1" sz="1400">
+              <a:defRPr b="1" sz="1800">
                 <a:solidFill>
                   <a:srgbClr val="E8A838"/>
                 </a:solidFill>
@@ -7199,7 +7203,7 @@
           <a:lstStyle/>
           <a:p>
             <a:pPr algn="l">
-              <a:defRPr sz="1700" b="0">
+              <a:defRPr sz="1800" b="0">
                 <a:solidFill>
                   <a:srgbClr val="FFFFFF"/>
                 </a:solidFill>
@@ -7209,13 +7213,16 @@
               <a:t>• Irradiancia GHI anual &gt; 2900 kWh/m² (máxima mundial).</a:t>
             </a:r>
             <a:br/>
+            <a:br/>
             <a:r>
               <a:t>• Cielos extremadamente limpios con baja atenuación.</a:t>
             </a:r>
             <a:br/>
+            <a:br/>
             <a:r>
               <a:t>• Altitud elevada (&gt;= 2400 m.s.n.m.): mayor radiación directa y UV.</a:t>
             </a:r>
+            <a:br/>
             <a:br/>
             <a:r>
               <a:t>• Coordenadas del estudio: Latitud -22.91°, Longitud -68.20°.</a:t>
@@ -7291,7 +7298,7 @@
           <a:lstStyle/>
           <a:p>
             <a:pPr>
-              <a:defRPr b="1" sz="1400">
+              <a:defRPr b="1" sz="1800">
                 <a:solidFill>
                   <a:srgbClr val="E8A838"/>
                 </a:solidFill>
@@ -7326,7 +7333,7 @@
           <a:lstStyle/>
           <a:p>
             <a:pPr algn="l">
-              <a:defRPr sz="1700" b="0">
+              <a:defRPr sz="1800" b="0">
                 <a:solidFill>
                   <a:srgbClr val="FFFFFF"/>
                 </a:solidFill>
@@ -7336,13 +7343,16 @@
               <a:t>• Las celdas solares operan a temperaturas &gt; 65°C a mediodía.</a:t>
             </a:r>
             <a:br/>
+            <a:br/>
             <a:r>
               <a:t>• La potencia y el voltaje decaen fuertemente con el calor.</a:t>
             </a:r>
             <a:br/>
+            <a:br/>
             <a:r>
               <a:t>• La eficiencia térmica es el factor dominante en pérdidas.</a:t>
             </a:r>
+            <a:br/>
             <a:br/>
             <a:r>
               <a:t>• Pregunta: ¿Qué tecnología resiste mejor este estrés extremo?</a:t>
@@ -7469,7 +7479,7 @@
           <a:lstStyle/>
           <a:p>
             <a:pPr algn="l">
-              <a:defRPr sz="1600" b="0">
+              <a:defRPr sz="1800" b="0">
                 <a:solidFill>
                   <a:srgbClr val="FFFFFF"/>
                 </a:solidFill>
@@ -7670,7 +7680,7 @@
           <a:lstStyle/>
           <a:p>
             <a:pPr>
-              <a:defRPr b="1" sz="1400">
+              <a:defRPr b="1" sz="1800">
                 <a:solidFill>
                   <a:srgbClr val="E8A838"/>
                 </a:solidFill>
@@ -7714,7 +7724,7 @@
                     <a:lstStyle/>
                     <a:p>
                       <a:pPr algn="ctr">
-                        <a:defRPr b="1" sz="1300">
+                        <a:defRPr b="1" sz="1400">
                           <a:solidFill>
                             <a:srgbClr val="E8A838"/>
                           </a:solidFill>
@@ -7737,7 +7747,7 @@
                     <a:lstStyle/>
                     <a:p>
                       <a:pPr algn="ctr">
-                        <a:defRPr b="1" sz="1300">
+                        <a:defRPr b="1" sz="1400">
                           <a:solidFill>
                             <a:srgbClr val="E8A838"/>
                           </a:solidFill>
@@ -7760,7 +7770,7 @@
                     <a:lstStyle/>
                     <a:p>
                       <a:pPr algn="ctr">
-                        <a:defRPr b="1" sz="1300">
+                        <a:defRPr b="1" sz="1400">
                           <a:solidFill>
                             <a:srgbClr val="E8A838"/>
                           </a:solidFill>
@@ -7783,7 +7793,7 @@
                     <a:lstStyle/>
                     <a:p>
                       <a:pPr algn="ctr">
-                        <a:defRPr b="1" sz="1300">
+                        <a:defRPr b="1" sz="1400">
                           <a:solidFill>
                             <a:srgbClr val="E8A838"/>
                           </a:solidFill>
@@ -7806,7 +7816,7 @@
                     <a:lstStyle/>
                     <a:p>
                       <a:pPr algn="ctr">
-                        <a:defRPr b="1" sz="1300">
+                        <a:defRPr b="1" sz="1400">
                           <a:solidFill>
                             <a:srgbClr val="E8A838"/>
                           </a:solidFill>
@@ -7831,7 +7841,7 @@
                     <a:lstStyle/>
                     <a:p>
                       <a:pPr algn="l">
-                        <a:defRPr sz="1150" b="1">
+                        <a:defRPr sz="1400" b="1">
                           <a:solidFill>
                             <a:srgbClr val="FFFFFF"/>
                           </a:solidFill>
@@ -7854,7 +7864,7 @@
                     <a:lstStyle/>
                     <a:p>
                       <a:pPr algn="ctr">
-                        <a:defRPr sz="1150">
+                        <a:defRPr sz="1400">
                           <a:solidFill>
                             <a:srgbClr val="FFFFFF"/>
                           </a:solidFill>
@@ -7877,7 +7887,7 @@
                     <a:lstStyle/>
                     <a:p>
                       <a:pPr algn="ctr">
-                        <a:defRPr sz="1150">
+                        <a:defRPr sz="1400">
                           <a:solidFill>
                             <a:srgbClr val="FFFFFF"/>
                           </a:solidFill>
@@ -7900,7 +7910,7 @@
                     <a:lstStyle/>
                     <a:p>
                       <a:pPr algn="l">
-                        <a:defRPr sz="1050">
+                        <a:defRPr sz="1300">
                           <a:solidFill>
                             <a:srgbClr val="FFFFFF"/>
                           </a:solidFill>
@@ -7923,7 +7933,7 @@
                     <a:lstStyle/>
                     <a:p>
                       <a:pPr algn="ctr">
-                        <a:defRPr sz="1150" b="1">
+                        <a:defRPr sz="1400" b="1">
                           <a:solidFill>
                             <a:srgbClr val="E8A838"/>
                           </a:solidFill>
@@ -7948,7 +7958,7 @@
                     <a:lstStyle/>
                     <a:p>
                       <a:pPr algn="l">
-                        <a:defRPr sz="1150" b="1">
+                        <a:defRPr sz="1400" b="1">
                           <a:solidFill>
                             <a:srgbClr val="FFFFFF"/>
                           </a:solidFill>
@@ -7971,7 +7981,7 @@
                     <a:lstStyle/>
                     <a:p>
                       <a:pPr algn="ctr">
-                        <a:defRPr sz="1150">
+                        <a:defRPr sz="1400">
                           <a:solidFill>
                             <a:srgbClr val="FFFFFF"/>
                           </a:solidFill>
@@ -7994,7 +8004,7 @@
                     <a:lstStyle/>
                     <a:p>
                       <a:pPr algn="ctr">
-                        <a:defRPr sz="1150">
+                        <a:defRPr sz="1400">
                           <a:solidFill>
                             <a:srgbClr val="FFFFFF"/>
                           </a:solidFill>
@@ -8017,7 +8027,7 @@
                     <a:lstStyle/>
                     <a:p>
                       <a:pPr algn="l">
-                        <a:defRPr sz="1050">
+                        <a:defRPr sz="1300">
                           <a:solidFill>
                             <a:srgbClr val="FFFFFF"/>
                           </a:solidFill>
@@ -8040,7 +8050,7 @@
                     <a:lstStyle/>
                     <a:p>
                       <a:pPr algn="ctr">
-                        <a:defRPr sz="1150" b="1">
+                        <a:defRPr sz="1400" b="1">
                           <a:solidFill>
                             <a:srgbClr val="E8A838"/>
                           </a:solidFill>
@@ -8065,7 +8075,7 @@
                     <a:lstStyle/>
                     <a:p>
                       <a:pPr algn="l">
-                        <a:defRPr sz="1150" b="1">
+                        <a:defRPr sz="1400" b="1">
                           <a:solidFill>
                             <a:srgbClr val="FFFFFF"/>
                           </a:solidFill>
@@ -8088,7 +8098,7 @@
                     <a:lstStyle/>
                     <a:p>
                       <a:pPr algn="ctr">
-                        <a:defRPr sz="1150">
+                        <a:defRPr sz="1400">
                           <a:solidFill>
                             <a:srgbClr val="FFFFFF"/>
                           </a:solidFill>
@@ -8111,7 +8121,7 @@
                     <a:lstStyle/>
                     <a:p>
                       <a:pPr algn="ctr">
-                        <a:defRPr sz="1150">
+                        <a:defRPr sz="1400">
                           <a:solidFill>
                             <a:srgbClr val="FFFFFF"/>
                           </a:solidFill>
@@ -8134,7 +8144,7 @@
                     <a:lstStyle/>
                     <a:p>
                       <a:pPr algn="l">
-                        <a:defRPr sz="1050">
+                        <a:defRPr sz="1300">
                           <a:solidFill>
                             <a:srgbClr val="FFFFFF"/>
                           </a:solidFill>
@@ -8157,7 +8167,7 @@
                     <a:lstStyle/>
                     <a:p>
                       <a:pPr algn="ctr">
-                        <a:defRPr sz="1150" b="1">
+                        <a:defRPr sz="1400" b="1">
                           <a:solidFill>
                             <a:srgbClr val="BBBBBB"/>
                           </a:solidFill>
@@ -8182,7 +8192,7 @@
                     <a:lstStyle/>
                     <a:p>
                       <a:pPr algn="l">
-                        <a:defRPr sz="1150" b="1">
+                        <a:defRPr sz="1400" b="1">
                           <a:solidFill>
                             <a:srgbClr val="FFFFFF"/>
                           </a:solidFill>
@@ -8205,7 +8215,7 @@
                     <a:lstStyle/>
                     <a:p>
                       <a:pPr algn="ctr">
-                        <a:defRPr sz="1150">
+                        <a:defRPr sz="1400">
                           <a:solidFill>
                             <a:srgbClr val="FFFFFF"/>
                           </a:solidFill>
@@ -8228,7 +8238,7 @@
                     <a:lstStyle/>
                     <a:p>
                       <a:pPr algn="ctr">
-                        <a:defRPr sz="1150">
+                        <a:defRPr sz="1400">
                           <a:solidFill>
                             <a:srgbClr val="FFFFFF"/>
                           </a:solidFill>
@@ -8251,7 +8261,7 @@
                     <a:lstStyle/>
                     <a:p>
                       <a:pPr algn="l">
-                        <a:defRPr sz="1050">
+                        <a:defRPr sz="1300">
                           <a:solidFill>
                             <a:srgbClr val="FFFFFF"/>
                           </a:solidFill>
@@ -8274,7 +8284,7 @@
                     <a:lstStyle/>
                     <a:p>
                       <a:pPr algn="ctr">
-                        <a:defRPr sz="1150" b="1">
+                        <a:defRPr sz="1400" b="1">
                           <a:solidFill>
                             <a:srgbClr val="BBBBBB"/>
                           </a:solidFill>
@@ -8299,7 +8309,7 @@
                     <a:lstStyle/>
                     <a:p>
                       <a:pPr algn="l">
-                        <a:defRPr sz="1150" b="1">
+                        <a:defRPr sz="1400" b="1">
                           <a:solidFill>
                             <a:srgbClr val="FFFFFF"/>
                           </a:solidFill>
@@ -8322,7 +8332,7 @@
                     <a:lstStyle/>
                     <a:p>
                       <a:pPr algn="ctr">
-                        <a:defRPr sz="1150">
+                        <a:defRPr sz="1400">
                           <a:solidFill>
                             <a:srgbClr val="FFFFFF"/>
                           </a:solidFill>
@@ -8345,7 +8355,7 @@
                     <a:lstStyle/>
                     <a:p>
                       <a:pPr algn="ctr">
-                        <a:defRPr sz="1150">
+                        <a:defRPr sz="1400">
                           <a:solidFill>
                             <a:srgbClr val="FFFFFF"/>
                           </a:solidFill>
@@ -8368,7 +8378,7 @@
                     <a:lstStyle/>
                     <a:p>
                       <a:pPr algn="l">
-                        <a:defRPr sz="1050">
+                        <a:defRPr sz="1300">
                           <a:solidFill>
                             <a:srgbClr val="FFFFFF"/>
                           </a:solidFill>
@@ -8391,7 +8401,7 @@
                     <a:lstStyle/>
                     <a:p>
                       <a:pPr algn="ctr">
-                        <a:defRPr sz="1150" b="1">
+                        <a:defRPr sz="1400" b="1">
                           <a:solidFill>
                             <a:srgbClr val="BBBBBB"/>
                           </a:solidFill>
@@ -8577,7 +8587,7 @@
           <a:lstStyle/>
           <a:p>
             <a:pPr>
-              <a:defRPr b="1" sz="1400">
+              <a:defRPr b="1" sz="1800">
                 <a:solidFill>
                   <a:srgbClr val="E8A838"/>
                 </a:solidFill>
@@ -8612,7 +8622,7 @@
           <a:lstStyle/>
           <a:p>
             <a:pPr algn="l">
-              <a:defRPr sz="1800" b="0">
+              <a:defRPr sz="1900" b="0">
                 <a:solidFill>
                   <a:srgbClr val="FFFFFF"/>
                 </a:solidFill>
@@ -8808,7 +8818,7 @@
           <a:lstStyle/>
           <a:p>
             <a:pPr>
-              <a:defRPr b="1" sz="1400">
+              <a:defRPr b="1" sz="1800">
                 <a:solidFill>
                   <a:srgbClr val="E8A838"/>
                 </a:solidFill>
@@ -8843,7 +8853,7 @@
           <a:lstStyle/>
           <a:p>
             <a:pPr algn="l">
-              <a:defRPr sz="1300" b="0">
+              <a:defRPr sz="1600" b="0">
                 <a:solidFill>
                   <a:srgbClr val="FFFFFF"/>
                 </a:solidFill>
@@ -8872,7 +8882,7 @@
         <p:spPr>
           <a:xfrm>
             <a:off x="640080" y="1920240"/>
-            <a:ext cx="5086990" cy="347472"/>
+            <a:ext cx="5029200" cy="343524"/>
           </a:xfrm>
           <a:prstGeom prst="rect">
             <a:avLst/>
@@ -8902,7 +8912,7 @@
           <a:lstStyle/>
           <a:p>
             <a:pPr algn="l">
-              <a:defRPr sz="1300" b="0">
+              <a:defRPr sz="1600" b="0">
                 <a:solidFill>
                   <a:srgbClr val="FFFFFF"/>
                 </a:solidFill>
@@ -8930,8 +8940,8 @@
         </p:blipFill>
         <p:spPr>
           <a:xfrm>
-            <a:off x="640080" y="2926080"/>
-            <a:ext cx="4878531" cy="274320"/>
+            <a:off x="640080" y="2971800"/>
+            <a:ext cx="5029200" cy="282792"/>
           </a:xfrm>
           <a:prstGeom prst="rect">
             <a:avLst/>
@@ -8961,7 +8971,7 @@
           <a:lstStyle/>
           <a:p>
             <a:pPr algn="l">
-              <a:defRPr sz="1300" b="0">
+              <a:defRPr sz="1500" b="0">
                 <a:solidFill>
                   <a:srgbClr val="E8A838"/>
                 </a:solidFill>
@@ -9041,7 +9051,7 @@
           <a:lstStyle/>
           <a:p>
             <a:pPr>
-              <a:defRPr b="1" sz="1400">
+              <a:defRPr b="1" sz="1800">
                 <a:solidFill>
                   <a:srgbClr val="E8A838"/>
                 </a:solidFill>
@@ -9061,7 +9071,7 @@
         </p:nvSpPr>
         <p:spPr>
           <a:xfrm>
-            <a:off x="6370167" y="1645920"/>
+            <a:off x="6370167" y="1554480"/>
             <a:ext cx="5181447" cy="4114800"/>
           </a:xfrm>
           <a:prstGeom prst="rect">
@@ -9076,7 +9086,7 @@
           <a:lstStyle/>
           <a:p>
             <a:pPr algn="l">
-              <a:defRPr sz="1300" b="0">
+              <a:defRPr sz="1500" b="0">
                 <a:solidFill>
                   <a:srgbClr val="FFFFFF"/>
                 </a:solidFill>
@@ -9086,20 +9096,24 @@
               <a:t>• G_b / G_d / G: Irradiancia directa, difusa y global horizontal (W/m²).</a:t>
             </a:r>
             <a:br/>
+            <a:br/>
             <a:r>
               <a:t>• β (Tilt): Ángulo de inclinación del panel (22.91° optimizado).</a:t>
             </a:r>
             <a:br/>
+            <a:br/>
             <a:r>
               <a:t>• ρ (Albedo): Reflectancia del suelo árido desértico (~0.20).</a:t>
             </a:r>
             <a:br/>
+            <a:br/>
             <a:r>
               <a:t>• R_beam: Factor de transposición geométrica para radiación directa.</a:t>
             </a:r>
             <a:br/>
-            <a:r>
-              <a:t>• K_τα,b / K_τα,d / K_τα,g: Modificadores por ángulo de incidencia (IAM) para componente directa, difusa y del suelo.</a:t>
+            <a:br/>
+            <a:r>
+              <a:t>• K_ta,b / K_ta,d / K_ta,g: Modificadores por IAM para directa, difusa y suelo.</a:t>
             </a:r>
           </a:p>
         </p:txBody>
@@ -9268,7 +9282,7 @@
           <a:lstStyle/>
           <a:p>
             <a:pPr>
-              <a:defRPr b="1" sz="1400">
+              <a:defRPr b="1" sz="1800">
                 <a:solidFill>
                   <a:srgbClr val="E8A838"/>
                 </a:solidFill>
@@ -9303,7 +9317,7 @@
           <a:lstStyle/>
           <a:p>
             <a:pPr algn="l">
-              <a:defRPr sz="1200" b="0">
+              <a:defRPr sz="1500" b="0">
                 <a:solidFill>
                   <a:srgbClr val="FFFFFF"/>
                 </a:solidFill>
@@ -9332,7 +9346,7 @@
         <p:spPr>
           <a:xfrm>
             <a:off x="640080" y="1920240"/>
-            <a:ext cx="932688" cy="310896"/>
+            <a:ext cx="1234440" cy="411480"/>
           </a:xfrm>
           <a:prstGeom prst="rect">
             <a:avLst/>
@@ -9356,7 +9370,7 @@
         <p:spPr>
           <a:xfrm>
             <a:off x="640080" y="2377440"/>
-            <a:ext cx="3103998" cy="310896"/>
+            <a:ext cx="3469175" cy="347472"/>
           </a:xfrm>
           <a:prstGeom prst="rect">
             <a:avLst/>
@@ -9379,8 +9393,8 @@
         </p:blipFill>
         <p:spPr>
           <a:xfrm>
-            <a:off x="640080" y="2971800"/>
-            <a:ext cx="1480521" cy="274320"/>
+            <a:off x="640080" y="2788920"/>
+            <a:ext cx="1974028" cy="365760"/>
           </a:xfrm>
           <a:prstGeom prst="rect">
             <a:avLst/>
@@ -9395,7 +9409,7 @@
         </p:nvSpPr>
         <p:spPr>
           <a:xfrm>
-            <a:off x="548640" y="3383280"/>
+            <a:off x="548640" y="3566160"/>
             <a:ext cx="5181447" cy="2286000"/>
           </a:xfrm>
           <a:prstGeom prst="rect">
@@ -9410,7 +9424,7 @@
           <a:lstStyle/>
           <a:p>
             <a:pPr algn="l">
-              <a:defRPr sz="1100" b="0">
+              <a:defRPr sz="1400" b="0">
                 <a:solidFill>
                   <a:srgbClr val="E8A838"/>
                 </a:solidFill>
@@ -9421,19 +9435,11 @@
             </a:r>
             <a:br/>
             <a:r>
-              <a:t>• θ: Ángulo de incidencia solar.</a:t>
-            </a:r>
-            <a:br/>
-            <a:r>
-              <a:t>• n = 1.526 (Índice de refracción del vidrio templado).</a:t>
-            </a:r>
-            <a:br/>
-            <a:r>
-              <a:t>• K = 4 m⁻¹ (Absorción del vidrio).</a:t>
-            </a:r>
-            <a:br/>
-            <a:r>
-              <a:t>• L = 2 mm (Espesor típico del vidrio).</a:t>
+              <a:t>• θ: Ángulo de incidencia  |  n = 1.526 (Índice refracción vidrio).</a:t>
+            </a:r>
+            <a:br/>
+            <a:r>
+              <a:t>• K = 4 m⁻¹ (Absorción del vidrio)  |  L = 2 mm (Espesor vidrio).</a:t>
             </a:r>
           </a:p>
         </p:txBody>
@@ -9506,7 +9512,7 @@
           <a:lstStyle/>
           <a:p>
             <a:pPr>
-              <a:defRPr b="1" sz="1400">
+              <a:defRPr b="1" sz="1800">
                 <a:solidFill>
                   <a:srgbClr val="E8A838"/>
                 </a:solidFill>
@@ -9541,7 +9547,7 @@
           <a:lstStyle/>
           <a:p>
             <a:pPr algn="l">
-              <a:defRPr sz="1200" b="0">
+              <a:defRPr sz="1500" b="0">
                 <a:solidFill>
                   <a:srgbClr val="FFFFFF"/>
                 </a:solidFill>
@@ -9569,8 +9575,8 @@
         </p:blipFill>
         <p:spPr>
           <a:xfrm>
-            <a:off x="6461607" y="2011680"/>
-            <a:ext cx="4688146" cy="310896"/>
+            <a:off x="6461607" y="1965960"/>
+            <a:ext cx="5029200" cy="333513"/>
           </a:xfrm>
           <a:prstGeom prst="rect">
             <a:avLst/>
@@ -9593,8 +9599,8 @@
         </p:blipFill>
         <p:spPr>
           <a:xfrm>
-            <a:off x="6461607" y="2514600"/>
-            <a:ext cx="3072849" cy="365760"/>
+            <a:off x="6461607" y="2423160"/>
+            <a:ext cx="3687419" cy="438912"/>
           </a:xfrm>
           <a:prstGeom prst="rect">
             <a:avLst/>
@@ -9609,7 +9615,7 @@
         </p:nvSpPr>
         <p:spPr>
           <a:xfrm>
-            <a:off x="6370167" y="3108960"/>
+            <a:off x="6370167" y="3154680"/>
             <a:ext cx="5181447" cy="2743200"/>
           </a:xfrm>
           <a:prstGeom prst="rect">
@@ -9624,7 +9630,7 @@
           <a:lstStyle/>
           <a:p>
             <a:pPr algn="l">
-              <a:defRPr sz="1200" b="0">
+              <a:defRPr sz="1500" b="0">
                 <a:solidFill>
                   <a:srgbClr val="FFFFFF"/>
                 </a:solidFill>
@@ -9635,11 +9641,7 @@
             </a:r>
             <a:br/>
             <a:r>
-              <a:t>• AM: Masa de aire absoluta.</a:t>
-            </a:r>
-            <a:br/>
-            <a:r>
-              <a:t>• θ_z: Ángulo cenital del sol.</a:t>
+              <a:t>• AM: Masa de aire absoluta  |  θ_z: Ángulo cenital del sol.</a:t>
             </a:r>
             <a:br/>
             <a:r>
@@ -9981,7 +9983,7 @@
           <a:lstStyle/>
           <a:p>
             <a:pPr>
-              <a:defRPr b="1" sz="1400">
+              <a:defRPr b="1" sz="1800">
                 <a:solidFill>
                   <a:srgbClr val="E8A838"/>
                 </a:solidFill>
@@ -10016,7 +10018,7 @@
           <a:lstStyle/>
           <a:p>
             <a:pPr algn="l">
-              <a:defRPr sz="1300" b="0">
+              <a:defRPr sz="1600" b="0">
                 <a:solidFill>
                   <a:srgbClr val="FFFFFF"/>
                 </a:solidFill>
@@ -10044,8 +10046,8 @@
         </p:blipFill>
         <p:spPr>
           <a:xfrm>
-            <a:off x="640080" y="2011680"/>
-            <a:ext cx="4300102" cy="411480"/>
+            <a:off x="640080" y="1965960"/>
+            <a:ext cx="4586775" cy="438912"/>
           </a:xfrm>
           <a:prstGeom prst="rect">
             <a:avLst/>
@@ -10060,7 +10062,7 @@
         </p:nvSpPr>
         <p:spPr>
           <a:xfrm>
-            <a:off x="548640" y="2651760"/>
+            <a:off x="548640" y="2606040"/>
             <a:ext cx="5181447" cy="2743200"/>
           </a:xfrm>
           <a:prstGeom prst="rect">
@@ -10075,7 +10077,7 @@
           <a:lstStyle/>
           <a:p>
             <a:pPr algn="l">
-              <a:defRPr sz="1300" b="0">
+              <a:defRPr sz="1500" b="0">
                 <a:solidFill>
                   <a:srgbClr val="E8A838"/>
                 </a:solidFill>
@@ -10171,7 +10173,7 @@
           <a:lstStyle/>
           <a:p>
             <a:pPr>
-              <a:defRPr b="1" sz="1400">
+              <a:defRPr b="1" sz="1800">
                 <a:solidFill>
                   <a:srgbClr val="E8A838"/>
                 </a:solidFill>
@@ -10191,7 +10193,7 @@
         </p:nvSpPr>
         <p:spPr>
           <a:xfrm>
-            <a:off x="6370167" y="1645920"/>
+            <a:off x="6370167" y="1554480"/>
             <a:ext cx="5181447" cy="4114800"/>
           </a:xfrm>
           <a:prstGeom prst="rect">
@@ -10206,7 +10208,7 @@
           <a:lstStyle/>
           <a:p>
             <a:pPr algn="l">
-              <a:defRPr sz="1400" b="0">
+              <a:defRPr sz="1500" b="0">
                 <a:solidFill>
                   <a:srgbClr val="FFFFFF"/>
                 </a:solidFill>
@@ -10222,11 +10224,7 @@
             </a:r>
             <a:br/>
             <a:r>
-              <a:t>   • a = -3.56  |  b = -0.075</a:t>
-            </a:r>
-            <a:br/>
-            <a:r>
-              <a:t>   • ΔT = 3.0 °C</a:t>
+              <a:t>   • a = -3.56  |  b = -0.075  |  ΔT = 3.0 °C</a:t>
             </a:r>
             <a:br/>
             <a:r>
@@ -10239,11 +10237,7 @@
             </a:r>
             <a:br/>
             <a:r>
-              <a:t>   • a = -3.47  |  b = -0.059</a:t>
-            </a:r>
-            <a:br/>
-            <a:r>
-              <a:t>   • ΔT = 3.0 °C</a:t>
+              <a:t>   • a = -3.47  |  b = -0.059  |  ΔT = 3.0 °C</a:t>
             </a:r>
             <a:br/>
             <a:r>
@@ -10416,7 +10410,7 @@
           <a:lstStyle/>
           <a:p>
             <a:pPr>
-              <a:defRPr b="1" sz="1400">
+              <a:defRPr b="1" sz="1800">
                 <a:solidFill>
                   <a:srgbClr val="E8A838"/>
                 </a:solidFill>
@@ -10520,7 +10514,7 @@
           <a:lstStyle/>
           <a:p>
             <a:pPr>
-              <a:defRPr b="1" sz="1400">
+              <a:defRPr b="1" sz="1800">
                 <a:solidFill>
                   <a:srgbClr val="E8A838"/>
                 </a:solidFill>
@@ -10555,7 +10549,7 @@
           <a:lstStyle/>
           <a:p>
             <a:pPr algn="l">
-              <a:defRPr sz="1600" b="0">
+              <a:defRPr sz="1700" b="0">
                 <a:solidFill>
                   <a:srgbClr val="FFFFFF"/>
                 </a:solidFill>
@@ -10565,13 +10559,16 @@
               <a:t>• Temperatura promedio diurna de celda: ~38°C a 45°C.</a:t>
             </a:r>
             <a:br/>
+            <a:br/>
             <a:r>
               <a:t>• Picos térmicos extremos superan los 65°C a mediodía en verano.</a:t>
             </a:r>
             <a:br/>
+            <a:br/>
             <a:r>
               <a:t>• Clima desértico seco reduce la convección natural del marco.</a:t>
             </a:r>
+            <a:br/>
             <a:br/>
             <a:r>
               <a:t>• Las altas temperaturas aumentan la corriente de saturación inversa (Io), reduciendo severamente el Voc.</a:t>

</xml_diff>

<commit_message>
Implement superscripted reference citations across slides and update numbered bibliography on slide 20
</commit_message>
<xml_diff>
--- a/output/Presentacion_Final_ELI556_Atacama.pptx
+++ b/output/Presentacion_Final_ELI556_Atacama.pptx
@@ -3192,6 +3192,14 @@
               </a:rPr>
               <a:t>Modelamiento Eléctrico mediante el Modelo de 5 Parámetros de De Soto</a:t>
             </a:r>
+            <a:r>
+              <a:rPr sz="2200">
+                <a:solidFill>
+                  <a:srgbClr val="FFFFFF"/>
+                </a:solidFill>
+              </a:rPr>
+              <a:t>[1]</a:t>
+            </a:r>
           </a:p>
         </p:txBody>
       </p:sp>
@@ -3386,7 +3394,7 @@
               </a:defRPr>
             </a:pPr>
             <a:r>
-              <a:t>Modelo de 5 Parámetros: Diodo Simple (SDM)</a:t>
+              <a:t>Modelo de 5 Parámetros: Diodo Simple (SDM) ^[1]^</a:t>
             </a:r>
           </a:p>
         </p:txBody>
@@ -4451,7 +4459,23 @@
                   <a:srgbClr val="FFFFFF"/>
                 </a:solidFill>
               </a:rPr>
-              <a:t> en STC:</a:t>
+              <a:t> en STC</a:t>
+            </a:r>
+            <a:r>
+              <a:rPr sz="1500">
+                <a:solidFill>
+                  <a:srgbClr val="FFFFFF"/>
+                </a:solidFill>
+              </a:rPr>
+              <a:t>[1]</a:t>
+            </a:r>
+            <a:r>
+              <a:rPr sz="1500">
+                <a:solidFill>
+                  <a:srgbClr val="FFFFFF"/>
+                </a:solidFill>
+              </a:rPr>
+              <a:t>:</a:t>
             </a:r>
           </a:p>
           <a:p>
@@ -5424,7 +5448,7 @@
               </a:defRPr>
             </a:pPr>
             <a:r>
-              <a:t>Dependencias con (G, Tc) de De Soto</a:t>
+              <a:t>Dependencias con (G, Tc) de De Soto ^[1]^</a:t>
             </a:r>
           </a:p>
         </p:txBody>
@@ -6089,7 +6113,23 @@
                   <a:srgbClr val="FFFFFF"/>
                 </a:solidFill>
               </a:rPr>
-              <a:t>  Justificación: De Soto (2006) demuestra mediante validaciones contra NIST que la variación térmica de </a:t>
+              <a:t>  Justificación: De Soto (2006)</a:t>
+            </a:r>
+            <a:r>
+              <a:rPr sz="1500">
+                <a:solidFill>
+                  <a:srgbClr val="FFFFFF"/>
+                </a:solidFill>
+              </a:rPr>
+              <a:t>[1]</a:t>
+            </a:r>
+            <a:r>
+              <a:rPr sz="1500">
+                <a:solidFill>
+                  <a:srgbClr val="FFFFFF"/>
+                </a:solidFill>
+              </a:rPr>
+              <a:t> demuestra mediante validaciones contra NIST que la variación térmica de </a:t>
             </a:r>
             <a:r>
               <a:rPr sz="1500" i="1">
@@ -7202,7 +7242,23 @@
                   <a:srgbClr val="E8A838"/>
                 </a:solidFill>
               </a:rPr>
-              <a:t>: Potencia MPP simulada hora a hora con De Soto (W).</a:t>
+              <a:t>: Potencia MPP simulada hora a hora con De Soto</a:t>
+            </a:r>
+            <a:r>
+              <a:rPr sz="1500">
+                <a:solidFill>
+                  <a:srgbClr val="E8A838"/>
+                </a:solidFill>
+              </a:rPr>
+              <a:t>[1]</a:t>
+            </a:r>
+            <a:r>
+              <a:rPr sz="1500">
+                <a:solidFill>
+                  <a:srgbClr val="E8A838"/>
+                </a:solidFill>
+              </a:rPr>
+              <a:t> (W).</a:t>
             </a:r>
           </a:p>
           <a:p>
@@ -9776,7 +9832,7 @@
                   <a:srgbClr val="FFFFFF"/>
                 </a:solidFill>
               </a:rPr>
-              <a:t>• De Soto, W., Klein, S.A., Beckman, W.A. (2006). "Improvement and validation of a model for photovoltaic array performance." Solar Energy 80 (2006) 78–88.</a:t>
+              <a:t>1. De Soto, W., Klein, S.A., Beckman, W.A. (2006). "Improvement and validation of a model for photovoltaic array performance." Solar Energy 80 (2006) 78–88.</a:t>
             </a:r>
           </a:p>
           <a:p>
@@ -9802,7 +9858,7 @@
                   <a:srgbClr val="FFFFFF"/>
                 </a:solidFill>
               </a:rPr>
-              <a:t>• Sandia National Laboratories - Photovoltaic Array Performance Model (Sandia Report SAND2004-3535).</a:t>
+              <a:t>2. Sandia National Laboratories - Photovoltaic Array Performance Model (Sandia Report SAND2004-3535).</a:t>
             </a:r>
           </a:p>
           <a:p>
@@ -9828,7 +9884,7 @@
                   <a:srgbClr val="FFFFFF"/>
                 </a:solidFill>
               </a:rPr>
-              <a:t>• NREL Cocoa Dataset - Experimental Measurements for Model Validation.</a:t>
+              <a:t>3. NREL Cocoa Dataset - Experimental Measurements for Model Validation.</a:t>
             </a:r>
           </a:p>
           <a:p>
@@ -9854,7 +9910,7 @@
                   <a:srgbClr val="FFFFFF"/>
                 </a:solidFill>
               </a:rPr>
-              <a:t>• pvlib-python Library documentation &amp; community contributors.</a:t>
+              <a:t>4. pvlib-python Library documentation &amp; community contributors.</a:t>
             </a:r>
           </a:p>
           <a:p>
@@ -9880,7 +9936,7 @@
                   <a:srgbClr val="FFFFFF"/>
                 </a:solidFill>
               </a:rPr>
-              <a:t>• Marion, B. et al. (2014). "Cocoa, Florida Data Set for Validating PV Models." NREL Technical Report.</a:t>
+              <a:t>5. Marion, B. et al. (2014). "Cocoa, Florida Data Set for Validating PV Models." NREL Technical Report.</a:t>
             </a:r>
           </a:p>
           <a:p>
@@ -10082,7 +10138,7 @@
               </a:defRPr>
             </a:pPr>
             <a:r>
-              <a:t>Familias Tecnológicas en Dataset Cocoa (NREL)</a:t>
+              <a:t>Familias Tecnológicas en Dataset Cocoa (NREL) ^[5]^</a:t>
             </a:r>
           </a:p>
         </p:txBody>
@@ -11029,7 +11085,23 @@
                   <a:srgbClr val="FFFFFF"/>
                 </a:solidFill>
               </a:rPr>
-              <a:t>1. Ingesta de Datos: Dataset NREL Cocoa (mediciones experimentales reales).</a:t>
+              <a:t>1. Ingesta de Datos: Dataset NREL Cocoa</a:t>
+            </a:r>
+            <a:r>
+              <a:rPr sz="1900">
+                <a:solidFill>
+                  <a:srgbClr val="FFFFFF"/>
+                </a:solidFill>
+              </a:rPr>
+              <a:t>[5]</a:t>
+            </a:r>
+            <a:r>
+              <a:rPr sz="1900">
+                <a:solidFill>
+                  <a:srgbClr val="FFFFFF"/>
+                </a:solidFill>
+              </a:rPr>
+              <a:t> (mediciones experimentales reales).</a:t>
             </a:r>
           </a:p>
           <a:p>
@@ -11081,7 +11153,47 @@
                   <a:srgbClr val="FFFFFF"/>
                 </a:solidFill>
               </a:rPr>
-              <a:t>3. Modelamiento Térmico: Modelo Sandia SAPM para estimación dinámica de la Temperatura de Celda (Tc).</a:t>
+              <a:t>3. Modelamiento Térmico: Modelo Sandia SAPM</a:t>
+            </a:r>
+            <a:r>
+              <a:rPr sz="1900">
+                <a:solidFill>
+                  <a:srgbClr val="FFFFFF"/>
+                </a:solidFill>
+              </a:rPr>
+              <a:t>[2]</a:t>
+            </a:r>
+            <a:r>
+              <a:rPr sz="1900">
+                <a:solidFill>
+                  <a:srgbClr val="FFFFFF"/>
+                </a:solidFill>
+              </a:rPr>
+              <a:t> para estimación dinámica de la Temperatura de Celda (</a:t>
+            </a:r>
+            <a:r>
+              <a:rPr sz="1900" i="1">
+                <a:solidFill>
+                  <a:srgbClr val="FFFFFF"/>
+                </a:solidFill>
+              </a:rPr>
+              <a:t>T</a:t>
+            </a:r>
+            <a:r>
+              <a:rPr sz="1900" i="1">
+                <a:solidFill>
+                  <a:srgbClr val="FFFFFF"/>
+                </a:solidFill>
+              </a:rPr>
+              <a:t>c</a:t>
+            </a:r>
+            <a:r>
+              <a:rPr sz="1900">
+                <a:solidFill>
+                  <a:srgbClr val="FFFFFF"/>
+                </a:solidFill>
+              </a:rPr>
+              <a:t>).</a:t>
             </a:r>
           </a:p>
           <a:p>
@@ -11107,7 +11219,23 @@
                   <a:srgbClr val="FFFFFF"/>
                 </a:solidFill>
               </a:rPr>
-              <a:t>4. Caracterización Eléctrica: Extracción de los 5 parámetros De Soto en SRC usando Scipy Optimize.</a:t>
+              <a:t>4. Caracterización Eléctrica: Extracción de los 5 parámetros De Soto</a:t>
+            </a:r>
+            <a:r>
+              <a:rPr sz="1900">
+                <a:solidFill>
+                  <a:srgbClr val="FFFFFF"/>
+                </a:solidFill>
+              </a:rPr>
+              <a:t>[1]</a:t>
+            </a:r>
+            <a:r>
+              <a:rPr sz="1900">
+                <a:solidFill>
+                  <a:srgbClr val="FFFFFF"/>
+                </a:solidFill>
+              </a:rPr>
+              <a:t> en SRC usando Scipy Optimize.</a:t>
             </a:r>
           </a:p>
           <a:p>
@@ -11133,7 +11261,39 @@
                   <a:srgbClr val="FFFFFF"/>
                 </a:solidFill>
               </a:rPr>
-              <a:t>5. Simulación de Desempeño: Traslado de parámetros a operación y cómputo de PR minutal anual.</a:t>
+              <a:t>5. Simulación de Desempeño: Traslado de parámetros a operación y cómputo de </a:t>
+            </a:r>
+            <a:r>
+              <a:rPr sz="1900" i="1">
+                <a:solidFill>
+                  <a:srgbClr val="FFFFFF"/>
+                </a:solidFill>
+              </a:rPr>
+              <a:t>PR</a:t>
+            </a:r>
+            <a:r>
+              <a:rPr sz="1900">
+                <a:solidFill>
+                  <a:srgbClr val="FFFFFF"/>
+                </a:solidFill>
+              </a:rPr>
+              <a:t> minutal anual usando pvlib-python</a:t>
+            </a:r>
+            <a:r>
+              <a:rPr sz="1900">
+                <a:solidFill>
+                  <a:srgbClr val="FFFFFF"/>
+                </a:solidFill>
+              </a:rPr>
+              <a:t>[4]</a:t>
+            </a:r>
+            <a:r>
+              <a:rPr sz="1900">
+                <a:solidFill>
+                  <a:srgbClr val="FFFFFF"/>
+                </a:solidFill>
+              </a:rPr>
+              <a:t>.</a:t>
             </a:r>
           </a:p>
         </p:txBody>
@@ -12149,7 +12309,7 @@
               </a:defRPr>
             </a:pPr>
             <a:r>
-              <a:t>Modificador por Ángulo de Incidencia (IAM)</a:t>
+              <a:t>Modificador por Ángulo de Incidencia (IAM) ^[2]^</a:t>
             </a:r>
           </a:p>
         </p:txBody>
@@ -12479,7 +12639,7 @@
               </a:defRPr>
             </a:pPr>
             <a:r>
-              <a:t>Modificador por Masa de Aire (AM)</a:t>
+              <a:t>Modificador por Masa de Aire (AM) ^[2]^</a:t>
             </a:r>
           </a:p>
         </p:txBody>
@@ -13103,7 +13263,7 @@
               </a:defRPr>
             </a:pPr>
             <a:r>
-              <a:t>Temperatura de Celda (Sandia SAPM)</a:t>
+              <a:t>Temperatura de Celda (Sandia SAPM) ^[2]^</a:t>
             </a:r>
           </a:p>
         </p:txBody>

</xml_diff>

<commit_message>
Optimize vertical spacing between equations/texts and remove Cover slide subtitle/citation
</commit_message>
<xml_diff>
--- a/output/Presentacion_Final_ELI556_Atacama.pptx
+++ b/output/Presentacion_Final_ELI556_Atacama.pptx
@@ -3163,8 +3163,8 @@
         </p:nvSpPr>
         <p:spPr>
           <a:xfrm>
-            <a:off x="365760" y="2926080"/>
-            <a:ext cx="11460175" cy="731520"/>
+            <a:off x="365760" y="3474720"/>
+            <a:ext cx="11460175" cy="1645920"/>
           </a:xfrm>
           <a:prstGeom prst="rect">
             <a:avLst/>
@@ -3178,52 +3178,21 @@
           <a:lstStyle/>
           <a:p>
             <a:pPr algn="ctr">
-              <a:defRPr sz="2200">
-                <a:solidFill>
-                  <a:srgbClr val="FFFFFF"/>
-                </a:solidFill>
-              </a:defRPr>
-            </a:pPr>
-            <a:r>
-              <a:rPr sz="2200">
-                <a:solidFill>
-                  <a:srgbClr val="FFFFFF"/>
-                </a:solidFill>
-              </a:rPr>
-              <a:t>Modelamiento Eléctrico mediante el Modelo de 5 Parámetros de De Soto</a:t>
-            </a:r>
-            <a:r>
-              <a:rPr sz="2200">
-                <a:solidFill>
-                  <a:srgbClr val="FFFFFF"/>
-                </a:solidFill>
-              </a:rPr>
-              <a:t>[1]</a:t>
-            </a:r>
-          </a:p>
-        </p:txBody>
-      </p:sp>
-      <p:sp>
-        <p:nvSpPr>
-          <p:cNvPr id="4" name="TextBox 3"/>
-          <p:cNvSpPr txBox="1"/>
-          <p:nvPr/>
-        </p:nvSpPr>
-        <p:spPr>
-          <a:xfrm>
-            <a:off x="365760" y="4114800"/>
-            <a:ext cx="11460175" cy="1645920"/>
-          </a:xfrm>
-          <a:prstGeom prst="rect">
-            <a:avLst/>
-          </a:prstGeom>
-          <a:noFill/>
-        </p:spPr>
-        <p:txBody>
-          <a:bodyPr wrap="square">
-            <a:spAutoFit/>
-          </a:bodyPr>
-          <a:lstStyle/>
+              <a:defRPr sz="1600">
+                <a:solidFill>
+                  <a:srgbClr val="FFFFFF"/>
+                </a:solidFill>
+              </a:defRPr>
+            </a:pPr>
+            <a:r>
+              <a:rPr sz="1600">
+                <a:solidFill>
+                  <a:srgbClr val="FFFFFF"/>
+                </a:solidFill>
+              </a:rPr>
+              <a:t>Integrantes / Estudiantes:</a:t>
+            </a:r>
+          </a:p>
           <a:p>
             <a:pPr algn="ctr">
               <a:defRPr sz="1600">
@@ -3238,7 +3207,7 @@
                   <a:srgbClr val="FFFFFF"/>
                 </a:solidFill>
               </a:rPr>
-              <a:t>Integrantes / Estudiantes:</a:t>
+              <a:t>Laury Gualdron  |  Sebastian Marin  |  Alejandro Hernández</a:t>
             </a:r>
           </a:p>
           <a:p>
@@ -3249,14 +3218,6 @@
                 </a:solidFill>
               </a:defRPr>
             </a:pPr>
-            <a:r>
-              <a:rPr sz="1600">
-                <a:solidFill>
-                  <a:srgbClr val="FFFFFF"/>
-                </a:solidFill>
-              </a:rPr>
-              <a:t>Laury Gualdron  |  Sebastian Marin  |  Alejandro Hernández</a:t>
-            </a:r>
           </a:p>
           <a:p>
             <a:pPr algn="ctr">
@@ -3266,6 +3227,14 @@
                 </a:solidFill>
               </a:defRPr>
             </a:pPr>
+            <a:r>
+              <a:rPr sz="1600">
+                <a:solidFill>
+                  <a:srgbClr val="FFFFFF"/>
+                </a:solidFill>
+              </a:rPr>
+              <a:t>Profesor Guía: Carlos Cardenas</a:t>
+            </a:r>
           </a:p>
           <a:p>
             <a:pPr algn="ctr">
@@ -3281,23 +3250,6 @@
                   <a:srgbClr val="FFFFFF"/>
                 </a:solidFill>
               </a:rPr>
-              <a:t>Profesor Guía: Carlos Cardenas</a:t>
-            </a:r>
-          </a:p>
-          <a:p>
-            <a:pPr algn="ctr">
-              <a:defRPr sz="1600">
-                <a:solidFill>
-                  <a:srgbClr val="FFFFFF"/>
-                </a:solidFill>
-              </a:defRPr>
-            </a:pPr>
-            <a:r>
-              <a:rPr sz="1600">
-                <a:solidFill>
-                  <a:srgbClr val="FFFFFF"/>
-                </a:solidFill>
-              </a:rPr>
               <a:t>ELI556 — Modelamiento y Análisis de Sistemas PV  |  Grupo Alta Tensión (AT)</a:t>
             </a:r>
           </a:p>
@@ -3305,7 +3257,7 @@
       </p:sp>
       <p:sp>
         <p:nvSpPr>
-          <p:cNvPr id="5" name="TextBox 4"/>
+          <p:cNvPr id="4" name="TextBox 3"/>
           <p:cNvSpPr txBox="1"/>
           <p:nvPr/>
         </p:nvSpPr>
@@ -3551,7 +3503,7 @@
         </p:nvSpPr>
         <p:spPr>
           <a:xfrm>
-            <a:off x="548640" y="2743200"/>
+            <a:off x="548640" y="3108960"/>
             <a:ext cx="5181447" cy="320040"/>
           </a:xfrm>
           <a:prstGeom prst="rect">
@@ -3615,7 +3567,7 @@
         </p:blipFill>
         <p:spPr>
           <a:xfrm>
-            <a:off x="640080" y="3429000"/>
+            <a:off x="640080" y="3611880"/>
             <a:ext cx="1835474" cy="457200"/>
           </a:xfrm>
           <a:prstGeom prst="rect">
@@ -4837,7 +4789,7 @@
         </p:nvSpPr>
         <p:spPr>
           <a:xfrm>
-            <a:off x="548640" y="3703320"/>
+            <a:off x="548640" y="3794760"/>
             <a:ext cx="5181447" cy="320040"/>
           </a:xfrm>
           <a:prstGeom prst="rect">
@@ -4909,7 +4861,7 @@
         </p:blipFill>
         <p:spPr>
           <a:xfrm>
-            <a:off x="640080" y="4114800"/>
+            <a:off x="640080" y="4206240"/>
             <a:ext cx="1093670" cy="411480"/>
           </a:xfrm>
           <a:prstGeom prst="rect">
@@ -5077,7 +5029,7 @@
         </p:blipFill>
         <p:spPr>
           <a:xfrm>
-            <a:off x="6461607" y="2514600"/>
+            <a:off x="6461607" y="2286000"/>
             <a:ext cx="3060757" cy="475488"/>
           </a:xfrm>
           <a:prstGeom prst="rect">
@@ -5093,7 +5045,7 @@
         </p:nvSpPr>
         <p:spPr>
           <a:xfrm>
-            <a:off x="6370167" y="3154680"/>
+            <a:off x="6370167" y="3337560"/>
             <a:ext cx="5181447" cy="320040"/>
           </a:xfrm>
           <a:prstGeom prst="rect">
@@ -5141,7 +5093,7 @@
         </p:blipFill>
         <p:spPr>
           <a:xfrm>
-            <a:off x="6461607" y="3566160"/>
+            <a:off x="6461607" y="3749039"/>
             <a:ext cx="2193902" cy="457200"/>
           </a:xfrm>
           <a:prstGeom prst="rect">
@@ -5165,7 +5117,7 @@
         </p:blipFill>
         <p:spPr>
           <a:xfrm>
-            <a:off x="6461607" y="4160520"/>
+            <a:off x="6461607" y="4389120"/>
             <a:ext cx="770708" cy="365760"/>
           </a:xfrm>
           <a:prstGeom prst="rect">
@@ -5181,7 +5133,7 @@
         </p:nvSpPr>
         <p:spPr>
           <a:xfrm>
-            <a:off x="6370167" y="4709160"/>
+            <a:off x="6370167" y="5074920"/>
             <a:ext cx="5181447" cy="1371600"/>
           </a:xfrm>
           <a:prstGeom prst="rect">
@@ -5984,7 +5936,7 @@
               </a:defRPr>
             </a:pPr>
             <a:r>
-              <a:t>Suposiciones Ficas Justificadas</a:t>
+              <a:t>Suposiciones Físicas Justificadas</a:t>
             </a:r>
           </a:p>
         </p:txBody>
@@ -7174,7 +7126,7 @@
         </p:nvSpPr>
         <p:spPr>
           <a:xfrm>
-            <a:off x="548640" y="2880360"/>
+            <a:off x="548640" y="3017520"/>
             <a:ext cx="5181447" cy="2743200"/>
           </a:xfrm>
           <a:prstGeom prst="rect">
@@ -11562,7 +11514,7 @@
         </p:nvSpPr>
         <p:spPr>
           <a:xfrm>
-            <a:off x="548640" y="2606040"/>
+            <a:off x="548640" y="2743200"/>
             <a:ext cx="5181447" cy="320040"/>
           </a:xfrm>
           <a:prstGeom prst="rect">
@@ -11626,7 +11578,7 @@
         </p:blipFill>
         <p:spPr>
           <a:xfrm>
-            <a:off x="640080" y="3017520"/>
+            <a:off x="640080" y="3154680"/>
             <a:ext cx="5029200" cy="282792"/>
           </a:xfrm>
           <a:prstGeom prst="rect">
@@ -11642,7 +11594,7 @@
         </p:nvSpPr>
         <p:spPr>
           <a:xfrm>
-            <a:off x="548640" y="3840480"/>
+            <a:off x="548640" y="4069080"/>
             <a:ext cx="5181447" cy="1828800"/>
           </a:xfrm>
           <a:prstGeom prst="rect">
@@ -12434,7 +12386,7 @@
         </p:nvSpPr>
         <p:spPr>
           <a:xfrm>
-            <a:off x="548640" y="3474720"/>
+            <a:off x="548640" y="3611880"/>
             <a:ext cx="5181447" cy="2286000"/>
           </a:xfrm>
           <a:prstGeom prst="rect">
@@ -12700,7 +12652,7 @@
         </p:blipFill>
         <p:spPr>
           <a:xfrm>
-            <a:off x="6461607" y="2240280"/>
+            <a:off x="6461607" y="2194560"/>
             <a:ext cx="5029200" cy="333513"/>
           </a:xfrm>
           <a:prstGeom prst="rect">
@@ -12724,7 +12676,7 @@
         </p:blipFill>
         <p:spPr>
           <a:xfrm>
-            <a:off x="6461607" y="2743200"/>
+            <a:off x="6461607" y="2788920"/>
             <a:ext cx="3687419" cy="438912"/>
           </a:xfrm>
           <a:prstGeom prst="rect">
@@ -12740,7 +12692,7 @@
         </p:nvSpPr>
         <p:spPr>
           <a:xfrm>
-            <a:off x="6370167" y="3749039"/>
+            <a:off x="6370167" y="3931920"/>
             <a:ext cx="5181447" cy="2743200"/>
           </a:xfrm>
           <a:prstGeom prst="rect">
@@ -13444,7 +13396,7 @@
         </p:nvSpPr>
         <p:spPr>
           <a:xfrm>
-            <a:off x="548640" y="2926080"/>
+            <a:off x="548640" y="3017520"/>
             <a:ext cx="5181447" cy="2743200"/>
           </a:xfrm>
           <a:prstGeom prst="rect">

</xml_diff>

<commit_message>
Support rich formatting (superscripts) inside slide and panel titles
</commit_message>
<xml_diff>
--- a/output/Presentacion_Final_ELI556_Atacama.pptx
+++ b/output/Presentacion_Final_ELI556_Atacama.pptx
@@ -3339,14 +3339,27 @@
           <a:lstStyle/>
           <a:p>
             <a:pPr>
-              <a:defRPr b="1" sz="2800">
-                <a:solidFill>
-                  <a:srgbClr val="E8A838"/>
-                </a:solidFill>
-              </a:defRPr>
-            </a:pPr>
-            <a:r>
-              <a:t>Modelo de 5 Parámetros: Diodo Simple (SDM) ^[1]^</a:t>
+              <a:defRPr sz="2800">
+                <a:solidFill>
+                  <a:srgbClr val="E8A838"/>
+                </a:solidFill>
+              </a:defRPr>
+            </a:pPr>
+            <a:r>
+              <a:rPr sz="2800" b="1">
+                <a:solidFill>
+                  <a:srgbClr val="E8A838"/>
+                </a:solidFill>
+              </a:rPr>
+              <a:t>Modelo de 5 Parámetros: Diodo Simple (SDM) </a:t>
+            </a:r>
+            <a:r>
+              <a:rPr sz="2800" b="1">
+                <a:solidFill>
+                  <a:srgbClr val="E8A838"/>
+                </a:solidFill>
+              </a:rPr>
+              <a:t>[1]</a:t>
             </a:r>
           </a:p>
         </p:txBody>
@@ -3405,7 +3418,7 @@
         <p:spPr>
           <a:xfrm>
             <a:off x="457200" y="1188720"/>
-            <a:ext cx="5364327" cy="365760"/>
+            <a:ext cx="5364327" cy="411480"/>
           </a:xfrm>
           <a:prstGeom prst="rect">
             <a:avLst/>
@@ -3419,13 +3432,18 @@
           <a:lstStyle/>
           <a:p>
             <a:pPr>
-              <a:defRPr b="1" sz="1800">
-                <a:solidFill>
-                  <a:srgbClr val="E8A838"/>
-                </a:solidFill>
-              </a:defRPr>
-            </a:pPr>
-            <a:r>
+              <a:defRPr sz="1800">
+                <a:solidFill>
+                  <a:srgbClr val="E8A838"/>
+                </a:solidFill>
+              </a:defRPr>
+            </a:pPr>
+            <a:r>
+              <a:rPr sz="1800" b="1">
+                <a:solidFill>
+                  <a:srgbClr val="E8A838"/>
+                </a:solidFill>
+              </a:rPr>
               <a:t>Ecuación del Circuito Equivalente</a:t>
             </a:r>
           </a:p>
@@ -3629,7 +3647,7 @@
         <p:spPr>
           <a:xfrm>
             <a:off x="6278727" y="1188720"/>
-            <a:ext cx="5364327" cy="365760"/>
+            <a:ext cx="5364327" cy="411480"/>
           </a:xfrm>
           <a:prstGeom prst="rect">
             <a:avLst/>
@@ -3643,13 +3661,18 @@
           <a:lstStyle/>
           <a:p>
             <a:pPr>
-              <a:defRPr b="1" sz="1800">
-                <a:solidFill>
-                  <a:srgbClr val="E8A838"/>
-                </a:solidFill>
-              </a:defRPr>
-            </a:pPr>
-            <a:r>
+              <a:defRPr sz="1800">
+                <a:solidFill>
+                  <a:srgbClr val="E8A838"/>
+                </a:solidFill>
+              </a:defRPr>
+            </a:pPr>
+            <a:r>
+              <a:rPr sz="1800" b="1">
+                <a:solidFill>
+                  <a:srgbClr val="E8A838"/>
+                </a:solidFill>
+              </a:rPr>
               <a:t>Glosario de Parámetros Físicos</a:t>
             </a:r>
           </a:p>
@@ -4164,13 +4187,18 @@
           <a:lstStyle/>
           <a:p>
             <a:pPr>
-              <a:defRPr b="1" sz="2800">
-                <a:solidFill>
-                  <a:srgbClr val="E8A838"/>
-                </a:solidFill>
-              </a:defRPr>
-            </a:pPr>
-            <a:r>
+              <a:defRPr sz="2800">
+                <a:solidFill>
+                  <a:srgbClr val="E8A838"/>
+                </a:solidFill>
+              </a:defRPr>
+            </a:pPr>
+            <a:r>
+              <a:rPr sz="2800" b="1">
+                <a:solidFill>
+                  <a:srgbClr val="E8A838"/>
+                </a:solidFill>
+              </a:rPr>
               <a:t>Extracción de Parámetros de Referencia</a:t>
             </a:r>
           </a:p>
@@ -4230,7 +4258,7 @@
         <p:spPr>
           <a:xfrm>
             <a:off x="457200" y="1188720"/>
-            <a:ext cx="5364327" cy="365760"/>
+            <a:ext cx="5364327" cy="411480"/>
           </a:xfrm>
           <a:prstGeom prst="rect">
             <a:avLst/>
@@ -4244,13 +4272,18 @@
           <a:lstStyle/>
           <a:p>
             <a:pPr>
-              <a:defRPr b="1" sz="1800">
-                <a:solidFill>
-                  <a:srgbClr val="E8A838"/>
-                </a:solidFill>
-              </a:defRPr>
-            </a:pPr>
-            <a:r>
+              <a:defRPr sz="1800">
+                <a:solidFill>
+                  <a:srgbClr val="E8A838"/>
+                </a:solidFill>
+              </a:defRPr>
+            </a:pPr>
+            <a:r>
+              <a:rPr sz="1800" b="1">
+                <a:solidFill>
+                  <a:srgbClr val="E8A838"/>
+                </a:solidFill>
+              </a:rPr>
               <a:t>Sistema No-Lineal de 5 Ecuaciones</a:t>
             </a:r>
           </a:p>
@@ -4923,7 +4956,7 @@
         <p:spPr>
           <a:xfrm>
             <a:off x="6278727" y="1188720"/>
-            <a:ext cx="5364327" cy="365760"/>
+            <a:ext cx="5364327" cy="411480"/>
           </a:xfrm>
           <a:prstGeom prst="rect">
             <a:avLst/>
@@ -4937,13 +4970,18 @@
           <a:lstStyle/>
           <a:p>
             <a:pPr>
-              <a:defRPr b="1" sz="1800">
-                <a:solidFill>
-                  <a:srgbClr val="E8A838"/>
-                </a:solidFill>
-              </a:defRPr>
-            </a:pPr>
-            <a:r>
+              <a:defRPr sz="1800">
+                <a:solidFill>
+                  <a:srgbClr val="E8A838"/>
+                </a:solidFill>
+              </a:defRPr>
+            </a:pPr>
+            <a:r>
+              <a:rPr sz="1800" b="1">
+                <a:solidFill>
+                  <a:srgbClr val="E8A838"/>
+                </a:solidFill>
+              </a:rPr>
               <a:t>Ecuación de la Derivada Analítica en MPP</a:t>
             </a:r>
           </a:p>
@@ -5313,13 +5351,18 @@
           <a:lstStyle/>
           <a:p>
             <a:pPr>
-              <a:defRPr b="1" sz="2800">
-                <a:solidFill>
-                  <a:srgbClr val="E8A838"/>
-                </a:solidFill>
-              </a:defRPr>
-            </a:pPr>
-            <a:r>
+              <a:defRPr sz="2800">
+                <a:solidFill>
+                  <a:srgbClr val="E8A838"/>
+                </a:solidFill>
+              </a:defRPr>
+            </a:pPr>
+            <a:r>
+              <a:rPr sz="2800" b="1">
+                <a:solidFill>
+                  <a:srgbClr val="E8A838"/>
+                </a:solidFill>
+              </a:rPr>
               <a:t>Escalamiento a Condiciones Reales</a:t>
             </a:r>
           </a:p>
@@ -5379,7 +5422,7 @@
         <p:spPr>
           <a:xfrm>
             <a:off x="457200" y="1188720"/>
-            <a:ext cx="5364327" cy="365760"/>
+            <a:ext cx="5364327" cy="411480"/>
           </a:xfrm>
           <a:prstGeom prst="rect">
             <a:avLst/>
@@ -5393,14 +5436,27 @@
           <a:lstStyle/>
           <a:p>
             <a:pPr>
-              <a:defRPr b="1" sz="1800">
-                <a:solidFill>
-                  <a:srgbClr val="E8A838"/>
-                </a:solidFill>
-              </a:defRPr>
-            </a:pPr>
-            <a:r>
-              <a:t>Dependencias con (G, Tc) de De Soto ^[1]^</a:t>
+              <a:defRPr sz="1800">
+                <a:solidFill>
+                  <a:srgbClr val="E8A838"/>
+                </a:solidFill>
+              </a:defRPr>
+            </a:pPr>
+            <a:r>
+              <a:rPr sz="1800" b="1">
+                <a:solidFill>
+                  <a:srgbClr val="E8A838"/>
+                </a:solidFill>
+              </a:rPr>
+              <a:t>Dependencias con (G, Tc) de De Soto </a:t>
+            </a:r>
+            <a:r>
+              <a:rPr sz="1800" b="1">
+                <a:solidFill>
+                  <a:srgbClr val="E8A838"/>
+                </a:solidFill>
+              </a:rPr>
+              <a:t>[1]</a:t>
             </a:r>
           </a:p>
         </p:txBody>
@@ -5915,7 +5971,7 @@
         <p:spPr>
           <a:xfrm>
             <a:off x="6278727" y="1188720"/>
-            <a:ext cx="5364327" cy="365760"/>
+            <a:ext cx="5364327" cy="411480"/>
           </a:xfrm>
           <a:prstGeom prst="rect">
             <a:avLst/>
@@ -5929,13 +5985,18 @@
           <a:lstStyle/>
           <a:p>
             <a:pPr>
-              <a:defRPr b="1" sz="1800">
-                <a:solidFill>
-                  <a:srgbClr val="E8A838"/>
-                </a:solidFill>
-              </a:defRPr>
-            </a:pPr>
-            <a:r>
+              <a:defRPr sz="1800">
+                <a:solidFill>
+                  <a:srgbClr val="E8A838"/>
+                </a:solidFill>
+              </a:defRPr>
+            </a:pPr>
+            <a:r>
+              <a:rPr sz="1800" b="1">
+                <a:solidFill>
+                  <a:srgbClr val="E8A838"/>
+                </a:solidFill>
+              </a:rPr>
               <a:t>Suposiciones Físicas Justificadas</a:t>
             </a:r>
           </a:p>
@@ -6383,13 +6444,18 @@
           <a:lstStyle/>
           <a:p>
             <a:pPr>
-              <a:defRPr b="1" sz="2800">
-                <a:solidFill>
-                  <a:srgbClr val="E8A838"/>
-                </a:solidFill>
-              </a:defRPr>
-            </a:pPr>
-            <a:r>
+              <a:defRPr sz="2800">
+                <a:solidFill>
+                  <a:srgbClr val="E8A838"/>
+                </a:solidFill>
+              </a:defRPr>
+            </a:pPr>
+            <a:r>
+              <a:rPr sz="2800" b="1">
+                <a:solidFill>
+                  <a:srgbClr val="E8A838"/>
+                </a:solidFill>
+              </a:rPr>
               <a:t>Validación: Reconstrucción Curvas IV en SRC</a:t>
             </a:r>
           </a:p>
@@ -6548,13 +6614,18 @@
           <a:lstStyle/>
           <a:p>
             <a:pPr>
-              <a:defRPr b="1" sz="2800">
-                <a:solidFill>
-                  <a:srgbClr val="E8A838"/>
-                </a:solidFill>
-              </a:defRPr>
-            </a:pPr>
-            <a:r>
+              <a:defRPr sz="2800">
+                <a:solidFill>
+                  <a:srgbClr val="E8A838"/>
+                </a:solidFill>
+              </a:defRPr>
+            </a:pPr>
+            <a:r>
+              <a:rPr sz="2800" b="1">
+                <a:solidFill>
+                  <a:srgbClr val="E8A838"/>
+                </a:solidFill>
+              </a:rPr>
               <a:t>Validación: Potencia Medida vs. Simulada</a:t>
             </a:r>
           </a:p>
@@ -6614,7 +6685,7 @@
         <p:spPr>
           <a:xfrm>
             <a:off x="457200" y="1188720"/>
-            <a:ext cx="5760720" cy="365760"/>
+            <a:ext cx="5760720" cy="411480"/>
           </a:xfrm>
           <a:prstGeom prst="rect">
             <a:avLst/>
@@ -6628,13 +6699,18 @@
           <a:lstStyle/>
           <a:p>
             <a:pPr>
-              <a:defRPr b="1" sz="1800">
-                <a:solidFill>
-                  <a:srgbClr val="E8A838"/>
-                </a:solidFill>
-              </a:defRPr>
-            </a:pPr>
-            <a:r>
+              <a:defRPr sz="1800">
+                <a:solidFill>
+                  <a:srgbClr val="E8A838"/>
+                </a:solidFill>
+              </a:defRPr>
+            </a:pPr>
+            <a:r>
+              <a:rPr sz="1800" b="1">
+                <a:solidFill>
+                  <a:srgbClr val="E8A838"/>
+                </a:solidFill>
+              </a:rPr>
               <a:t>Correlación de Potencia</a:t>
             </a:r>
           </a:p>
@@ -6718,7 +6794,7 @@
         <p:spPr>
           <a:xfrm>
             <a:off x="6492240" y="1188720"/>
-            <a:ext cx="5212080" cy="365760"/>
+            <a:ext cx="5212080" cy="411480"/>
           </a:xfrm>
           <a:prstGeom prst="rect">
             <a:avLst/>
@@ -6732,13 +6808,18 @@
           <a:lstStyle/>
           <a:p>
             <a:pPr>
-              <a:defRPr b="1" sz="1800">
-                <a:solidFill>
-                  <a:srgbClr val="E8A838"/>
-                </a:solidFill>
-              </a:defRPr>
-            </a:pPr>
-            <a:r>
+              <a:defRPr sz="1800">
+                <a:solidFill>
+                  <a:srgbClr val="E8A838"/>
+                </a:solidFill>
+              </a:defRPr>
+            </a:pPr>
+            <a:r>
+              <a:rPr sz="1800" b="1">
+                <a:solidFill>
+                  <a:srgbClr val="E8A838"/>
+                </a:solidFill>
+              </a:rPr>
               <a:t>Métricas de Ajuste</a:t>
             </a:r>
           </a:p>
@@ -6946,13 +7027,18 @@
           <a:lstStyle/>
           <a:p>
             <a:pPr>
-              <a:defRPr b="1" sz="2800">
-                <a:solidFill>
-                  <a:srgbClr val="E8A838"/>
-                </a:solidFill>
-              </a:defRPr>
-            </a:pPr>
-            <a:r>
+              <a:defRPr sz="2800">
+                <a:solidFill>
+                  <a:srgbClr val="E8A838"/>
+                </a:solidFill>
+              </a:defRPr>
+            </a:pPr>
+            <a:r>
+              <a:rPr sz="2800" b="1">
+                <a:solidFill>
+                  <a:srgbClr val="E8A838"/>
+                </a:solidFill>
+              </a:rPr>
               <a:t>Performance Ratio: Evaluación de Desempeño</a:t>
             </a:r>
           </a:p>
@@ -7012,7 +7098,7 @@
         <p:spPr>
           <a:xfrm>
             <a:off x="457200" y="1188720"/>
-            <a:ext cx="5364327" cy="365760"/>
+            <a:ext cx="5364327" cy="411480"/>
           </a:xfrm>
           <a:prstGeom prst="rect">
             <a:avLst/>
@@ -7026,13 +7112,18 @@
           <a:lstStyle/>
           <a:p>
             <a:pPr>
-              <a:defRPr b="1" sz="1800">
-                <a:solidFill>
-                  <a:srgbClr val="E8A838"/>
-                </a:solidFill>
-              </a:defRPr>
-            </a:pPr>
-            <a:r>
+              <a:defRPr sz="1800">
+                <a:solidFill>
+                  <a:srgbClr val="E8A838"/>
+                </a:solidFill>
+              </a:defRPr>
+            </a:pPr>
+            <a:r>
+              <a:rPr sz="1800" b="1">
+                <a:solidFill>
+                  <a:srgbClr val="E8A838"/>
+                </a:solidFill>
+              </a:rPr>
               <a:t>Ecuación Matemática del PR</a:t>
             </a:r>
           </a:p>
@@ -7368,7 +7459,7 @@
         <p:spPr>
           <a:xfrm>
             <a:off x="6278727" y="1188720"/>
-            <a:ext cx="5364327" cy="365760"/>
+            <a:ext cx="5364327" cy="411480"/>
           </a:xfrm>
           <a:prstGeom prst="rect">
             <a:avLst/>
@@ -7382,13 +7473,18 @@
           <a:lstStyle/>
           <a:p>
             <a:pPr>
-              <a:defRPr b="1" sz="1800">
-                <a:solidFill>
-                  <a:srgbClr val="E8A838"/>
-                </a:solidFill>
-              </a:defRPr>
-            </a:pPr>
-            <a:r>
+              <a:defRPr sz="1800">
+                <a:solidFill>
+                  <a:srgbClr val="E8A838"/>
+                </a:solidFill>
+              </a:defRPr>
+            </a:pPr>
+            <a:r>
+              <a:rPr sz="1800" b="1">
+                <a:solidFill>
+                  <a:srgbClr val="E8A838"/>
+                </a:solidFill>
+              </a:rPr>
               <a:t>Significado Físico del PR</a:t>
             </a:r>
           </a:p>
@@ -7702,13 +7798,18 @@
           <a:lstStyle/>
           <a:p>
             <a:pPr>
-              <a:defRPr b="1" sz="2800">
-                <a:solidFill>
-                  <a:srgbClr val="E8A838"/>
-                </a:solidFill>
-              </a:defRPr>
-            </a:pPr>
-            <a:r>
+              <a:defRPr sz="2800">
+                <a:solidFill>
+                  <a:srgbClr val="E8A838"/>
+                </a:solidFill>
+              </a:defRPr>
+            </a:pPr>
+            <a:r>
+              <a:rPr sz="2800" b="1">
+                <a:solidFill>
+                  <a:srgbClr val="E8A838"/>
+                </a:solidFill>
+              </a:rPr>
               <a:t>Resultados: Performance Ratio Mensual</a:t>
             </a:r>
           </a:p>
@@ -7867,13 +7968,18 @@
           <a:lstStyle/>
           <a:p>
             <a:pPr>
-              <a:defRPr b="1" sz="2800">
-                <a:solidFill>
-                  <a:srgbClr val="E8A838"/>
-                </a:solidFill>
-              </a:defRPr>
-            </a:pPr>
-            <a:r>
+              <a:defRPr sz="2800">
+                <a:solidFill>
+                  <a:srgbClr val="E8A838"/>
+                </a:solidFill>
+              </a:defRPr>
+            </a:pPr>
+            <a:r>
+              <a:rPr sz="2800" b="1">
+                <a:solidFill>
+                  <a:srgbClr val="E8A838"/>
+                </a:solidFill>
+              </a:rPr>
               <a:t>Análisis: Sensibilidad Térmica Realizada</a:t>
             </a:r>
           </a:p>
@@ -7933,7 +8039,7 @@
         <p:spPr>
           <a:xfrm>
             <a:off x="457200" y="1188720"/>
-            <a:ext cx="7132320" cy="365760"/>
+            <a:ext cx="7132320" cy="411480"/>
           </a:xfrm>
           <a:prstGeom prst="rect">
             <a:avLst/>
@@ -7947,13 +8053,18 @@
           <a:lstStyle/>
           <a:p>
             <a:pPr>
-              <a:defRPr b="1" sz="1800">
-                <a:solidFill>
-                  <a:srgbClr val="E8A838"/>
-                </a:solidFill>
-              </a:defRPr>
-            </a:pPr>
-            <a:r>
+              <a:defRPr sz="1800">
+                <a:solidFill>
+                  <a:srgbClr val="E8A838"/>
+                </a:solidFill>
+              </a:defRPr>
+            </a:pPr>
+            <a:r>
+              <a:rPr sz="1800" b="1">
+                <a:solidFill>
+                  <a:srgbClr val="E8A838"/>
+                </a:solidFill>
+              </a:rPr>
               <a:t>Normalización por Potencia Nominal</a:t>
             </a:r>
           </a:p>
@@ -8037,7 +8148,7 @@
         <p:spPr>
           <a:xfrm>
             <a:off x="7680960" y="1188720"/>
-            <a:ext cx="4023360" cy="365760"/>
+            <a:ext cx="4023360" cy="411480"/>
           </a:xfrm>
           <a:prstGeom prst="rect">
             <a:avLst/>
@@ -8051,13 +8162,18 @@
           <a:lstStyle/>
           <a:p>
             <a:pPr>
-              <a:defRPr b="1" sz="1800">
-                <a:solidFill>
-                  <a:srgbClr val="E8A838"/>
-                </a:solidFill>
-              </a:defRPr>
-            </a:pPr>
-            <a:r>
+              <a:defRPr sz="1800">
+                <a:solidFill>
+                  <a:srgbClr val="E8A838"/>
+                </a:solidFill>
+              </a:defRPr>
+            </a:pPr>
+            <a:r>
+              <a:rPr sz="1800" b="1">
+                <a:solidFill>
+                  <a:srgbClr val="E8A838"/>
+                </a:solidFill>
+              </a:rPr>
               <a:t>Observación Científica</a:t>
             </a:r>
           </a:p>
@@ -8213,13 +8329,18 @@
           <a:lstStyle/>
           <a:p>
             <a:pPr>
-              <a:defRPr b="1" sz="2800">
-                <a:solidFill>
-                  <a:srgbClr val="E8A838"/>
-                </a:solidFill>
-              </a:defRPr>
-            </a:pPr>
-            <a:r>
+              <a:defRPr sz="2800">
+                <a:solidFill>
+                  <a:srgbClr val="E8A838"/>
+                </a:solidFill>
+              </a:defRPr>
+            </a:pPr>
+            <a:r>
+              <a:rPr sz="2800" b="1">
+                <a:solidFill>
+                  <a:srgbClr val="E8A838"/>
+                </a:solidFill>
+              </a:rPr>
               <a:t>Resultados Anuales: m-Si vs. HIT en Atacama</a:t>
             </a:r>
           </a:p>
@@ -8279,7 +8400,7 @@
         <p:spPr>
           <a:xfrm>
             <a:off x="457200" y="1188720"/>
-            <a:ext cx="5364327" cy="365760"/>
+            <a:ext cx="5364327" cy="411480"/>
           </a:xfrm>
           <a:prstGeom prst="rect">
             <a:avLst/>
@@ -8293,13 +8414,18 @@
           <a:lstStyle/>
           <a:p>
             <a:pPr>
-              <a:defRPr b="1" sz="1800">
-                <a:solidFill>
-                  <a:srgbClr val="E8A838"/>
-                </a:solidFill>
-              </a:defRPr>
-            </a:pPr>
-            <a:r>
+              <a:defRPr sz="1800">
+                <a:solidFill>
+                  <a:srgbClr val="E8A838"/>
+                </a:solidFill>
+              </a:defRPr>
+            </a:pPr>
+            <a:r>
+              <a:rPr sz="1800" b="1">
+                <a:solidFill>
+                  <a:srgbClr val="E8A838"/>
+                </a:solidFill>
+              </a:rPr>
               <a:t>Veredicto Técnico</a:t>
             </a:r>
           </a:p>
@@ -8493,7 +8619,7 @@
         <p:spPr>
           <a:xfrm>
             <a:off x="6278727" y="1188720"/>
-            <a:ext cx="5364327" cy="365760"/>
+            <a:ext cx="5364327" cy="411480"/>
           </a:xfrm>
           <a:prstGeom prst="rect">
             <a:avLst/>
@@ -8507,13 +8633,18 @@
           <a:lstStyle/>
           <a:p>
             <a:pPr>
-              <a:defRPr b="1" sz="1800">
-                <a:solidFill>
-                  <a:srgbClr val="E8A838"/>
-                </a:solidFill>
-              </a:defRPr>
-            </a:pPr>
-            <a:r>
+              <a:defRPr sz="1800">
+                <a:solidFill>
+                  <a:srgbClr val="E8A838"/>
+                </a:solidFill>
+              </a:defRPr>
+            </a:pPr>
+            <a:r>
+              <a:rPr sz="1800" b="1">
+                <a:solidFill>
+                  <a:srgbClr val="E8A838"/>
+                </a:solidFill>
+              </a:rPr>
               <a:t>Impacto en Proyectos a Gran Escala</a:t>
             </a:r>
           </a:p>
@@ -8721,13 +8852,18 @@
           <a:lstStyle/>
           <a:p>
             <a:pPr>
-              <a:defRPr b="1" sz="2800">
-                <a:solidFill>
-                  <a:srgbClr val="E8A838"/>
-                </a:solidFill>
-              </a:defRPr>
-            </a:pPr>
-            <a:r>
+              <a:defRPr sz="2800">
+                <a:solidFill>
+                  <a:srgbClr val="E8A838"/>
+                </a:solidFill>
+              </a:defRPr>
+            </a:pPr>
+            <a:r>
+              <a:rPr sz="2800" b="1">
+                <a:solidFill>
+                  <a:srgbClr val="E8A838"/>
+                </a:solidFill>
+              </a:rPr>
               <a:t>Conclusiones y Proyecciones</a:t>
             </a:r>
           </a:p>
@@ -8787,7 +8923,7 @@
         <p:spPr>
           <a:xfrm>
             <a:off x="457200" y="1188720"/>
-            <a:ext cx="5364327" cy="365760"/>
+            <a:ext cx="5364327" cy="411480"/>
           </a:xfrm>
           <a:prstGeom prst="rect">
             <a:avLst/>
@@ -8801,13 +8937,18 @@
           <a:lstStyle/>
           <a:p>
             <a:pPr>
-              <a:defRPr b="1" sz="1800">
-                <a:solidFill>
-                  <a:srgbClr val="E8A838"/>
-                </a:solidFill>
-              </a:defRPr>
-            </a:pPr>
-            <a:r>
+              <a:defRPr sz="1800">
+                <a:solidFill>
+                  <a:srgbClr val="E8A838"/>
+                </a:solidFill>
+              </a:defRPr>
+            </a:pPr>
+            <a:r>
+              <a:rPr sz="1800" b="1">
+                <a:solidFill>
+                  <a:srgbClr val="E8A838"/>
+                </a:solidFill>
+              </a:rPr>
               <a:t>Conclusiones del Estudio</a:t>
             </a:r>
           </a:p>
@@ -9001,7 +9142,7 @@
         <p:spPr>
           <a:xfrm>
             <a:off x="6278727" y="1188720"/>
-            <a:ext cx="5364327" cy="365760"/>
+            <a:ext cx="5364327" cy="411480"/>
           </a:xfrm>
           <a:prstGeom prst="rect">
             <a:avLst/>
@@ -9015,13 +9156,18 @@
           <a:lstStyle/>
           <a:p>
             <a:pPr>
-              <a:defRPr b="1" sz="1800">
-                <a:solidFill>
-                  <a:srgbClr val="E8A838"/>
-                </a:solidFill>
-              </a:defRPr>
-            </a:pPr>
-            <a:r>
+              <a:defRPr sz="1800">
+                <a:solidFill>
+                  <a:srgbClr val="E8A838"/>
+                </a:solidFill>
+              </a:defRPr>
+            </a:pPr>
+            <a:r>
+              <a:rPr sz="1800" b="1">
+                <a:solidFill>
+                  <a:srgbClr val="E8A838"/>
+                </a:solidFill>
+              </a:rPr>
               <a:t>Trabajos Futuros</a:t>
             </a:r>
           </a:p>
@@ -9245,13 +9391,18 @@
           <a:lstStyle/>
           <a:p>
             <a:pPr>
-              <a:defRPr b="1" sz="2800">
-                <a:solidFill>
-                  <a:srgbClr val="E8A838"/>
-                </a:solidFill>
-              </a:defRPr>
-            </a:pPr>
-            <a:r>
+              <a:defRPr sz="2800">
+                <a:solidFill>
+                  <a:srgbClr val="E8A838"/>
+                </a:solidFill>
+              </a:defRPr>
+            </a:pPr>
+            <a:r>
+              <a:rPr sz="2800" b="1">
+                <a:solidFill>
+                  <a:srgbClr val="E8A838"/>
+                </a:solidFill>
+              </a:rPr>
               <a:t>¿Por qué el Desierto de Atacama?</a:t>
             </a:r>
           </a:p>
@@ -9311,7 +9462,7 @@
         <p:spPr>
           <a:xfrm>
             <a:off x="457200" y="1188720"/>
-            <a:ext cx="5364327" cy="365760"/>
+            <a:ext cx="5364327" cy="411480"/>
           </a:xfrm>
           <a:prstGeom prst="rect">
             <a:avLst/>
@@ -9325,13 +9476,18 @@
           <a:lstStyle/>
           <a:p>
             <a:pPr>
-              <a:defRPr b="1" sz="1800">
-                <a:solidFill>
-                  <a:srgbClr val="E8A838"/>
-                </a:solidFill>
-              </a:defRPr>
-            </a:pPr>
-            <a:r>
+              <a:defRPr sz="1800">
+                <a:solidFill>
+                  <a:srgbClr val="E8A838"/>
+                </a:solidFill>
+              </a:defRPr>
+            </a:pPr>
+            <a:r>
+              <a:rPr sz="1800" b="1">
+                <a:solidFill>
+                  <a:srgbClr val="E8A838"/>
+                </a:solidFill>
+              </a:rPr>
               <a:t>El Recurso Solar más Extremo</a:t>
             </a:r>
           </a:p>
@@ -9509,7 +9665,7 @@
         <p:spPr>
           <a:xfrm>
             <a:off x="6278727" y="1188720"/>
-            <a:ext cx="5364327" cy="365760"/>
+            <a:ext cx="5364327" cy="411480"/>
           </a:xfrm>
           <a:prstGeom prst="rect">
             <a:avLst/>
@@ -9523,13 +9679,18 @@
           <a:lstStyle/>
           <a:p>
             <a:pPr>
-              <a:defRPr b="1" sz="1800">
-                <a:solidFill>
-                  <a:srgbClr val="E8A838"/>
-                </a:solidFill>
-              </a:defRPr>
-            </a:pPr>
-            <a:r>
+              <a:defRPr sz="1800">
+                <a:solidFill>
+                  <a:srgbClr val="E8A838"/>
+                </a:solidFill>
+              </a:defRPr>
+            </a:pPr>
+            <a:r>
+              <a:rPr sz="1800" b="1">
+                <a:solidFill>
+                  <a:srgbClr val="E8A838"/>
+                </a:solidFill>
+              </a:rPr>
               <a:t>El Desafío Térmico desértico</a:t>
             </a:r>
           </a:p>
@@ -9737,13 +9898,18 @@
           <a:lstStyle/>
           <a:p>
             <a:pPr>
-              <a:defRPr b="1" sz="2800">
-                <a:solidFill>
-                  <a:srgbClr val="E8A838"/>
-                </a:solidFill>
-              </a:defRPr>
-            </a:pPr>
-            <a:r>
+              <a:defRPr sz="2800">
+                <a:solidFill>
+                  <a:srgbClr val="E8A838"/>
+                </a:solidFill>
+              </a:defRPr>
+            </a:pPr>
+            <a:r>
+              <a:rPr sz="2800" b="1">
+                <a:solidFill>
+                  <a:srgbClr val="E8A838"/>
+                </a:solidFill>
+              </a:rPr>
               <a:t>Referencias y Agradecimientos</a:t>
             </a:r>
           </a:p>
@@ -10003,13 +10169,18 @@
           <a:lstStyle/>
           <a:p>
             <a:pPr>
-              <a:defRPr b="1" sz="2800">
-                <a:solidFill>
-                  <a:srgbClr val="E8A838"/>
-                </a:solidFill>
-              </a:defRPr>
-            </a:pPr>
-            <a:r>
+              <a:defRPr sz="2800">
+                <a:solidFill>
+                  <a:srgbClr val="E8A838"/>
+                </a:solidFill>
+              </a:defRPr>
+            </a:pPr>
+            <a:r>
+              <a:rPr sz="2800" b="1">
+                <a:solidFill>
+                  <a:srgbClr val="E8A838"/>
+                </a:solidFill>
+              </a:rPr>
               <a:t>¿Por qué m-Si y HIT? Comparativa de la Base de Datos</a:t>
             </a:r>
           </a:p>
@@ -10069,7 +10240,7 @@
         <p:spPr>
           <a:xfrm>
             <a:off x="457200" y="1188720"/>
-            <a:ext cx="11277295" cy="365760"/>
+            <a:ext cx="11277295" cy="411480"/>
           </a:xfrm>
           <a:prstGeom prst="rect">
             <a:avLst/>
@@ -10083,14 +10254,27 @@
           <a:lstStyle/>
           <a:p>
             <a:pPr>
-              <a:defRPr b="1" sz="1800">
-                <a:solidFill>
-                  <a:srgbClr val="E8A838"/>
-                </a:solidFill>
-              </a:defRPr>
-            </a:pPr>
-            <a:r>
-              <a:t>Familias Tecnológicas en Dataset Cocoa (NREL) ^[5]^</a:t>
+              <a:defRPr sz="1800">
+                <a:solidFill>
+                  <a:srgbClr val="E8A838"/>
+                </a:solidFill>
+              </a:defRPr>
+            </a:pPr>
+            <a:r>
+              <a:rPr sz="1800" b="1">
+                <a:solidFill>
+                  <a:srgbClr val="E8A838"/>
+                </a:solidFill>
+              </a:rPr>
+              <a:t>Familias Tecnológicas en Dataset Cocoa (NREL) </a:t>
+            </a:r>
+            <a:r>
+              <a:rPr sz="1800" b="1">
+                <a:solidFill>
+                  <a:srgbClr val="E8A838"/>
+                </a:solidFill>
+              </a:rPr>
+              <a:t>[5]</a:t>
             </a:r>
           </a:p>
         </p:txBody>
@@ -10910,13 +11094,18 @@
           <a:lstStyle/>
           <a:p>
             <a:pPr>
-              <a:defRPr b="1" sz="2800">
-                <a:solidFill>
-                  <a:srgbClr val="E8A838"/>
-                </a:solidFill>
-              </a:defRPr>
-            </a:pPr>
-            <a:r>
+              <a:defRPr sz="2800">
+                <a:solidFill>
+                  <a:srgbClr val="E8A838"/>
+                </a:solidFill>
+              </a:defRPr>
+            </a:pPr>
+            <a:r>
+              <a:rPr sz="2800" b="1">
+                <a:solidFill>
+                  <a:srgbClr val="E8A838"/>
+                </a:solidFill>
+              </a:rPr>
               <a:t>Metodología: Pipeline de Simulación</a:t>
             </a:r>
           </a:p>
@@ -10976,7 +11165,7 @@
         <p:spPr>
           <a:xfrm>
             <a:off x="457200" y="1188720"/>
-            <a:ext cx="11277295" cy="365760"/>
+            <a:ext cx="11277295" cy="411480"/>
           </a:xfrm>
           <a:prstGeom prst="rect">
             <a:avLst/>
@@ -10990,13 +11179,18 @@
           <a:lstStyle/>
           <a:p>
             <a:pPr>
-              <a:defRPr b="1" sz="1800">
-                <a:solidFill>
-                  <a:srgbClr val="E8A838"/>
-                </a:solidFill>
-              </a:defRPr>
-            </a:pPr>
-            <a:r>
+              <a:defRPr sz="1800">
+                <a:solidFill>
+                  <a:srgbClr val="E8A838"/>
+                </a:solidFill>
+              </a:defRPr>
+            </a:pPr>
+            <a:r>
+              <a:rPr sz="1800" b="1">
+                <a:solidFill>
+                  <a:srgbClr val="E8A838"/>
+                </a:solidFill>
+              </a:rPr>
               <a:t>Flujo de Procesamiento Automatizado</a:t>
             </a:r>
           </a:p>
@@ -11334,13 +11528,18 @@
           <a:lstStyle/>
           <a:p>
             <a:pPr>
-              <a:defRPr b="1" sz="2800">
-                <a:solidFill>
-                  <a:srgbClr val="E8A838"/>
-                </a:solidFill>
-              </a:defRPr>
-            </a:pPr>
-            <a:r>
+              <a:defRPr sz="2800">
+                <a:solidFill>
+                  <a:srgbClr val="E8A838"/>
+                </a:solidFill>
+              </a:defRPr>
+            </a:pPr>
+            <a:r>
+              <a:rPr sz="2800" b="1">
+                <a:solidFill>
+                  <a:srgbClr val="E8A838"/>
+                </a:solidFill>
+              </a:rPr>
               <a:t>Recurso Solar: Transposición y Absorción</a:t>
             </a:r>
           </a:p>
@@ -11400,7 +11599,7 @@
         <p:spPr>
           <a:xfrm>
             <a:off x="457200" y="1188720"/>
-            <a:ext cx="5364327" cy="365760"/>
+            <a:ext cx="5364327" cy="411480"/>
           </a:xfrm>
           <a:prstGeom prst="rect">
             <a:avLst/>
@@ -11414,13 +11613,18 @@
           <a:lstStyle/>
           <a:p>
             <a:pPr>
-              <a:defRPr b="1" sz="1800">
-                <a:solidFill>
-                  <a:srgbClr val="E8A838"/>
-                </a:solidFill>
-              </a:defRPr>
-            </a:pPr>
-            <a:r>
+              <a:defRPr sz="1800">
+                <a:solidFill>
+                  <a:srgbClr val="E8A838"/>
+                </a:solidFill>
+              </a:defRPr>
+            </a:pPr>
+            <a:r>
+              <a:rPr sz="1800" b="1">
+                <a:solidFill>
+                  <a:srgbClr val="E8A838"/>
+                </a:solidFill>
+              </a:rPr>
               <a:t>Fórmulas POA (Perez) y Absorción</a:t>
             </a:r>
           </a:p>
@@ -11728,7 +11932,7 @@
         <p:spPr>
           <a:xfrm>
             <a:off x="6278727" y="1188720"/>
-            <a:ext cx="5364327" cy="365760"/>
+            <a:ext cx="5364327" cy="411480"/>
           </a:xfrm>
           <a:prstGeom prst="rect">
             <a:avLst/>
@@ -11742,13 +11946,18 @@
           <a:lstStyle/>
           <a:p>
             <a:pPr>
-              <a:defRPr b="1" sz="1800">
-                <a:solidFill>
-                  <a:srgbClr val="E8A838"/>
-                </a:solidFill>
-              </a:defRPr>
-            </a:pPr>
-            <a:r>
+              <a:defRPr sz="1800">
+                <a:solidFill>
+                  <a:srgbClr val="E8A838"/>
+                </a:solidFill>
+              </a:defRPr>
+            </a:pPr>
+            <a:r>
+              <a:rPr sz="1800" b="1">
+                <a:solidFill>
+                  <a:srgbClr val="E8A838"/>
+                </a:solidFill>
+              </a:rPr>
               <a:t>Glosario de Términos</a:t>
             </a:r>
           </a:p>
@@ -12174,13 +12383,18 @@
           <a:lstStyle/>
           <a:p>
             <a:pPr>
-              <a:defRPr b="1" sz="2800">
-                <a:solidFill>
-                  <a:srgbClr val="E8A838"/>
-                </a:solidFill>
-              </a:defRPr>
-            </a:pPr>
-            <a:r>
+              <a:defRPr sz="2800">
+                <a:solidFill>
+                  <a:srgbClr val="E8A838"/>
+                </a:solidFill>
+              </a:defRPr>
+            </a:pPr>
+            <a:r>
+              <a:rPr sz="2800" b="1">
+                <a:solidFill>
+                  <a:srgbClr val="E8A838"/>
+                </a:solidFill>
+              </a:rPr>
               <a:t>Modificadores Ópticos: IAM y Masa de Aire</a:t>
             </a:r>
           </a:p>
@@ -12240,7 +12454,7 @@
         <p:spPr>
           <a:xfrm>
             <a:off x="457200" y="1188720"/>
-            <a:ext cx="5364327" cy="365760"/>
+            <a:ext cx="5364327" cy="411480"/>
           </a:xfrm>
           <a:prstGeom prst="rect">
             <a:avLst/>
@@ -12254,14 +12468,27 @@
           <a:lstStyle/>
           <a:p>
             <a:pPr>
-              <a:defRPr b="1" sz="1800">
-                <a:solidFill>
-                  <a:srgbClr val="E8A838"/>
-                </a:solidFill>
-              </a:defRPr>
-            </a:pPr>
-            <a:r>
-              <a:t>Modificador por Ángulo de Incidencia (IAM) ^[2]^</a:t>
+              <a:defRPr sz="1800">
+                <a:solidFill>
+                  <a:srgbClr val="E8A838"/>
+                </a:solidFill>
+              </a:defRPr>
+            </a:pPr>
+            <a:r>
+              <a:rPr sz="1800" b="1">
+                <a:solidFill>
+                  <a:srgbClr val="E8A838"/>
+                </a:solidFill>
+              </a:rPr>
+              <a:t>Modificador por Ángulo de Incidencia (IAM) </a:t>
+            </a:r>
+            <a:r>
+              <a:rPr sz="1800" b="1">
+                <a:solidFill>
+                  <a:srgbClr val="E8A838"/>
+                </a:solidFill>
+              </a:rPr>
+              <a:t>[2]</a:t>
             </a:r>
           </a:p>
         </p:txBody>
@@ -12570,7 +12797,7 @@
         <p:spPr>
           <a:xfrm>
             <a:off x="6278727" y="1188720"/>
-            <a:ext cx="5364327" cy="365760"/>
+            <a:ext cx="5364327" cy="411480"/>
           </a:xfrm>
           <a:prstGeom prst="rect">
             <a:avLst/>
@@ -12584,14 +12811,27 @@
           <a:lstStyle/>
           <a:p>
             <a:pPr>
-              <a:defRPr b="1" sz="1800">
-                <a:solidFill>
-                  <a:srgbClr val="E8A838"/>
-                </a:solidFill>
-              </a:defRPr>
-            </a:pPr>
-            <a:r>
-              <a:t>Modificador por Masa de Aire (AM) ^[2]^</a:t>
+              <a:defRPr sz="1800">
+                <a:solidFill>
+                  <a:srgbClr val="E8A838"/>
+                </a:solidFill>
+              </a:defRPr>
+            </a:pPr>
+            <a:r>
+              <a:rPr sz="1800" b="1">
+                <a:solidFill>
+                  <a:srgbClr val="E8A838"/>
+                </a:solidFill>
+              </a:rPr>
+              <a:t>Modificador por Masa de Aire (AM) </a:t>
+            </a:r>
+            <a:r>
+              <a:rPr sz="1800" b="1">
+                <a:solidFill>
+                  <a:srgbClr val="E8A838"/>
+                </a:solidFill>
+              </a:rPr>
+              <a:t>[2]</a:t>
             </a:r>
           </a:p>
         </p:txBody>
@@ -13043,13 +13283,18 @@
           <a:lstStyle/>
           <a:p>
             <a:pPr>
-              <a:defRPr b="1" sz="2800">
-                <a:solidFill>
-                  <a:srgbClr val="E8A838"/>
-                </a:solidFill>
-              </a:defRPr>
-            </a:pPr>
-            <a:r>
+              <a:defRPr sz="2800">
+                <a:solidFill>
+                  <a:srgbClr val="E8A838"/>
+                </a:solidFill>
+              </a:defRPr>
+            </a:pPr>
+            <a:r>
+              <a:rPr sz="2800" b="1">
+                <a:solidFill>
+                  <a:srgbClr val="E8A838"/>
+                </a:solidFill>
+              </a:rPr>
               <a:t>Dinámica Horaria: Irradiancia en Día Despejado</a:t>
             </a:r>
           </a:p>
@@ -13208,14 +13453,27 @@
           <a:lstStyle/>
           <a:p>
             <a:pPr>
-              <a:defRPr b="1" sz="2800">
-                <a:solidFill>
-                  <a:srgbClr val="E8A838"/>
-                </a:solidFill>
-              </a:defRPr>
-            </a:pPr>
-            <a:r>
-              <a:t>Temperatura de Celda (Sandia SAPM) ^[2]^</a:t>
+              <a:defRPr sz="2800">
+                <a:solidFill>
+                  <a:srgbClr val="E8A838"/>
+                </a:solidFill>
+              </a:defRPr>
+            </a:pPr>
+            <a:r>
+              <a:rPr sz="2800" b="1">
+                <a:solidFill>
+                  <a:srgbClr val="E8A838"/>
+                </a:solidFill>
+              </a:rPr>
+              <a:t>Temperatura de Celda (Sandia SAPM) </a:t>
+            </a:r>
+            <a:r>
+              <a:rPr sz="2800" b="1">
+                <a:solidFill>
+                  <a:srgbClr val="E8A838"/>
+                </a:solidFill>
+              </a:rPr>
+              <a:t>[2]</a:t>
             </a:r>
           </a:p>
         </p:txBody>
@@ -13274,7 +13532,7 @@
         <p:spPr>
           <a:xfrm>
             <a:off x="457200" y="1188720"/>
-            <a:ext cx="5364327" cy="365760"/>
+            <a:ext cx="5364327" cy="411480"/>
           </a:xfrm>
           <a:prstGeom prst="rect">
             <a:avLst/>
@@ -13288,13 +13546,18 @@
           <a:lstStyle/>
           <a:p>
             <a:pPr>
-              <a:defRPr b="1" sz="1800">
-                <a:solidFill>
-                  <a:srgbClr val="E8A838"/>
-                </a:solidFill>
-              </a:defRPr>
-            </a:pPr>
-            <a:r>
+              <a:defRPr sz="1800">
+                <a:solidFill>
+                  <a:srgbClr val="E8A838"/>
+                </a:solidFill>
+              </a:defRPr>
+            </a:pPr>
+            <a:r>
+              <a:rPr sz="1800" b="1">
+                <a:solidFill>
+                  <a:srgbClr val="E8A838"/>
+                </a:solidFill>
+              </a:rPr>
               <a:t>Ecuación del Modelo Térmico</a:t>
             </a:r>
           </a:p>
@@ -13694,7 +13957,7 @@
         <p:spPr>
           <a:xfrm>
             <a:off x="6278727" y="1188720"/>
-            <a:ext cx="5364327" cy="365760"/>
+            <a:ext cx="5364327" cy="411480"/>
           </a:xfrm>
           <a:prstGeom prst="rect">
             <a:avLst/>
@@ -13708,13 +13971,18 @@
           <a:lstStyle/>
           <a:p>
             <a:pPr>
-              <a:defRPr b="1" sz="1800">
-                <a:solidFill>
-                  <a:srgbClr val="E8A838"/>
-                </a:solidFill>
-              </a:defRPr>
-            </a:pPr>
-            <a:r>
+              <a:defRPr sz="1800">
+                <a:solidFill>
+                  <a:srgbClr val="E8A838"/>
+                </a:solidFill>
+              </a:defRPr>
+            </a:pPr>
+            <a:r>
+              <a:rPr sz="1800" b="1">
+                <a:solidFill>
+                  <a:srgbClr val="E8A838"/>
+                </a:solidFill>
+              </a:rPr>
               <a:t>Coeficientes por Tecnología</a:t>
             </a:r>
           </a:p>
@@ -14060,13 +14328,18 @@
           <a:lstStyle/>
           <a:p>
             <a:pPr>
-              <a:defRPr b="1" sz="2800">
-                <a:solidFill>
-                  <a:srgbClr val="E8A838"/>
-                </a:solidFill>
-              </a:defRPr>
-            </a:pPr>
-            <a:r>
+              <a:defRPr sz="2800">
+                <a:solidFill>
+                  <a:srgbClr val="E8A838"/>
+                </a:solidFill>
+              </a:defRPr>
+            </a:pPr>
+            <a:r>
+              <a:rPr sz="2800" b="1">
+                <a:solidFill>
+                  <a:srgbClr val="E8A838"/>
+                </a:solidFill>
+              </a:rPr>
               <a:t>Resultados Térmicos: Distribución Anual Tc</a:t>
             </a:r>
           </a:p>
@@ -14126,7 +14399,7 @@
         <p:spPr>
           <a:xfrm>
             <a:off x="457200" y="1188720"/>
-            <a:ext cx="6217920" cy="365760"/>
+            <a:ext cx="6217920" cy="411480"/>
           </a:xfrm>
           <a:prstGeom prst="rect">
             <a:avLst/>
@@ -14140,13 +14413,18 @@
           <a:lstStyle/>
           <a:p>
             <a:pPr>
-              <a:defRPr b="1" sz="1800">
-                <a:solidFill>
-                  <a:srgbClr val="E8A838"/>
-                </a:solidFill>
-              </a:defRPr>
-            </a:pPr>
-            <a:r>
+              <a:defRPr sz="1800">
+                <a:solidFill>
+                  <a:srgbClr val="E8A838"/>
+                </a:solidFill>
+              </a:defRPr>
+            </a:pPr>
+            <a:r>
+              <a:rPr sz="1800" b="1">
+                <a:solidFill>
+                  <a:srgbClr val="E8A838"/>
+                </a:solidFill>
+              </a:rPr>
               <a:t>Distribución de Temperatura de Celda</a:t>
             </a:r>
           </a:p>
@@ -14230,7 +14508,7 @@
         <p:spPr>
           <a:xfrm>
             <a:off x="6949440" y="1188720"/>
-            <a:ext cx="4754880" cy="365760"/>
+            <a:ext cx="4754880" cy="411480"/>
           </a:xfrm>
           <a:prstGeom prst="rect">
             <a:avLst/>
@@ -14244,13 +14522,18 @@
           <a:lstStyle/>
           <a:p>
             <a:pPr>
-              <a:defRPr b="1" sz="1800">
-                <a:solidFill>
-                  <a:srgbClr val="E8A838"/>
-                </a:solidFill>
-              </a:defRPr>
-            </a:pPr>
-            <a:r>
+              <a:defRPr sz="1800">
+                <a:solidFill>
+                  <a:srgbClr val="E8A838"/>
+                </a:solidFill>
+              </a:defRPr>
+            </a:pPr>
+            <a:r>
+              <a:rPr sz="1800" b="1">
+                <a:solidFill>
+                  <a:srgbClr val="E8A838"/>
+                </a:solidFill>
+              </a:rPr>
               <a:t>Comportamiento en Atacama</a:t>
             </a:r>
           </a:p>

</xml_diff>

<commit_message>
Explicitate technology acronym meanings in Slide 3 table
</commit_message>
<xml_diff>
--- a/output/Presentacion_Final_ELI556_Atacama.pptx
+++ b/output/Presentacion_Final_ELI556_Atacama.pptx
@@ -10298,10 +10298,10 @@
                 <a:tableStyleId>{5940675A-B579-460E-94D1-54222C63F5DA}</a:tableStyleId>
               </a:tblPr>
               <a:tblGrid>
-                <a:gridCol w="1828800"/>
+                <a:gridCol w="2377440"/>
                 <a:gridCol w="1097280"/>
                 <a:gridCol w="1645920"/>
-                <a:gridCol w="3931920"/>
+                <a:gridCol w="3383280"/>
                 <a:gridCol w="2560320"/>
               </a:tblGrid>
               <a:tr h="685800">
@@ -10438,6 +10438,18 @@
                         <a:t>m-Si / x-Si</a:t>
                       </a:r>
                     </a:p>
+                    <a:p>
+                      <a:pPr algn="l">
+                        <a:defRPr sz="1400" b="1">
+                          <a:solidFill>
+                            <a:srgbClr val="FFFFFF"/>
+                          </a:solidFill>
+                        </a:defRPr>
+                      </a:pPr>
+                      <a:r>
+                        <a:t>(Silicio Monocristalino / Cristalino)</a:t>
+                      </a:r>
+                    </a:p>
                   </a:txBody>
                   <a:tcPr anchor="ctr">
                     <a:solidFill>
@@ -10553,6 +10565,18 @@
                       </a:pPr>
                       <a:r>
                         <a:t>HIT</a:t>
+                      </a:r>
+                    </a:p>
+                    <a:p>
+                      <a:pPr algn="l">
+                        <a:defRPr sz="1400" b="1">
+                          <a:solidFill>
+                            <a:srgbClr val="FFFFFF"/>
+                          </a:solidFill>
+                        </a:defRPr>
+                      </a:pPr>
+                      <a:r>
+                        <a:t>(Heterounión con Capa Fina Intrínseca)</a:t>
                       </a:r>
                     </a:p>
                   </a:txBody>
@@ -10672,6 +10696,18 @@
                         <a:t>CdTe</a:t>
                       </a:r>
                     </a:p>
+                    <a:p>
+                      <a:pPr algn="l">
+                        <a:defRPr sz="1400" b="1">
+                          <a:solidFill>
+                            <a:srgbClr val="FFFFFF"/>
+                          </a:solidFill>
+                        </a:defRPr>
+                      </a:pPr>
+                      <a:r>
+                        <a:t>(Teluro de Cadmio)</a:t>
+                      </a:r>
+                    </a:p>
                   </a:txBody>
                   <a:tcPr anchor="ctr">
                     <a:solidFill>
@@ -10789,6 +10825,18 @@
                         <a:t>CIGS</a:t>
                       </a:r>
                     </a:p>
+                    <a:p>
+                      <a:pPr algn="l">
+                        <a:defRPr sz="1400" b="1">
+                          <a:solidFill>
+                            <a:srgbClr val="FFFFFF"/>
+                          </a:solidFill>
+                        </a:defRPr>
+                      </a:pPr>
+                      <a:r>
+                        <a:t>(Seleniuro de Cobre, Indio y Galio)</a:t>
+                      </a:r>
+                    </a:p>
                   </a:txBody>
                   <a:tcPr anchor="ctr">
                     <a:solidFill>
@@ -10904,6 +10952,18 @@
                       </a:pPr>
                       <a:r>
                         <a:t>a-Si (Película Fina)</a:t>
+                      </a:r>
+                    </a:p>
+                    <a:p>
+                      <a:pPr algn="l">
+                        <a:defRPr sz="1400" b="1">
+                          <a:solidFill>
+                            <a:srgbClr val="FFFFFF"/>
+                          </a:solidFill>
+                        </a:defRPr>
+                      </a:pPr>
+                      <a:r>
+                        <a:t>(Silicio Amorfo)</a:t>
                       </a:r>
                     </a:p>
                   </a:txBody>

</xml_diff>

<commit_message>
Redesign Slide 5, 6, and 12 layouts for visual symmetry and equation breathing room
</commit_message>
<xml_diff>
--- a/output/Presentacion_Final_ELI556_Atacama.pptx
+++ b/output/Presentacion_Final_ELI556_Atacama.pptx
@@ -5448,7 +5448,7 @@
                   <a:srgbClr val="E8A838"/>
                 </a:solidFill>
               </a:rPr>
-              <a:t>Dependencias con (G, Tc) de De Soto </a:t>
+              <a:t>Corrientes y Factor de Idealidad </a:t>
             </a:r>
             <a:r>
               <a:rPr sz="1800" b="1">
@@ -5496,14 +5496,38 @@
                   <a:srgbClr val="FFFFFF"/>
                 </a:solidFill>
               </a:rPr>
-              <a:t>1. Factor de Idealidad:</a:t>
+              <a:t>1. Corriente Fotogenerada (</a:t>
+            </a:r>
+            <a:r>
+              <a:rPr sz="1500" i="1">
+                <a:solidFill>
+                  <a:srgbClr val="FFFFFF"/>
+                </a:solidFill>
+              </a:rPr>
+              <a:t>I</a:t>
+            </a:r>
+            <a:r>
+              <a:rPr sz="1500" i="1">
+                <a:solidFill>
+                  <a:srgbClr val="FFFFFF"/>
+                </a:solidFill>
+              </a:rPr>
+              <a:t>L</a:t>
+            </a:r>
+            <a:r>
+              <a:rPr sz="1500">
+                <a:solidFill>
+                  <a:srgbClr val="FFFFFF"/>
+                </a:solidFill>
+              </a:rPr>
+              <a:t>):</a:t>
             </a:r>
           </a:p>
         </p:txBody>
       </p:sp>
       <p:pic>
         <p:nvPicPr>
-          <p:cNvPr id="6" name="Picture 5" descr="eq_4d3e1415cb08b8bc20f12f74abe8552d.png"/>
+          <p:cNvPr id="6" name="Picture 5" descr="eq_ff8bf6d291204b91b8f99a74fbb13960.png"/>
           <p:cNvPicPr>
             <a:picLocks noChangeAspect="1"/>
           </p:cNvPicPr>
@@ -5518,7 +5542,7 @@
         <p:spPr>
           <a:xfrm>
             <a:off x="640080" y="1874519"/>
-            <a:ext cx="693420" cy="320040"/>
+            <a:ext cx="4260506" cy="347472"/>
           </a:xfrm>
           <a:prstGeom prst="rect">
             <a:avLst/>
@@ -5533,7 +5557,7 @@
         </p:nvSpPr>
         <p:spPr>
           <a:xfrm>
-            <a:off x="548640" y="2240280"/>
+            <a:off x="548640" y="2468880"/>
             <a:ext cx="5181447" cy="274320"/>
           </a:xfrm>
           <a:prstGeom prst="rect">
@@ -5605,7 +5629,7 @@
         </p:blipFill>
         <p:spPr>
           <a:xfrm>
-            <a:off x="640080" y="2560320"/>
+            <a:off x="640080" y="2788920"/>
             <a:ext cx="2956947" cy="384048"/>
           </a:xfrm>
           <a:prstGeom prst="rect">
@@ -5621,7 +5645,7 @@
         </p:nvSpPr>
         <p:spPr>
           <a:xfrm>
-            <a:off x="548640" y="3017520"/>
+            <a:off x="548640" y="3474720"/>
             <a:ext cx="5181447" cy="274320"/>
           </a:xfrm>
           <a:prstGeom prst="rect">
@@ -5648,7 +5672,7 @@
                   <a:srgbClr val="FFFFFF"/>
                 </a:solidFill>
               </a:rPr>
-              <a:t>3. Energía de Bandgap (</a:t>
+              <a:t>3. Factor de Idealidad térmico (</a:t>
             </a:r>
             <a:r>
               <a:rPr sz="1500" i="1">
@@ -5656,15 +5680,7 @@
                   <a:srgbClr val="FFFFFF"/>
                 </a:solidFill>
               </a:rPr>
-              <a:t>E</a:t>
-            </a:r>
-            <a:r>
-              <a:rPr sz="1500" i="1">
-                <a:solidFill>
-                  <a:srgbClr val="FFFFFF"/>
-                </a:solidFill>
-              </a:rPr>
-              <a:t>g</a:t>
+              <a:t>a</a:t>
             </a:r>
             <a:r>
               <a:rPr sz="1500">
@@ -5679,7 +5695,7 @@
       </p:sp>
       <p:pic>
         <p:nvPicPr>
-          <p:cNvPr id="10" name="Picture 9" descr="eq_0ed50450f33c4ace764411b1918723c3.png"/>
+          <p:cNvPr id="10" name="Picture 9" descr="eq_4d3e1415cb08b8bc20f12f74abe8552d.png"/>
           <p:cNvPicPr>
             <a:picLocks noChangeAspect="1"/>
           </p:cNvPicPr>
@@ -5693,8 +5709,8 @@
         </p:blipFill>
         <p:spPr>
           <a:xfrm>
-            <a:off x="640080" y="3337560"/>
-            <a:ext cx="2671973" cy="329184"/>
+            <a:off x="640080" y="3794760"/>
+            <a:ext cx="693420" cy="320040"/>
           </a:xfrm>
           <a:prstGeom prst="rect">
             <a:avLst/>
@@ -5709,8 +5725,8 @@
         </p:nvSpPr>
         <p:spPr>
           <a:xfrm>
-            <a:off x="548640" y="3749039"/>
-            <a:ext cx="5181447" cy="274320"/>
+            <a:off x="548640" y="4389120"/>
+            <a:ext cx="5181447" cy="1828800"/>
           </a:xfrm>
           <a:prstGeom prst="rect">
             <a:avLst/>
@@ -5726,200 +5742,130 @@
             <a:pPr algn="l">
               <a:defRPr sz="1500">
                 <a:solidFill>
-                  <a:srgbClr val="FFFFFF"/>
-                </a:solidFill>
-              </a:defRPr>
-            </a:pPr>
-            <a:r>
-              <a:rPr sz="1500">
-                <a:solidFill>
-                  <a:srgbClr val="FFFFFF"/>
-                </a:solidFill>
-              </a:rPr>
-              <a:t>4. Corriente Fotogenerada (</a:t>
+                  <a:srgbClr val="E8A838"/>
+                </a:solidFill>
+              </a:defRPr>
+            </a:pPr>
+            <a:r>
+              <a:rPr sz="1500">
+                <a:solidFill>
+                  <a:srgbClr val="E8A838"/>
+                </a:solidFill>
+              </a:rPr>
+              <a:t>Donde:</a:t>
+            </a:r>
+          </a:p>
+          <a:p>
+            <a:pPr algn="l">
+              <a:defRPr sz="1500">
+                <a:solidFill>
+                  <a:srgbClr val="E8A838"/>
+                </a:solidFill>
+              </a:defRPr>
+            </a:pPr>
+            <a:r>
+              <a:rPr sz="1500">
+                <a:solidFill>
+                  <a:srgbClr val="E8A838"/>
+                </a:solidFill>
+              </a:rPr>
+              <a:t>• </a:t>
             </a:r>
             <a:r>
               <a:rPr sz="1500" i="1">
                 <a:solidFill>
-                  <a:srgbClr val="FFFFFF"/>
-                </a:solidFill>
-              </a:rPr>
-              <a:t>I</a:t>
+                  <a:srgbClr val="E8A838"/>
+                </a:solidFill>
+              </a:rPr>
+              <a:t>T</a:t>
             </a:r>
             <a:r>
               <a:rPr sz="1500" i="1">
                 <a:solidFill>
-                  <a:srgbClr val="FFFFFF"/>
-                </a:solidFill>
-              </a:rPr>
-              <a:t>L</a:t>
-            </a:r>
-            <a:r>
-              <a:rPr sz="1500">
-                <a:solidFill>
-                  <a:srgbClr val="FFFFFF"/>
-                </a:solidFill>
-              </a:rPr>
-              <a:t>):</a:t>
-            </a:r>
-          </a:p>
-        </p:txBody>
-      </p:sp>
-      <p:pic>
-        <p:nvPicPr>
-          <p:cNvPr id="12" name="Picture 11" descr="eq_ff8bf6d291204b91b8f99a74fbb13960.png"/>
-          <p:cNvPicPr>
-            <a:picLocks noChangeAspect="1"/>
-          </p:cNvPicPr>
-          <p:nvPr/>
-        </p:nvPicPr>
-        <p:blipFill>
-          <a:blip r:embed="rId5"/>
-          <a:stretch>
-            <a:fillRect/>
-          </a:stretch>
-        </p:blipFill>
-        <p:spPr>
-          <a:xfrm>
-            <a:off x="640080" y="4069080"/>
-            <a:ext cx="4260506" cy="347472"/>
-          </a:xfrm>
-          <a:prstGeom prst="rect">
-            <a:avLst/>
-          </a:prstGeom>
-        </p:spPr>
-      </p:pic>
-      <p:sp>
-        <p:nvSpPr>
-          <p:cNvPr id="13" name="TextBox 12"/>
-          <p:cNvSpPr txBox="1"/>
-          <p:nvPr/>
-        </p:nvSpPr>
-        <p:spPr>
-          <a:xfrm>
-            <a:off x="548640" y="4480560"/>
-            <a:ext cx="5181447" cy="274320"/>
-          </a:xfrm>
-          <a:prstGeom prst="rect">
-            <a:avLst/>
-          </a:prstGeom>
-          <a:noFill/>
-        </p:spPr>
-        <p:txBody>
-          <a:bodyPr wrap="square">
-            <a:spAutoFit/>
-          </a:bodyPr>
-          <a:lstStyle/>
+                  <a:srgbClr val="E8A838"/>
+                </a:solidFill>
+              </a:rPr>
+              <a:t>ref</a:t>
+            </a:r>
+            <a:r>
+              <a:rPr sz="1500">
+                <a:solidFill>
+                  <a:srgbClr val="E8A838"/>
+                </a:solidFill>
+              </a:rPr>
+              <a:t> = 298.15 K (25°C)  |  </a:t>
+            </a:r>
+            <a:r>
+              <a:rPr sz="1500" i="1">
+                <a:solidFill>
+                  <a:srgbClr val="E8A838"/>
+                </a:solidFill>
+              </a:rPr>
+              <a:t>S</a:t>
+            </a:r>
+            <a:r>
+              <a:rPr sz="1500" i="1">
+                <a:solidFill>
+                  <a:srgbClr val="E8A838"/>
+                </a:solidFill>
+              </a:rPr>
+              <a:t>ref</a:t>
+            </a:r>
+            <a:r>
+              <a:rPr sz="1500">
+                <a:solidFill>
+                  <a:srgbClr val="E8A838"/>
+                </a:solidFill>
+              </a:rPr>
+              <a:t> = 1000 W/m².</a:t>
+            </a:r>
+          </a:p>
           <a:p>
             <a:pPr algn="l">
               <a:defRPr sz="1500">
                 <a:solidFill>
-                  <a:srgbClr val="FFFFFF"/>
-                </a:solidFill>
-              </a:defRPr>
-            </a:pPr>
-            <a:r>
-              <a:rPr sz="1500">
-                <a:solidFill>
-                  <a:srgbClr val="FFFFFF"/>
-                </a:solidFill>
-              </a:rPr>
-              <a:t>5. Resistencia Shunt:</a:t>
-            </a:r>
-          </a:p>
-        </p:txBody>
-      </p:sp>
-      <p:pic>
-        <p:nvPicPr>
-          <p:cNvPr id="14" name="Picture 13" descr="eq_41b6b711a3ee54ec226a0ceb62a105c8.png"/>
-          <p:cNvPicPr>
-            <a:picLocks noChangeAspect="1"/>
-          </p:cNvPicPr>
-          <p:nvPr/>
-        </p:nvPicPr>
-        <p:blipFill>
-          <a:blip r:embed="rId6"/>
-          <a:stretch>
-            <a:fillRect/>
-          </a:stretch>
-        </p:blipFill>
-        <p:spPr>
-          <a:xfrm>
-            <a:off x="640080" y="4800600"/>
-            <a:ext cx="1741270" cy="320040"/>
-          </a:xfrm>
-          <a:prstGeom prst="rect">
-            <a:avLst/>
-          </a:prstGeom>
-        </p:spPr>
-      </p:pic>
-      <p:sp>
-        <p:nvSpPr>
-          <p:cNvPr id="15" name="TextBox 14"/>
-          <p:cNvSpPr txBox="1"/>
-          <p:nvPr/>
-        </p:nvSpPr>
-        <p:spPr>
-          <a:xfrm>
-            <a:off x="548640" y="5212080"/>
-            <a:ext cx="5181447" cy="274320"/>
-          </a:xfrm>
-          <a:prstGeom prst="rect">
-            <a:avLst/>
-          </a:prstGeom>
-          <a:noFill/>
-        </p:spPr>
-        <p:txBody>
-          <a:bodyPr wrap="square">
-            <a:spAutoFit/>
-          </a:bodyPr>
-          <a:lstStyle/>
-          <a:p>
-            <a:pPr algn="l">
-              <a:defRPr sz="1400">
-                <a:solidFill>
-                  <a:srgbClr val="E8A838"/>
-                </a:solidFill>
-              </a:defRPr>
-            </a:pPr>
-            <a:r>
-              <a:rPr sz="1400">
-                <a:solidFill>
-                  <a:srgbClr val="E8A838"/>
-                </a:solidFill>
-              </a:rPr>
-              <a:t>Donde </a:t>
-            </a:r>
-            <a:r>
-              <a:rPr sz="1400" i="1">
-                <a:solidFill>
-                  <a:srgbClr val="E8A838"/>
-                </a:solidFill>
-              </a:rPr>
-              <a:t>E</a:t>
-            </a:r>
-            <a:r>
-              <a:rPr sz="1400" i="1">
-                <a:solidFill>
-                  <a:srgbClr val="E8A838"/>
-                </a:solidFill>
-              </a:rPr>
-              <a:t>g,ref</a:t>
-            </a:r>
-            <a:r>
-              <a:rPr sz="1400">
-                <a:solidFill>
-                  <a:srgbClr val="E8A838"/>
-                </a:solidFill>
-              </a:rPr>
-              <a:t> = 1.121 eV para Silicio a 25°C.</a:t>
-            </a:r>
-          </a:p>
-        </p:txBody>
-      </p:sp>
-      <p:sp>
-        <p:nvSpPr>
-          <p:cNvPr id="16" name="Rectangle 15"/>
+                  <a:srgbClr val="E8A838"/>
+                </a:solidFill>
+              </a:defRPr>
+            </a:pPr>
+            <a:r>
+              <a:rPr sz="1500">
+                <a:solidFill>
+                  <a:srgbClr val="E8A838"/>
+                </a:solidFill>
+              </a:rPr>
+              <a:t>• </a:t>
+            </a:r>
+            <a:r>
+              <a:rPr sz="1500" i="1">
+                <a:solidFill>
+                  <a:srgbClr val="E8A838"/>
+                </a:solidFill>
+              </a:rPr>
+              <a:t>M</a:t>
+            </a:r>
+            <a:r>
+              <a:rPr sz="1500" i="1">
+                <a:solidFill>
+                  <a:srgbClr val="E8A838"/>
+                </a:solidFill>
+              </a:rPr>
+              <a:t>ref</a:t>
+            </a:r>
+            <a:r>
+              <a:rPr sz="1500">
+                <a:solidFill>
+                  <a:srgbClr val="E8A838"/>
+                </a:solidFill>
+              </a:rPr>
+              <a:t>: Transmitancia espectral a STC.</a:t>
+            </a:r>
+          </a:p>
+        </p:txBody>
+      </p:sp>
+      <p:sp>
+        <p:nvSpPr>
+          <p:cNvPr id="12" name="Rectangle 11"/>
           <p:cNvSpPr/>
           <p:nvPr/>
         </p:nvSpPr>
@@ -5964,7 +5910,7 @@
       </p:sp>
       <p:sp>
         <p:nvSpPr>
-          <p:cNvPr id="17" name="TextBox 16"/>
+          <p:cNvPr id="13" name="TextBox 12"/>
           <p:cNvSpPr txBox="1"/>
           <p:nvPr/>
         </p:nvSpPr>
@@ -5997,21 +5943,29 @@
                   <a:srgbClr val="E8A838"/>
                 </a:solidFill>
               </a:rPr>
-              <a:t>Suposiciones Físicas Justificadas</a:t>
-            </a:r>
-          </a:p>
-        </p:txBody>
-      </p:sp>
-      <p:sp>
-        <p:nvSpPr>
-          <p:cNvPr id="18" name="TextBox 17"/>
+              <a:t>Resistencias y Energía de Bandgap </a:t>
+            </a:r>
+            <a:r>
+              <a:rPr sz="1800" b="1">
+                <a:solidFill>
+                  <a:srgbClr val="E8A838"/>
+                </a:solidFill>
+              </a:rPr>
+              <a:t>[1]</a:t>
+            </a:r>
+          </a:p>
+        </p:txBody>
+      </p:sp>
+      <p:sp>
+        <p:nvSpPr>
+          <p:cNvPr id="14" name="TextBox 13"/>
           <p:cNvSpPr txBox="1"/>
           <p:nvPr/>
         </p:nvSpPr>
         <p:spPr>
           <a:xfrm>
-            <a:off x="6370167" y="1645920"/>
-            <a:ext cx="5181447" cy="4114800"/>
+            <a:off x="6370167" y="1554480"/>
+            <a:ext cx="5181447" cy="274320"/>
           </a:xfrm>
           <a:prstGeom prst="rect">
             <a:avLst/>
@@ -6037,6 +5991,199 @@
                   <a:srgbClr val="FFFFFF"/>
                 </a:solidFill>
               </a:rPr>
+              <a:t>4. Resistencia Shunt (</a:t>
+            </a:r>
+            <a:r>
+              <a:rPr sz="1500" i="1">
+                <a:solidFill>
+                  <a:srgbClr val="FFFFFF"/>
+                </a:solidFill>
+              </a:rPr>
+              <a:t>R</a:t>
+            </a:r>
+            <a:r>
+              <a:rPr sz="1500" i="1">
+                <a:solidFill>
+                  <a:srgbClr val="FFFFFF"/>
+                </a:solidFill>
+              </a:rPr>
+              <a:t>sh</a:t>
+            </a:r>
+            <a:r>
+              <a:rPr sz="1500">
+                <a:solidFill>
+                  <a:srgbClr val="FFFFFF"/>
+                </a:solidFill>
+              </a:rPr>
+              <a:t>):</a:t>
+            </a:r>
+          </a:p>
+        </p:txBody>
+      </p:sp>
+      <p:pic>
+        <p:nvPicPr>
+          <p:cNvPr id="15" name="Picture 14" descr="eq_41b6b711a3ee54ec226a0ceb62a105c8.png"/>
+          <p:cNvPicPr>
+            <a:picLocks noChangeAspect="1"/>
+          </p:cNvPicPr>
+          <p:nvPr/>
+        </p:nvPicPr>
+        <p:blipFill>
+          <a:blip r:embed="rId5"/>
+          <a:stretch>
+            <a:fillRect/>
+          </a:stretch>
+        </p:blipFill>
+        <p:spPr>
+          <a:xfrm>
+            <a:off x="6461607" y="1874519"/>
+            <a:ext cx="1741270" cy="320040"/>
+          </a:xfrm>
+          <a:prstGeom prst="rect">
+            <a:avLst/>
+          </a:prstGeom>
+        </p:spPr>
+      </p:pic>
+      <p:sp>
+        <p:nvSpPr>
+          <p:cNvPr id="16" name="TextBox 15"/>
+          <p:cNvSpPr txBox="1"/>
+          <p:nvPr/>
+        </p:nvSpPr>
+        <p:spPr>
+          <a:xfrm>
+            <a:off x="6370167" y="2468880"/>
+            <a:ext cx="5181447" cy="274320"/>
+          </a:xfrm>
+          <a:prstGeom prst="rect">
+            <a:avLst/>
+          </a:prstGeom>
+          <a:noFill/>
+        </p:spPr>
+        <p:txBody>
+          <a:bodyPr wrap="square">
+            <a:spAutoFit/>
+          </a:bodyPr>
+          <a:lstStyle/>
+          <a:p>
+            <a:pPr algn="l">
+              <a:defRPr sz="1500">
+                <a:solidFill>
+                  <a:srgbClr val="FFFFFF"/>
+                </a:solidFill>
+              </a:defRPr>
+            </a:pPr>
+            <a:r>
+              <a:rPr sz="1500">
+                <a:solidFill>
+                  <a:srgbClr val="FFFFFF"/>
+                </a:solidFill>
+              </a:rPr>
+              <a:t>5. Energía de Bandgap del Silicio (</a:t>
+            </a:r>
+            <a:r>
+              <a:rPr sz="1500" i="1">
+                <a:solidFill>
+                  <a:srgbClr val="FFFFFF"/>
+                </a:solidFill>
+              </a:rPr>
+              <a:t>E</a:t>
+            </a:r>
+            <a:r>
+              <a:rPr sz="1500" i="1">
+                <a:solidFill>
+                  <a:srgbClr val="FFFFFF"/>
+                </a:solidFill>
+              </a:rPr>
+              <a:t>g</a:t>
+            </a:r>
+            <a:r>
+              <a:rPr sz="1500">
+                <a:solidFill>
+                  <a:srgbClr val="FFFFFF"/>
+                </a:solidFill>
+              </a:rPr>
+              <a:t>):</a:t>
+            </a:r>
+          </a:p>
+        </p:txBody>
+      </p:sp>
+      <p:pic>
+        <p:nvPicPr>
+          <p:cNvPr id="17" name="Picture 16" descr="eq_0ed50450f33c4ace764411b1918723c3.png"/>
+          <p:cNvPicPr>
+            <a:picLocks noChangeAspect="1"/>
+          </p:cNvPicPr>
+          <p:nvPr/>
+        </p:nvPicPr>
+        <p:blipFill>
+          <a:blip r:embed="rId6"/>
+          <a:stretch>
+            <a:fillRect/>
+          </a:stretch>
+        </p:blipFill>
+        <p:spPr>
+          <a:xfrm>
+            <a:off x="6461607" y="2788920"/>
+            <a:ext cx="2671973" cy="329184"/>
+          </a:xfrm>
+          <a:prstGeom prst="rect">
+            <a:avLst/>
+          </a:prstGeom>
+        </p:spPr>
+      </p:pic>
+      <p:sp>
+        <p:nvSpPr>
+          <p:cNvPr id="18" name="TextBox 17"/>
+          <p:cNvSpPr txBox="1"/>
+          <p:nvPr/>
+        </p:nvSpPr>
+        <p:spPr>
+          <a:xfrm>
+            <a:off x="6370167" y="3474720"/>
+            <a:ext cx="5181447" cy="2743200"/>
+          </a:xfrm>
+          <a:prstGeom prst="rect">
+            <a:avLst/>
+          </a:prstGeom>
+          <a:noFill/>
+        </p:spPr>
+        <p:txBody>
+          <a:bodyPr wrap="square">
+            <a:spAutoFit/>
+          </a:bodyPr>
+          <a:lstStyle/>
+          <a:p>
+            <a:pPr algn="l">
+              <a:defRPr sz="1500">
+                <a:solidFill>
+                  <a:srgbClr val="FFFFFF"/>
+                </a:solidFill>
+              </a:defRPr>
+            </a:pPr>
+            <a:r>
+              <a:rPr sz="1500">
+                <a:solidFill>
+                  <a:srgbClr val="FFFFFF"/>
+                </a:solidFill>
+              </a:rPr>
+              <a:t>Suposiciones Físicas Justificadas:</a:t>
+            </a:r>
+          </a:p>
+          <a:p>
+            <a:pPr algn="l">
+              <a:defRPr sz="1500">
+                <a:solidFill>
+                  <a:srgbClr val="FFFFFF"/>
+                </a:solidFill>
+              </a:defRPr>
+            </a:pPr>
+            <a:r>
+              <a:rPr sz="1500">
+                <a:solidFill>
+                  <a:srgbClr val="FFFFFF"/>
+                </a:solidFill>
+              </a:rPr>
               <a:t>• </a:t>
             </a:r>
             <a:r>
@@ -6126,23 +6273,7 @@
                   <a:srgbClr val="FFFFFF"/>
                 </a:solidFill>
               </a:rPr>
-              <a:t>  Justificación: De Soto (2006)</a:t>
-            </a:r>
-            <a:r>
-              <a:rPr sz="1500">
-                <a:solidFill>
-                  <a:srgbClr val="FFFFFF"/>
-                </a:solidFill>
-              </a:rPr>
-              <a:t>[1]</a:t>
-            </a:r>
-            <a:r>
-              <a:rPr sz="1500">
-                <a:solidFill>
-                  <a:srgbClr val="FFFFFF"/>
-                </a:solidFill>
-              </a:rPr>
-              <a:t> demuestra mediante validaciones contra NIST que la variación térmica de </a:t>
+              <a:t>  La variación térmica de </a:t>
             </a:r>
             <a:r>
               <a:rPr sz="1500" i="1">
@@ -6281,7 +6412,7 @@
                   <a:srgbClr val="FFFFFF"/>
                 </a:solidFill>
               </a:rPr>
-              <a:t> para modelar cómo el aumento de portadores minoritarios abre caminos de fuga paralelos en la celda.</a:t>
+              <a:t> para modelar fugas asociadas a portadores minoritarios.</a:t>
             </a:r>
           </a:p>
           <a:p>
@@ -6315,7 +6446,7 @@
                   <a:srgbClr val="FFFFFF"/>
                 </a:solidFill>
               </a:rPr>
-              <a:t>T</a:t>
+              <a:t>E</a:t>
             </a:r>
             <a:r>
               <a:rPr sz="1500" i="1">
@@ -6323,39 +6454,15 @@
                   <a:srgbClr val="FFFFFF"/>
                 </a:solidFill>
               </a:rPr>
-              <a:t>ref</a:t>
-            </a:r>
-            <a:r>
-              <a:rPr sz="1500">
-                <a:solidFill>
-                  <a:srgbClr val="FFFFFF"/>
-                </a:solidFill>
-              </a:rPr>
-              <a:t> = 298.15 K (25°C)  |  </a:t>
-            </a:r>
-            <a:r>
-              <a:rPr sz="1500" i="1">
-                <a:solidFill>
-                  <a:srgbClr val="FFFFFF"/>
-                </a:solidFill>
-              </a:rPr>
-              <a:t>S</a:t>
-            </a:r>
-            <a:r>
-              <a:rPr sz="1500" i="1">
-                <a:solidFill>
-                  <a:srgbClr val="FFFFFF"/>
-                </a:solidFill>
-              </a:rPr>
-              <a:t>ref</a:t>
-            </a:r>
-            <a:r>
-              <a:rPr sz="1500">
-                <a:solidFill>
-                  <a:srgbClr val="FFFFFF"/>
-                </a:solidFill>
-              </a:rPr>
-              <a:t> = 1000 W/m².</a:t>
+              <a:t>g,ref</a:t>
+            </a:r>
+            <a:r>
+              <a:rPr sz="1500">
+                <a:solidFill>
+                  <a:srgbClr val="FFFFFF"/>
+                </a:solidFill>
+              </a:rPr>
+              <a:t> = 1.121 eV para Silicio a 25°C.</a:t>
             </a:r>
           </a:p>
         </p:txBody>
@@ -11685,7 +11792,7 @@
                   <a:srgbClr val="E8A838"/>
                 </a:solidFill>
               </a:rPr>
-              <a:t>Fórmulas POA (Perez) y Absorción</a:t>
+              <a:t>Transposición POA (Modelo de Perez)</a:t>
             </a:r>
           </a:p>
         </p:txBody>
@@ -11713,35 +11820,19 @@
           <a:lstStyle/>
           <a:p>
             <a:pPr algn="l">
-              <a:defRPr sz="1600">
-                <a:solidFill>
-                  <a:srgbClr val="FFFFFF"/>
-                </a:solidFill>
-              </a:defRPr>
-            </a:pPr>
-            <a:r>
-              <a:rPr sz="1600">
-                <a:solidFill>
-                  <a:srgbClr val="FFFFFF"/>
-                </a:solidFill>
-              </a:rPr>
-              <a:t>1. Irradiancia en Plano de Arreglo (</a:t>
-            </a:r>
-            <a:r>
-              <a:rPr sz="1600" i="1">
-                <a:solidFill>
-                  <a:srgbClr val="FFFFFF"/>
-                </a:solidFill>
-              </a:rPr>
-              <a:t>POA</a:t>
-            </a:r>
-            <a:r>
-              <a:rPr sz="1600">
-                <a:solidFill>
-                  <a:srgbClr val="FFFFFF"/>
-                </a:solidFill>
-              </a:rPr>
-              <a:t>):</a:t>
+              <a:defRPr sz="1500">
+                <a:solidFill>
+                  <a:srgbClr val="FFFFFF"/>
+                </a:solidFill>
+              </a:defRPr>
+            </a:pPr>
+            <a:r>
+              <a:rPr sz="1500">
+                <a:solidFill>
+                  <a:srgbClr val="FFFFFF"/>
+                </a:solidFill>
+              </a:rPr>
+              <a:t>Calcula la irradiancia incidente total en el panel inclinado:</a:t>
             </a:r>
           </a:p>
         </p:txBody>
@@ -11762,7 +11853,7 @@
         </p:blipFill>
         <p:spPr>
           <a:xfrm>
-            <a:off x="640080" y="1920240"/>
+            <a:off x="640080" y="2011680"/>
             <a:ext cx="5029200" cy="343524"/>
           </a:xfrm>
           <a:prstGeom prst="rect">
@@ -11778,8 +11869,8 @@
         </p:nvSpPr>
         <p:spPr>
           <a:xfrm>
-            <a:off x="548640" y="2743200"/>
-            <a:ext cx="5181447" cy="320040"/>
+            <a:off x="548640" y="2926080"/>
+            <a:ext cx="5181447" cy="2743200"/>
           </a:xfrm>
           <a:prstGeom prst="rect">
             <a:avLst/>
@@ -11793,86 +11884,6 @@
           <a:lstStyle/>
           <a:p>
             <a:pPr algn="l">
-              <a:defRPr sz="1600">
-                <a:solidFill>
-                  <a:srgbClr val="FFFFFF"/>
-                </a:solidFill>
-              </a:defRPr>
-            </a:pPr>
-            <a:r>
-              <a:rPr sz="1600">
-                <a:solidFill>
-                  <a:srgbClr val="FFFFFF"/>
-                </a:solidFill>
-              </a:rPr>
-              <a:t>2. Irradiancia Absorbida por Celdas (</a:t>
-            </a:r>
-            <a:r>
-              <a:rPr sz="1600" i="1">
-                <a:solidFill>
-                  <a:srgbClr val="FFFFFF"/>
-                </a:solidFill>
-              </a:rPr>
-              <a:t>S</a:t>
-            </a:r>
-            <a:r>
-              <a:rPr sz="1600">
-                <a:solidFill>
-                  <a:srgbClr val="FFFFFF"/>
-                </a:solidFill>
-              </a:rPr>
-              <a:t>):</a:t>
-            </a:r>
-          </a:p>
-        </p:txBody>
-      </p:sp>
-      <p:pic>
-        <p:nvPicPr>
-          <p:cNvPr id="8" name="Picture 7" descr="eq_84c6ff8f0a6225d1da45a3b2826e84f0.png"/>
-          <p:cNvPicPr>
-            <a:picLocks noChangeAspect="1"/>
-          </p:cNvPicPr>
-          <p:nvPr/>
-        </p:nvPicPr>
-        <p:blipFill>
-          <a:blip r:embed="rId3"/>
-          <a:stretch>
-            <a:fillRect/>
-          </a:stretch>
-        </p:blipFill>
-        <p:spPr>
-          <a:xfrm>
-            <a:off x="640080" y="3154680"/>
-            <a:ext cx="5029200" cy="282792"/>
-          </a:xfrm>
-          <a:prstGeom prst="rect">
-            <a:avLst/>
-          </a:prstGeom>
-        </p:spPr>
-      </p:pic>
-      <p:sp>
-        <p:nvSpPr>
-          <p:cNvPr id="9" name="TextBox 8"/>
-          <p:cNvSpPr txBox="1"/>
-          <p:nvPr/>
-        </p:nvSpPr>
-        <p:spPr>
-          <a:xfrm>
-            <a:off x="548640" y="4069080"/>
-            <a:ext cx="5181447" cy="1828800"/>
-          </a:xfrm>
-          <a:prstGeom prst="rect">
-            <a:avLst/>
-          </a:prstGeom>
-          <a:noFill/>
-        </p:spPr>
-        <p:txBody>
-          <a:bodyPr wrap="square">
-            <a:spAutoFit/>
-          </a:bodyPr>
-          <a:lstStyle/>
-          <a:p>
-            <a:pPr algn="l">
               <a:defRPr sz="1500">
                 <a:solidFill>
                   <a:srgbClr val="E8A838"/>
@@ -11885,7 +11896,24 @@
                   <a:srgbClr val="E8A838"/>
                 </a:solidFill>
               </a:rPr>
-              <a:t>Donde </a:t>
+              <a:t>Donde:</a:t>
+            </a:r>
+          </a:p>
+          <a:p>
+            <a:pPr algn="l">
+              <a:defRPr sz="1500">
+                <a:solidFill>
+                  <a:srgbClr val="E8A838"/>
+                </a:solidFill>
+              </a:defRPr>
+            </a:pPr>
+            <a:r>
+              <a:rPr sz="1500">
+                <a:solidFill>
+                  <a:srgbClr val="E8A838"/>
+                </a:solidFill>
+              </a:rPr>
+              <a:t>• </a:t>
             </a:r>
             <a:r>
               <a:rPr sz="1500" i="1">
@@ -11893,7 +11921,7 @@
                   <a:srgbClr val="E8A838"/>
                 </a:solidFill>
               </a:rPr>
-              <a:t>S</a:t>
+              <a:t>G</a:t>
             </a:r>
             <a:r>
               <a:rPr sz="1500" i="1">
@@ -11901,15 +11929,15 @@
                   <a:srgbClr val="E8A838"/>
                 </a:solidFill>
               </a:rPr>
-              <a:t>ref</a:t>
-            </a:r>
-            <a:r>
-              <a:rPr sz="1500">
-                <a:solidFill>
-                  <a:srgbClr val="E8A838"/>
-                </a:solidFill>
-              </a:rPr>
-              <a:t> = </a:t>
+              <a:t>b</a:t>
+            </a:r>
+            <a:r>
+              <a:rPr sz="1500">
+                <a:solidFill>
+                  <a:srgbClr val="E8A838"/>
+                </a:solidFill>
+              </a:rPr>
+              <a:t> / </a:t>
             </a:r>
             <a:r>
               <a:rPr sz="1500" i="1">
@@ -11925,22 +11953,145 @@
                   <a:srgbClr val="E8A838"/>
                 </a:solidFill>
               </a:rPr>
-              <a:t>ref</a:t>
-            </a:r>
-            <a:r>
-              <a:rPr sz="1500">
-                <a:solidFill>
-                  <a:srgbClr val="E8A838"/>
-                </a:solidFill>
-              </a:rPr>
-              <a:t> = 1000 W/m² en condiciones de referencia (SRC).</a:t>
-            </a:r>
-          </a:p>
-        </p:txBody>
-      </p:sp>
-      <p:sp>
-        <p:nvSpPr>
-          <p:cNvPr id="10" name="Rectangle 9"/>
+              <a:t>d</a:t>
+            </a:r>
+            <a:r>
+              <a:rPr sz="1500">
+                <a:solidFill>
+                  <a:srgbClr val="E8A838"/>
+                </a:solidFill>
+              </a:rPr>
+              <a:t> / </a:t>
+            </a:r>
+            <a:r>
+              <a:rPr sz="1500" i="1">
+                <a:solidFill>
+                  <a:srgbClr val="E8A838"/>
+                </a:solidFill>
+              </a:rPr>
+              <a:t>G</a:t>
+            </a:r>
+            <a:r>
+              <a:rPr sz="1500">
+                <a:solidFill>
+                  <a:srgbClr val="E8A838"/>
+                </a:solidFill>
+              </a:rPr>
+              <a:t>: Irradiancia directa, difusa y global (W/m²).</a:t>
+            </a:r>
+          </a:p>
+          <a:p>
+            <a:pPr algn="l">
+              <a:defRPr sz="1500">
+                <a:solidFill>
+                  <a:srgbClr val="E8A838"/>
+                </a:solidFill>
+              </a:defRPr>
+            </a:pPr>
+            <a:r>
+              <a:rPr sz="1500">
+                <a:solidFill>
+                  <a:srgbClr val="E8A838"/>
+                </a:solidFill>
+              </a:rPr>
+              <a:t>• </a:t>
+            </a:r>
+            <a:r>
+              <a:rPr sz="1500" i="1">
+                <a:solidFill>
+                  <a:srgbClr val="E8A838"/>
+                </a:solidFill>
+              </a:rPr>
+              <a:t>β</a:t>
+            </a:r>
+            <a:r>
+              <a:rPr sz="1500">
+                <a:solidFill>
+                  <a:srgbClr val="E8A838"/>
+                </a:solidFill>
+              </a:rPr>
+              <a:t> (Tilt): Ángulo de inclinación óptimo (22.91°).</a:t>
+            </a:r>
+          </a:p>
+          <a:p>
+            <a:pPr algn="l">
+              <a:defRPr sz="1500">
+                <a:solidFill>
+                  <a:srgbClr val="E8A838"/>
+                </a:solidFill>
+              </a:defRPr>
+            </a:pPr>
+            <a:r>
+              <a:rPr sz="1500">
+                <a:solidFill>
+                  <a:srgbClr val="E8A838"/>
+                </a:solidFill>
+              </a:rPr>
+              <a:t>• </a:t>
+            </a:r>
+            <a:r>
+              <a:rPr sz="1500" i="1">
+                <a:solidFill>
+                  <a:srgbClr val="E8A838"/>
+                </a:solidFill>
+              </a:rPr>
+              <a:t>ρ</a:t>
+            </a:r>
+            <a:r>
+              <a:rPr sz="1500">
+                <a:solidFill>
+                  <a:srgbClr val="E8A838"/>
+                </a:solidFill>
+              </a:rPr>
+              <a:t> (Albedo): Reflectancia del suelo desértico (~0.20).</a:t>
+            </a:r>
+          </a:p>
+          <a:p>
+            <a:pPr algn="l">
+              <a:defRPr sz="1500">
+                <a:solidFill>
+                  <a:srgbClr val="E8A838"/>
+                </a:solidFill>
+              </a:defRPr>
+            </a:pPr>
+            <a:r>
+              <a:rPr sz="1500">
+                <a:solidFill>
+                  <a:srgbClr val="E8A838"/>
+                </a:solidFill>
+              </a:rPr>
+              <a:t>• </a:t>
+            </a:r>
+            <a:r>
+              <a:rPr sz="1500" i="1">
+                <a:solidFill>
+                  <a:srgbClr val="E8A838"/>
+                </a:solidFill>
+              </a:rPr>
+              <a:t>R</a:t>
+            </a:r>
+            <a:r>
+              <a:rPr sz="1500" i="1">
+                <a:solidFill>
+                  <a:srgbClr val="E8A838"/>
+                </a:solidFill>
+              </a:rPr>
+              <a:t>beam</a:t>
+            </a:r>
+            <a:r>
+              <a:rPr sz="1500">
+                <a:solidFill>
+                  <a:srgbClr val="E8A838"/>
+                </a:solidFill>
+              </a:rPr>
+              <a:t>: Factor de transposición geométrica directa.</a:t>
+            </a:r>
+          </a:p>
+        </p:txBody>
+      </p:sp>
+      <p:sp>
+        <p:nvSpPr>
+          <p:cNvPr id="8" name="Rectangle 7"/>
           <p:cNvSpPr/>
           <p:nvPr/>
         </p:nvSpPr>
@@ -11985,7 +12136,7 @@
       </p:sp>
       <p:sp>
         <p:nvSpPr>
-          <p:cNvPr id="11" name="TextBox 10"/>
+          <p:cNvPr id="9" name="TextBox 8"/>
           <p:cNvSpPr txBox="1"/>
           <p:nvPr/>
         </p:nvSpPr>
@@ -12018,21 +12169,21 @@
                   <a:srgbClr val="E8A838"/>
                 </a:solidFill>
               </a:rPr>
-              <a:t>Glosario de Términos</a:t>
-            </a:r>
-          </a:p>
-        </p:txBody>
-      </p:sp>
-      <p:sp>
-        <p:nvSpPr>
-          <p:cNvPr id="12" name="TextBox 11"/>
+              <a:t>Absorción en Celda (Pérdidas Ópticas)</a:t>
+            </a:r>
+          </a:p>
+        </p:txBody>
+      </p:sp>
+      <p:sp>
+        <p:nvSpPr>
+          <p:cNvPr id="10" name="TextBox 9"/>
           <p:cNvSpPr txBox="1"/>
           <p:nvPr/>
         </p:nvSpPr>
         <p:spPr>
           <a:xfrm>
             <a:off x="6370167" y="1554480"/>
-            <a:ext cx="5181447" cy="4114800"/>
+            <a:ext cx="5181447" cy="320040"/>
           </a:xfrm>
           <a:prstGeom prst="rect">
             <a:avLst/>
@@ -12058,6 +12209,87 @@
                   <a:srgbClr val="FFFFFF"/>
                 </a:solidFill>
               </a:rPr>
+              <a:t>Modela la radiación real que penetra y es absorbida por la celda:</a:t>
+            </a:r>
+          </a:p>
+        </p:txBody>
+      </p:sp>
+      <p:pic>
+        <p:nvPicPr>
+          <p:cNvPr id="11" name="Picture 10" descr="eq_84c6ff8f0a6225d1da45a3b2826e84f0.png"/>
+          <p:cNvPicPr>
+            <a:picLocks noChangeAspect="1"/>
+          </p:cNvPicPr>
+          <p:nvPr/>
+        </p:nvPicPr>
+        <p:blipFill>
+          <a:blip r:embed="rId3"/>
+          <a:stretch>
+            <a:fillRect/>
+          </a:stretch>
+        </p:blipFill>
+        <p:spPr>
+          <a:xfrm>
+            <a:off x="6461607" y="2011680"/>
+            <a:ext cx="5029200" cy="282792"/>
+          </a:xfrm>
+          <a:prstGeom prst="rect">
+            <a:avLst/>
+          </a:prstGeom>
+        </p:spPr>
+      </p:pic>
+      <p:sp>
+        <p:nvSpPr>
+          <p:cNvPr id="12" name="TextBox 11"/>
+          <p:cNvSpPr txBox="1"/>
+          <p:nvPr/>
+        </p:nvSpPr>
+        <p:spPr>
+          <a:xfrm>
+            <a:off x="6370167" y="2926080"/>
+            <a:ext cx="5181447" cy="2743200"/>
+          </a:xfrm>
+          <a:prstGeom prst="rect">
+            <a:avLst/>
+          </a:prstGeom>
+          <a:noFill/>
+        </p:spPr>
+        <p:txBody>
+          <a:bodyPr wrap="square">
+            <a:spAutoFit/>
+          </a:bodyPr>
+          <a:lstStyle/>
+          <a:p>
+            <a:pPr algn="l">
+              <a:defRPr sz="1500">
+                <a:solidFill>
+                  <a:srgbClr val="FFFFFF"/>
+                </a:solidFill>
+              </a:defRPr>
+            </a:pPr>
+            <a:r>
+              <a:rPr sz="1500">
+                <a:solidFill>
+                  <a:srgbClr val="FFFFFF"/>
+                </a:solidFill>
+              </a:rPr>
+              <a:t>Donde:</a:t>
+            </a:r>
+          </a:p>
+          <a:p>
+            <a:pPr algn="l">
+              <a:defRPr sz="1500">
+                <a:solidFill>
+                  <a:srgbClr val="FFFFFF"/>
+                </a:solidFill>
+              </a:defRPr>
+            </a:pPr>
+            <a:r>
+              <a:rPr sz="1500">
+                <a:solidFill>
+                  <a:srgbClr val="FFFFFF"/>
+                </a:solidFill>
+              </a:rPr>
               <a:t>• </a:t>
             </a:r>
             <a:r>
@@ -12066,7 +12298,15 @@
                   <a:srgbClr val="FFFFFF"/>
                 </a:solidFill>
               </a:rPr>
-              <a:t>G</a:t>
+              <a:t>S</a:t>
+            </a:r>
+            <a:r>
+              <a:rPr sz="1500">
+                <a:solidFill>
+                  <a:srgbClr val="FFFFFF"/>
+                </a:solidFill>
+              </a:rPr>
+              <a:t> / </a:t>
             </a:r>
             <a:r>
               <a:rPr sz="1500" i="1">
@@ -12074,7 +12314,56 @@
                   <a:srgbClr val="FFFFFF"/>
                 </a:solidFill>
               </a:rPr>
-              <a:t>b</a:t>
+              <a:t>S</a:t>
+            </a:r>
+            <a:r>
+              <a:rPr sz="1500" i="1">
+                <a:solidFill>
+                  <a:srgbClr val="FFFFFF"/>
+                </a:solidFill>
+              </a:rPr>
+              <a:t>ref</a:t>
+            </a:r>
+            <a:r>
+              <a:rPr sz="1500">
+                <a:solidFill>
+                  <a:srgbClr val="FFFFFF"/>
+                </a:solidFill>
+              </a:rPr>
+              <a:t>: Irradiancia efectiva y de referencia (1000 W/m²).</a:t>
+            </a:r>
+          </a:p>
+          <a:p>
+            <a:pPr algn="l">
+              <a:defRPr sz="1500">
+                <a:solidFill>
+                  <a:srgbClr val="FFFFFF"/>
+                </a:solidFill>
+              </a:defRPr>
+            </a:pPr>
+            <a:r>
+              <a:rPr sz="1500">
+                <a:solidFill>
+                  <a:srgbClr val="FFFFFF"/>
+                </a:solidFill>
+              </a:rPr>
+              <a:t>• </a:t>
+            </a:r>
+            <a:r>
+              <a:rPr sz="1500" i="1">
+                <a:solidFill>
+                  <a:srgbClr val="FFFFFF"/>
+                </a:solidFill>
+              </a:rPr>
+              <a:t>K</a:t>
+            </a:r>
+            <a:r>
+              <a:rPr sz="1500" i="1">
+                <a:solidFill>
+                  <a:srgbClr val="FFFFFF"/>
+                </a:solidFill>
+              </a:rPr>
+              <a:t>τα,b</a:t>
             </a:r>
             <a:r>
               <a:rPr sz="1500">
@@ -12090,7 +12379,7 @@
                   <a:srgbClr val="FFFFFF"/>
                 </a:solidFill>
               </a:rPr>
-              <a:t>G</a:t>
+              <a:t>K</a:t>
             </a:r>
             <a:r>
               <a:rPr sz="1500" i="1">
@@ -12098,7 +12387,7 @@
                   <a:srgbClr val="FFFFFF"/>
                 </a:solidFill>
               </a:rPr>
-              <a:t>d</a:t>
+              <a:t>τα,d</a:t>
             </a:r>
             <a:r>
               <a:rPr sz="1500">
@@ -12114,15 +12403,23 @@
                   <a:srgbClr val="FFFFFF"/>
                 </a:solidFill>
               </a:rPr>
-              <a:t>G</a:t>
-            </a:r>
-            <a:r>
-              <a:rPr sz="1500">
-                <a:solidFill>
-                  <a:srgbClr val="FFFFFF"/>
-                </a:solidFill>
-              </a:rPr>
-              <a:t>: Irradiancia directa, difusa y global horizontal (W/m²).</a:t>
+              <a:t>K</a:t>
+            </a:r>
+            <a:r>
+              <a:rPr sz="1500" i="1">
+                <a:solidFill>
+                  <a:srgbClr val="FFFFFF"/>
+                </a:solidFill>
+              </a:rPr>
+              <a:t>τα,g</a:t>
+            </a:r>
+            <a:r>
+              <a:rPr sz="1500">
+                <a:solidFill>
+                  <a:srgbClr val="FFFFFF"/>
+                </a:solidFill>
+              </a:rPr>
+              <a:t>: Modificadores por IAM para directa, difusa y albedo.</a:t>
             </a:r>
           </a:p>
           <a:p>
@@ -12133,228 +12430,29 @@
                 </a:solidFill>
               </a:defRPr>
             </a:pPr>
-          </a:p>
-          <a:p>
-            <a:pPr algn="l">
-              <a:defRPr sz="1500">
-                <a:solidFill>
-                  <a:srgbClr val="FFFFFF"/>
-                </a:solidFill>
-              </a:defRPr>
-            </a:pPr>
-            <a:r>
-              <a:rPr sz="1500">
-                <a:solidFill>
-                  <a:srgbClr val="FFFFFF"/>
-                </a:solidFill>
-              </a:rPr>
-              <a:t>• </a:t>
-            </a:r>
-            <a:r>
-              <a:rPr sz="1500" i="1">
-                <a:solidFill>
-                  <a:srgbClr val="FFFFFF"/>
-                </a:solidFill>
-              </a:rPr>
-              <a:t>β</a:t>
-            </a:r>
-            <a:r>
-              <a:rPr sz="1500">
-                <a:solidFill>
-                  <a:srgbClr val="FFFFFF"/>
-                </a:solidFill>
-              </a:rPr>
-              <a:t> (Tilt): Ángulo de inclinación del panel (22.91° optimizado).</a:t>
-            </a:r>
-          </a:p>
-          <a:p>
-            <a:pPr algn="l">
-              <a:defRPr sz="1500">
-                <a:solidFill>
-                  <a:srgbClr val="FFFFFF"/>
-                </a:solidFill>
-              </a:defRPr>
-            </a:pPr>
-          </a:p>
-          <a:p>
-            <a:pPr algn="l">
-              <a:defRPr sz="1500">
-                <a:solidFill>
-                  <a:srgbClr val="FFFFFF"/>
-                </a:solidFill>
-              </a:defRPr>
-            </a:pPr>
-            <a:r>
-              <a:rPr sz="1500">
-                <a:solidFill>
-                  <a:srgbClr val="FFFFFF"/>
-                </a:solidFill>
-              </a:rPr>
-              <a:t>• </a:t>
-            </a:r>
-            <a:r>
-              <a:rPr sz="1500" i="1">
-                <a:solidFill>
-                  <a:srgbClr val="FFFFFF"/>
-                </a:solidFill>
-              </a:rPr>
-              <a:t>ρ</a:t>
-            </a:r>
-            <a:r>
-              <a:rPr sz="1500">
-                <a:solidFill>
-                  <a:srgbClr val="FFFFFF"/>
-                </a:solidFill>
-              </a:rPr>
-              <a:t> (Albedo): Reflectancia del suelo árido desértico (~0.20).</a:t>
-            </a:r>
-          </a:p>
-          <a:p>
-            <a:pPr algn="l">
-              <a:defRPr sz="1500">
-                <a:solidFill>
-                  <a:srgbClr val="FFFFFF"/>
-                </a:solidFill>
-              </a:defRPr>
-            </a:pPr>
-          </a:p>
-          <a:p>
-            <a:pPr algn="l">
-              <a:defRPr sz="1500">
-                <a:solidFill>
-                  <a:srgbClr val="FFFFFF"/>
-                </a:solidFill>
-              </a:defRPr>
-            </a:pPr>
-            <a:r>
-              <a:rPr sz="1500">
-                <a:solidFill>
-                  <a:srgbClr val="FFFFFF"/>
-                </a:solidFill>
-              </a:rPr>
-              <a:t>• </a:t>
-            </a:r>
-            <a:r>
-              <a:rPr sz="1500" i="1">
-                <a:solidFill>
-                  <a:srgbClr val="FFFFFF"/>
-                </a:solidFill>
-              </a:rPr>
-              <a:t>R</a:t>
-            </a:r>
-            <a:r>
-              <a:rPr sz="1500" i="1">
-                <a:solidFill>
-                  <a:srgbClr val="FFFFFF"/>
-                </a:solidFill>
-              </a:rPr>
-              <a:t>beam</a:t>
-            </a:r>
-            <a:r>
-              <a:rPr sz="1500">
-                <a:solidFill>
-                  <a:srgbClr val="FFFFFF"/>
-                </a:solidFill>
-              </a:rPr>
-              <a:t>: Factor de transposición geométrica para radiación directa.</a:t>
-            </a:r>
-          </a:p>
-          <a:p>
-            <a:pPr algn="l">
-              <a:defRPr sz="1500">
-                <a:solidFill>
-                  <a:srgbClr val="FFFFFF"/>
-                </a:solidFill>
-              </a:defRPr>
-            </a:pPr>
-          </a:p>
-          <a:p>
-            <a:pPr algn="l">
-              <a:defRPr sz="1500">
-                <a:solidFill>
-                  <a:srgbClr val="FFFFFF"/>
-                </a:solidFill>
-              </a:defRPr>
-            </a:pPr>
-            <a:r>
-              <a:rPr sz="1500">
-                <a:solidFill>
-                  <a:srgbClr val="FFFFFF"/>
-                </a:solidFill>
-              </a:rPr>
-              <a:t>• </a:t>
-            </a:r>
-            <a:r>
-              <a:rPr sz="1500" i="1">
-                <a:solidFill>
-                  <a:srgbClr val="FFFFFF"/>
-                </a:solidFill>
-              </a:rPr>
-              <a:t>K</a:t>
-            </a:r>
-            <a:r>
-              <a:rPr sz="1500" i="1">
-                <a:solidFill>
-                  <a:srgbClr val="FFFFFF"/>
-                </a:solidFill>
-              </a:rPr>
-              <a:t>τα,b</a:t>
-            </a:r>
-            <a:r>
-              <a:rPr sz="1500">
-                <a:solidFill>
-                  <a:srgbClr val="FFFFFF"/>
-                </a:solidFill>
-              </a:rPr>
-              <a:t> / </a:t>
-            </a:r>
-            <a:r>
-              <a:rPr sz="1500" i="1">
-                <a:solidFill>
-                  <a:srgbClr val="FFFFFF"/>
-                </a:solidFill>
-              </a:rPr>
-              <a:t>K</a:t>
-            </a:r>
-            <a:r>
-              <a:rPr sz="1500" i="1">
-                <a:solidFill>
-                  <a:srgbClr val="FFFFFF"/>
-                </a:solidFill>
-              </a:rPr>
-              <a:t>τα,d</a:t>
-            </a:r>
-            <a:r>
-              <a:rPr sz="1500">
-                <a:solidFill>
-                  <a:srgbClr val="FFFFFF"/>
-                </a:solidFill>
-              </a:rPr>
-              <a:t> / </a:t>
-            </a:r>
-            <a:r>
-              <a:rPr sz="1500" i="1">
-                <a:solidFill>
-                  <a:srgbClr val="FFFFFF"/>
-                </a:solidFill>
-              </a:rPr>
-              <a:t>K</a:t>
-            </a:r>
-            <a:r>
-              <a:rPr sz="1500" i="1">
-                <a:solidFill>
-                  <a:srgbClr val="FFFFFF"/>
-                </a:solidFill>
-              </a:rPr>
-              <a:t>τα,g</a:t>
-            </a:r>
-            <a:r>
-              <a:rPr sz="1500">
-                <a:solidFill>
-                  <a:srgbClr val="FFFFFF"/>
-                </a:solidFill>
-              </a:rPr>
-              <a:t>: Modificadores por IAM para directa, difusa y suelo.</a:t>
+            <a:r>
+              <a:rPr sz="1500">
+                <a:solidFill>
+                  <a:srgbClr val="FFFFFF"/>
+                </a:solidFill>
+              </a:rPr>
+              <a:t>• Incorpora las pérdidas ópticas por ángulo de incidencia</a:t>
+            </a:r>
+            <a:r>
+              <a:rPr sz="1500">
+                <a:solidFill>
+                  <a:srgbClr val="FFFFFF"/>
+                </a:solidFill>
+              </a:rPr>
+              <a:t>[2]</a:t>
+            </a:r>
+            <a:r>
+              <a:rPr sz="1500">
+                <a:solidFill>
+                  <a:srgbClr val="FFFFFF"/>
+                </a:solidFill>
+              </a:rPr>
+              <a:t>.</a:t>
             </a:r>
           </a:p>
         </p:txBody>
@@ -12609,7 +12707,7 @@
         </p:blipFill>
         <p:spPr>
           <a:xfrm>
-            <a:off x="640080" y="1965960"/>
+            <a:off x="640080" y="1920240"/>
             <a:ext cx="1234440" cy="411480"/>
           </a:xfrm>
           <a:prstGeom prst="rect">
@@ -12634,7 +12732,7 @@
         <p:spPr>
           <a:xfrm>
             <a:off x="640080" y="2468880"/>
-            <a:ext cx="3469175" cy="347472"/>
+            <a:ext cx="4108233" cy="411480"/>
           </a:xfrm>
           <a:prstGeom prst="rect">
             <a:avLst/>
@@ -12657,7 +12755,7 @@
         </p:blipFill>
         <p:spPr>
           <a:xfrm>
-            <a:off x="640080" y="2880360"/>
+            <a:off x="640080" y="3154680"/>
             <a:ext cx="1974028" cy="365760"/>
           </a:xfrm>
           <a:prstGeom prst="rect">
@@ -12673,8 +12771,8 @@
         </p:nvSpPr>
         <p:spPr>
           <a:xfrm>
-            <a:off x="548640" y="3611880"/>
-            <a:ext cx="5181447" cy="2286000"/>
+            <a:off x="548640" y="3931920"/>
+            <a:ext cx="5181447" cy="1828800"/>
           </a:xfrm>
           <a:prstGeom prst="rect">
             <a:avLst/>
@@ -12688,14 +12786,14 @@
           <a:lstStyle/>
           <a:p>
             <a:pPr algn="l">
-              <a:defRPr sz="1400">
-                <a:solidFill>
-                  <a:srgbClr val="E8A838"/>
-                </a:solidFill>
-              </a:defRPr>
-            </a:pPr>
-            <a:r>
-              <a:rPr sz="1400">
+              <a:defRPr sz="1500">
+                <a:solidFill>
+                  <a:srgbClr val="E8A838"/>
+                </a:solidFill>
+              </a:defRPr>
+            </a:pPr>
+            <a:r>
+              <a:rPr sz="1500">
                 <a:solidFill>
                   <a:srgbClr val="E8A838"/>
                 </a:solidFill>
@@ -12705,14 +12803,14 @@
           </a:p>
           <a:p>
             <a:pPr algn="l">
-              <a:defRPr sz="1400">
-                <a:solidFill>
-                  <a:srgbClr val="E8A838"/>
-                </a:solidFill>
-              </a:defRPr>
-            </a:pPr>
-            <a:r>
-              <a:rPr sz="1400">
+              <a:defRPr sz="1500">
+                <a:solidFill>
+                  <a:srgbClr val="E8A838"/>
+                </a:solidFill>
+              </a:defRPr>
+            </a:pPr>
+            <a:r>
+              <a:rPr sz="1500">
                 <a:solidFill>
                   <a:srgbClr val="E8A838"/>
                 </a:solidFill>
@@ -12720,7 +12818,7 @@
               <a:t>• </a:t>
             </a:r>
             <a:r>
-              <a:rPr sz="1400" i="1">
+              <a:rPr sz="1500" i="1">
                 <a:solidFill>
                   <a:srgbClr val="E8A838"/>
                 </a:solidFill>
@@ -12728,7 +12826,7 @@
               <a:t>θ</a:t>
             </a:r>
             <a:r>
-              <a:rPr sz="1400">
+              <a:rPr sz="1500">
                 <a:solidFill>
                   <a:srgbClr val="E8A838"/>
                 </a:solidFill>
@@ -12736,7 +12834,7 @@
               <a:t>: Ángulo de incidencia  |  </a:t>
             </a:r>
             <a:r>
-              <a:rPr sz="1400" i="1">
+              <a:rPr sz="1500" i="1">
                 <a:solidFill>
                   <a:srgbClr val="E8A838"/>
                 </a:solidFill>
@@ -12744,7 +12842,7 @@
               <a:t>n</a:t>
             </a:r>
             <a:r>
-              <a:rPr sz="1400">
+              <a:rPr sz="1500">
                 <a:solidFill>
                   <a:srgbClr val="E8A838"/>
                 </a:solidFill>
@@ -12754,14 +12852,14 @@
           </a:p>
           <a:p>
             <a:pPr algn="l">
-              <a:defRPr sz="1400">
-                <a:solidFill>
-                  <a:srgbClr val="E8A838"/>
-                </a:solidFill>
-              </a:defRPr>
-            </a:pPr>
-            <a:r>
-              <a:rPr sz="1400">
+              <a:defRPr sz="1500">
+                <a:solidFill>
+                  <a:srgbClr val="E8A838"/>
+                </a:solidFill>
+              </a:defRPr>
+            </a:pPr>
+            <a:r>
+              <a:rPr sz="1500">
                 <a:solidFill>
                   <a:srgbClr val="E8A838"/>
                 </a:solidFill>
@@ -12769,7 +12867,7 @@
               <a:t>• </a:t>
             </a:r>
             <a:r>
-              <a:rPr sz="1400" i="1">
+              <a:rPr sz="1500" i="1">
                 <a:solidFill>
                   <a:srgbClr val="E8A838"/>
                 </a:solidFill>
@@ -12777,7 +12875,7 @@
               <a:t>K</a:t>
             </a:r>
             <a:r>
-              <a:rPr sz="1400">
+              <a:rPr sz="1500">
                 <a:solidFill>
                   <a:srgbClr val="E8A838"/>
                 </a:solidFill>
@@ -12785,7 +12883,7 @@
               <a:t> = 4 m⁻¹ (Absorción del vidrio)  |  </a:t>
             </a:r>
             <a:r>
-              <a:rPr sz="1400" i="1">
+              <a:rPr sz="1500" i="1">
                 <a:solidFill>
                   <a:srgbClr val="E8A838"/>
                 </a:solidFill>
@@ -12793,7 +12891,7 @@
               <a:t>L</a:t>
             </a:r>
             <a:r>
-              <a:rPr sz="1400">
+              <a:rPr sz="1500">
                 <a:solidFill>
                   <a:srgbClr val="E8A838"/>
                 </a:solidFill>
@@ -12952,7 +13050,7 @@
         </p:blipFill>
         <p:spPr>
           <a:xfrm>
-            <a:off x="6461607" y="2194560"/>
+            <a:off x="6461607" y="2011680"/>
             <a:ext cx="5029200" cy="333513"/>
           </a:xfrm>
           <a:prstGeom prst="rect">
@@ -12976,7 +13074,7 @@
         </p:blipFill>
         <p:spPr>
           <a:xfrm>
-            <a:off x="6461607" y="2788920"/>
+            <a:off x="6461607" y="2697480"/>
             <a:ext cx="3687419" cy="438912"/>
           </a:xfrm>
           <a:prstGeom prst="rect">
@@ -12992,8 +13090,8 @@
         </p:nvSpPr>
         <p:spPr>
           <a:xfrm>
-            <a:off x="6370167" y="3931920"/>
-            <a:ext cx="5181447" cy="2743200"/>
+            <a:off x="6370167" y="3611880"/>
+            <a:ext cx="5181447" cy="2286000"/>
           </a:xfrm>
           <a:prstGeom prst="rect">
             <a:avLst/>

</xml_diff>

<commit_message>
Redesign Slides 5, 8, 10, 11, and 15 with horizontal segmentation and asymmetric columns for math legibility
</commit_message>
<xml_diff>
--- a/output/Presentacion_Final_ELI556_Atacama.pptx
+++ b/output/Presentacion_Final_ELI556_Atacama.pptx
@@ -3373,7 +3373,7 @@
         <p:spPr>
           <a:xfrm>
             <a:off x="365760" y="1097280"/>
-            <a:ext cx="5547207" cy="5029200"/>
+            <a:ext cx="11460175" cy="2011680"/>
           </a:xfrm>
           <a:prstGeom prst="rect">
             <a:avLst/>
@@ -3418,7 +3418,7 @@
         <p:spPr>
           <a:xfrm>
             <a:off x="457200" y="1188720"/>
-            <a:ext cx="5364327" cy="411480"/>
+            <a:ext cx="11277295" cy="411480"/>
           </a:xfrm>
           <a:prstGeom prst="rect">
             <a:avLst/>
@@ -3457,8 +3457,8 @@
         </p:nvSpPr>
         <p:spPr>
           <a:xfrm>
-            <a:off x="548640" y="1554480"/>
-            <a:ext cx="5181447" cy="320040"/>
+            <a:off x="548640" y="1508760"/>
+            <a:ext cx="11094415" cy="320040"/>
           </a:xfrm>
           <a:prstGeom prst="rect">
             <a:avLst/>
@@ -3472,19 +3472,19 @@
           <a:lstStyle/>
           <a:p>
             <a:pPr algn="l">
-              <a:defRPr sz="1600">
-                <a:solidFill>
-                  <a:srgbClr val="FFFFFF"/>
-                </a:solidFill>
-              </a:defRPr>
-            </a:pPr>
-            <a:r>
-              <a:rPr sz="1600">
-                <a:solidFill>
-                  <a:srgbClr val="FFFFFF"/>
-                </a:solidFill>
-              </a:rPr>
-              <a:t>El módulo se modela como un circuito equivalente de un diodo y pérdidas óhmicas:</a:t>
+              <a:defRPr sz="1500">
+                <a:solidFill>
+                  <a:srgbClr val="FFFFFF"/>
+                </a:solidFill>
+              </a:defRPr>
+            </a:pPr>
+            <a:r>
+              <a:rPr sz="1500">
+                <a:solidFill>
+                  <a:srgbClr val="FFFFFF"/>
+                </a:solidFill>
+              </a:rPr>
+              <a:t>El comportamiento eléctrico del módulo se modela mediante la ecuación trascendental del diodo:</a:t>
             </a:r>
           </a:p>
         </p:txBody>
@@ -3505,8 +3505,8 @@
         </p:blipFill>
         <p:spPr>
           <a:xfrm>
-            <a:off x="640080" y="2240280"/>
-            <a:ext cx="3853986" cy="347472"/>
+            <a:off x="1463040" y="1965960"/>
+            <a:ext cx="4259669" cy="384048"/>
           </a:xfrm>
           <a:prstGeom prst="rect">
             <a:avLst/>
@@ -3515,94 +3515,14 @@
       </p:pic>
       <p:sp>
         <p:nvSpPr>
-          <p:cNvPr id="7" name="TextBox 6"/>
-          <p:cNvSpPr txBox="1"/>
-          <p:nvPr/>
-        </p:nvSpPr>
-        <p:spPr>
-          <a:xfrm>
-            <a:off x="548640" y="3108960"/>
-            <a:ext cx="5181447" cy="320040"/>
-          </a:xfrm>
-          <a:prstGeom prst="rect">
-            <a:avLst/>
-          </a:prstGeom>
-          <a:noFill/>
-        </p:spPr>
-        <p:txBody>
-          <a:bodyPr wrap="square">
-            <a:spAutoFit/>
-          </a:bodyPr>
-          <a:lstStyle/>
-          <a:p>
-            <a:pPr algn="l">
-              <a:defRPr sz="1600">
-                <a:solidFill>
-                  <a:srgbClr val="FFFFFF"/>
-                </a:solidFill>
-              </a:defRPr>
-            </a:pPr>
-            <a:r>
-              <a:rPr sz="1600">
-                <a:solidFill>
-                  <a:srgbClr val="FFFFFF"/>
-                </a:solidFill>
-              </a:rPr>
-              <a:t>El factor de idealidad térmico (</a:t>
-            </a:r>
-            <a:r>
-              <a:rPr sz="1600" i="1">
-                <a:solidFill>
-                  <a:srgbClr val="FFFFFF"/>
-                </a:solidFill>
-              </a:rPr>
-              <a:t>a</a:t>
-            </a:r>
-            <a:r>
-              <a:rPr sz="1600">
-                <a:solidFill>
-                  <a:srgbClr val="FFFFFF"/>
-                </a:solidFill>
-              </a:rPr>
-              <a:t>) se define formalmente como:</a:t>
-            </a:r>
-          </a:p>
-        </p:txBody>
-      </p:sp>
-      <p:pic>
-        <p:nvPicPr>
-          <p:cNvPr id="8" name="Picture 7" descr="eq_81b193729b5e8ca3d3141349bc52cf9d.png"/>
-          <p:cNvPicPr>
-            <a:picLocks noChangeAspect="1"/>
-          </p:cNvPicPr>
-          <p:nvPr/>
-        </p:nvPicPr>
-        <p:blipFill>
-          <a:blip r:embed="rId3"/>
-          <a:stretch>
-            <a:fillRect/>
-          </a:stretch>
-        </p:blipFill>
-        <p:spPr>
-          <a:xfrm>
-            <a:off x="640080" y="3611880"/>
-            <a:ext cx="1835474" cy="457200"/>
-          </a:xfrm>
-          <a:prstGeom prst="rect">
-            <a:avLst/>
-          </a:prstGeom>
-        </p:spPr>
-      </p:pic>
-      <p:sp>
-        <p:nvSpPr>
-          <p:cNvPr id="9" name="Rectangle 8"/>
+          <p:cNvPr id="7" name="Rectangle 6"/>
           <p:cNvSpPr/>
           <p:nvPr/>
         </p:nvSpPr>
         <p:spPr>
           <a:xfrm>
-            <a:off x="6187287" y="1097280"/>
-            <a:ext cx="5547207" cy="5029200"/>
+            <a:off x="365760" y="3291840"/>
+            <a:ext cx="4937760" cy="2834640"/>
           </a:xfrm>
           <a:prstGeom prst="rect">
             <a:avLst/>
@@ -3640,14 +3560,14 @@
       </p:sp>
       <p:sp>
         <p:nvSpPr>
-          <p:cNvPr id="10" name="TextBox 9"/>
+          <p:cNvPr id="8" name="TextBox 7"/>
           <p:cNvSpPr txBox="1"/>
           <p:nvPr/>
         </p:nvSpPr>
         <p:spPr>
           <a:xfrm>
-            <a:off x="6278727" y="1188720"/>
-            <a:ext cx="5364327" cy="411480"/>
+            <a:off x="457200" y="3383280"/>
+            <a:ext cx="4754880" cy="411480"/>
           </a:xfrm>
           <a:prstGeom prst="rect">
             <a:avLst/>
@@ -3673,21 +3593,21 @@
                   <a:srgbClr val="E8A838"/>
                 </a:solidFill>
               </a:rPr>
-              <a:t>Glosario de Parámetros Físicos</a:t>
-            </a:r>
-          </a:p>
-        </p:txBody>
-      </p:sp>
-      <p:sp>
-        <p:nvSpPr>
-          <p:cNvPr id="11" name="TextBox 10"/>
+              <a:t>Factor de Idealidad Térmico (a)</a:t>
+            </a:r>
+          </a:p>
+        </p:txBody>
+      </p:sp>
+      <p:sp>
+        <p:nvSpPr>
+          <p:cNvPr id="9" name="TextBox 8"/>
           <p:cNvSpPr txBox="1"/>
           <p:nvPr/>
         </p:nvSpPr>
         <p:spPr>
           <a:xfrm>
-            <a:off x="6370167" y="1554480"/>
-            <a:ext cx="5181447" cy="4114800"/>
+            <a:off x="548640" y="3657600"/>
+            <a:ext cx="4572000" cy="320040"/>
           </a:xfrm>
           <a:prstGeom prst="rect">
             <a:avLst/>
@@ -3713,10 +3633,223 @@
                   <a:srgbClr val="FFFFFF"/>
                 </a:solidFill>
               </a:rPr>
+              <a:t>El factor de idealidad térmico se define formalmente como:</a:t>
+            </a:r>
+          </a:p>
+        </p:txBody>
+      </p:sp>
+      <p:pic>
+        <p:nvPicPr>
+          <p:cNvPr id="10" name="Picture 9" descr="eq_81b193729b5e8ca3d3141349bc52cf9d.png"/>
+          <p:cNvPicPr>
+            <a:picLocks noChangeAspect="1"/>
+          </p:cNvPicPr>
+          <p:nvPr/>
+        </p:nvPicPr>
+        <p:blipFill>
+          <a:blip r:embed="rId3"/>
+          <a:stretch>
+            <a:fillRect/>
+          </a:stretch>
+        </p:blipFill>
+        <p:spPr>
+          <a:xfrm>
+            <a:off x="822960" y="4069080"/>
+            <a:ext cx="1762055" cy="438912"/>
+          </a:xfrm>
+          <a:prstGeom prst="rect">
+            <a:avLst/>
+          </a:prstGeom>
+        </p:spPr>
+      </p:pic>
+      <p:sp>
+        <p:nvSpPr>
+          <p:cNvPr id="11" name="TextBox 10"/>
+          <p:cNvSpPr txBox="1"/>
+          <p:nvPr/>
+        </p:nvSpPr>
+        <p:spPr>
+          <a:xfrm>
+            <a:off x="548640" y="4800600"/>
+            <a:ext cx="4572000" cy="914400"/>
+          </a:xfrm>
+          <a:prstGeom prst="rect">
+            <a:avLst/>
+          </a:prstGeom>
+          <a:noFill/>
+        </p:spPr>
+        <p:txBody>
+          <a:bodyPr wrap="square">
+            <a:spAutoFit/>
+          </a:bodyPr>
+          <a:lstStyle/>
+          <a:p>
+            <a:pPr algn="l">
+              <a:defRPr sz="1400">
+                <a:solidFill>
+                  <a:srgbClr val="E8A838"/>
+                </a:solidFill>
+              </a:defRPr>
+            </a:pPr>
+            <a:r>
+              <a:rPr sz="1400">
+                <a:solidFill>
+                  <a:srgbClr val="E8A838"/>
+                </a:solidFill>
+              </a:rPr>
+              <a:t>Donde </a:t>
+            </a:r>
+            <a:r>
+              <a:rPr sz="1400" i="1">
+                <a:solidFill>
+                  <a:srgbClr val="E8A838"/>
+                </a:solidFill>
+              </a:rPr>
+              <a:t>N</a:t>
+            </a:r>
+            <a:r>
+              <a:rPr sz="1400" i="1">
+                <a:solidFill>
+                  <a:srgbClr val="E8A838"/>
+                </a:solidFill>
+              </a:rPr>
+              <a:t>s</a:t>
+            </a:r>
+            <a:r>
+              <a:rPr sz="1400">
+                <a:solidFill>
+                  <a:srgbClr val="E8A838"/>
+                </a:solidFill>
+              </a:rPr>
+              <a:t> es el número de celdas en serie (m-Si: 36, HIT: 72).</a:t>
+            </a:r>
+          </a:p>
+        </p:txBody>
+      </p:sp>
+      <p:sp>
+        <p:nvSpPr>
+          <p:cNvPr id="12" name="Rectangle 11"/>
+          <p:cNvSpPr/>
+          <p:nvPr/>
+        </p:nvSpPr>
+        <p:spPr>
+          <a:xfrm>
+            <a:off x="5577840" y="3291840"/>
+            <a:ext cx="5760720" cy="2834640"/>
+          </a:xfrm>
+          <a:prstGeom prst="rect">
+            <a:avLst/>
+          </a:prstGeom>
+          <a:solidFill>
+            <a:srgbClr val="22223A"/>
+          </a:solidFill>
+          <a:ln w="12700">
+            <a:solidFill>
+              <a:srgbClr val="007ACC"/>
+            </a:solidFill>
+          </a:ln>
+        </p:spPr>
+        <p:style>
+          <a:lnRef idx="1">
+            <a:schemeClr val="accent1"/>
+          </a:lnRef>
+          <a:fillRef idx="3">
+            <a:schemeClr val="accent1"/>
+          </a:fillRef>
+          <a:effectRef idx="2">
+            <a:schemeClr val="accent1"/>
+          </a:effectRef>
+          <a:fontRef idx="minor">
+            <a:schemeClr val="lt1"/>
+          </a:fontRef>
+        </p:style>
+        <p:txBody>
+          <a:bodyPr rtlCol="0" anchor="ctr"/>
+          <a:lstStyle/>
+          <a:p>
+            <a:pPr algn="ctr"/>
+          </a:p>
+        </p:txBody>
+      </p:sp>
+      <p:sp>
+        <p:nvSpPr>
+          <p:cNvPr id="13" name="TextBox 12"/>
+          <p:cNvSpPr txBox="1"/>
+          <p:nvPr/>
+        </p:nvSpPr>
+        <p:spPr>
+          <a:xfrm>
+            <a:off x="5669280" y="3383280"/>
+            <a:ext cx="5577840" cy="411480"/>
+          </a:xfrm>
+          <a:prstGeom prst="rect">
+            <a:avLst/>
+          </a:prstGeom>
+          <a:noFill/>
+        </p:spPr>
+        <p:txBody>
+          <a:bodyPr wrap="none">
+            <a:spAutoFit/>
+          </a:bodyPr>
+          <a:lstStyle/>
+          <a:p>
+            <a:pPr>
+              <a:defRPr sz="1800">
+                <a:solidFill>
+                  <a:srgbClr val="E8A838"/>
+                </a:solidFill>
+              </a:defRPr>
+            </a:pPr>
+            <a:r>
+              <a:rPr sz="1800" b="1">
+                <a:solidFill>
+                  <a:srgbClr val="E8A838"/>
+                </a:solidFill>
+              </a:rPr>
+              <a:t>Glosario de Parámetros Físicos</a:t>
+            </a:r>
+          </a:p>
+        </p:txBody>
+      </p:sp>
+      <p:sp>
+        <p:nvSpPr>
+          <p:cNvPr id="14" name="TextBox 13"/>
+          <p:cNvSpPr txBox="1"/>
+          <p:nvPr/>
+        </p:nvSpPr>
+        <p:spPr>
+          <a:xfrm>
+            <a:off x="5760720" y="3657600"/>
+            <a:ext cx="5394960" cy="2103120"/>
+          </a:xfrm>
+          <a:prstGeom prst="rect">
+            <a:avLst/>
+          </a:prstGeom>
+          <a:noFill/>
+        </p:spPr>
+        <p:txBody>
+          <a:bodyPr wrap="square">
+            <a:spAutoFit/>
+          </a:bodyPr>
+          <a:lstStyle/>
+          <a:p>
+            <a:pPr algn="l">
+              <a:defRPr sz="1400">
+                <a:solidFill>
+                  <a:srgbClr val="FFFFFF"/>
+                </a:solidFill>
+              </a:defRPr>
+            </a:pPr>
+            <a:r>
+              <a:rPr sz="1400">
+                <a:solidFill>
+                  <a:srgbClr val="FFFFFF"/>
+                </a:solidFill>
+              </a:rPr>
               <a:t>• </a:t>
             </a:r>
             <a:r>
-              <a:rPr sz="1500" i="1">
+              <a:rPr sz="1400" i="1">
                 <a:solidFill>
                   <a:srgbClr val="FFFFFF"/>
                 </a:solidFill>
@@ -3724,7 +3857,7 @@
               <a:t>I</a:t>
             </a:r>
             <a:r>
-              <a:rPr sz="1500">
+              <a:rPr sz="1400">
                 <a:solidFill>
                   <a:srgbClr val="FFFFFF"/>
                 </a:solidFill>
@@ -3732,7 +3865,7 @@
               <a:t> / </a:t>
             </a:r>
             <a:r>
-              <a:rPr sz="1500" i="1">
+              <a:rPr sz="1400" i="1">
                 <a:solidFill>
                   <a:srgbClr val="FFFFFF"/>
                 </a:solidFill>
@@ -3740,7 +3873,7 @@
               <a:t>V</a:t>
             </a:r>
             <a:r>
-              <a:rPr sz="1500">
+              <a:rPr sz="1400">
                 <a:solidFill>
                   <a:srgbClr val="FFFFFF"/>
                 </a:solidFill>
@@ -3750,14 +3883,14 @@
           </a:p>
           <a:p>
             <a:pPr algn="l">
-              <a:defRPr sz="1500">
-                <a:solidFill>
-                  <a:srgbClr val="FFFFFF"/>
-                </a:solidFill>
-              </a:defRPr>
-            </a:pPr>
-            <a:r>
-              <a:rPr sz="1500">
+              <a:defRPr sz="1400">
+                <a:solidFill>
+                  <a:srgbClr val="FFFFFF"/>
+                </a:solidFill>
+              </a:defRPr>
+            </a:pPr>
+            <a:r>
+              <a:rPr sz="1400">
                 <a:solidFill>
                   <a:srgbClr val="FFFFFF"/>
                 </a:solidFill>
@@ -3765,7 +3898,7 @@
               <a:t>• </a:t>
             </a:r>
             <a:r>
-              <a:rPr sz="1500" i="1">
+              <a:rPr sz="1400" i="1">
                 <a:solidFill>
                   <a:srgbClr val="FFFFFF"/>
                 </a:solidFill>
@@ -3773,7 +3906,7 @@
               <a:t>I</a:t>
             </a:r>
             <a:r>
-              <a:rPr sz="1500" i="1">
+              <a:rPr sz="1400" i="1">
                 <a:solidFill>
                   <a:srgbClr val="FFFFFF"/>
                 </a:solidFill>
@@ -3781,24 +3914,48 @@
               <a:t>L</a:t>
             </a:r>
             <a:r>
-              <a:rPr sz="1500">
-                <a:solidFill>
-                  <a:srgbClr val="FFFFFF"/>
-                </a:solidFill>
-              </a:rPr>
-              <a:t>: Corriente fotogenerada por irradiancia (A).</a:t>
-            </a:r>
-          </a:p>
-          <a:p>
-            <a:pPr algn="l">
-              <a:defRPr sz="1500">
-                <a:solidFill>
-                  <a:srgbClr val="FFFFFF"/>
-                </a:solidFill>
-              </a:defRPr>
-            </a:pPr>
-            <a:r>
-              <a:rPr sz="1500">
+              <a:rPr sz="1400">
+                <a:solidFill>
+                  <a:srgbClr val="FFFFFF"/>
+                </a:solidFill>
+              </a:rPr>
+              <a:t> / </a:t>
+            </a:r>
+            <a:r>
+              <a:rPr sz="1400" i="1">
+                <a:solidFill>
+                  <a:srgbClr val="FFFFFF"/>
+                </a:solidFill>
+              </a:rPr>
+              <a:t>I</a:t>
+            </a:r>
+            <a:r>
+              <a:rPr sz="1400" i="1">
+                <a:solidFill>
+                  <a:srgbClr val="FFFFFF"/>
+                </a:solidFill>
+              </a:rPr>
+              <a:t>0</a:t>
+            </a:r>
+            <a:r>
+              <a:rPr sz="1400">
+                <a:solidFill>
+                  <a:srgbClr val="FFFFFF"/>
+                </a:solidFill>
+              </a:rPr>
+              <a:t>: Corrientes fotogenerada y de saturación (A).</a:t>
+            </a:r>
+          </a:p>
+          <a:p>
+            <a:pPr algn="l">
+              <a:defRPr sz="1400">
+                <a:solidFill>
+                  <a:srgbClr val="FFFFFF"/>
+                </a:solidFill>
+              </a:defRPr>
+            </a:pPr>
+            <a:r>
+              <a:rPr sz="1400">
                 <a:solidFill>
                   <a:srgbClr val="FFFFFF"/>
                 </a:solidFill>
@@ -3806,40 +3963,64 @@
               <a:t>• </a:t>
             </a:r>
             <a:r>
-              <a:rPr sz="1500" i="1">
-                <a:solidFill>
-                  <a:srgbClr val="FFFFFF"/>
-                </a:solidFill>
-              </a:rPr>
-              <a:t>I</a:t>
-            </a:r>
-            <a:r>
-              <a:rPr sz="1500" i="1">
-                <a:solidFill>
-                  <a:srgbClr val="FFFFFF"/>
-                </a:solidFill>
-              </a:rPr>
-              <a:t>0</a:t>
-            </a:r>
-            <a:r>
-              <a:rPr sz="1500">
-                <a:solidFill>
-                  <a:srgbClr val="FFFFFF"/>
-                </a:solidFill>
-              </a:rPr>
-              <a:t>: Corriente de saturación inversa del diodo (A).</a:t>
-            </a:r>
-          </a:p>
-          <a:p>
-            <a:pPr algn="l">
-              <a:defRPr sz="1500">
-                <a:solidFill>
-                  <a:srgbClr val="FFFFFF"/>
-                </a:solidFill>
-              </a:defRPr>
-            </a:pPr>
-            <a:r>
-              <a:rPr sz="1500">
+              <a:rPr sz="1400" i="1">
+                <a:solidFill>
+                  <a:srgbClr val="FFFFFF"/>
+                </a:solidFill>
+              </a:rPr>
+              <a:t>R</a:t>
+            </a:r>
+            <a:r>
+              <a:rPr sz="1400" i="1">
+                <a:solidFill>
+                  <a:srgbClr val="FFFFFF"/>
+                </a:solidFill>
+              </a:rPr>
+              <a:t>s</a:t>
+            </a:r>
+            <a:r>
+              <a:rPr sz="1400">
+                <a:solidFill>
+                  <a:srgbClr val="FFFFFF"/>
+                </a:solidFill>
+              </a:rPr>
+              <a:t> / </a:t>
+            </a:r>
+            <a:r>
+              <a:rPr sz="1400" i="1">
+                <a:solidFill>
+                  <a:srgbClr val="FFFFFF"/>
+                </a:solidFill>
+              </a:rPr>
+              <a:t>R</a:t>
+            </a:r>
+            <a:r>
+              <a:rPr sz="1400" i="1">
+                <a:solidFill>
+                  <a:srgbClr val="FFFFFF"/>
+                </a:solidFill>
+              </a:rPr>
+              <a:t>sh</a:t>
+            </a:r>
+            <a:r>
+              <a:rPr sz="1400">
+                <a:solidFill>
+                  <a:srgbClr val="FFFFFF"/>
+                </a:solidFill>
+              </a:rPr>
+              <a:t>: Resistencia serie (pérdidas) y paralelo (fugas) (Ω).</a:t>
+            </a:r>
+          </a:p>
+          <a:p>
+            <a:pPr algn="l">
+              <a:defRPr sz="1400">
+                <a:solidFill>
+                  <a:srgbClr val="FFFFFF"/>
+                </a:solidFill>
+              </a:defRPr>
+            </a:pPr>
+            <a:r>
+              <a:rPr sz="1400">
                 <a:solidFill>
                   <a:srgbClr val="FFFFFF"/>
                 </a:solidFill>
@@ -3847,171 +4028,7 @@
               <a:t>• </a:t>
             </a:r>
             <a:r>
-              <a:rPr sz="1500" i="1">
-                <a:solidFill>
-                  <a:srgbClr val="FFFFFF"/>
-                </a:solidFill>
-              </a:rPr>
-              <a:t>R</a:t>
-            </a:r>
-            <a:r>
-              <a:rPr sz="1500" i="1">
-                <a:solidFill>
-                  <a:srgbClr val="FFFFFF"/>
-                </a:solidFill>
-              </a:rPr>
-              <a:t>s</a:t>
-            </a:r>
-            <a:r>
-              <a:rPr sz="1500">
-                <a:solidFill>
-                  <a:srgbClr val="FFFFFF"/>
-                </a:solidFill>
-              </a:rPr>
-              <a:t>: Resistencia serie de pérdidas (Ω).</a:t>
-            </a:r>
-          </a:p>
-          <a:p>
-            <a:pPr algn="l">
-              <a:defRPr sz="1500">
-                <a:solidFill>
-                  <a:srgbClr val="FFFFFF"/>
-                </a:solidFill>
-              </a:defRPr>
-            </a:pPr>
-            <a:r>
-              <a:rPr sz="1500">
-                <a:solidFill>
-                  <a:srgbClr val="FFFFFF"/>
-                </a:solidFill>
-              </a:rPr>
-              <a:t>• </a:t>
-            </a:r>
-            <a:r>
-              <a:rPr sz="1500" i="1">
-                <a:solidFill>
-                  <a:srgbClr val="FFFFFF"/>
-                </a:solidFill>
-              </a:rPr>
-              <a:t>R</a:t>
-            </a:r>
-            <a:r>
-              <a:rPr sz="1500" i="1">
-                <a:solidFill>
-                  <a:srgbClr val="FFFFFF"/>
-                </a:solidFill>
-              </a:rPr>
-              <a:t>sh</a:t>
-            </a:r>
-            <a:r>
-              <a:rPr sz="1500">
-                <a:solidFill>
-                  <a:srgbClr val="FFFFFF"/>
-                </a:solidFill>
-              </a:rPr>
-              <a:t>: Resistencia paralelo o shunt de fugas (Ω).</a:t>
-            </a:r>
-          </a:p>
-          <a:p>
-            <a:pPr algn="l">
-              <a:defRPr sz="1500">
-                <a:solidFill>
-                  <a:srgbClr val="FFFFFF"/>
-                </a:solidFill>
-              </a:defRPr>
-            </a:pPr>
-            <a:r>
-              <a:rPr sz="1500">
-                <a:solidFill>
-                  <a:srgbClr val="FFFFFF"/>
-                </a:solidFill>
-              </a:rPr>
-              <a:t>• </a:t>
-            </a:r>
-            <a:r>
-              <a:rPr sz="1500" i="1">
-                <a:solidFill>
-                  <a:srgbClr val="FFFFFF"/>
-                </a:solidFill>
-              </a:rPr>
-              <a:t>N</a:t>
-            </a:r>
-            <a:r>
-              <a:rPr sz="1500" i="1">
-                <a:solidFill>
-                  <a:srgbClr val="FFFFFF"/>
-                </a:solidFill>
-              </a:rPr>
-              <a:t>s</a:t>
-            </a:r>
-            <a:r>
-              <a:rPr sz="1500">
-                <a:solidFill>
-                  <a:srgbClr val="FFFFFF"/>
-                </a:solidFill>
-              </a:rPr>
-              <a:t>: Número de celdas en serie (m-Si: 36, HIT: 72).</a:t>
-            </a:r>
-          </a:p>
-          <a:p>
-            <a:pPr algn="l">
-              <a:defRPr sz="1500">
-                <a:solidFill>
-                  <a:srgbClr val="FFFFFF"/>
-                </a:solidFill>
-              </a:defRPr>
-            </a:pPr>
-            <a:r>
-              <a:rPr sz="1500">
-                <a:solidFill>
-                  <a:srgbClr val="FFFFFF"/>
-                </a:solidFill>
-              </a:rPr>
-              <a:t>• </a:t>
-            </a:r>
-            <a:r>
-              <a:rPr sz="1500" i="1">
-                <a:solidFill>
-                  <a:srgbClr val="FFFFFF"/>
-                </a:solidFill>
-              </a:rPr>
-              <a:t>n</a:t>
-            </a:r>
-            <a:r>
-              <a:rPr sz="1500" i="1">
-                <a:solidFill>
-                  <a:srgbClr val="FFFFFF"/>
-                </a:solidFill>
-              </a:rPr>
-              <a:t>I</a:t>
-            </a:r>
-            <a:r>
-              <a:rPr sz="1500">
-                <a:solidFill>
-                  <a:srgbClr val="FFFFFF"/>
-                </a:solidFill>
-              </a:rPr>
-              <a:t>: Factor de idealidad del diodo.</a:t>
-            </a:r>
-          </a:p>
-          <a:p>
-            <a:pPr algn="l">
-              <a:defRPr sz="1500">
-                <a:solidFill>
-                  <a:srgbClr val="FFFFFF"/>
-                </a:solidFill>
-              </a:defRPr>
-            </a:pPr>
-            <a:r>
-              <a:rPr sz="1500">
-                <a:solidFill>
-                  <a:srgbClr val="FFFFFF"/>
-                </a:solidFill>
-              </a:rPr>
-              <a:t>• </a:t>
-            </a:r>
-            <a:r>
-              <a:rPr sz="1500" i="1">
+              <a:rPr sz="1400" i="1">
                 <a:solidFill>
                   <a:srgbClr val="FFFFFF"/>
                 </a:solidFill>
@@ -4019,32 +4036,15 @@
               <a:t>k</a:t>
             </a:r>
             <a:r>
-              <a:rPr sz="1500">
-                <a:solidFill>
-                  <a:srgbClr val="FFFFFF"/>
-                </a:solidFill>
-              </a:rPr>
-              <a:t>: Constante de Boltzmann (1.3806 × 10⁻²³ J/K).</a:t>
-            </a:r>
-          </a:p>
-          <a:p>
-            <a:pPr algn="l">
-              <a:defRPr sz="1500">
-                <a:solidFill>
-                  <a:srgbClr val="FFFFFF"/>
-                </a:solidFill>
-              </a:defRPr>
-            </a:pPr>
-            <a:r>
-              <a:rPr sz="1500">
-                <a:solidFill>
-                  <a:srgbClr val="FFFFFF"/>
-                </a:solidFill>
-              </a:rPr>
-              <a:t>• </a:t>
-            </a:r>
-            <a:r>
-              <a:rPr sz="1500" i="1">
+              <a:rPr sz="1400">
+                <a:solidFill>
+                  <a:srgbClr val="FFFFFF"/>
+                </a:solidFill>
+              </a:rPr>
+              <a:t> / </a:t>
+            </a:r>
+            <a:r>
+              <a:rPr sz="1400" i="1">
                 <a:solidFill>
                   <a:srgbClr val="FFFFFF"/>
                 </a:solidFill>
@@ -4052,32 +4052,15 @@
               <a:t>q</a:t>
             </a:r>
             <a:r>
-              <a:rPr sz="1500">
-                <a:solidFill>
-                  <a:srgbClr val="FFFFFF"/>
-                </a:solidFill>
-              </a:rPr>
-              <a:t>: Carga elemental del electrón (1.6022 × 10⁻¹⁹ C).</a:t>
-            </a:r>
-          </a:p>
-          <a:p>
-            <a:pPr algn="l">
-              <a:defRPr sz="1500">
-                <a:solidFill>
-                  <a:srgbClr val="FFFFFF"/>
-                </a:solidFill>
-              </a:defRPr>
-            </a:pPr>
-            <a:r>
-              <a:rPr sz="1500">
-                <a:solidFill>
-                  <a:srgbClr val="FFFFFF"/>
-                </a:solidFill>
-              </a:rPr>
-              <a:t>• </a:t>
-            </a:r>
-            <a:r>
-              <a:rPr sz="1500" i="1">
+              <a:rPr sz="1400">
+                <a:solidFill>
+                  <a:srgbClr val="FFFFFF"/>
+                </a:solidFill>
+              </a:rPr>
+              <a:t> / </a:t>
+            </a:r>
+            <a:r>
+              <a:rPr sz="1400" i="1">
                 <a:solidFill>
                   <a:srgbClr val="FFFFFF"/>
                 </a:solidFill>
@@ -4085,7 +4068,7 @@
               <a:t>T</a:t>
             </a:r>
             <a:r>
-              <a:rPr sz="1500" i="1">
+              <a:rPr sz="1400" i="1">
                 <a:solidFill>
                   <a:srgbClr val="FFFFFF"/>
                 </a:solidFill>
@@ -4093,19 +4076,19 @@
               <a:t>c</a:t>
             </a:r>
             <a:r>
-              <a:rPr sz="1500">
-                <a:solidFill>
-                  <a:srgbClr val="FFFFFF"/>
-                </a:solidFill>
-              </a:rPr>
-              <a:t>: Temperatura de celda absoluta (K).</a:t>
-            </a:r>
-          </a:p>
-        </p:txBody>
-      </p:sp>
-      <p:sp>
-        <p:nvSpPr>
-          <p:cNvPr id="12" name="TextBox 11"/>
+              <a:rPr sz="1400">
+                <a:solidFill>
+                  <a:srgbClr val="FFFFFF"/>
+                </a:solidFill>
+              </a:rPr>
+              <a:t>: Constante de Boltzmann, carga elemental y Temp. (K).</a:t>
+            </a:r>
+          </a:p>
+        </p:txBody>
+      </p:sp>
+      <p:sp>
+        <p:nvSpPr>
+          <p:cNvPr id="15" name="TextBox 14"/>
           <p:cNvSpPr txBox="1"/>
           <p:nvPr/>
         </p:nvSpPr>
@@ -4213,7 +4196,7 @@
         <p:spPr>
           <a:xfrm>
             <a:off x="365760" y="1097280"/>
-            <a:ext cx="5547207" cy="5029200"/>
+            <a:ext cx="4572000" cy="5029200"/>
           </a:xfrm>
           <a:prstGeom prst="rect">
             <a:avLst/>
@@ -4258,7 +4241,7 @@
         <p:spPr>
           <a:xfrm>
             <a:off x="457200" y="1188720"/>
-            <a:ext cx="5364327" cy="411480"/>
+            <a:ext cx="4389120" cy="411480"/>
           </a:xfrm>
           <a:prstGeom prst="rect">
             <a:avLst/>
@@ -4284,7 +4267,15 @@
                   <a:srgbClr val="E8A838"/>
                 </a:solidFill>
               </a:rPr>
-              <a:t>Sistema No-Lineal de 5 Ecuaciones</a:t>
+              <a:t>Extracción en STC </a:t>
+            </a:r>
+            <a:r>
+              <a:rPr sz="1800" b="1">
+                <a:solidFill>
+                  <a:srgbClr val="E8A838"/>
+                </a:solidFill>
+              </a:rPr>
+              <a:t>[1]</a:t>
             </a:r>
           </a:p>
         </p:txBody>
@@ -4298,7 +4289,7 @@
         <p:spPr>
           <a:xfrm>
             <a:off x="548640" y="1554480"/>
-            <a:ext cx="5181447" cy="1188720"/>
+            <a:ext cx="4206240" cy="1371600"/>
           </a:xfrm>
           <a:prstGeom prst="rect">
             <a:avLst/>
@@ -4312,14 +4303,14 @@
           <a:lstStyle/>
           <a:p>
             <a:pPr algn="l">
-              <a:defRPr sz="1500">
-                <a:solidFill>
-                  <a:srgbClr val="FFFFFF"/>
-                </a:solidFill>
-              </a:defRPr>
-            </a:pPr>
-            <a:r>
-              <a:rPr sz="1500">
+              <a:defRPr sz="1400">
+                <a:solidFill>
+                  <a:srgbClr val="FFFFFF"/>
+                </a:solidFill>
+              </a:defRPr>
+            </a:pPr>
+            <a:r>
+              <a:rPr sz="1400">
                 <a:solidFill>
                   <a:srgbClr val="FFFFFF"/>
                 </a:solidFill>
@@ -4327,7 +4318,7 @@
               <a:t>Se extraen </a:t>
             </a:r>
             <a:r>
-              <a:rPr sz="1500" i="1">
+              <a:rPr sz="1400" i="1">
                 <a:solidFill>
                   <a:srgbClr val="FFFFFF"/>
                 </a:solidFill>
@@ -4335,7 +4326,7 @@
               <a:t>a</a:t>
             </a:r>
             <a:r>
-              <a:rPr sz="1500" i="1">
+              <a:rPr sz="1400" i="1">
                 <a:solidFill>
                   <a:srgbClr val="FFFFFF"/>
                 </a:solidFill>
@@ -4343,7 +4334,7 @@
               <a:t>ref</a:t>
             </a:r>
             <a:r>
-              <a:rPr sz="1500">
+              <a:rPr sz="1400">
                 <a:solidFill>
                   <a:srgbClr val="FFFFFF"/>
                 </a:solidFill>
@@ -4351,7 +4342,7 @@
               <a:t>, </a:t>
             </a:r>
             <a:r>
-              <a:rPr sz="1500" i="1">
+              <a:rPr sz="1400" i="1">
                 <a:solidFill>
                   <a:srgbClr val="FFFFFF"/>
                 </a:solidFill>
@@ -4359,7 +4350,7 @@
               <a:t>I</a:t>
             </a:r>
             <a:r>
-              <a:rPr sz="1500" i="1">
+              <a:rPr sz="1400" i="1">
                 <a:solidFill>
                   <a:srgbClr val="FFFFFF"/>
                 </a:solidFill>
@@ -4367,7 +4358,7 @@
               <a:t>L,ref</a:t>
             </a:r>
             <a:r>
-              <a:rPr sz="1500">
+              <a:rPr sz="1400">
                 <a:solidFill>
                   <a:srgbClr val="FFFFFF"/>
                 </a:solidFill>
@@ -4375,7 +4366,7 @@
               <a:t>, </a:t>
             </a:r>
             <a:r>
-              <a:rPr sz="1500" i="1">
+              <a:rPr sz="1400" i="1">
                 <a:solidFill>
                   <a:srgbClr val="FFFFFF"/>
                 </a:solidFill>
@@ -4383,7 +4374,7 @@
               <a:t>I</a:t>
             </a:r>
             <a:r>
-              <a:rPr sz="1500" i="1">
+              <a:rPr sz="1400" i="1">
                 <a:solidFill>
                   <a:srgbClr val="FFFFFF"/>
                 </a:solidFill>
@@ -4391,7 +4382,7 @@
               <a:t>0,ref</a:t>
             </a:r>
             <a:r>
-              <a:rPr sz="1500">
+              <a:rPr sz="1400">
                 <a:solidFill>
                   <a:srgbClr val="FFFFFF"/>
                 </a:solidFill>
@@ -4399,7 +4390,7 @@
               <a:t>, </a:t>
             </a:r>
             <a:r>
-              <a:rPr sz="1500" i="1">
+              <a:rPr sz="1400" i="1">
                 <a:solidFill>
                   <a:srgbClr val="FFFFFF"/>
                 </a:solidFill>
@@ -4407,7 +4398,7 @@
               <a:t>R</a:t>
             </a:r>
             <a:r>
-              <a:rPr sz="1500" i="1">
+              <a:rPr sz="1400" i="1">
                 <a:solidFill>
                   <a:srgbClr val="FFFFFF"/>
                 </a:solidFill>
@@ -4415,7 +4406,7 @@
               <a:t>s,ref</a:t>
             </a:r>
             <a:r>
-              <a:rPr sz="1500">
+              <a:rPr sz="1400">
                 <a:solidFill>
                   <a:srgbClr val="FFFFFF"/>
                 </a:solidFill>
@@ -4423,7 +4414,7 @@
               <a:t>, </a:t>
             </a:r>
             <a:r>
-              <a:rPr sz="1500" i="1">
+              <a:rPr sz="1400" i="1">
                 <a:solidFill>
                   <a:srgbClr val="FFFFFF"/>
                 </a:solidFill>
@@ -4431,7 +4422,7 @@
               <a:t>R</a:t>
             </a:r>
             <a:r>
-              <a:rPr sz="1500" i="1">
+              <a:rPr sz="1400" i="1">
                 <a:solidFill>
                   <a:srgbClr val="FFFFFF"/>
                 </a:solidFill>
@@ -4439,57 +4430,57 @@
               <a:t>sh,ref</a:t>
             </a:r>
             <a:r>
-              <a:rPr sz="1500">
-                <a:solidFill>
-                  <a:srgbClr val="FFFFFF"/>
-                </a:solidFill>
-              </a:rPr>
-              <a:t> en STC</a:t>
-            </a:r>
-            <a:r>
-              <a:rPr sz="1500">
-                <a:solidFill>
-                  <a:srgbClr val="FFFFFF"/>
-                </a:solidFill>
-              </a:rPr>
-              <a:t>[1]</a:t>
-            </a:r>
-            <a:r>
-              <a:rPr sz="1500">
-                <a:solidFill>
-                  <a:srgbClr val="FFFFFF"/>
-                </a:solidFill>
-              </a:rPr>
-              <a:t>:</a:t>
-            </a:r>
-          </a:p>
-          <a:p>
-            <a:pPr algn="l">
-              <a:defRPr sz="1500">
-                <a:solidFill>
-                  <a:srgbClr val="FFFFFF"/>
-                </a:solidFill>
-              </a:defRPr>
-            </a:pPr>
-          </a:p>
-          <a:p>
-            <a:pPr algn="l">
-              <a:defRPr sz="1500">
-                <a:solidFill>
-                  <a:srgbClr val="FFFFFF"/>
-                </a:solidFill>
-              </a:defRPr>
-            </a:pPr>
-            <a:r>
-              <a:rPr sz="1500">
-                <a:solidFill>
-                  <a:srgbClr val="FFFFFF"/>
-                </a:solidFill>
-              </a:rPr>
-              <a:t>1. Cortocircuito (</a:t>
-            </a:r>
-            <a:r>
-              <a:rPr sz="1500" i="1">
+              <a:rPr sz="1400">
+                <a:solidFill>
+                  <a:srgbClr val="FFFFFF"/>
+                </a:solidFill>
+              </a:rPr>
+              <a:t> en STC:</a:t>
+            </a:r>
+          </a:p>
+          <a:p>
+            <a:pPr algn="l">
+              <a:defRPr sz="1400">
+                <a:solidFill>
+                  <a:srgbClr val="FFFFFF"/>
+                </a:solidFill>
+              </a:defRPr>
+            </a:pPr>
+          </a:p>
+          <a:p>
+            <a:pPr algn="l">
+              <a:defRPr sz="1400">
+                <a:solidFill>
+                  <a:srgbClr val="FFFFFF"/>
+                </a:solidFill>
+              </a:defRPr>
+            </a:pPr>
+            <a:r>
+              <a:rPr sz="1400">
+                <a:solidFill>
+                  <a:srgbClr val="FFFFFF"/>
+                </a:solidFill>
+              </a:rPr>
+              <a:t>1. Cortocircuito: </a:t>
+            </a:r>
+            <a:r>
+              <a:rPr sz="1400" i="1">
+                <a:solidFill>
+                  <a:srgbClr val="FFFFFF"/>
+                </a:solidFill>
+              </a:rPr>
+              <a:t>V</a:t>
+            </a:r>
+            <a:r>
+              <a:rPr sz="1400">
+                <a:solidFill>
+                  <a:srgbClr val="FFFFFF"/>
+                </a:solidFill>
+              </a:rPr>
+              <a:t> = 0, </a:t>
+            </a:r>
+            <a:r>
+              <a:rPr sz="1400" i="1">
                 <a:solidFill>
                   <a:srgbClr val="FFFFFF"/>
                 </a:solidFill>
@@ -4497,23 +4488,64 @@
               <a:t>I</a:t>
             </a:r>
             <a:r>
-              <a:rPr sz="1500" i="1">
-                <a:solidFill>
-                  <a:srgbClr val="FFFFFF"/>
-                </a:solidFill>
-              </a:rPr>
-              <a:t>sc</a:t>
-            </a:r>
-            <a:r>
-              <a:rPr sz="1500">
-                <a:solidFill>
-                  <a:srgbClr val="FFFFFF"/>
-                </a:solidFill>
-              </a:rPr>
-              <a:t>): </a:t>
-            </a:r>
-            <a:r>
-              <a:rPr sz="1500" i="1">
+              <a:rPr sz="1400">
+                <a:solidFill>
+                  <a:srgbClr val="FFFFFF"/>
+                </a:solidFill>
+              </a:rPr>
+              <a:t> = </a:t>
+            </a:r>
+            <a:r>
+              <a:rPr sz="1400" i="1">
+                <a:solidFill>
+                  <a:srgbClr val="FFFFFF"/>
+                </a:solidFill>
+              </a:rPr>
+              <a:t>I</a:t>
+            </a:r>
+            <a:r>
+              <a:rPr sz="1400" i="1">
+                <a:solidFill>
+                  <a:srgbClr val="FFFFFF"/>
+                </a:solidFill>
+              </a:rPr>
+              <a:t>sc,ref</a:t>
+            </a:r>
+          </a:p>
+          <a:p>
+            <a:pPr algn="l">
+              <a:defRPr sz="1400">
+                <a:solidFill>
+                  <a:srgbClr val="FFFFFF"/>
+                </a:solidFill>
+              </a:defRPr>
+            </a:pPr>
+            <a:r>
+              <a:rPr sz="1400">
+                <a:solidFill>
+                  <a:srgbClr val="FFFFFF"/>
+                </a:solidFill>
+              </a:rPr>
+              <a:t>2. Circuito Abierto: </a:t>
+            </a:r>
+            <a:r>
+              <a:rPr sz="1400" i="1">
+                <a:solidFill>
+                  <a:srgbClr val="FFFFFF"/>
+                </a:solidFill>
+              </a:rPr>
+              <a:t>I</a:t>
+            </a:r>
+            <a:r>
+              <a:rPr sz="1400">
+                <a:solidFill>
+                  <a:srgbClr val="FFFFFF"/>
+                </a:solidFill>
+              </a:rPr>
+              <a:t> = 0, </a:t>
+            </a:r>
+            <a:r>
+              <a:rPr sz="1400" i="1">
                 <a:solidFill>
                   <a:srgbClr val="FFFFFF"/>
                 </a:solidFill>
@@ -4521,15 +4553,48 @@
               <a:t>V</a:t>
             </a:r>
             <a:r>
-              <a:rPr sz="1500">
-                <a:solidFill>
-                  <a:srgbClr val="FFFFFF"/>
-                </a:solidFill>
-              </a:rPr>
-              <a:t> = 0, </a:t>
-            </a:r>
-            <a:r>
-              <a:rPr sz="1500" i="1">
+              <a:rPr sz="1400">
+                <a:solidFill>
+                  <a:srgbClr val="FFFFFF"/>
+                </a:solidFill>
+              </a:rPr>
+              <a:t> = </a:t>
+            </a:r>
+            <a:r>
+              <a:rPr sz="1400" i="1">
+                <a:solidFill>
+                  <a:srgbClr val="FFFFFF"/>
+                </a:solidFill>
+              </a:rPr>
+              <a:t>V</a:t>
+            </a:r>
+            <a:r>
+              <a:rPr sz="1400" i="1">
+                <a:solidFill>
+                  <a:srgbClr val="FFFFFF"/>
+                </a:solidFill>
+              </a:rPr>
+              <a:t>oc,ref</a:t>
+            </a:r>
+          </a:p>
+          <a:p>
+            <a:pPr algn="l">
+              <a:defRPr sz="1400">
+                <a:solidFill>
+                  <a:srgbClr val="FFFFFF"/>
+                </a:solidFill>
+              </a:defRPr>
+            </a:pPr>
+            <a:r>
+              <a:rPr sz="1400">
+                <a:solidFill>
+                  <a:srgbClr val="FFFFFF"/>
+                </a:solidFill>
+              </a:rPr>
+              <a:t>3. Máxima Potencia: </a:t>
+            </a:r>
+            <a:r>
+              <a:rPr sz="1400" i="1">
                 <a:solidFill>
                   <a:srgbClr val="FFFFFF"/>
                 </a:solidFill>
@@ -4537,7 +4602,7 @@
               <a:t>I</a:t>
             </a:r>
             <a:r>
-              <a:rPr sz="1500">
+              <a:rPr sz="1400">
                 <a:solidFill>
                   <a:srgbClr val="FFFFFF"/>
                 </a:solidFill>
@@ -4545,7 +4610,7 @@
               <a:t> = </a:t>
             </a:r>
             <a:r>
-              <a:rPr sz="1500" i="1">
+              <a:rPr sz="1400" i="1">
                 <a:solidFill>
                   <a:srgbClr val="FFFFFF"/>
                 </a:solidFill>
@@ -4553,32 +4618,23 @@
               <a:t>I</a:t>
             </a:r>
             <a:r>
-              <a:rPr sz="1500" i="1">
-                <a:solidFill>
-                  <a:srgbClr val="FFFFFF"/>
-                </a:solidFill>
-              </a:rPr>
-              <a:t>sc,ref</a:t>
-            </a:r>
-          </a:p>
-          <a:p>
-            <a:pPr algn="l">
-              <a:defRPr sz="1500">
-                <a:solidFill>
-                  <a:srgbClr val="FFFFFF"/>
-                </a:solidFill>
-              </a:defRPr>
-            </a:pPr>
-            <a:r>
-              <a:rPr sz="1500">
-                <a:solidFill>
-                  <a:srgbClr val="FFFFFF"/>
-                </a:solidFill>
-              </a:rPr>
-              <a:t>2. Circuito Abierto (</a:t>
-            </a:r>
-            <a:r>
-              <a:rPr sz="1500" i="1">
+              <a:rPr sz="1400" i="1">
+                <a:solidFill>
+                  <a:srgbClr val="FFFFFF"/>
+                </a:solidFill>
+              </a:rPr>
+              <a:t>mp,ref</a:t>
+            </a:r>
+            <a:r>
+              <a:rPr sz="1400">
+                <a:solidFill>
+                  <a:srgbClr val="FFFFFF"/>
+                </a:solidFill>
+              </a:rPr>
+              <a:t>, </a:t>
+            </a:r>
+            <a:r>
+              <a:rPr sz="1400" i="1">
                 <a:solidFill>
                   <a:srgbClr val="FFFFFF"/>
                 </a:solidFill>
@@ -4586,39 +4642,15 @@
               <a:t>V</a:t>
             </a:r>
             <a:r>
-              <a:rPr sz="1500" i="1">
-                <a:solidFill>
-                  <a:srgbClr val="FFFFFF"/>
-                </a:solidFill>
-              </a:rPr>
-              <a:t>oc</a:t>
-            </a:r>
-            <a:r>
-              <a:rPr sz="1500">
-                <a:solidFill>
-                  <a:srgbClr val="FFFFFF"/>
-                </a:solidFill>
-              </a:rPr>
-              <a:t>): </a:t>
-            </a:r>
-            <a:r>
-              <a:rPr sz="1500" i="1">
-                <a:solidFill>
-                  <a:srgbClr val="FFFFFF"/>
-                </a:solidFill>
-              </a:rPr>
-              <a:t>I</a:t>
-            </a:r>
-            <a:r>
-              <a:rPr sz="1500">
-                <a:solidFill>
-                  <a:srgbClr val="FFFFFF"/>
-                </a:solidFill>
-              </a:rPr>
-              <a:t> = 0, </a:t>
-            </a:r>
-            <a:r>
-              <a:rPr sz="1500" i="1">
+              <a:rPr sz="1400">
+                <a:solidFill>
+                  <a:srgbClr val="FFFFFF"/>
+                </a:solidFill>
+              </a:rPr>
+              <a:t> = </a:t>
+            </a:r>
+            <a:r>
+              <a:rPr sz="1400" i="1">
                 <a:solidFill>
                   <a:srgbClr val="FFFFFF"/>
                 </a:solidFill>
@@ -4626,15 +4658,48 @@
               <a:t>V</a:t>
             </a:r>
             <a:r>
-              <a:rPr sz="1500">
-                <a:solidFill>
-                  <a:srgbClr val="FFFFFF"/>
-                </a:solidFill>
-              </a:rPr>
-              <a:t> = </a:t>
-            </a:r>
-            <a:r>
-              <a:rPr sz="1500" i="1">
+              <a:rPr sz="1400" i="1">
+                <a:solidFill>
+                  <a:srgbClr val="FFFFFF"/>
+                </a:solidFill>
+              </a:rPr>
+              <a:t>mp,ref</a:t>
+            </a:r>
+          </a:p>
+          <a:p>
+            <a:pPr algn="l">
+              <a:defRPr sz="1400">
+                <a:solidFill>
+                  <a:srgbClr val="FFFFFF"/>
+                </a:solidFill>
+              </a:defRPr>
+            </a:pPr>
+            <a:r>
+              <a:rPr sz="1400">
+                <a:solidFill>
+                  <a:srgbClr val="FFFFFF"/>
+                </a:solidFill>
+              </a:rPr>
+              <a:t>4. Pendiente en MPP (d</a:t>
+            </a:r>
+            <a:r>
+              <a:rPr sz="1400" i="1">
+                <a:solidFill>
+                  <a:srgbClr val="FFFFFF"/>
+                </a:solidFill>
+              </a:rPr>
+              <a:t>P</a:t>
+            </a:r>
+            <a:r>
+              <a:rPr sz="1400">
+                <a:solidFill>
+                  <a:srgbClr val="FFFFFF"/>
+                </a:solidFill>
+              </a:rPr>
+              <a:t>/d</a:t>
+            </a:r>
+            <a:r>
+              <a:rPr sz="1400" i="1">
                 <a:solidFill>
                   <a:srgbClr val="FFFFFF"/>
                 </a:solidFill>
@@ -4642,145 +4707,7 @@
               <a:t>V</a:t>
             </a:r>
             <a:r>
-              <a:rPr sz="1500" i="1">
-                <a:solidFill>
-                  <a:srgbClr val="FFFFFF"/>
-                </a:solidFill>
-              </a:rPr>
-              <a:t>oc,ref</a:t>
-            </a:r>
-          </a:p>
-          <a:p>
-            <a:pPr algn="l">
-              <a:defRPr sz="1500">
-                <a:solidFill>
-                  <a:srgbClr val="FFFFFF"/>
-                </a:solidFill>
-              </a:defRPr>
-            </a:pPr>
-            <a:r>
-              <a:rPr sz="1500">
-                <a:solidFill>
-                  <a:srgbClr val="FFFFFF"/>
-                </a:solidFill>
-              </a:rPr>
-              <a:t>3. Máxima Potencia (MPP): </a:t>
-            </a:r>
-            <a:r>
-              <a:rPr sz="1500" i="1">
-                <a:solidFill>
-                  <a:srgbClr val="FFFFFF"/>
-                </a:solidFill>
-              </a:rPr>
-              <a:t>I</a:t>
-            </a:r>
-            <a:r>
-              <a:rPr sz="1500">
-                <a:solidFill>
-                  <a:srgbClr val="FFFFFF"/>
-                </a:solidFill>
-              </a:rPr>
-              <a:t> = </a:t>
-            </a:r>
-            <a:r>
-              <a:rPr sz="1500" i="1">
-                <a:solidFill>
-                  <a:srgbClr val="FFFFFF"/>
-                </a:solidFill>
-              </a:rPr>
-              <a:t>I</a:t>
-            </a:r>
-            <a:r>
-              <a:rPr sz="1500" i="1">
-                <a:solidFill>
-                  <a:srgbClr val="FFFFFF"/>
-                </a:solidFill>
-              </a:rPr>
-              <a:t>mp,ref</a:t>
-            </a:r>
-            <a:r>
-              <a:rPr sz="1500">
-                <a:solidFill>
-                  <a:srgbClr val="FFFFFF"/>
-                </a:solidFill>
-              </a:rPr>
-              <a:t>, </a:t>
-            </a:r>
-            <a:r>
-              <a:rPr sz="1500" i="1">
-                <a:solidFill>
-                  <a:srgbClr val="FFFFFF"/>
-                </a:solidFill>
-              </a:rPr>
-              <a:t>V</a:t>
-            </a:r>
-            <a:r>
-              <a:rPr sz="1500">
-                <a:solidFill>
-                  <a:srgbClr val="FFFFFF"/>
-                </a:solidFill>
-              </a:rPr>
-              <a:t> = </a:t>
-            </a:r>
-            <a:r>
-              <a:rPr sz="1500" i="1">
-                <a:solidFill>
-                  <a:srgbClr val="FFFFFF"/>
-                </a:solidFill>
-              </a:rPr>
-              <a:t>V</a:t>
-            </a:r>
-            <a:r>
-              <a:rPr sz="1500" i="1">
-                <a:solidFill>
-                  <a:srgbClr val="FFFFFF"/>
-                </a:solidFill>
-              </a:rPr>
-              <a:t>mp,ref</a:t>
-            </a:r>
-          </a:p>
-          <a:p>
-            <a:pPr algn="l">
-              <a:defRPr sz="1500">
-                <a:solidFill>
-                  <a:srgbClr val="FFFFFF"/>
-                </a:solidFill>
-              </a:defRPr>
-            </a:pPr>
-            <a:r>
-              <a:rPr sz="1500">
-                <a:solidFill>
-                  <a:srgbClr val="FFFFFF"/>
-                </a:solidFill>
-              </a:rPr>
-              <a:t>4. Pendiente en MPP (d</a:t>
-            </a:r>
-            <a:r>
-              <a:rPr sz="1500" i="1">
-                <a:solidFill>
-                  <a:srgbClr val="FFFFFF"/>
-                </a:solidFill>
-              </a:rPr>
-              <a:t>P</a:t>
-            </a:r>
-            <a:r>
-              <a:rPr sz="1500">
-                <a:solidFill>
-                  <a:srgbClr val="FFFFFF"/>
-                </a:solidFill>
-              </a:rPr>
-              <a:t>/d</a:t>
-            </a:r>
-            <a:r>
-              <a:rPr sz="1500" i="1">
-                <a:solidFill>
-                  <a:srgbClr val="FFFFFF"/>
-                </a:solidFill>
-              </a:rPr>
-              <a:t>V</a:t>
-            </a:r>
-            <a:r>
-              <a:rPr sz="1500">
+              <a:rPr sz="1400">
                 <a:solidFill>
                   <a:srgbClr val="FFFFFF"/>
                 </a:solidFill>
@@ -4806,8 +4733,8 @@
         </p:blipFill>
         <p:spPr>
           <a:xfrm>
-            <a:off x="640080" y="3063240"/>
-            <a:ext cx="1671969" cy="457200"/>
+            <a:off x="548640" y="3246120"/>
+            <a:ext cx="1404454" cy="384048"/>
           </a:xfrm>
           <a:prstGeom prst="rect">
             <a:avLst/>
@@ -4823,7 +4750,7 @@
         <p:spPr>
           <a:xfrm>
             <a:off x="548640" y="3794760"/>
-            <a:ext cx="5181447" cy="320040"/>
+            <a:ext cx="4206240" cy="320040"/>
           </a:xfrm>
           <a:prstGeom prst="rect">
             <a:avLst/>
@@ -4837,14 +4764,14 @@
           <a:lstStyle/>
           <a:p>
             <a:pPr algn="l">
-              <a:defRPr sz="1500">
-                <a:solidFill>
-                  <a:srgbClr val="FFFFFF"/>
-                </a:solidFill>
-              </a:defRPr>
-            </a:pPr>
-            <a:r>
-              <a:rPr sz="1500">
+              <a:defRPr sz="1400">
+                <a:solidFill>
+                  <a:srgbClr val="FFFFFF"/>
+                </a:solidFill>
+              </a:defRPr>
+            </a:pPr>
+            <a:r>
+              <a:rPr sz="1400">
                 <a:solidFill>
                   <a:srgbClr val="FFFFFF"/>
                 </a:solidFill>
@@ -4852,7 +4779,7 @@
               <a:t>5. Coeficiente térmico de </a:t>
             </a:r>
             <a:r>
-              <a:rPr sz="1500" i="1">
+              <a:rPr sz="1400" i="1">
                 <a:solidFill>
                   <a:srgbClr val="FFFFFF"/>
                 </a:solidFill>
@@ -4860,7 +4787,7 @@
               <a:t>V</a:t>
             </a:r>
             <a:r>
-              <a:rPr sz="1500" i="1">
+              <a:rPr sz="1400" i="1">
                 <a:solidFill>
                   <a:srgbClr val="FFFFFF"/>
                 </a:solidFill>
@@ -4868,7 +4795,7 @@
               <a:t>oc</a:t>
             </a:r>
             <a:r>
-              <a:rPr sz="1500">
+              <a:rPr sz="1400">
                 <a:solidFill>
                   <a:srgbClr val="FFFFFF"/>
                 </a:solidFill>
@@ -4894,8 +4821,8 @@
         </p:blipFill>
         <p:spPr>
           <a:xfrm>
-            <a:off x="640080" y="4206240"/>
-            <a:ext cx="1093670" cy="411480"/>
+            <a:off x="548640" y="4160520"/>
+            <a:ext cx="972151" cy="365760"/>
           </a:xfrm>
           <a:prstGeom prst="rect">
             <a:avLst/>
@@ -4910,8 +4837,8 @@
         </p:nvSpPr>
         <p:spPr>
           <a:xfrm>
-            <a:off x="6187287" y="1097280"/>
-            <a:ext cx="5547207" cy="5029200"/>
+            <a:off x="5212080" y="1097280"/>
+            <a:ext cx="6126480" cy="5029200"/>
           </a:xfrm>
           <a:prstGeom prst="rect">
             <a:avLst/>
@@ -4955,8 +4882,8 @@
         </p:nvSpPr>
         <p:spPr>
           <a:xfrm>
-            <a:off x="6278727" y="1188720"/>
-            <a:ext cx="5364327" cy="411480"/>
+            <a:off x="5303520" y="1188720"/>
+            <a:ext cx="5943600" cy="411480"/>
           </a:xfrm>
           <a:prstGeom prst="rect">
             <a:avLst/>
@@ -4982,7 +4909,7 @@
                   <a:srgbClr val="E8A838"/>
                 </a:solidFill>
               </a:rPr>
-              <a:t>Ecuación de la Derivada Analítica en MPP</a:t>
+              <a:t>Derivada Analítica en MPP</a:t>
             </a:r>
           </a:p>
         </p:txBody>
@@ -4995,8 +4922,8 @@
         </p:nvSpPr>
         <p:spPr>
           <a:xfrm>
-            <a:off x="6370167" y="1554480"/>
-            <a:ext cx="5181447" cy="320040"/>
+            <a:off x="5394960" y="1554480"/>
+            <a:ext cx="5760720" cy="548640"/>
           </a:xfrm>
           <a:prstGeom prst="rect">
             <a:avLst/>
@@ -5010,14 +4937,14 @@
           <a:lstStyle/>
           <a:p>
             <a:pPr algn="l">
-              <a:defRPr sz="1500">
-                <a:solidFill>
-                  <a:srgbClr val="FFFFFF"/>
-                </a:solidFill>
-              </a:defRPr>
-            </a:pPr>
-            <a:r>
-              <a:rPr sz="1500">
+              <a:defRPr sz="1400">
+                <a:solidFill>
+                  <a:srgbClr val="FFFFFF"/>
+                </a:solidFill>
+              </a:defRPr>
+            </a:pPr>
+            <a:r>
+              <a:rPr sz="1400">
                 <a:solidFill>
                   <a:srgbClr val="FFFFFF"/>
                 </a:solidFill>
@@ -5025,7 +4952,7 @@
               <a:t>Para acoplar </a:t>
             </a:r>
             <a:r>
-              <a:rPr sz="1500" i="1">
+              <a:rPr sz="1400" i="1">
                 <a:solidFill>
                   <a:srgbClr val="FFFFFF"/>
                 </a:solidFill>
@@ -5033,7 +4960,7 @@
               <a:t>R</a:t>
             </a:r>
             <a:r>
-              <a:rPr sz="1500" i="1">
+              <a:rPr sz="1400" i="1">
                 <a:solidFill>
                   <a:srgbClr val="FFFFFF"/>
                 </a:solidFill>
@@ -5041,7 +4968,7 @@
               <a:t>s</a:t>
             </a:r>
             <a:r>
-              <a:rPr sz="1500">
+              <a:rPr sz="1400">
                 <a:solidFill>
                   <a:srgbClr val="FFFFFF"/>
                 </a:solidFill>
@@ -5067,8 +4994,8 @@
         </p:blipFill>
         <p:spPr>
           <a:xfrm>
-            <a:off x="6461607" y="2286000"/>
-            <a:ext cx="3060757" cy="475488"/>
+            <a:off x="5394960" y="2148840"/>
+            <a:ext cx="2825314" cy="438912"/>
           </a:xfrm>
           <a:prstGeom prst="rect">
             <a:avLst/>
@@ -5083,8 +5010,8 @@
         </p:nvSpPr>
         <p:spPr>
           <a:xfrm>
-            <a:off x="6370167" y="3337560"/>
-            <a:ext cx="5181447" cy="320040"/>
+            <a:off x="5394960" y="2834640"/>
+            <a:ext cx="5760720" cy="320040"/>
           </a:xfrm>
           <a:prstGeom prst="rect">
             <a:avLst/>
@@ -5098,19 +5025,19 @@
           <a:lstStyle/>
           <a:p>
             <a:pPr algn="l">
-              <a:defRPr sz="1500">
-                <a:solidFill>
-                  <a:srgbClr val="FFFFFF"/>
-                </a:solidFill>
-              </a:defRPr>
-            </a:pPr>
-            <a:r>
-              <a:rPr sz="1500">
-                <a:solidFill>
-                  <a:srgbClr val="FFFFFF"/>
-                </a:solidFill>
-              </a:rPr>
-              <a:t>Donde:</a:t>
+              <a:defRPr sz="1400">
+                <a:solidFill>
+                  <a:srgbClr val="FFFFFF"/>
+                </a:solidFill>
+              </a:defRPr>
+            </a:pPr>
+            <a:r>
+              <a:rPr sz="1400">
+                <a:solidFill>
+                  <a:srgbClr val="FFFFFF"/>
+                </a:solidFill>
+              </a:rPr>
+              <a:t>Donde los coeficientes se definen como:</a:t>
             </a:r>
           </a:p>
         </p:txBody>
@@ -5131,8 +5058,8 @@
         </p:blipFill>
         <p:spPr>
           <a:xfrm>
-            <a:off x="6461607" y="3749039"/>
-            <a:ext cx="2193902" cy="457200"/>
+            <a:off x="5394960" y="3246120"/>
+            <a:ext cx="1974511" cy="411480"/>
           </a:xfrm>
           <a:prstGeom prst="rect">
             <a:avLst/>
@@ -5155,8 +5082,8 @@
         </p:blipFill>
         <p:spPr>
           <a:xfrm>
-            <a:off x="6461607" y="4389120"/>
-            <a:ext cx="770708" cy="365760"/>
+            <a:off x="5394960" y="3794760"/>
+            <a:ext cx="674370" cy="320040"/>
           </a:xfrm>
           <a:prstGeom prst="rect">
             <a:avLst/>
@@ -5171,8 +5098,8 @@
         </p:nvSpPr>
         <p:spPr>
           <a:xfrm>
-            <a:off x="6370167" y="5074920"/>
-            <a:ext cx="5181447" cy="1371600"/>
+            <a:off x="5394960" y="4434840"/>
+            <a:ext cx="5760720" cy="914400"/>
           </a:xfrm>
           <a:prstGeom prst="rect">
             <a:avLst/>
@@ -7160,7 +7087,7 @@
         <p:spPr>
           <a:xfrm>
             <a:off x="365760" y="1097280"/>
-            <a:ext cx="5547207" cy="5029200"/>
+            <a:ext cx="11460175" cy="2011680"/>
           </a:xfrm>
           <a:prstGeom prst="rect">
             <a:avLst/>
@@ -7205,7 +7132,7 @@
         <p:spPr>
           <a:xfrm>
             <a:off x="457200" y="1188720"/>
-            <a:ext cx="5364327" cy="411480"/>
+            <a:ext cx="11277295" cy="411480"/>
           </a:xfrm>
           <a:prstGeom prst="rect">
             <a:avLst/>
@@ -7244,8 +7171,8 @@
         </p:nvSpPr>
         <p:spPr>
           <a:xfrm>
-            <a:off x="548640" y="1554480"/>
-            <a:ext cx="5181447" cy="320040"/>
+            <a:off x="548640" y="1508760"/>
+            <a:ext cx="11094415" cy="320040"/>
           </a:xfrm>
           <a:prstGeom prst="rect">
             <a:avLst/>
@@ -7259,14 +7186,14 @@
           <a:lstStyle/>
           <a:p>
             <a:pPr algn="l">
-              <a:defRPr sz="1600">
-                <a:solidFill>
-                  <a:srgbClr val="FFFFFF"/>
-                </a:solidFill>
-              </a:defRPr>
-            </a:pPr>
-            <a:r>
-              <a:rPr sz="1600">
+              <a:defRPr sz="1500">
+                <a:solidFill>
+                  <a:srgbClr val="FFFFFF"/>
+                </a:solidFill>
+              </a:defRPr>
+            </a:pPr>
+            <a:r>
+              <a:rPr sz="1500">
                 <a:solidFill>
                   <a:srgbClr val="FFFFFF"/>
                 </a:solidFill>
@@ -7274,7 +7201,7 @@
               <a:t>El Performance Ratio (</a:t>
             </a:r>
             <a:r>
-              <a:rPr sz="1600" i="1">
+              <a:rPr sz="1500" i="1">
                 <a:solidFill>
                   <a:srgbClr val="FFFFFF"/>
                 </a:solidFill>
@@ -7282,12 +7209,12 @@
               <a:t>PR</a:t>
             </a:r>
             <a:r>
-              <a:rPr sz="1600">
-                <a:solidFill>
-                  <a:srgbClr val="FFFFFF"/>
-                </a:solidFill>
-              </a:rPr>
-              <a:t>) evalúa la eficiencia neta del sistema fotovoltaico:</a:t>
+              <a:rPr sz="1500">
+                <a:solidFill>
+                  <a:srgbClr val="FFFFFF"/>
+                </a:solidFill>
+              </a:rPr>
+              <a:t>) evalúa la eficiencia neta del sistema fotovoltaico frente a condiciones de referencia STC:</a:t>
             </a:r>
           </a:p>
         </p:txBody>
@@ -7308,7 +7235,7 @@
         </p:blipFill>
         <p:spPr>
           <a:xfrm>
-            <a:off x="640080" y="2240280"/>
+            <a:off x="2011680" y="1965960"/>
             <a:ext cx="1726410" cy="502920"/>
           </a:xfrm>
           <a:prstGeom prst="rect">
@@ -7318,210 +7245,14 @@
       </p:pic>
       <p:sp>
         <p:nvSpPr>
-          <p:cNvPr id="7" name="TextBox 6"/>
-          <p:cNvSpPr txBox="1"/>
-          <p:nvPr/>
-        </p:nvSpPr>
-        <p:spPr>
-          <a:xfrm>
-            <a:off x="548640" y="3017520"/>
-            <a:ext cx="5181447" cy="2743200"/>
-          </a:xfrm>
-          <a:prstGeom prst="rect">
-            <a:avLst/>
-          </a:prstGeom>
-          <a:noFill/>
-        </p:spPr>
-        <p:txBody>
-          <a:bodyPr wrap="square">
-            <a:spAutoFit/>
-          </a:bodyPr>
-          <a:lstStyle/>
-          <a:p>
-            <a:pPr algn="l">
-              <a:defRPr sz="1500">
-                <a:solidFill>
-                  <a:srgbClr val="E8A838"/>
-                </a:solidFill>
-              </a:defRPr>
-            </a:pPr>
-            <a:r>
-              <a:rPr sz="1500">
-                <a:solidFill>
-                  <a:srgbClr val="E8A838"/>
-                </a:solidFill>
-              </a:rPr>
-              <a:t>Donde:</a:t>
-            </a:r>
-          </a:p>
-          <a:p>
-            <a:pPr algn="l">
-              <a:defRPr sz="1500">
-                <a:solidFill>
-                  <a:srgbClr val="E8A838"/>
-                </a:solidFill>
-              </a:defRPr>
-            </a:pPr>
-            <a:r>
-              <a:rPr sz="1500">
-                <a:solidFill>
-                  <a:srgbClr val="E8A838"/>
-                </a:solidFill>
-              </a:rPr>
-              <a:t>• </a:t>
-            </a:r>
-            <a:r>
-              <a:rPr sz="1500" i="1">
-                <a:solidFill>
-                  <a:srgbClr val="E8A838"/>
-                </a:solidFill>
-              </a:rPr>
-              <a:t>P</a:t>
-            </a:r>
-            <a:r>
-              <a:rPr sz="1500" i="1">
-                <a:solidFill>
-                  <a:srgbClr val="E8A838"/>
-                </a:solidFill>
-              </a:rPr>
-              <a:t>mp,SDM</a:t>
-            </a:r>
-            <a:r>
-              <a:rPr sz="1500">
-                <a:solidFill>
-                  <a:srgbClr val="E8A838"/>
-                </a:solidFill>
-              </a:rPr>
-              <a:t>: Potencia MPP simulada hora a hora con De Soto</a:t>
-            </a:r>
-            <a:r>
-              <a:rPr sz="1500">
-                <a:solidFill>
-                  <a:srgbClr val="E8A838"/>
-                </a:solidFill>
-              </a:rPr>
-              <a:t>[1]</a:t>
-            </a:r>
-            <a:r>
-              <a:rPr sz="1500">
-                <a:solidFill>
-                  <a:srgbClr val="E8A838"/>
-                </a:solidFill>
-              </a:rPr>
-              <a:t> (W).</a:t>
-            </a:r>
-          </a:p>
-          <a:p>
-            <a:pPr algn="l">
-              <a:defRPr sz="1500">
-                <a:solidFill>
-                  <a:srgbClr val="E8A838"/>
-                </a:solidFill>
-              </a:defRPr>
-            </a:pPr>
-            <a:r>
-              <a:rPr sz="1500">
-                <a:solidFill>
-                  <a:srgbClr val="E8A838"/>
-                </a:solidFill>
-              </a:rPr>
-              <a:t>• </a:t>
-            </a:r>
-            <a:r>
-              <a:rPr sz="1500" i="1">
-                <a:solidFill>
-                  <a:srgbClr val="E8A838"/>
-                </a:solidFill>
-              </a:rPr>
-              <a:t>P</a:t>
-            </a:r>
-            <a:r>
-              <a:rPr sz="1500" i="1">
-                <a:solidFill>
-                  <a:srgbClr val="E8A838"/>
-                </a:solidFill>
-              </a:rPr>
-              <a:t>STC</a:t>
-            </a:r>
-            <a:r>
-              <a:rPr sz="1500">
-                <a:solidFill>
-                  <a:srgbClr val="E8A838"/>
-                </a:solidFill>
-              </a:rPr>
-              <a:t>: Potencia nominal a STC (m-Si: 46.68 W | HIT: 217.52 W).</a:t>
-            </a:r>
-          </a:p>
-          <a:p>
-            <a:pPr algn="l">
-              <a:defRPr sz="1500">
-                <a:solidFill>
-                  <a:srgbClr val="E8A838"/>
-                </a:solidFill>
-              </a:defRPr>
-            </a:pPr>
-            <a:r>
-              <a:rPr sz="1500">
-                <a:solidFill>
-                  <a:srgbClr val="E8A838"/>
-                </a:solidFill>
-              </a:rPr>
-              <a:t>• </a:t>
-            </a:r>
-            <a:r>
-              <a:rPr sz="1500" i="1">
-                <a:solidFill>
-                  <a:srgbClr val="E8A838"/>
-                </a:solidFill>
-              </a:rPr>
-              <a:t>G</a:t>
-            </a:r>
-            <a:r>
-              <a:rPr sz="1500" i="1">
-                <a:solidFill>
-                  <a:srgbClr val="E8A838"/>
-                </a:solidFill>
-              </a:rPr>
-              <a:t>poa</a:t>
-            </a:r>
-            <a:r>
-              <a:rPr sz="1500">
-                <a:solidFill>
-                  <a:srgbClr val="E8A838"/>
-                </a:solidFill>
-              </a:rPr>
-              <a:t>: Irradiancia calculada en el plano del panel (W/m²).</a:t>
-            </a:r>
-          </a:p>
-          <a:p>
-            <a:pPr algn="l">
-              <a:defRPr sz="1500">
-                <a:solidFill>
-                  <a:srgbClr val="E8A838"/>
-                </a:solidFill>
-              </a:defRPr>
-            </a:pPr>
-            <a:r>
-              <a:rPr sz="1500">
-                <a:solidFill>
-                  <a:srgbClr val="E8A838"/>
-                </a:solidFill>
-              </a:rPr>
-              <a:t>• 1000: Irradiancia de referencia a STC (W/m²).</a:t>
-            </a:r>
-          </a:p>
-        </p:txBody>
-      </p:sp>
-      <p:sp>
-        <p:nvSpPr>
-          <p:cNvPr id="8" name="Rectangle 7"/>
+          <p:cNvPr id="7" name="Rectangle 6"/>
           <p:cNvSpPr/>
           <p:nvPr/>
         </p:nvSpPr>
         <p:spPr>
           <a:xfrm>
-            <a:off x="6187287" y="1097280"/>
-            <a:ext cx="5547207" cy="5029200"/>
+            <a:off x="365760" y="3291840"/>
+            <a:ext cx="4754880" cy="2834640"/>
           </a:xfrm>
           <a:prstGeom prst="rect">
             <a:avLst/>
@@ -7559,14 +7290,14 @@
       </p:sp>
       <p:sp>
         <p:nvSpPr>
-          <p:cNvPr id="9" name="TextBox 8"/>
+          <p:cNvPr id="8" name="TextBox 7"/>
           <p:cNvSpPr txBox="1"/>
           <p:nvPr/>
         </p:nvSpPr>
         <p:spPr>
           <a:xfrm>
-            <a:off x="6278727" y="1188720"/>
-            <a:ext cx="5364327" cy="411480"/>
+            <a:off x="457200" y="3383280"/>
+            <a:ext cx="4572000" cy="411480"/>
           </a:xfrm>
           <a:prstGeom prst="rect">
             <a:avLst/>
@@ -7592,21 +7323,21 @@
                   <a:srgbClr val="E8A838"/>
                 </a:solidFill>
               </a:rPr>
-              <a:t>Significado Físico del PR</a:t>
-            </a:r>
-          </a:p>
-        </p:txBody>
-      </p:sp>
-      <p:sp>
-        <p:nvSpPr>
-          <p:cNvPr id="10" name="TextBox 9"/>
+              <a:t>Glosario de Variables</a:t>
+            </a:r>
+          </a:p>
+        </p:txBody>
+      </p:sp>
+      <p:sp>
+        <p:nvSpPr>
+          <p:cNvPr id="9" name="TextBox 8"/>
           <p:cNvSpPr txBox="1"/>
           <p:nvPr/>
         </p:nvSpPr>
         <p:spPr>
           <a:xfrm>
-            <a:off x="6370167" y="1554480"/>
-            <a:ext cx="5181447" cy="4114800"/>
+            <a:off x="548640" y="3749039"/>
+            <a:ext cx="4389120" cy="2103120"/>
           </a:xfrm>
           <a:prstGeom prst="rect">
             <a:avLst/>
@@ -7620,107 +7351,286 @@
           <a:lstStyle/>
           <a:p>
             <a:pPr algn="l">
-              <a:defRPr sz="1600">
-                <a:solidFill>
-                  <a:srgbClr val="FFFFFF"/>
-                </a:solidFill>
-              </a:defRPr>
-            </a:pPr>
-            <a:r>
-              <a:rPr sz="1600">
-                <a:solidFill>
-                  <a:srgbClr val="FFFFFF"/>
-                </a:solidFill>
-              </a:rPr>
-              <a:t>• Indica la fracción de energía disponible que es realmente convertida en potencia útil de salida.</a:t>
-            </a:r>
-          </a:p>
-          <a:p>
-            <a:pPr algn="l">
-              <a:defRPr sz="1600">
-                <a:solidFill>
-                  <a:srgbClr val="FFFFFF"/>
-                </a:solidFill>
-              </a:defRPr>
-            </a:pPr>
-          </a:p>
-          <a:p>
-            <a:pPr algn="l">
-              <a:defRPr sz="1600">
-                <a:solidFill>
-                  <a:srgbClr val="FFFFFF"/>
-                </a:solidFill>
-              </a:defRPr>
-            </a:pPr>
-            <a:r>
-              <a:rPr sz="1600">
-                <a:solidFill>
-                  <a:srgbClr val="FFFFFF"/>
-                </a:solidFill>
-              </a:rPr>
-              <a:t>• Un </a:t>
-            </a:r>
-            <a:r>
-              <a:rPr sz="1600" i="1">
-                <a:solidFill>
-                  <a:srgbClr val="FFFFFF"/>
-                </a:solidFill>
-              </a:rPr>
-              <a:t>PR</a:t>
-            </a:r>
-            <a:r>
-              <a:rPr sz="1600">
-                <a:solidFill>
-                  <a:srgbClr val="FFFFFF"/>
-                </a:solidFill>
-              </a:rPr>
-              <a:t> de 100% representaría un panel operando permanentemente a 25°C de temperatura de celda y sin ninguna pérdida reflectiva, de cableado o de suciedad.</a:t>
-            </a:r>
-          </a:p>
-          <a:p>
-            <a:pPr algn="l">
-              <a:defRPr sz="1600">
-                <a:solidFill>
-                  <a:srgbClr val="FFFFFF"/>
-                </a:solidFill>
-              </a:defRPr>
-            </a:pPr>
-          </a:p>
-          <a:p>
-            <a:pPr algn="l">
-              <a:defRPr sz="1600">
-                <a:solidFill>
-                  <a:srgbClr val="FFFFFF"/>
-                </a:solidFill>
-              </a:defRPr>
-            </a:pPr>
-            <a:r>
-              <a:rPr sz="1600">
-                <a:solidFill>
-                  <a:srgbClr val="FFFFFF"/>
-                </a:solidFill>
-              </a:rPr>
-              <a:t>• Captura y penaliza de forma acumulativa:</a:t>
-            </a:r>
-          </a:p>
-          <a:p>
-            <a:pPr algn="l">
-              <a:defRPr sz="1600">
-                <a:solidFill>
-                  <a:srgbClr val="FFFFFF"/>
-                </a:solidFill>
-              </a:defRPr>
-            </a:pPr>
-            <a:r>
-              <a:rPr sz="1600">
-                <a:solidFill>
-                  <a:srgbClr val="FFFFFF"/>
-                </a:solidFill>
-              </a:rPr>
-              <a:t>  1. Pérdidas Térmicas (elevada temperatura </a:t>
-            </a:r>
-            <a:r>
-              <a:rPr sz="1600" i="1">
+              <a:defRPr sz="1400">
+                <a:solidFill>
+                  <a:srgbClr val="E8A838"/>
+                </a:solidFill>
+              </a:defRPr>
+            </a:pPr>
+            <a:r>
+              <a:rPr sz="1400">
+                <a:solidFill>
+                  <a:srgbClr val="E8A838"/>
+                </a:solidFill>
+              </a:rPr>
+              <a:t>• </a:t>
+            </a:r>
+            <a:r>
+              <a:rPr sz="1400" i="1">
+                <a:solidFill>
+                  <a:srgbClr val="E8A838"/>
+                </a:solidFill>
+              </a:rPr>
+              <a:t>P</a:t>
+            </a:r>
+            <a:r>
+              <a:rPr sz="1400" i="1">
+                <a:solidFill>
+                  <a:srgbClr val="E8A838"/>
+                </a:solidFill>
+              </a:rPr>
+              <a:t>mp,SDM</a:t>
+            </a:r>
+            <a:r>
+              <a:rPr sz="1400">
+                <a:solidFill>
+                  <a:srgbClr val="E8A838"/>
+                </a:solidFill>
+              </a:rPr>
+              <a:t>: Potencia MPP simulada hora a hora con De Soto</a:t>
+            </a:r>
+            <a:r>
+              <a:rPr sz="1400">
+                <a:solidFill>
+                  <a:srgbClr val="E8A838"/>
+                </a:solidFill>
+              </a:rPr>
+              <a:t>[1]</a:t>
+            </a:r>
+            <a:r>
+              <a:rPr sz="1400">
+                <a:solidFill>
+                  <a:srgbClr val="E8A838"/>
+                </a:solidFill>
+              </a:rPr>
+              <a:t> (W).</a:t>
+            </a:r>
+          </a:p>
+          <a:p>
+            <a:pPr algn="l">
+              <a:defRPr sz="1400">
+                <a:solidFill>
+                  <a:srgbClr val="E8A838"/>
+                </a:solidFill>
+              </a:defRPr>
+            </a:pPr>
+            <a:r>
+              <a:rPr sz="1400">
+                <a:solidFill>
+                  <a:srgbClr val="E8A838"/>
+                </a:solidFill>
+              </a:rPr>
+              <a:t>• </a:t>
+            </a:r>
+            <a:r>
+              <a:rPr sz="1400" i="1">
+                <a:solidFill>
+                  <a:srgbClr val="E8A838"/>
+                </a:solidFill>
+              </a:rPr>
+              <a:t>P</a:t>
+            </a:r>
+            <a:r>
+              <a:rPr sz="1400" i="1">
+                <a:solidFill>
+                  <a:srgbClr val="E8A838"/>
+                </a:solidFill>
+              </a:rPr>
+              <a:t>STC</a:t>
+            </a:r>
+            <a:r>
+              <a:rPr sz="1400">
+                <a:solidFill>
+                  <a:srgbClr val="E8A838"/>
+                </a:solidFill>
+              </a:rPr>
+              <a:t>: Potencia nominal en STC (m-Si: 46.68 W | HIT: 217.52 W).</a:t>
+            </a:r>
+          </a:p>
+          <a:p>
+            <a:pPr algn="l">
+              <a:defRPr sz="1400">
+                <a:solidFill>
+                  <a:srgbClr val="E8A838"/>
+                </a:solidFill>
+              </a:defRPr>
+            </a:pPr>
+            <a:r>
+              <a:rPr sz="1400">
+                <a:solidFill>
+                  <a:srgbClr val="E8A838"/>
+                </a:solidFill>
+              </a:rPr>
+              <a:t>• </a:t>
+            </a:r>
+            <a:r>
+              <a:rPr sz="1400" i="1">
+                <a:solidFill>
+                  <a:srgbClr val="E8A838"/>
+                </a:solidFill>
+              </a:rPr>
+              <a:t>G</a:t>
+            </a:r>
+            <a:r>
+              <a:rPr sz="1400" i="1">
+                <a:solidFill>
+                  <a:srgbClr val="E8A838"/>
+                </a:solidFill>
+              </a:rPr>
+              <a:t>poa</a:t>
+            </a:r>
+            <a:r>
+              <a:rPr sz="1400">
+                <a:solidFill>
+                  <a:srgbClr val="E8A838"/>
+                </a:solidFill>
+              </a:rPr>
+              <a:t>: Irradiancia calculada en el plano del panel (W/m²).</a:t>
+            </a:r>
+          </a:p>
+          <a:p>
+            <a:pPr algn="l">
+              <a:defRPr sz="1400">
+                <a:solidFill>
+                  <a:srgbClr val="E8A838"/>
+                </a:solidFill>
+              </a:defRPr>
+            </a:pPr>
+            <a:r>
+              <a:rPr sz="1400">
+                <a:solidFill>
+                  <a:srgbClr val="E8A838"/>
+                </a:solidFill>
+              </a:rPr>
+              <a:t>• 1000: Irradiancia de referencia a STC (W/m²).</a:t>
+            </a:r>
+          </a:p>
+        </p:txBody>
+      </p:sp>
+      <p:sp>
+        <p:nvSpPr>
+          <p:cNvPr id="10" name="Rectangle 9"/>
+          <p:cNvSpPr/>
+          <p:nvPr/>
+        </p:nvSpPr>
+        <p:spPr>
+          <a:xfrm>
+            <a:off x="5394960" y="3291840"/>
+            <a:ext cx="5943600" cy="2834640"/>
+          </a:xfrm>
+          <a:prstGeom prst="rect">
+            <a:avLst/>
+          </a:prstGeom>
+          <a:solidFill>
+            <a:srgbClr val="22223A"/>
+          </a:solidFill>
+          <a:ln w="12700">
+            <a:solidFill>
+              <a:srgbClr val="007ACC"/>
+            </a:solidFill>
+          </a:ln>
+        </p:spPr>
+        <p:style>
+          <a:lnRef idx="1">
+            <a:schemeClr val="accent1"/>
+          </a:lnRef>
+          <a:fillRef idx="3">
+            <a:schemeClr val="accent1"/>
+          </a:fillRef>
+          <a:effectRef idx="2">
+            <a:schemeClr val="accent1"/>
+          </a:effectRef>
+          <a:fontRef idx="minor">
+            <a:schemeClr val="lt1"/>
+          </a:fontRef>
+        </p:style>
+        <p:txBody>
+          <a:bodyPr rtlCol="0" anchor="ctr"/>
+          <a:lstStyle/>
+          <a:p>
+            <a:pPr algn="ctr"/>
+          </a:p>
+        </p:txBody>
+      </p:sp>
+      <p:sp>
+        <p:nvSpPr>
+          <p:cNvPr id="11" name="TextBox 10"/>
+          <p:cNvSpPr txBox="1"/>
+          <p:nvPr/>
+        </p:nvSpPr>
+        <p:spPr>
+          <a:xfrm>
+            <a:off x="5486400" y="3383280"/>
+            <a:ext cx="5760720" cy="411480"/>
+          </a:xfrm>
+          <a:prstGeom prst="rect">
+            <a:avLst/>
+          </a:prstGeom>
+          <a:noFill/>
+        </p:spPr>
+        <p:txBody>
+          <a:bodyPr wrap="none">
+            <a:spAutoFit/>
+          </a:bodyPr>
+          <a:lstStyle/>
+          <a:p>
+            <a:pPr>
+              <a:defRPr sz="1800">
+                <a:solidFill>
+                  <a:srgbClr val="E8A838"/>
+                </a:solidFill>
+              </a:defRPr>
+            </a:pPr>
+            <a:r>
+              <a:rPr sz="1800" b="1">
+                <a:solidFill>
+                  <a:srgbClr val="E8A838"/>
+                </a:solidFill>
+              </a:rPr>
+              <a:t>Pérdidas Penalizadas por el PR</a:t>
+            </a:r>
+          </a:p>
+        </p:txBody>
+      </p:sp>
+      <p:sp>
+        <p:nvSpPr>
+          <p:cNvPr id="12" name="TextBox 11"/>
+          <p:cNvSpPr txBox="1"/>
+          <p:nvPr/>
+        </p:nvSpPr>
+        <p:spPr>
+          <a:xfrm>
+            <a:off x="5577840" y="3749039"/>
+            <a:ext cx="5577840" cy="2103120"/>
+          </a:xfrm>
+          <a:prstGeom prst="rect">
+            <a:avLst/>
+          </a:prstGeom>
+          <a:noFill/>
+        </p:spPr>
+        <p:txBody>
+          <a:bodyPr wrap="square">
+            <a:spAutoFit/>
+          </a:bodyPr>
+          <a:lstStyle/>
+          <a:p>
+            <a:pPr algn="l">
+              <a:defRPr sz="1500">
+                <a:solidFill>
+                  <a:srgbClr val="FFFFFF"/>
+                </a:solidFill>
+              </a:defRPr>
+            </a:pPr>
+            <a:r>
+              <a:rPr sz="1500">
+                <a:solidFill>
+                  <a:srgbClr val="FFFFFF"/>
+                </a:solidFill>
+              </a:rPr>
+              <a:t>• **Pérdidas Térmicas:** Caídas debidas a la elevada temperatura </a:t>
+            </a:r>
+            <a:r>
+              <a:rPr sz="1500" i="1">
                 <a:solidFill>
                   <a:srgbClr val="FFFFFF"/>
                 </a:solidFill>
@@ -7728,7 +7638,7 @@
               <a:t>T</a:t>
             </a:r>
             <a:r>
-              <a:rPr sz="1600" i="1">
+              <a:rPr sz="1500" i="1">
                 <a:solidFill>
                   <a:srgbClr val="FFFFFF"/>
                 </a:solidFill>
@@ -7736,66 +7646,66 @@
               <a:t>c</a:t>
             </a:r>
             <a:r>
-              <a:rPr sz="1600">
-                <a:solidFill>
-                  <a:srgbClr val="FFFFFF"/>
-                </a:solidFill>
-              </a:rPr>
-              <a:t>).</a:t>
-            </a:r>
-          </a:p>
-          <a:p>
-            <a:pPr algn="l">
-              <a:defRPr sz="1600">
-                <a:solidFill>
-                  <a:srgbClr val="FFFFFF"/>
-                </a:solidFill>
-              </a:defRPr>
-            </a:pPr>
-            <a:r>
-              <a:rPr sz="1600">
-                <a:solidFill>
-                  <a:srgbClr val="FFFFFF"/>
-                </a:solidFill>
-              </a:rPr>
-              <a:t>  2. Pérdidas Ópticas por Ángulo de Incidencia (IAM).</a:t>
-            </a:r>
-          </a:p>
-          <a:p>
-            <a:pPr algn="l">
-              <a:defRPr sz="1600">
-                <a:solidFill>
-                  <a:srgbClr val="FFFFFF"/>
-                </a:solidFill>
-              </a:defRPr>
-            </a:pPr>
-            <a:r>
-              <a:rPr sz="1600">
-                <a:solidFill>
-                  <a:srgbClr val="FFFFFF"/>
-                </a:solidFill>
-              </a:rPr>
-              <a:t>  3. Pérdidas por Atenuación Espectral (Masa de Aire).</a:t>
-            </a:r>
-          </a:p>
-          <a:p>
-            <a:pPr algn="l">
-              <a:defRPr sz="1600">
-                <a:solidFill>
-                  <a:srgbClr val="FFFFFF"/>
-                </a:solidFill>
-              </a:defRPr>
-            </a:pPr>
-            <a:r>
-              <a:rPr sz="1600">
-                <a:solidFill>
-                  <a:srgbClr val="FFFFFF"/>
-                </a:solidFill>
-              </a:rPr>
-              <a:t>  4. Pérdidas Óhmicas Internas (Resistencia Serie </a:t>
-            </a:r>
-            <a:r>
-              <a:rPr sz="1600" i="1">
+              <a:rPr sz="1500">
+                <a:solidFill>
+                  <a:srgbClr val="FFFFFF"/>
+                </a:solidFill>
+              </a:rPr>
+              <a:t>.</a:t>
+            </a:r>
+          </a:p>
+          <a:p>
+            <a:pPr algn="l">
+              <a:defRPr sz="1500">
+                <a:solidFill>
+                  <a:srgbClr val="FFFFFF"/>
+                </a:solidFill>
+              </a:defRPr>
+            </a:pPr>
+            <a:r>
+              <a:rPr sz="1500">
+                <a:solidFill>
+                  <a:srgbClr val="FFFFFF"/>
+                </a:solidFill>
+              </a:rPr>
+              <a:t>• **Pérdidas Ópticas:** Efectos reflectivos por ángulo de incidencia (IAM).</a:t>
+            </a:r>
+          </a:p>
+          <a:p>
+            <a:pPr algn="l">
+              <a:defRPr sz="1500">
+                <a:solidFill>
+                  <a:srgbClr val="FFFFFF"/>
+                </a:solidFill>
+              </a:defRPr>
+            </a:pPr>
+            <a:r>
+              <a:rPr sz="1500">
+                <a:solidFill>
+                  <a:srgbClr val="FFFFFF"/>
+                </a:solidFill>
+              </a:rPr>
+              <a:t>• **Pérdidas Espectrales:** Desajustes causados por la Masa de Aire (AM).</a:t>
+            </a:r>
+          </a:p>
+          <a:p>
+            <a:pPr algn="l">
+              <a:defRPr sz="1500">
+                <a:solidFill>
+                  <a:srgbClr val="FFFFFF"/>
+                </a:solidFill>
+              </a:defRPr>
+            </a:pPr>
+            <a:r>
+              <a:rPr sz="1500">
+                <a:solidFill>
+                  <a:srgbClr val="FFFFFF"/>
+                </a:solidFill>
+              </a:rPr>
+              <a:t>• **Pérdidas Óhmicas:** Pérdidas resistivas en la resistencia serie </a:t>
+            </a:r>
+            <a:r>
+              <a:rPr sz="1500" i="1">
                 <a:solidFill>
                   <a:srgbClr val="FFFFFF"/>
                 </a:solidFill>
@@ -7803,7 +7713,7 @@
               <a:t>R</a:t>
             </a:r>
             <a:r>
-              <a:rPr sz="1600" i="1">
+              <a:rPr sz="1500" i="1">
                 <a:solidFill>
                   <a:srgbClr val="FFFFFF"/>
                 </a:solidFill>
@@ -7811,19 +7721,19 @@
               <a:t>s</a:t>
             </a:r>
             <a:r>
-              <a:rPr sz="1600">
-                <a:solidFill>
-                  <a:srgbClr val="FFFFFF"/>
-                </a:solidFill>
-              </a:rPr>
-              <a:t>).</a:t>
-            </a:r>
-          </a:p>
-        </p:txBody>
-      </p:sp>
-      <p:sp>
-        <p:nvSpPr>
-          <p:cNvPr id="11" name="TextBox 10"/>
+              <a:rPr sz="1500">
+                <a:solidFill>
+                  <a:srgbClr val="FFFFFF"/>
+                </a:solidFill>
+              </a:rPr>
+              <a:t>.</a:t>
+            </a:r>
+          </a:p>
+        </p:txBody>
+      </p:sp>
+      <p:sp>
+        <p:nvSpPr>
+          <p:cNvPr id="13" name="TextBox 12"/>
           <p:cNvSpPr txBox="1"/>
           <p:nvPr/>
         </p:nvSpPr>
@@ -11721,7 +11631,7 @@
         <p:spPr>
           <a:xfrm>
             <a:off x="365760" y="1097280"/>
-            <a:ext cx="5547207" cy="5029200"/>
+            <a:ext cx="5029200" cy="5029200"/>
           </a:xfrm>
           <a:prstGeom prst="rect">
             <a:avLst/>
@@ -11766,7 +11676,7 @@
         <p:spPr>
           <a:xfrm>
             <a:off x="457200" y="1188720"/>
-            <a:ext cx="5364327" cy="411480"/>
+            <a:ext cx="4846320" cy="411480"/>
           </a:xfrm>
           <a:prstGeom prst="rect">
             <a:avLst/>
@@ -11806,7 +11716,7 @@
         <p:spPr>
           <a:xfrm>
             <a:off x="548640" y="1554480"/>
-            <a:ext cx="5181447" cy="320040"/>
+            <a:ext cx="4663440" cy="320040"/>
           </a:xfrm>
           <a:prstGeom prst="rect">
             <a:avLst/>
@@ -11853,8 +11763,8 @@
         </p:blipFill>
         <p:spPr>
           <a:xfrm>
-            <a:off x="640080" y="2011680"/>
-            <a:ext cx="5029200" cy="343524"/>
+            <a:off x="548640" y="2011680"/>
+            <a:ext cx="4663440" cy="318540"/>
           </a:xfrm>
           <a:prstGeom prst="rect">
             <a:avLst/>
@@ -11870,7 +11780,7 @@
         <p:spPr>
           <a:xfrm>
             <a:off x="548640" y="2926080"/>
-            <a:ext cx="5181447" cy="2743200"/>
+            <a:ext cx="4663440" cy="2743200"/>
           </a:xfrm>
           <a:prstGeom prst="rect">
             <a:avLst/>
@@ -12097,8 +12007,8 @@
         </p:nvSpPr>
         <p:spPr>
           <a:xfrm>
-            <a:off x="6187287" y="1097280"/>
-            <a:ext cx="5547207" cy="5029200"/>
+            <a:off x="5669280" y="1097280"/>
+            <a:ext cx="5669280" cy="5029200"/>
           </a:xfrm>
           <a:prstGeom prst="rect">
             <a:avLst/>
@@ -12142,8 +12052,8 @@
         </p:nvSpPr>
         <p:spPr>
           <a:xfrm>
-            <a:off x="6278727" y="1188720"/>
-            <a:ext cx="5364327" cy="411480"/>
+            <a:off x="5760720" y="1188720"/>
+            <a:ext cx="5486400" cy="411480"/>
           </a:xfrm>
           <a:prstGeom prst="rect">
             <a:avLst/>
@@ -12182,8 +12092,8 @@
         </p:nvSpPr>
         <p:spPr>
           <a:xfrm>
-            <a:off x="6370167" y="1554480"/>
-            <a:ext cx="5181447" cy="320040"/>
+            <a:off x="5852160" y="1554480"/>
+            <a:ext cx="5303520" cy="320040"/>
           </a:xfrm>
           <a:prstGeom prst="rect">
             <a:avLst/>
@@ -12230,7 +12140,7 @@
         </p:blipFill>
         <p:spPr>
           <a:xfrm>
-            <a:off x="6461607" y="2011680"/>
+            <a:off x="5852160" y="2011680"/>
             <a:ext cx="5029200" cy="282792"/>
           </a:xfrm>
           <a:prstGeom prst="rect">
@@ -12246,8 +12156,8 @@
         </p:nvSpPr>
         <p:spPr>
           <a:xfrm>
-            <a:off x="6370167" y="2926080"/>
-            <a:ext cx="5181447" cy="2743200"/>
+            <a:off x="5852160" y="2926080"/>
+            <a:ext cx="5303520" cy="2743200"/>
           </a:xfrm>
           <a:prstGeom prst="rect">
             <a:avLst/>
@@ -13645,7 +13555,7 @@
         <p:spPr>
           <a:xfrm>
             <a:off x="365760" y="1097280"/>
-            <a:ext cx="5547207" cy="5029200"/>
+            <a:ext cx="11460175" cy="2011680"/>
           </a:xfrm>
           <a:prstGeom prst="rect">
             <a:avLst/>
@@ -13690,7 +13600,7 @@
         <p:spPr>
           <a:xfrm>
             <a:off x="457200" y="1188720"/>
-            <a:ext cx="5364327" cy="411480"/>
+            <a:ext cx="11277295" cy="411480"/>
           </a:xfrm>
           <a:prstGeom prst="rect">
             <a:avLst/>
@@ -13729,8 +13639,8 @@
         </p:nvSpPr>
         <p:spPr>
           <a:xfrm>
-            <a:off x="548640" y="1554480"/>
-            <a:ext cx="5181447" cy="320040"/>
+            <a:off x="548640" y="1508760"/>
+            <a:ext cx="11094415" cy="320040"/>
           </a:xfrm>
           <a:prstGeom prst="rect">
             <a:avLst/>
@@ -13744,14 +13654,14 @@
           <a:lstStyle/>
           <a:p>
             <a:pPr algn="l">
-              <a:defRPr sz="1600">
-                <a:solidFill>
-                  <a:srgbClr val="FFFFFF"/>
-                </a:solidFill>
-              </a:defRPr>
-            </a:pPr>
-            <a:r>
-              <a:rPr sz="1600">
+              <a:defRPr sz="1500">
+                <a:solidFill>
+                  <a:srgbClr val="FFFFFF"/>
+                </a:solidFill>
+              </a:defRPr>
+            </a:pPr>
+            <a:r>
+              <a:rPr sz="1500">
                 <a:solidFill>
                   <a:srgbClr val="FFFFFF"/>
                 </a:solidFill>
@@ -13759,7 +13669,7 @@
               <a:t>La temperatura interna de la celda (</a:t>
             </a:r>
             <a:r>
-              <a:rPr sz="1600" i="1">
+              <a:rPr sz="1500" i="1">
                 <a:solidFill>
                   <a:srgbClr val="FFFFFF"/>
                 </a:solidFill>
@@ -13767,7 +13677,7 @@
               <a:t>T</a:t>
             </a:r>
             <a:r>
-              <a:rPr sz="1600" i="1">
+              <a:rPr sz="1500" i="1">
                 <a:solidFill>
                   <a:srgbClr val="FFFFFF"/>
                 </a:solidFill>
@@ -13775,12 +13685,12 @@
               <a:t>c</a:t>
             </a:r>
             <a:r>
-              <a:rPr sz="1600">
-                <a:solidFill>
-                  <a:srgbClr val="FFFFFF"/>
-                </a:solidFill>
-              </a:rPr>
-              <a:t>) depende del recurso solar y del viento:</a:t>
+              <a:rPr sz="1500">
+                <a:solidFill>
+                  <a:srgbClr val="FFFFFF"/>
+                </a:solidFill>
+              </a:rPr>
+              <a:t>) depende de la irradiancia incidente y de la velocidad del viento:</a:t>
             </a:r>
           </a:p>
         </p:txBody>
@@ -13801,8 +13711,8 @@
         </p:blipFill>
         <p:spPr>
           <a:xfrm>
-            <a:off x="640080" y="2240280"/>
-            <a:ext cx="4586775" cy="438912"/>
+            <a:off x="2011680" y="1965960"/>
+            <a:ext cx="5029200" cy="481247"/>
           </a:xfrm>
           <a:prstGeom prst="rect">
             <a:avLst/>
@@ -13811,266 +13721,14 @@
       </p:pic>
       <p:sp>
         <p:nvSpPr>
-          <p:cNvPr id="7" name="TextBox 6"/>
-          <p:cNvSpPr txBox="1"/>
-          <p:nvPr/>
-        </p:nvSpPr>
-        <p:spPr>
-          <a:xfrm>
-            <a:off x="548640" y="3017520"/>
-            <a:ext cx="5181447" cy="2743200"/>
-          </a:xfrm>
-          <a:prstGeom prst="rect">
-            <a:avLst/>
-          </a:prstGeom>
-          <a:noFill/>
-        </p:spPr>
-        <p:txBody>
-          <a:bodyPr wrap="square">
-            <a:spAutoFit/>
-          </a:bodyPr>
-          <a:lstStyle/>
-          <a:p>
-            <a:pPr algn="l">
-              <a:defRPr sz="1500">
-                <a:solidFill>
-                  <a:srgbClr val="E8A838"/>
-                </a:solidFill>
-              </a:defRPr>
-            </a:pPr>
-            <a:r>
-              <a:rPr sz="1500">
-                <a:solidFill>
-                  <a:srgbClr val="E8A838"/>
-                </a:solidFill>
-              </a:rPr>
-              <a:t>Donde:</a:t>
-            </a:r>
-          </a:p>
-          <a:p>
-            <a:pPr algn="l">
-              <a:defRPr sz="1500">
-                <a:solidFill>
-                  <a:srgbClr val="E8A838"/>
-                </a:solidFill>
-              </a:defRPr>
-            </a:pPr>
-            <a:r>
-              <a:rPr sz="1500">
-                <a:solidFill>
-                  <a:srgbClr val="E8A838"/>
-                </a:solidFill>
-              </a:rPr>
-              <a:t>• </a:t>
-            </a:r>
-            <a:r>
-              <a:rPr sz="1500" i="1">
-                <a:solidFill>
-                  <a:srgbClr val="E8A838"/>
-                </a:solidFill>
-              </a:rPr>
-              <a:t>T</a:t>
-            </a:r>
-            <a:r>
-              <a:rPr sz="1500" i="1">
-                <a:solidFill>
-                  <a:srgbClr val="E8A838"/>
-                </a:solidFill>
-              </a:rPr>
-              <a:t>c</a:t>
-            </a:r>
-            <a:r>
-              <a:rPr sz="1500">
-                <a:solidFill>
-                  <a:srgbClr val="E8A838"/>
-                </a:solidFill>
-              </a:rPr>
-              <a:t> / </a:t>
-            </a:r>
-            <a:r>
-              <a:rPr sz="1500" i="1">
-                <a:solidFill>
-                  <a:srgbClr val="E8A838"/>
-                </a:solidFill>
-              </a:rPr>
-              <a:t>T</a:t>
-            </a:r>
-            <a:r>
-              <a:rPr sz="1500" i="1">
-                <a:solidFill>
-                  <a:srgbClr val="E8A838"/>
-                </a:solidFill>
-              </a:rPr>
-              <a:t>a</a:t>
-            </a:r>
-            <a:r>
-              <a:rPr sz="1500">
-                <a:solidFill>
-                  <a:srgbClr val="E8A838"/>
-                </a:solidFill>
-              </a:rPr>
-              <a:t>: Temperatura de celda y ambiental (°C).</a:t>
-            </a:r>
-          </a:p>
-          <a:p>
-            <a:pPr algn="l">
-              <a:defRPr sz="1500">
-                <a:solidFill>
-                  <a:srgbClr val="E8A838"/>
-                </a:solidFill>
-              </a:defRPr>
-            </a:pPr>
-            <a:r>
-              <a:rPr sz="1500">
-                <a:solidFill>
-                  <a:srgbClr val="E8A838"/>
-                </a:solidFill>
-              </a:rPr>
-              <a:t>• </a:t>
-            </a:r>
-            <a:r>
-              <a:rPr sz="1500" i="1">
-                <a:solidFill>
-                  <a:srgbClr val="E8A838"/>
-                </a:solidFill>
-              </a:rPr>
-              <a:t>G</a:t>
-            </a:r>
-            <a:r>
-              <a:rPr sz="1500" i="1">
-                <a:solidFill>
-                  <a:srgbClr val="E8A838"/>
-                </a:solidFill>
-              </a:rPr>
-              <a:t>poa</a:t>
-            </a:r>
-            <a:r>
-              <a:rPr sz="1500">
-                <a:solidFill>
-                  <a:srgbClr val="E8A838"/>
-                </a:solidFill>
-              </a:rPr>
-              <a:t>: Irradiancia en el plano del panel (W/m²).</a:t>
-            </a:r>
-          </a:p>
-          <a:p>
-            <a:pPr algn="l">
-              <a:defRPr sz="1500">
-                <a:solidFill>
-                  <a:srgbClr val="E8A838"/>
-                </a:solidFill>
-              </a:defRPr>
-            </a:pPr>
-            <a:r>
-              <a:rPr sz="1500">
-                <a:solidFill>
-                  <a:srgbClr val="E8A838"/>
-                </a:solidFill>
-              </a:rPr>
-              <a:t>• </a:t>
-            </a:r>
-            <a:r>
-              <a:rPr sz="1500" i="1">
-                <a:solidFill>
-                  <a:srgbClr val="E8A838"/>
-                </a:solidFill>
-              </a:rPr>
-              <a:t>v</a:t>
-            </a:r>
-            <a:r>
-              <a:rPr sz="1500" i="1">
-                <a:solidFill>
-                  <a:srgbClr val="E8A838"/>
-                </a:solidFill>
-              </a:rPr>
-              <a:t>w</a:t>
-            </a:r>
-            <a:r>
-              <a:rPr sz="1500">
-                <a:solidFill>
-                  <a:srgbClr val="E8A838"/>
-                </a:solidFill>
-              </a:rPr>
-              <a:t>: Velocidad del viento (m/s).</a:t>
-            </a:r>
-          </a:p>
-          <a:p>
-            <a:pPr algn="l">
-              <a:defRPr sz="1500">
-                <a:solidFill>
-                  <a:srgbClr val="E8A838"/>
-                </a:solidFill>
-              </a:defRPr>
-            </a:pPr>
-            <a:r>
-              <a:rPr sz="1500">
-                <a:solidFill>
-                  <a:srgbClr val="E8A838"/>
-                </a:solidFill>
-              </a:rPr>
-              <a:t>• </a:t>
-            </a:r>
-            <a:r>
-              <a:rPr sz="1500" i="1">
-                <a:solidFill>
-                  <a:srgbClr val="E8A838"/>
-                </a:solidFill>
-              </a:rPr>
-              <a:t>a</a:t>
-            </a:r>
-            <a:r>
-              <a:rPr sz="1500">
-                <a:solidFill>
-                  <a:srgbClr val="E8A838"/>
-                </a:solidFill>
-              </a:rPr>
-              <a:t>, </a:t>
-            </a:r>
-            <a:r>
-              <a:rPr sz="1500" i="1">
-                <a:solidFill>
-                  <a:srgbClr val="E8A838"/>
-                </a:solidFill>
-              </a:rPr>
-              <a:t>b</a:t>
-            </a:r>
-            <a:r>
-              <a:rPr sz="1500">
-                <a:solidFill>
-                  <a:srgbClr val="E8A838"/>
-                </a:solidFill>
-              </a:rPr>
-              <a:t>, </a:t>
-            </a:r>
-            <a:r>
-              <a:rPr sz="1500" i="1">
-                <a:solidFill>
-                  <a:srgbClr val="E8A838"/>
-                </a:solidFill>
-              </a:rPr>
-              <a:t>ΔT</a:t>
-            </a:r>
-            <a:r>
-              <a:rPr sz="1500">
-                <a:solidFill>
-                  <a:srgbClr val="E8A838"/>
-                </a:solidFill>
-              </a:rPr>
-              <a:t>: Parámetros empíricos del encapsulado.</a:t>
-            </a:r>
-          </a:p>
-        </p:txBody>
-      </p:sp>
-      <p:sp>
-        <p:nvSpPr>
-          <p:cNvPr id="8" name="Rectangle 7"/>
+          <p:cNvPr id="7" name="Rectangle 6"/>
           <p:cNvSpPr/>
           <p:nvPr/>
         </p:nvSpPr>
         <p:spPr>
           <a:xfrm>
-            <a:off x="6187287" y="1097280"/>
-            <a:ext cx="5547207" cy="5029200"/>
+            <a:off x="365760" y="3291840"/>
+            <a:ext cx="4572000" cy="2834640"/>
           </a:xfrm>
           <a:prstGeom prst="rect">
             <a:avLst/>
@@ -14108,14 +13766,14 @@
       </p:sp>
       <p:sp>
         <p:nvSpPr>
-          <p:cNvPr id="9" name="TextBox 8"/>
+          <p:cNvPr id="8" name="TextBox 7"/>
           <p:cNvSpPr txBox="1"/>
           <p:nvPr/>
         </p:nvSpPr>
         <p:spPr>
           <a:xfrm>
-            <a:off x="6278727" y="1188720"/>
-            <a:ext cx="5364327" cy="411480"/>
+            <a:off x="457200" y="3383280"/>
+            <a:ext cx="4389120" cy="411480"/>
           </a:xfrm>
           <a:prstGeom prst="rect">
             <a:avLst/>
@@ -14141,21 +13799,21 @@
                   <a:srgbClr val="E8A838"/>
                 </a:solidFill>
               </a:rPr>
-              <a:t>Coeficientes por Tecnología</a:t>
-            </a:r>
-          </a:p>
-        </p:txBody>
-      </p:sp>
-      <p:sp>
-        <p:nvSpPr>
-          <p:cNvPr id="10" name="TextBox 9"/>
+              <a:t>Glosario de Variables</a:t>
+            </a:r>
+          </a:p>
+        </p:txBody>
+      </p:sp>
+      <p:sp>
+        <p:nvSpPr>
+          <p:cNvPr id="9" name="TextBox 8"/>
           <p:cNvSpPr txBox="1"/>
           <p:nvPr/>
         </p:nvSpPr>
         <p:spPr>
           <a:xfrm>
-            <a:off x="6370167" y="1554480"/>
-            <a:ext cx="5181447" cy="4114800"/>
+            <a:off x="548640" y="3749039"/>
+            <a:ext cx="4206240" cy="2103120"/>
           </a:xfrm>
           <a:prstGeom prst="rect">
             <a:avLst/>
@@ -14171,65 +13829,169 @@
             <a:pPr algn="l">
               <a:defRPr sz="1500">
                 <a:solidFill>
-                  <a:srgbClr val="FFFFFF"/>
+                  <a:srgbClr val="E8A838"/>
                 </a:solidFill>
               </a:defRPr>
             </a:pPr>
             <a:r>
               <a:rPr sz="1500">
                 <a:solidFill>
-                  <a:srgbClr val="FFFFFF"/>
-                </a:solidFill>
-              </a:rPr>
-              <a:t>Los parámetros empíricos varían según la disipación del marco y capas protectoras:</a:t>
+                  <a:srgbClr val="E8A838"/>
+                </a:solidFill>
+              </a:rPr>
+              <a:t>• </a:t>
+            </a:r>
+            <a:r>
+              <a:rPr sz="1500" i="1">
+                <a:solidFill>
+                  <a:srgbClr val="E8A838"/>
+                </a:solidFill>
+              </a:rPr>
+              <a:t>T</a:t>
+            </a:r>
+            <a:r>
+              <a:rPr sz="1500" i="1">
+                <a:solidFill>
+                  <a:srgbClr val="E8A838"/>
+                </a:solidFill>
+              </a:rPr>
+              <a:t>c</a:t>
+            </a:r>
+            <a:r>
+              <a:rPr sz="1500">
+                <a:solidFill>
+                  <a:srgbClr val="E8A838"/>
+                </a:solidFill>
+              </a:rPr>
+              <a:t> / </a:t>
+            </a:r>
+            <a:r>
+              <a:rPr sz="1500" i="1">
+                <a:solidFill>
+                  <a:srgbClr val="E8A838"/>
+                </a:solidFill>
+              </a:rPr>
+              <a:t>T</a:t>
+            </a:r>
+            <a:r>
+              <a:rPr sz="1500" i="1">
+                <a:solidFill>
+                  <a:srgbClr val="E8A838"/>
+                </a:solidFill>
+              </a:rPr>
+              <a:t>a</a:t>
+            </a:r>
+            <a:r>
+              <a:rPr sz="1500">
+                <a:solidFill>
+                  <a:srgbClr val="E8A838"/>
+                </a:solidFill>
+              </a:rPr>
+              <a:t>: Temp. de celda y ambiental (°C).</a:t>
             </a:r>
           </a:p>
           <a:p>
             <a:pPr algn="l">
               <a:defRPr sz="1500">
                 <a:solidFill>
-                  <a:srgbClr val="FFFFFF"/>
-                </a:solidFill>
-              </a:defRPr>
-            </a:pPr>
+                  <a:srgbClr val="E8A838"/>
+                </a:solidFill>
+              </a:defRPr>
+            </a:pPr>
+            <a:r>
+              <a:rPr sz="1500">
+                <a:solidFill>
+                  <a:srgbClr val="E8A838"/>
+                </a:solidFill>
+              </a:rPr>
+              <a:t>• </a:t>
+            </a:r>
+            <a:r>
+              <a:rPr sz="1500" i="1">
+                <a:solidFill>
+                  <a:srgbClr val="E8A838"/>
+                </a:solidFill>
+              </a:rPr>
+              <a:t>G</a:t>
+            </a:r>
+            <a:r>
+              <a:rPr sz="1500" i="1">
+                <a:solidFill>
+                  <a:srgbClr val="E8A838"/>
+                </a:solidFill>
+              </a:rPr>
+              <a:t>poa</a:t>
+            </a:r>
+            <a:r>
+              <a:rPr sz="1500">
+                <a:solidFill>
+                  <a:srgbClr val="E8A838"/>
+                </a:solidFill>
+              </a:rPr>
+              <a:t>: Irradiancia en plano de panel (W/m²).</a:t>
+            </a:r>
           </a:p>
           <a:p>
             <a:pPr algn="l">
               <a:defRPr sz="1500">
                 <a:solidFill>
-                  <a:srgbClr val="FFFFFF"/>
+                  <a:srgbClr val="E8A838"/>
                 </a:solidFill>
               </a:defRPr>
             </a:pPr>
             <a:r>
               <a:rPr sz="1500">
                 <a:solidFill>
-                  <a:srgbClr val="FFFFFF"/>
-                </a:solidFill>
-              </a:rPr>
-              <a:t>1. Silicio Monocristalino (m-Si) — glass/polymer:</a:t>
+                  <a:srgbClr val="E8A838"/>
+                </a:solidFill>
+              </a:rPr>
+              <a:t>• </a:t>
+            </a:r>
+            <a:r>
+              <a:rPr sz="1500" i="1">
+                <a:solidFill>
+                  <a:srgbClr val="E8A838"/>
+                </a:solidFill>
+              </a:rPr>
+              <a:t>v</a:t>
+            </a:r>
+            <a:r>
+              <a:rPr sz="1500" i="1">
+                <a:solidFill>
+                  <a:srgbClr val="E8A838"/>
+                </a:solidFill>
+              </a:rPr>
+              <a:t>w</a:t>
+            </a:r>
+            <a:r>
+              <a:rPr sz="1500">
+                <a:solidFill>
+                  <a:srgbClr val="E8A838"/>
+                </a:solidFill>
+              </a:rPr>
+              <a:t>: Velocidad del viento local (m/s).</a:t>
             </a:r>
           </a:p>
           <a:p>
             <a:pPr algn="l">
               <a:defRPr sz="1500">
                 <a:solidFill>
-                  <a:srgbClr val="FFFFFF"/>
+                  <a:srgbClr val="E8A838"/>
                 </a:solidFill>
               </a:defRPr>
             </a:pPr>
             <a:r>
               <a:rPr sz="1500">
                 <a:solidFill>
-                  <a:srgbClr val="FFFFFF"/>
-                </a:solidFill>
-              </a:rPr>
-              <a:t>   • </a:t>
+                  <a:srgbClr val="E8A838"/>
+                </a:solidFill>
+              </a:rPr>
+              <a:t>• </a:t>
             </a:r>
             <a:r>
               <a:rPr sz="1500" i="1">
                 <a:solidFill>
-                  <a:srgbClr val="FFFFFF"/>
+                  <a:srgbClr val="E8A838"/>
                 </a:solidFill>
               </a:rPr>
               <a:t>a</a:t>
@@ -14237,13 +13999,203 @@
             <a:r>
               <a:rPr sz="1500">
                 <a:solidFill>
+                  <a:srgbClr val="E8A838"/>
+                </a:solidFill>
+              </a:rPr>
+              <a:t>, </a:t>
+            </a:r>
+            <a:r>
+              <a:rPr sz="1500" i="1">
+                <a:solidFill>
+                  <a:srgbClr val="E8A838"/>
+                </a:solidFill>
+              </a:rPr>
+              <a:t>b</a:t>
+            </a:r>
+            <a:r>
+              <a:rPr sz="1500">
+                <a:solidFill>
+                  <a:srgbClr val="E8A838"/>
+                </a:solidFill>
+              </a:rPr>
+              <a:t>, </a:t>
+            </a:r>
+            <a:r>
+              <a:rPr sz="1500" i="1">
+                <a:solidFill>
+                  <a:srgbClr val="E8A838"/>
+                </a:solidFill>
+              </a:rPr>
+              <a:t>ΔT</a:t>
+            </a:r>
+            <a:r>
+              <a:rPr sz="1500">
+                <a:solidFill>
+                  <a:srgbClr val="E8A838"/>
+                </a:solidFill>
+              </a:rPr>
+              <a:t>: Parámetros empíricos del encapsulado.</a:t>
+            </a:r>
+          </a:p>
+        </p:txBody>
+      </p:sp>
+      <p:sp>
+        <p:nvSpPr>
+          <p:cNvPr id="10" name="Rectangle 9"/>
+          <p:cNvSpPr/>
+          <p:nvPr/>
+        </p:nvSpPr>
+        <p:spPr>
+          <a:xfrm>
+            <a:off x="5212080" y="3291840"/>
+            <a:ext cx="6126480" cy="2834640"/>
+          </a:xfrm>
+          <a:prstGeom prst="rect">
+            <a:avLst/>
+          </a:prstGeom>
+          <a:solidFill>
+            <a:srgbClr val="22223A"/>
+          </a:solidFill>
+          <a:ln w="12700">
+            <a:solidFill>
+              <a:srgbClr val="007ACC"/>
+            </a:solidFill>
+          </a:ln>
+        </p:spPr>
+        <p:style>
+          <a:lnRef idx="1">
+            <a:schemeClr val="accent1"/>
+          </a:lnRef>
+          <a:fillRef idx="3">
+            <a:schemeClr val="accent1"/>
+          </a:fillRef>
+          <a:effectRef idx="2">
+            <a:schemeClr val="accent1"/>
+          </a:effectRef>
+          <a:fontRef idx="minor">
+            <a:schemeClr val="lt1"/>
+          </a:fontRef>
+        </p:style>
+        <p:txBody>
+          <a:bodyPr rtlCol="0" anchor="ctr"/>
+          <a:lstStyle/>
+          <a:p>
+            <a:pPr algn="ctr"/>
+          </a:p>
+        </p:txBody>
+      </p:sp>
+      <p:sp>
+        <p:nvSpPr>
+          <p:cNvPr id="11" name="TextBox 10"/>
+          <p:cNvSpPr txBox="1"/>
+          <p:nvPr/>
+        </p:nvSpPr>
+        <p:spPr>
+          <a:xfrm>
+            <a:off x="5303520" y="3383280"/>
+            <a:ext cx="5943600" cy="411480"/>
+          </a:xfrm>
+          <a:prstGeom prst="rect">
+            <a:avLst/>
+          </a:prstGeom>
+          <a:noFill/>
+        </p:spPr>
+        <p:txBody>
+          <a:bodyPr wrap="none">
+            <a:spAutoFit/>
+          </a:bodyPr>
+          <a:lstStyle/>
+          <a:p>
+            <a:pPr>
+              <a:defRPr sz="1800">
+                <a:solidFill>
+                  <a:srgbClr val="E8A838"/>
+                </a:solidFill>
+              </a:defRPr>
+            </a:pPr>
+            <a:r>
+              <a:rPr sz="1800" b="1">
+                <a:solidFill>
+                  <a:srgbClr val="E8A838"/>
+                </a:solidFill>
+              </a:rPr>
+              <a:t>Coeficientes Empíricos por Tecnología</a:t>
+            </a:r>
+          </a:p>
+        </p:txBody>
+      </p:sp>
+      <p:sp>
+        <p:nvSpPr>
+          <p:cNvPr id="12" name="TextBox 11"/>
+          <p:cNvSpPr txBox="1"/>
+          <p:nvPr/>
+        </p:nvSpPr>
+        <p:spPr>
+          <a:xfrm>
+            <a:off x="5394960" y="3749039"/>
+            <a:ext cx="5760720" cy="2103120"/>
+          </a:xfrm>
+          <a:prstGeom prst="rect">
+            <a:avLst/>
+          </a:prstGeom>
+          <a:noFill/>
+        </p:spPr>
+        <p:txBody>
+          <a:bodyPr wrap="square">
+            <a:spAutoFit/>
+          </a:bodyPr>
+          <a:lstStyle/>
+          <a:p>
+            <a:pPr algn="l">
+              <a:defRPr sz="1400">
+                <a:solidFill>
+                  <a:srgbClr val="FFFFFF"/>
+                </a:solidFill>
+              </a:defRPr>
+            </a:pPr>
+            <a:r>
+              <a:rPr sz="1400">
+                <a:solidFill>
+                  <a:srgbClr val="FFFFFF"/>
+                </a:solidFill>
+              </a:rPr>
+              <a:t>• **Silicio Monocristalino (m-Si) — glass/polymer:**</a:t>
+            </a:r>
+          </a:p>
+          <a:p>
+            <a:pPr algn="l">
+              <a:defRPr sz="1400">
+                <a:solidFill>
+                  <a:srgbClr val="FFFFFF"/>
+                </a:solidFill>
+              </a:defRPr>
+            </a:pPr>
+            <a:r>
+              <a:rPr sz="1400">
+                <a:solidFill>
+                  <a:srgbClr val="FFFFFF"/>
+                </a:solidFill>
+              </a:rPr>
+              <a:t>  </a:t>
+            </a:r>
+            <a:r>
+              <a:rPr sz="1400" i="1">
+                <a:solidFill>
+                  <a:srgbClr val="FFFFFF"/>
+                </a:solidFill>
+              </a:rPr>
+              <a:t>a</a:t>
+            </a:r>
+            <a:r>
+              <a:rPr sz="1400">
+                <a:solidFill>
                   <a:srgbClr val="FFFFFF"/>
                 </a:solidFill>
               </a:rPr>
               <a:t> = -3.56  |  </a:t>
             </a:r>
             <a:r>
-              <a:rPr sz="1500" i="1">
+              <a:rPr sz="1400" i="1">
                 <a:solidFill>
                   <a:srgbClr val="FFFFFF"/>
                 </a:solidFill>
@@ -14251,7 +14203,7 @@
               <a:t>b</a:t>
             </a:r>
             <a:r>
-              <a:rPr sz="1500">
+              <a:rPr sz="1400">
                 <a:solidFill>
                   <a:srgbClr val="FFFFFF"/>
                 </a:solidFill>
@@ -14259,7 +14211,7 @@
               <a:t> = -0.075  |  </a:t>
             </a:r>
             <a:r>
-              <a:rPr sz="1500" i="1">
+              <a:rPr sz="1400" i="1">
                 <a:solidFill>
                   <a:srgbClr val="FFFFFF"/>
                 </a:solidFill>
@@ -14267,7 +14219,7 @@
               <a:t>ΔT</a:t>
             </a:r>
             <a:r>
-              <a:rPr sz="1500">
+              <a:rPr sz="1400">
                 <a:solidFill>
                   <a:srgbClr val="FFFFFF"/>
                 </a:solidFill>
@@ -14277,65 +14229,65 @@
           </a:p>
           <a:p>
             <a:pPr algn="l">
-              <a:defRPr sz="1500">
-                <a:solidFill>
-                  <a:srgbClr val="FFFFFF"/>
-                </a:solidFill>
-              </a:defRPr>
-            </a:pPr>
-            <a:r>
-              <a:rPr sz="1500">
-                <a:solidFill>
-                  <a:srgbClr val="FFFFFF"/>
-                </a:solidFill>
-              </a:rPr>
-              <a:t>   → Comportamiento: Disipación estándar, mayor calentamiento.</a:t>
-            </a:r>
-          </a:p>
-          <a:p>
-            <a:pPr algn="l">
-              <a:defRPr sz="1500">
-                <a:solidFill>
-                  <a:srgbClr val="FFFFFF"/>
-                </a:solidFill>
-              </a:defRPr>
-            </a:pPr>
-          </a:p>
-          <a:p>
-            <a:pPr algn="l">
-              <a:defRPr sz="1500">
-                <a:solidFill>
-                  <a:srgbClr val="FFFFFF"/>
-                </a:solidFill>
-              </a:defRPr>
-            </a:pPr>
-            <a:r>
-              <a:rPr sz="1500">
-                <a:solidFill>
-                  <a:srgbClr val="FFFFFF"/>
-                </a:solidFill>
-              </a:rPr>
-              <a:t>2. Heterounión (HIT) — glass/glass:</a:t>
-            </a:r>
-          </a:p>
-          <a:p>
-            <a:pPr algn="l">
-              <a:defRPr sz="1500">
-                <a:solidFill>
-                  <a:srgbClr val="FFFFFF"/>
-                </a:solidFill>
-              </a:defRPr>
-            </a:pPr>
-            <a:r>
-              <a:rPr sz="1500">
-                <a:solidFill>
-                  <a:srgbClr val="FFFFFF"/>
-                </a:solidFill>
-              </a:rPr>
-              <a:t>   • </a:t>
-            </a:r>
-            <a:r>
-              <a:rPr sz="1500" i="1">
+              <a:defRPr sz="1400">
+                <a:solidFill>
+                  <a:srgbClr val="FFFFFF"/>
+                </a:solidFill>
+              </a:defRPr>
+            </a:pPr>
+            <a:r>
+              <a:rPr sz="1400">
+                <a:solidFill>
+                  <a:srgbClr val="FFFFFF"/>
+                </a:solidFill>
+              </a:rPr>
+              <a:t>  → Comportamiento: Disipación estándar, mayor calentamiento.</a:t>
+            </a:r>
+          </a:p>
+          <a:p>
+            <a:pPr algn="l">
+              <a:defRPr sz="1400">
+                <a:solidFill>
+                  <a:srgbClr val="FFFFFF"/>
+                </a:solidFill>
+              </a:defRPr>
+            </a:pPr>
+          </a:p>
+          <a:p>
+            <a:pPr algn="l">
+              <a:defRPr sz="1400">
+                <a:solidFill>
+                  <a:srgbClr val="FFFFFF"/>
+                </a:solidFill>
+              </a:defRPr>
+            </a:pPr>
+            <a:r>
+              <a:rPr sz="1400">
+                <a:solidFill>
+                  <a:srgbClr val="FFFFFF"/>
+                </a:solidFill>
+              </a:rPr>
+              <a:t>• **Heterounión (HIT) — glass/glass:**</a:t>
+            </a:r>
+          </a:p>
+          <a:p>
+            <a:pPr algn="l">
+              <a:defRPr sz="1400">
+                <a:solidFill>
+                  <a:srgbClr val="FFFFFF"/>
+                </a:solidFill>
+              </a:defRPr>
+            </a:pPr>
+            <a:r>
+              <a:rPr sz="1400">
+                <a:solidFill>
+                  <a:srgbClr val="FFFFFF"/>
+                </a:solidFill>
+              </a:rPr>
+              <a:t>  </a:t>
+            </a:r>
+            <a:r>
+              <a:rPr sz="1400" i="1">
                 <a:solidFill>
                   <a:srgbClr val="FFFFFF"/>
                 </a:solidFill>
@@ -14343,7 +14295,7 @@
               <a:t>a</a:t>
             </a:r>
             <a:r>
-              <a:rPr sz="1500">
+              <a:rPr sz="1400">
                 <a:solidFill>
                   <a:srgbClr val="FFFFFF"/>
                 </a:solidFill>
@@ -14351,7 +14303,7 @@
               <a:t> = -3.47  |  </a:t>
             </a:r>
             <a:r>
-              <a:rPr sz="1500" i="1">
+              <a:rPr sz="1400" i="1">
                 <a:solidFill>
                   <a:srgbClr val="FFFFFF"/>
                 </a:solidFill>
@@ -14359,7 +14311,7 @@
               <a:t>b</a:t>
             </a:r>
             <a:r>
-              <a:rPr sz="1500">
+              <a:rPr sz="1400">
                 <a:solidFill>
                   <a:srgbClr val="FFFFFF"/>
                 </a:solidFill>
@@ -14367,7 +14319,7 @@
               <a:t> = -0.059  |  </a:t>
             </a:r>
             <a:r>
-              <a:rPr sz="1500" i="1">
+              <a:rPr sz="1400" i="1">
                 <a:solidFill>
                   <a:srgbClr val="FFFFFF"/>
                 </a:solidFill>
@@ -14375,7 +14327,7 @@
               <a:t>ΔT</a:t>
             </a:r>
             <a:r>
-              <a:rPr sz="1500">
+              <a:rPr sz="1400">
                 <a:solidFill>
                   <a:srgbClr val="FFFFFF"/>
                 </a:solidFill>
@@ -14385,26 +14337,26 @@
           </a:p>
           <a:p>
             <a:pPr algn="l">
-              <a:defRPr sz="1500">
-                <a:solidFill>
-                  <a:srgbClr val="FFFFFF"/>
-                </a:solidFill>
-              </a:defRPr>
-            </a:pPr>
-            <a:r>
-              <a:rPr sz="1500">
-                <a:solidFill>
-                  <a:srgbClr val="FFFFFF"/>
-                </a:solidFill>
-              </a:rPr>
-              <a:t>   → Comportamiento: Estructura de doble vidrio, retiene ligeramente más calor, pero se compensa por su bajo coeficiente térmico.</a:t>
-            </a:r>
-          </a:p>
-        </p:txBody>
-      </p:sp>
-      <p:sp>
-        <p:nvSpPr>
-          <p:cNvPr id="11" name="TextBox 10"/>
+              <a:defRPr sz="1400">
+                <a:solidFill>
+                  <a:srgbClr val="FFFFFF"/>
+                </a:solidFill>
+              </a:defRPr>
+            </a:pPr>
+            <a:r>
+              <a:rPr sz="1400">
+                <a:solidFill>
+                  <a:srgbClr val="FFFFFF"/>
+                </a:solidFill>
+              </a:rPr>
+              <a:t>  → Comportamiento: Retiene más calor, pero se compensa por su bajo coeficiente térmico.</a:t>
+            </a:r>
+          </a:p>
+        </p:txBody>
+      </p:sp>
+      <p:sp>
+        <p:nvSpPr>
+          <p:cNvPr id="13" name="TextBox 12"/>
           <p:cNvSpPr txBox="1"/>
           <p:nvPr/>
         </p:nvSpPr>

</xml_diff>

<commit_message>
Corrige errores de formato, solapamientos y estandariza nomenclatura m-Si en slides y graficos
</commit_message>
<xml_diff>
--- a/output/Presentacion_Final_ELI556_Atacama.pptx
+++ b/output/Presentacion_Final_ELI556_Atacama.pptx
@@ -3654,7 +3654,7 @@
         </p:blipFill>
         <p:spPr>
           <a:xfrm>
-            <a:off x="822960" y="4069080"/>
+            <a:off x="822960" y="4160520"/>
             <a:ext cx="1762055" cy="438912"/>
           </a:xfrm>
           <a:prstGeom prst="rect">
@@ -7627,7 +7627,23 @@
                   <a:srgbClr val="FFFFFF"/>
                 </a:solidFill>
               </a:rPr>
-              <a:t>• **Pérdidas Térmicas:** Caídas debidas a la elevada temperatura </a:t>
+              <a:t>• </a:t>
+            </a:r>
+            <a:r>
+              <a:rPr sz="1500" b="1">
+                <a:solidFill>
+                  <a:srgbClr val="FFFFFF"/>
+                </a:solidFill>
+              </a:rPr>
+              <a:t>Pérdidas Térmicas:</a:t>
+            </a:r>
+            <a:r>
+              <a:rPr sz="1500">
+                <a:solidFill>
+                  <a:srgbClr val="FFFFFF"/>
+                </a:solidFill>
+              </a:rPr>
+              <a:t> Caídas debidas a la elevada temperatura </a:t>
             </a:r>
             <a:r>
               <a:rPr sz="1500" i="1">
@@ -7668,7 +7684,23 @@
                   <a:srgbClr val="FFFFFF"/>
                 </a:solidFill>
               </a:rPr>
-              <a:t>• **Pérdidas Ópticas:** Efectos reflectivos por ángulo de incidencia (IAM).</a:t>
+              <a:t>• </a:t>
+            </a:r>
+            <a:r>
+              <a:rPr sz="1500" b="1">
+                <a:solidFill>
+                  <a:srgbClr val="FFFFFF"/>
+                </a:solidFill>
+              </a:rPr>
+              <a:t>Pérdidas Ópticas:</a:t>
+            </a:r>
+            <a:r>
+              <a:rPr sz="1500">
+                <a:solidFill>
+                  <a:srgbClr val="FFFFFF"/>
+                </a:solidFill>
+              </a:rPr>
+              <a:t> Efectos reflectivos por ángulo de incidencia (IAM).</a:t>
             </a:r>
           </a:p>
           <a:p>
@@ -7685,7 +7717,23 @@
                   <a:srgbClr val="FFFFFF"/>
                 </a:solidFill>
               </a:rPr>
-              <a:t>• **Pérdidas Espectrales:** Desajustes causados por la Masa de Aire (AM).</a:t>
+              <a:t>• </a:t>
+            </a:r>
+            <a:r>
+              <a:rPr sz="1500" b="1">
+                <a:solidFill>
+                  <a:srgbClr val="FFFFFF"/>
+                </a:solidFill>
+              </a:rPr>
+              <a:t>Pérdidas Espectrales:</a:t>
+            </a:r>
+            <a:r>
+              <a:rPr sz="1500">
+                <a:solidFill>
+                  <a:srgbClr val="FFFFFF"/>
+                </a:solidFill>
+              </a:rPr>
+              <a:t> Desajustes causados por la Masa de Aire (AM).</a:t>
             </a:r>
           </a:p>
           <a:p>
@@ -7702,7 +7750,23 @@
                   <a:srgbClr val="FFFFFF"/>
                 </a:solidFill>
               </a:rPr>
-              <a:t>• **Pérdidas Óhmicas:** Pérdidas resistivas en la resistencia serie </a:t>
+              <a:t>• </a:t>
+            </a:r>
+            <a:r>
+              <a:rPr sz="1500" b="1">
+                <a:solidFill>
+                  <a:srgbClr val="FFFFFF"/>
+                </a:solidFill>
+              </a:rPr>
+              <a:t>Pérdidas Óhmicas:</a:t>
+            </a:r>
+            <a:r>
+              <a:rPr sz="1500">
+                <a:solidFill>
+                  <a:srgbClr val="FFFFFF"/>
+                </a:solidFill>
+              </a:rPr>
+              <a:t> Pérdidas resistivas en la resistencia serie </a:t>
             </a:r>
             <a:r>
               <a:rPr sz="1500" i="1">
@@ -12912,8 +12976,8 @@
         </p:nvSpPr>
         <p:spPr>
           <a:xfrm>
-            <a:off x="6370167" y="1554480"/>
-            <a:ext cx="5181447" cy="320040"/>
+            <a:off x="6370167" y="1508760"/>
+            <a:ext cx="5181447" cy="502920"/>
           </a:xfrm>
           <a:prstGeom prst="rect">
             <a:avLst/>
@@ -12960,7 +13024,7 @@
         </p:blipFill>
         <p:spPr>
           <a:xfrm>
-            <a:off x="6461607" y="2011680"/>
+            <a:off x="6461607" y="2148840"/>
             <a:ext cx="5029200" cy="333513"/>
           </a:xfrm>
           <a:prstGeom prst="rect">
@@ -12984,7 +13048,7 @@
         </p:blipFill>
         <p:spPr>
           <a:xfrm>
-            <a:off x="6461607" y="2697480"/>
+            <a:off x="6461607" y="2834640"/>
             <a:ext cx="3687419" cy="438912"/>
           </a:xfrm>
           <a:prstGeom prst="rect">
@@ -13000,7 +13064,7 @@
         </p:nvSpPr>
         <p:spPr>
           <a:xfrm>
-            <a:off x="6370167" y="3611880"/>
+            <a:off x="6370167" y="3749039"/>
             <a:ext cx="5181447" cy="2286000"/>
           </a:xfrm>
           <a:prstGeom prst="rect">
@@ -14159,7 +14223,15 @@
                   <a:srgbClr val="FFFFFF"/>
                 </a:solidFill>
               </a:rPr>
-              <a:t>• **Silicio Monocristalino (m-Si) — glass/polymer:**</a:t>
+              <a:t>• </a:t>
+            </a:r>
+            <a:r>
+              <a:rPr sz="1400" b="1">
+                <a:solidFill>
+                  <a:srgbClr val="FFFFFF"/>
+                </a:solidFill>
+              </a:rPr>
+              <a:t>Silicio Monocristalino (m-Si) — glass/polymer:</a:t>
             </a:r>
           </a:p>
           <a:p>
@@ -14267,7 +14339,15 @@
                   <a:srgbClr val="FFFFFF"/>
                 </a:solidFill>
               </a:rPr>
-              <a:t>• **Heterounión (HIT) — glass/glass:**</a:t>
+              <a:t>• </a:t>
+            </a:r>
+            <a:r>
+              <a:rPr sz="1400" b="1">
+                <a:solidFill>
+                  <a:srgbClr val="FFFFFF"/>
+                </a:solidFill>
+              </a:rPr>
+              <a:t>Heterounión (HIT) — glass/glass:</a:t>
             </a:r>
           </a:p>
           <a:p>

</xml_diff>

<commit_message>
Expande perfil horaria y performance ratio mensual a ancho completo de panel
</commit_message>
<xml_diff>
--- a/output/Presentacion_Final_ELI556_Atacama.pptx
+++ b/output/Presentacion_Final_ELI556_Atacama.pptx
@@ -7957,8 +7957,8 @@
         </p:blipFill>
         <p:spPr>
           <a:xfrm>
-            <a:off x="2203704" y="1280160"/>
-            <a:ext cx="7772400" cy="4663440"/>
+            <a:off x="914400" y="1234440"/>
+            <a:ext cx="10360152" cy="4937760"/>
           </a:xfrm>
           <a:prstGeom prst="rect">
             <a:avLst/>
@@ -13493,8 +13493,8 @@
         </p:blipFill>
         <p:spPr>
           <a:xfrm>
-            <a:off x="2203704" y="1280160"/>
-            <a:ext cx="7772400" cy="4663440"/>
+            <a:off x="914400" y="1234440"/>
+            <a:ext cx="10360152" cy="4937760"/>
           </a:xfrm>
           <a:prstGeom prst="rect">
             <a:avLst/>

</xml_diff>

<commit_message>
Incrementa el alto y presencia vertical del histograma en la slide 9
</commit_message>
<xml_diff>
--- a/output/Presentacion_Final_ELI556_Atacama.pptx
+++ b/output/Presentacion_Final_ELI556_Atacama.pptx
@@ -14636,8 +14636,8 @@
         </p:blipFill>
         <p:spPr>
           <a:xfrm>
-            <a:off x="548640" y="1645920"/>
-            <a:ext cx="5303520" cy="2651760"/>
+            <a:off x="914400" y="1508760"/>
+            <a:ext cx="6035040" cy="4526280"/>
           </a:xfrm>
           <a:prstGeom prst="rect">
             <a:avLst/>

</xml_diff>

<commit_message>
Segmenta ecuacion de absorcion en celda (S) en tres lineas para mejorar legibilidad
</commit_message>
<xml_diff>
--- a/output/Presentacion_Final_ELI556_Atacama.pptx
+++ b/output/Presentacion_Final_ELI556_Atacama.pptx
@@ -12190,7 +12190,7 @@
       </p:sp>
       <p:pic>
         <p:nvPicPr>
-          <p:cNvPr id="11" name="Picture 10" descr="eq_84c6ff8f0a6225d1da45a3b2826e84f0.png"/>
+          <p:cNvPr id="11" name="Picture 10" descr="eq_bb06151bcf09291bead73672e21c10fb.png"/>
           <p:cNvPicPr>
             <a:picLocks noChangeAspect="1"/>
           </p:cNvPicPr>
@@ -12204,8 +12204,8 @@
         </p:blipFill>
         <p:spPr>
           <a:xfrm>
-            <a:off x="5852160" y="2011680"/>
-            <a:ext cx="5029200" cy="282792"/>
+            <a:off x="5852160" y="1920240"/>
+            <a:ext cx="1669139" cy="868680"/>
           </a:xfrm>
           <a:prstGeom prst="rect">
             <a:avLst/>

</xml_diff>

<commit_message>
Aumenta el tamaño vertical de la ecuacion de absorcion en la slide 5 y el tamaño del glosario
</commit_message>
<xml_diff>
--- a/output/Presentacion_Final_ELI556_Atacama.pptx
+++ b/output/Presentacion_Final_ELI556_Atacama.pptx
@@ -12204,8 +12204,8 @@
         </p:blipFill>
         <p:spPr>
           <a:xfrm>
-            <a:off x="5852160" y="1920240"/>
-            <a:ext cx="1669139" cy="868680"/>
+            <a:off x="5852160" y="1874519"/>
+            <a:ext cx="2459783" cy="1280160"/>
           </a:xfrm>
           <a:prstGeom prst="rect">
             <a:avLst/>
@@ -12220,8 +12220,8 @@
         </p:nvSpPr>
         <p:spPr>
           <a:xfrm>
-            <a:off x="5852160" y="2926080"/>
-            <a:ext cx="5303520" cy="2743200"/>
+            <a:off x="5852160" y="3337560"/>
+            <a:ext cx="5303520" cy="2377440"/>
           </a:xfrm>
           <a:prstGeom prst="rect">
             <a:avLst/>
@@ -12235,14 +12235,14 @@
           <a:lstStyle/>
           <a:p>
             <a:pPr algn="l">
-              <a:defRPr sz="1500">
-                <a:solidFill>
-                  <a:srgbClr val="FFFFFF"/>
-                </a:solidFill>
-              </a:defRPr>
-            </a:pPr>
-            <a:r>
-              <a:rPr sz="1500">
+              <a:defRPr sz="1600">
+                <a:solidFill>
+                  <a:srgbClr val="FFFFFF"/>
+                </a:solidFill>
+              </a:defRPr>
+            </a:pPr>
+            <a:r>
+              <a:rPr sz="1600">
                 <a:solidFill>
                   <a:srgbClr val="FFFFFF"/>
                 </a:solidFill>
@@ -12252,14 +12252,14 @@
           </a:p>
           <a:p>
             <a:pPr algn="l">
-              <a:defRPr sz="1500">
-                <a:solidFill>
-                  <a:srgbClr val="FFFFFF"/>
-                </a:solidFill>
-              </a:defRPr>
-            </a:pPr>
-            <a:r>
-              <a:rPr sz="1500">
+              <a:defRPr sz="1600">
+                <a:solidFill>
+                  <a:srgbClr val="FFFFFF"/>
+                </a:solidFill>
+              </a:defRPr>
+            </a:pPr>
+            <a:r>
+              <a:rPr sz="1600">
                 <a:solidFill>
                   <a:srgbClr val="FFFFFF"/>
                 </a:solidFill>
@@ -12267,7 +12267,7 @@
               <a:t>• </a:t>
             </a:r>
             <a:r>
-              <a:rPr sz="1500" i="1">
+              <a:rPr sz="1600" i="1">
                 <a:solidFill>
                   <a:srgbClr val="FFFFFF"/>
                 </a:solidFill>
@@ -12275,7 +12275,7 @@
               <a:t>S</a:t>
             </a:r>
             <a:r>
-              <a:rPr sz="1500">
+              <a:rPr sz="1600">
                 <a:solidFill>
                   <a:srgbClr val="FFFFFF"/>
                 </a:solidFill>
@@ -12283,7 +12283,7 @@
               <a:t> / </a:t>
             </a:r>
             <a:r>
-              <a:rPr sz="1500" i="1">
+              <a:rPr sz="1600" i="1">
                 <a:solidFill>
                   <a:srgbClr val="FFFFFF"/>
                 </a:solidFill>
@@ -12291,7 +12291,7 @@
               <a:t>S</a:t>
             </a:r>
             <a:r>
-              <a:rPr sz="1500" i="1">
+              <a:rPr sz="1600" i="1">
                 <a:solidFill>
                   <a:srgbClr val="FFFFFF"/>
                 </a:solidFill>
@@ -12299,7 +12299,7 @@
               <a:t>ref</a:t>
             </a:r>
             <a:r>
-              <a:rPr sz="1500">
+              <a:rPr sz="1600">
                 <a:solidFill>
                   <a:srgbClr val="FFFFFF"/>
                 </a:solidFill>
@@ -12309,14 +12309,14 @@
           </a:p>
           <a:p>
             <a:pPr algn="l">
-              <a:defRPr sz="1500">
-                <a:solidFill>
-                  <a:srgbClr val="FFFFFF"/>
-                </a:solidFill>
-              </a:defRPr>
-            </a:pPr>
-            <a:r>
-              <a:rPr sz="1500">
+              <a:defRPr sz="1600">
+                <a:solidFill>
+                  <a:srgbClr val="FFFFFF"/>
+                </a:solidFill>
+              </a:defRPr>
+            </a:pPr>
+            <a:r>
+              <a:rPr sz="1600">
                 <a:solidFill>
                   <a:srgbClr val="FFFFFF"/>
                 </a:solidFill>
@@ -12324,7 +12324,7 @@
               <a:t>• </a:t>
             </a:r>
             <a:r>
-              <a:rPr sz="1500" i="1">
+              <a:rPr sz="1600" i="1">
                 <a:solidFill>
                   <a:srgbClr val="FFFFFF"/>
                 </a:solidFill>
@@ -12332,7 +12332,7 @@
               <a:t>K</a:t>
             </a:r>
             <a:r>
-              <a:rPr sz="1500" i="1">
+              <a:rPr sz="1600" i="1">
                 <a:solidFill>
                   <a:srgbClr val="FFFFFF"/>
                 </a:solidFill>
@@ -12340,7 +12340,7 @@
               <a:t>τα,b</a:t>
             </a:r>
             <a:r>
-              <a:rPr sz="1500">
+              <a:rPr sz="1600">
                 <a:solidFill>
                   <a:srgbClr val="FFFFFF"/>
                 </a:solidFill>
@@ -12348,7 +12348,7 @@
               <a:t> / </a:t>
             </a:r>
             <a:r>
-              <a:rPr sz="1500" i="1">
+              <a:rPr sz="1600" i="1">
                 <a:solidFill>
                   <a:srgbClr val="FFFFFF"/>
                 </a:solidFill>
@@ -12356,7 +12356,7 @@
               <a:t>K</a:t>
             </a:r>
             <a:r>
-              <a:rPr sz="1500" i="1">
+              <a:rPr sz="1600" i="1">
                 <a:solidFill>
                   <a:srgbClr val="FFFFFF"/>
                 </a:solidFill>
@@ -12364,7 +12364,7 @@
               <a:t>τα,d</a:t>
             </a:r>
             <a:r>
-              <a:rPr sz="1500">
+              <a:rPr sz="1600">
                 <a:solidFill>
                   <a:srgbClr val="FFFFFF"/>
                 </a:solidFill>
@@ -12372,7 +12372,7 @@
               <a:t> / </a:t>
             </a:r>
             <a:r>
-              <a:rPr sz="1500" i="1">
+              <a:rPr sz="1600" i="1">
                 <a:solidFill>
                   <a:srgbClr val="FFFFFF"/>
                 </a:solidFill>
@@ -12380,7 +12380,7 @@
               <a:t>K</a:t>
             </a:r>
             <a:r>
-              <a:rPr sz="1500" i="1">
+              <a:rPr sz="1600" i="1">
                 <a:solidFill>
                   <a:srgbClr val="FFFFFF"/>
                 </a:solidFill>
@@ -12388,7 +12388,7 @@
               <a:t>τα,g</a:t>
             </a:r>
             <a:r>
-              <a:rPr sz="1500">
+              <a:rPr sz="1600">
                 <a:solidFill>
                   <a:srgbClr val="FFFFFF"/>
                 </a:solidFill>
@@ -12398,14 +12398,14 @@
           </a:p>
           <a:p>
             <a:pPr algn="l">
-              <a:defRPr sz="1500">
-                <a:solidFill>
-                  <a:srgbClr val="FFFFFF"/>
-                </a:solidFill>
-              </a:defRPr>
-            </a:pPr>
-            <a:r>
-              <a:rPr sz="1500">
+              <a:defRPr sz="1600">
+                <a:solidFill>
+                  <a:srgbClr val="FFFFFF"/>
+                </a:solidFill>
+              </a:defRPr>
+            </a:pPr>
+            <a:r>
+              <a:rPr sz="1600">
                 <a:solidFill>
                   <a:srgbClr val="FFFFFF"/>
                 </a:solidFill>
@@ -12413,7 +12413,7 @@
               <a:t>• Incorpora las pérdidas ópticas por ángulo de incidencia</a:t>
             </a:r>
             <a:r>
-              <a:rPr sz="1500">
+              <a:rPr sz="1600">
                 <a:solidFill>
                   <a:srgbClr val="FFFFFF"/>
                 </a:solidFill>
@@ -12421,7 +12421,7 @@
               <a:t>[2]</a:t>
             </a:r>
             <a:r>
-              <a:rPr sz="1500">
+              <a:rPr sz="1600">
                 <a:solidFill>
                   <a:srgbClr val="FFFFFF"/>
                 </a:solidFill>

</xml_diff>

<commit_message>
Ajusta histograma en Slide 9 y agranda ecuaciones en Slide 11 y 12 para maxima legibilidad
</commit_message>
<xml_diff>
--- a/output/Presentacion_Final_ELI556_Atacama.pptx
+++ b/output/Presentacion_Final_ELI556_Atacama.pptx
@@ -4289,7 +4289,7 @@
         <p:spPr>
           <a:xfrm>
             <a:off x="548640" y="1554480"/>
-            <a:ext cx="4206240" cy="1371600"/>
+            <a:ext cx="4206240" cy="1463040"/>
           </a:xfrm>
           <a:prstGeom prst="rect">
             <a:avLst/>
@@ -4303,14 +4303,14 @@
           <a:lstStyle/>
           <a:p>
             <a:pPr algn="l">
-              <a:defRPr sz="1400">
-                <a:solidFill>
-                  <a:srgbClr val="FFFFFF"/>
-                </a:solidFill>
-              </a:defRPr>
-            </a:pPr>
-            <a:r>
-              <a:rPr sz="1400">
+              <a:defRPr sz="1500">
+                <a:solidFill>
+                  <a:srgbClr val="FFFFFF"/>
+                </a:solidFill>
+              </a:defRPr>
+            </a:pPr>
+            <a:r>
+              <a:rPr sz="1500">
                 <a:solidFill>
                   <a:srgbClr val="FFFFFF"/>
                 </a:solidFill>
@@ -4318,7 +4318,7 @@
               <a:t>Se extraen </a:t>
             </a:r>
             <a:r>
-              <a:rPr sz="1400" i="1">
+              <a:rPr sz="1500" i="1">
                 <a:solidFill>
                   <a:srgbClr val="FFFFFF"/>
                 </a:solidFill>
@@ -4326,7 +4326,7 @@
               <a:t>a</a:t>
             </a:r>
             <a:r>
-              <a:rPr sz="1400" i="1">
+              <a:rPr sz="1500" i="1">
                 <a:solidFill>
                   <a:srgbClr val="FFFFFF"/>
                 </a:solidFill>
@@ -4334,7 +4334,7 @@
               <a:t>ref</a:t>
             </a:r>
             <a:r>
-              <a:rPr sz="1400">
+              <a:rPr sz="1500">
                 <a:solidFill>
                   <a:srgbClr val="FFFFFF"/>
                 </a:solidFill>
@@ -4342,7 +4342,7 @@
               <a:t>, </a:t>
             </a:r>
             <a:r>
-              <a:rPr sz="1400" i="1">
+              <a:rPr sz="1500" i="1">
                 <a:solidFill>
                   <a:srgbClr val="FFFFFF"/>
                 </a:solidFill>
@@ -4350,7 +4350,7 @@
               <a:t>I</a:t>
             </a:r>
             <a:r>
-              <a:rPr sz="1400" i="1">
+              <a:rPr sz="1500" i="1">
                 <a:solidFill>
                   <a:srgbClr val="FFFFFF"/>
                 </a:solidFill>
@@ -4358,7 +4358,7 @@
               <a:t>L,ref</a:t>
             </a:r>
             <a:r>
-              <a:rPr sz="1400">
+              <a:rPr sz="1500">
                 <a:solidFill>
                   <a:srgbClr val="FFFFFF"/>
                 </a:solidFill>
@@ -4366,7 +4366,7 @@
               <a:t>, </a:t>
             </a:r>
             <a:r>
-              <a:rPr sz="1400" i="1">
+              <a:rPr sz="1500" i="1">
                 <a:solidFill>
                   <a:srgbClr val="FFFFFF"/>
                 </a:solidFill>
@@ -4374,7 +4374,7 @@
               <a:t>I</a:t>
             </a:r>
             <a:r>
-              <a:rPr sz="1400" i="1">
+              <a:rPr sz="1500" i="1">
                 <a:solidFill>
                   <a:srgbClr val="FFFFFF"/>
                 </a:solidFill>
@@ -4382,7 +4382,7 @@
               <a:t>0,ref</a:t>
             </a:r>
             <a:r>
-              <a:rPr sz="1400">
+              <a:rPr sz="1500">
                 <a:solidFill>
                   <a:srgbClr val="FFFFFF"/>
                 </a:solidFill>
@@ -4390,7 +4390,7 @@
               <a:t>, </a:t>
             </a:r>
             <a:r>
-              <a:rPr sz="1400" i="1">
+              <a:rPr sz="1500" i="1">
                 <a:solidFill>
                   <a:srgbClr val="FFFFFF"/>
                 </a:solidFill>
@@ -4398,7 +4398,7 @@
               <a:t>R</a:t>
             </a:r>
             <a:r>
-              <a:rPr sz="1400" i="1">
+              <a:rPr sz="1500" i="1">
                 <a:solidFill>
                   <a:srgbClr val="FFFFFF"/>
                 </a:solidFill>
@@ -4406,7 +4406,7 @@
               <a:t>s,ref</a:t>
             </a:r>
             <a:r>
-              <a:rPr sz="1400">
+              <a:rPr sz="1500">
                 <a:solidFill>
                   <a:srgbClr val="FFFFFF"/>
                 </a:solidFill>
@@ -4414,7 +4414,7 @@
               <a:t>, </a:t>
             </a:r>
             <a:r>
-              <a:rPr sz="1400" i="1">
+              <a:rPr sz="1500" i="1">
                 <a:solidFill>
                   <a:srgbClr val="FFFFFF"/>
                 </a:solidFill>
@@ -4422,7 +4422,7 @@
               <a:t>R</a:t>
             </a:r>
             <a:r>
-              <a:rPr sz="1400" i="1">
+              <a:rPr sz="1500" i="1">
                 <a:solidFill>
                   <a:srgbClr val="FFFFFF"/>
                 </a:solidFill>
@@ -4430,7 +4430,7 @@
               <a:t>sh,ref</a:t>
             </a:r>
             <a:r>
-              <a:rPr sz="1400">
+              <a:rPr sz="1500">
                 <a:solidFill>
                   <a:srgbClr val="FFFFFF"/>
                 </a:solidFill>
@@ -4440,23 +4440,23 @@
           </a:p>
           <a:p>
             <a:pPr algn="l">
-              <a:defRPr sz="1400">
-                <a:solidFill>
-                  <a:srgbClr val="FFFFFF"/>
-                </a:solidFill>
-              </a:defRPr>
-            </a:pPr>
-          </a:p>
-          <a:p>
-            <a:pPr algn="l">
-              <a:defRPr sz="1400">
-                <a:solidFill>
-                  <a:srgbClr val="FFFFFF"/>
-                </a:solidFill>
-              </a:defRPr>
-            </a:pPr>
-            <a:r>
-              <a:rPr sz="1400">
+              <a:defRPr sz="1500">
+                <a:solidFill>
+                  <a:srgbClr val="FFFFFF"/>
+                </a:solidFill>
+              </a:defRPr>
+            </a:pPr>
+          </a:p>
+          <a:p>
+            <a:pPr algn="l">
+              <a:defRPr sz="1500">
+                <a:solidFill>
+                  <a:srgbClr val="FFFFFF"/>
+                </a:solidFill>
+              </a:defRPr>
+            </a:pPr>
+            <a:r>
+              <a:rPr sz="1500">
                 <a:solidFill>
                   <a:srgbClr val="FFFFFF"/>
                 </a:solidFill>
@@ -4464,7 +4464,7 @@
               <a:t>1. Cortocircuito: </a:t>
             </a:r>
             <a:r>
-              <a:rPr sz="1400" i="1">
+              <a:rPr sz="1500" i="1">
                 <a:solidFill>
                   <a:srgbClr val="FFFFFF"/>
                 </a:solidFill>
@@ -4472,7 +4472,7 @@
               <a:t>V</a:t>
             </a:r>
             <a:r>
-              <a:rPr sz="1400">
+              <a:rPr sz="1500">
                 <a:solidFill>
                   <a:srgbClr val="FFFFFF"/>
                 </a:solidFill>
@@ -4480,7 +4480,7 @@
               <a:t> = 0, </a:t>
             </a:r>
             <a:r>
-              <a:rPr sz="1400" i="1">
+              <a:rPr sz="1500" i="1">
                 <a:solidFill>
                   <a:srgbClr val="FFFFFF"/>
                 </a:solidFill>
@@ -4488,7 +4488,7 @@
               <a:t>I</a:t>
             </a:r>
             <a:r>
-              <a:rPr sz="1400">
+              <a:rPr sz="1500">
                 <a:solidFill>
                   <a:srgbClr val="FFFFFF"/>
                 </a:solidFill>
@@ -4496,7 +4496,7 @@
               <a:t> = </a:t>
             </a:r>
             <a:r>
-              <a:rPr sz="1400" i="1">
+              <a:rPr sz="1500" i="1">
                 <a:solidFill>
                   <a:srgbClr val="FFFFFF"/>
                 </a:solidFill>
@@ -4504,7 +4504,7 @@
               <a:t>I</a:t>
             </a:r>
             <a:r>
-              <a:rPr sz="1400" i="1">
+              <a:rPr sz="1500" i="1">
                 <a:solidFill>
                   <a:srgbClr val="FFFFFF"/>
                 </a:solidFill>
@@ -4514,14 +4514,14 @@
           </a:p>
           <a:p>
             <a:pPr algn="l">
-              <a:defRPr sz="1400">
-                <a:solidFill>
-                  <a:srgbClr val="FFFFFF"/>
-                </a:solidFill>
-              </a:defRPr>
-            </a:pPr>
-            <a:r>
-              <a:rPr sz="1400">
+              <a:defRPr sz="1500">
+                <a:solidFill>
+                  <a:srgbClr val="FFFFFF"/>
+                </a:solidFill>
+              </a:defRPr>
+            </a:pPr>
+            <a:r>
+              <a:rPr sz="1500">
                 <a:solidFill>
                   <a:srgbClr val="FFFFFF"/>
                 </a:solidFill>
@@ -4529,7 +4529,7 @@
               <a:t>2. Circuito Abierto: </a:t>
             </a:r>
             <a:r>
-              <a:rPr sz="1400" i="1">
+              <a:rPr sz="1500" i="1">
                 <a:solidFill>
                   <a:srgbClr val="FFFFFF"/>
                 </a:solidFill>
@@ -4537,7 +4537,7 @@
               <a:t>I</a:t>
             </a:r>
             <a:r>
-              <a:rPr sz="1400">
+              <a:rPr sz="1500">
                 <a:solidFill>
                   <a:srgbClr val="FFFFFF"/>
                 </a:solidFill>
@@ -4545,7 +4545,7 @@
               <a:t> = 0, </a:t>
             </a:r>
             <a:r>
-              <a:rPr sz="1400" i="1">
+              <a:rPr sz="1500" i="1">
                 <a:solidFill>
                   <a:srgbClr val="FFFFFF"/>
                 </a:solidFill>
@@ -4553,7 +4553,7 @@
               <a:t>V</a:t>
             </a:r>
             <a:r>
-              <a:rPr sz="1400">
+              <a:rPr sz="1500">
                 <a:solidFill>
                   <a:srgbClr val="FFFFFF"/>
                 </a:solidFill>
@@ -4561,7 +4561,7 @@
               <a:t> = </a:t>
             </a:r>
             <a:r>
-              <a:rPr sz="1400" i="1">
+              <a:rPr sz="1500" i="1">
                 <a:solidFill>
                   <a:srgbClr val="FFFFFF"/>
                 </a:solidFill>
@@ -4569,7 +4569,7 @@
               <a:t>V</a:t>
             </a:r>
             <a:r>
-              <a:rPr sz="1400" i="1">
+              <a:rPr sz="1500" i="1">
                 <a:solidFill>
                   <a:srgbClr val="FFFFFF"/>
                 </a:solidFill>
@@ -4579,14 +4579,14 @@
           </a:p>
           <a:p>
             <a:pPr algn="l">
-              <a:defRPr sz="1400">
-                <a:solidFill>
-                  <a:srgbClr val="FFFFFF"/>
-                </a:solidFill>
-              </a:defRPr>
-            </a:pPr>
-            <a:r>
-              <a:rPr sz="1400">
+              <a:defRPr sz="1500">
+                <a:solidFill>
+                  <a:srgbClr val="FFFFFF"/>
+                </a:solidFill>
+              </a:defRPr>
+            </a:pPr>
+            <a:r>
+              <a:rPr sz="1500">
                 <a:solidFill>
                   <a:srgbClr val="FFFFFF"/>
                 </a:solidFill>
@@ -4594,7 +4594,7 @@
               <a:t>3. Máxima Potencia: </a:t>
             </a:r>
             <a:r>
-              <a:rPr sz="1400" i="1">
+              <a:rPr sz="1500" i="1">
                 <a:solidFill>
                   <a:srgbClr val="FFFFFF"/>
                 </a:solidFill>
@@ -4602,7 +4602,7 @@
               <a:t>I</a:t>
             </a:r>
             <a:r>
-              <a:rPr sz="1400">
+              <a:rPr sz="1500">
                 <a:solidFill>
                   <a:srgbClr val="FFFFFF"/>
                 </a:solidFill>
@@ -4610,7 +4610,7 @@
               <a:t> = </a:t>
             </a:r>
             <a:r>
-              <a:rPr sz="1400" i="1">
+              <a:rPr sz="1500" i="1">
                 <a:solidFill>
                   <a:srgbClr val="FFFFFF"/>
                 </a:solidFill>
@@ -4618,7 +4618,7 @@
               <a:t>I</a:t>
             </a:r>
             <a:r>
-              <a:rPr sz="1400" i="1">
+              <a:rPr sz="1500" i="1">
                 <a:solidFill>
                   <a:srgbClr val="FFFFFF"/>
                 </a:solidFill>
@@ -4626,7 +4626,7 @@
               <a:t>mp,ref</a:t>
             </a:r>
             <a:r>
-              <a:rPr sz="1400">
+              <a:rPr sz="1500">
                 <a:solidFill>
                   <a:srgbClr val="FFFFFF"/>
                 </a:solidFill>
@@ -4634,7 +4634,7 @@
               <a:t>, </a:t>
             </a:r>
             <a:r>
-              <a:rPr sz="1400" i="1">
+              <a:rPr sz="1500" i="1">
                 <a:solidFill>
                   <a:srgbClr val="FFFFFF"/>
                 </a:solidFill>
@@ -4642,7 +4642,7 @@
               <a:t>V</a:t>
             </a:r>
             <a:r>
-              <a:rPr sz="1400">
+              <a:rPr sz="1500">
                 <a:solidFill>
                   <a:srgbClr val="FFFFFF"/>
                 </a:solidFill>
@@ -4650,7 +4650,7 @@
               <a:t> = </a:t>
             </a:r>
             <a:r>
-              <a:rPr sz="1400" i="1">
+              <a:rPr sz="1500" i="1">
                 <a:solidFill>
                   <a:srgbClr val="FFFFFF"/>
                 </a:solidFill>
@@ -4658,7 +4658,7 @@
               <a:t>V</a:t>
             </a:r>
             <a:r>
-              <a:rPr sz="1400" i="1">
+              <a:rPr sz="1500" i="1">
                 <a:solidFill>
                   <a:srgbClr val="FFFFFF"/>
                 </a:solidFill>
@@ -4668,14 +4668,14 @@
           </a:p>
           <a:p>
             <a:pPr algn="l">
-              <a:defRPr sz="1400">
-                <a:solidFill>
-                  <a:srgbClr val="FFFFFF"/>
-                </a:solidFill>
-              </a:defRPr>
-            </a:pPr>
-            <a:r>
-              <a:rPr sz="1400">
+              <a:defRPr sz="1500">
+                <a:solidFill>
+                  <a:srgbClr val="FFFFFF"/>
+                </a:solidFill>
+              </a:defRPr>
+            </a:pPr>
+            <a:r>
+              <a:rPr sz="1500">
                 <a:solidFill>
                   <a:srgbClr val="FFFFFF"/>
                 </a:solidFill>
@@ -4683,7 +4683,7 @@
               <a:t>4. Pendiente en MPP (d</a:t>
             </a:r>
             <a:r>
-              <a:rPr sz="1400" i="1">
+              <a:rPr sz="1500" i="1">
                 <a:solidFill>
                   <a:srgbClr val="FFFFFF"/>
                 </a:solidFill>
@@ -4691,7 +4691,7 @@
               <a:t>P</a:t>
             </a:r>
             <a:r>
-              <a:rPr sz="1400">
+              <a:rPr sz="1500">
                 <a:solidFill>
                   <a:srgbClr val="FFFFFF"/>
                 </a:solidFill>
@@ -4699,7 +4699,7 @@
               <a:t>/d</a:t>
             </a:r>
             <a:r>
-              <a:rPr sz="1400" i="1">
+              <a:rPr sz="1500" i="1">
                 <a:solidFill>
                   <a:srgbClr val="FFFFFF"/>
                 </a:solidFill>
@@ -4707,7 +4707,7 @@
               <a:t>V</a:t>
             </a:r>
             <a:r>
-              <a:rPr sz="1400">
+              <a:rPr sz="1500">
                 <a:solidFill>
                   <a:srgbClr val="FFFFFF"/>
                 </a:solidFill>
@@ -4733,8 +4733,8 @@
         </p:blipFill>
         <p:spPr>
           <a:xfrm>
-            <a:off x="548640" y="3246120"/>
-            <a:ext cx="1404454" cy="384048"/>
+            <a:off x="548640" y="3108960"/>
+            <a:ext cx="2173560" cy="594360"/>
           </a:xfrm>
           <a:prstGeom prst="rect">
             <a:avLst/>
@@ -4749,7 +4749,7 @@
         </p:nvSpPr>
         <p:spPr>
           <a:xfrm>
-            <a:off x="548640" y="3794760"/>
+            <a:off x="548640" y="3886200"/>
             <a:ext cx="4206240" cy="320040"/>
           </a:xfrm>
           <a:prstGeom prst="rect">
@@ -4764,14 +4764,14 @@
           <a:lstStyle/>
           <a:p>
             <a:pPr algn="l">
-              <a:defRPr sz="1400">
-                <a:solidFill>
-                  <a:srgbClr val="FFFFFF"/>
-                </a:solidFill>
-              </a:defRPr>
-            </a:pPr>
-            <a:r>
-              <a:rPr sz="1400">
+              <a:defRPr sz="1500">
+                <a:solidFill>
+                  <a:srgbClr val="FFFFFF"/>
+                </a:solidFill>
+              </a:defRPr>
+            </a:pPr>
+            <a:r>
+              <a:rPr sz="1500">
                 <a:solidFill>
                   <a:srgbClr val="FFFFFF"/>
                 </a:solidFill>
@@ -4779,7 +4779,7 @@
               <a:t>5. Coeficiente térmico de </a:t>
             </a:r>
             <a:r>
-              <a:rPr sz="1400" i="1">
+              <a:rPr sz="1500" i="1">
                 <a:solidFill>
                   <a:srgbClr val="FFFFFF"/>
                 </a:solidFill>
@@ -4787,7 +4787,7 @@
               <a:t>V</a:t>
             </a:r>
             <a:r>
-              <a:rPr sz="1400" i="1">
+              <a:rPr sz="1500" i="1">
                 <a:solidFill>
                   <a:srgbClr val="FFFFFF"/>
                 </a:solidFill>
@@ -4795,7 +4795,7 @@
               <a:t>oc</a:t>
             </a:r>
             <a:r>
-              <a:rPr sz="1400">
+              <a:rPr sz="1500">
                 <a:solidFill>
                   <a:srgbClr val="FFFFFF"/>
                 </a:solidFill>
@@ -4821,8 +4821,8 @@
         </p:blipFill>
         <p:spPr>
           <a:xfrm>
-            <a:off x="548640" y="4160520"/>
-            <a:ext cx="972151" cy="365760"/>
+            <a:off x="548640" y="4297680"/>
+            <a:ext cx="1579746" cy="594360"/>
           </a:xfrm>
           <a:prstGeom prst="rect">
             <a:avLst/>
@@ -4831,7 +4831,47 @@
       </p:pic>
       <p:sp>
         <p:nvSpPr>
-          <p:cNvPr id="9" name="Rectangle 8"/>
+          <p:cNvPr id="9" name="TextBox 8"/>
+          <p:cNvSpPr txBox="1"/>
+          <p:nvPr/>
+        </p:nvSpPr>
+        <p:spPr>
+          <a:xfrm>
+            <a:off x="548640" y="5120640"/>
+            <a:ext cx="4206240" cy="822960"/>
+          </a:xfrm>
+          <a:prstGeom prst="rect">
+            <a:avLst/>
+          </a:prstGeom>
+          <a:noFill/>
+        </p:spPr>
+        <p:txBody>
+          <a:bodyPr wrap="square">
+            <a:spAutoFit/>
+          </a:bodyPr>
+          <a:lstStyle/>
+          <a:p>
+            <a:pPr algn="l">
+              <a:defRPr sz="1400">
+                <a:solidFill>
+                  <a:srgbClr val="E8A838"/>
+                </a:solidFill>
+              </a:defRPr>
+            </a:pPr>
+            <a:r>
+              <a:rPr sz="1400">
+                <a:solidFill>
+                  <a:srgbClr val="E8A838"/>
+                </a:solidFill>
+              </a:rPr>
+              <a:t>→ Parámetros base para el escalado dinámico a las condiciones reales de Atacama.</a:t>
+            </a:r>
+          </a:p>
+        </p:txBody>
+      </p:sp>
+      <p:sp>
+        <p:nvSpPr>
+          <p:cNvPr id="10" name="Rectangle 9"/>
           <p:cNvSpPr/>
           <p:nvPr/>
         </p:nvSpPr>
@@ -4876,7 +4916,7 @@
       </p:sp>
       <p:sp>
         <p:nvSpPr>
-          <p:cNvPr id="10" name="TextBox 9"/>
+          <p:cNvPr id="11" name="TextBox 10"/>
           <p:cNvSpPr txBox="1"/>
           <p:nvPr/>
         </p:nvSpPr>
@@ -4916,7 +4956,7 @@
       </p:sp>
       <p:sp>
         <p:nvSpPr>
-          <p:cNvPr id="11" name="TextBox 10"/>
+          <p:cNvPr id="12" name="TextBox 11"/>
           <p:cNvSpPr txBox="1"/>
           <p:nvPr/>
         </p:nvSpPr>
@@ -4937,14 +4977,14 @@
           <a:lstStyle/>
           <a:p>
             <a:pPr algn="l">
-              <a:defRPr sz="1400">
-                <a:solidFill>
-                  <a:srgbClr val="FFFFFF"/>
-                </a:solidFill>
-              </a:defRPr>
-            </a:pPr>
-            <a:r>
-              <a:rPr sz="1400">
+              <a:defRPr sz="1500">
+                <a:solidFill>
+                  <a:srgbClr val="FFFFFF"/>
+                </a:solidFill>
+              </a:defRPr>
+            </a:pPr>
+            <a:r>
+              <a:rPr sz="1500">
                 <a:solidFill>
                   <a:srgbClr val="FFFFFF"/>
                 </a:solidFill>
@@ -4952,7 +4992,7 @@
               <a:t>Para acoplar </a:t>
             </a:r>
             <a:r>
-              <a:rPr sz="1400" i="1">
+              <a:rPr sz="1500" i="1">
                 <a:solidFill>
                   <a:srgbClr val="FFFFFF"/>
                 </a:solidFill>
@@ -4960,7 +5000,7 @@
               <a:t>R</a:t>
             </a:r>
             <a:r>
-              <a:rPr sz="1400" i="1">
+              <a:rPr sz="1500" i="1">
                 <a:solidFill>
                   <a:srgbClr val="FFFFFF"/>
                 </a:solidFill>
@@ -4968,7 +5008,7 @@
               <a:t>s</a:t>
             </a:r>
             <a:r>
-              <a:rPr sz="1400">
+              <a:rPr sz="1500">
                 <a:solidFill>
                   <a:srgbClr val="FFFFFF"/>
                 </a:solidFill>
@@ -4980,7 +5020,7 @@
       </p:sp>
       <p:pic>
         <p:nvPicPr>
-          <p:cNvPr id="12" name="Picture 11" descr="eq_a76554b1ee03916d0fb4d4b17eb59988.png"/>
+          <p:cNvPr id="13" name="Picture 12" descr="eq_a76554b1ee03916d0fb4d4b17eb59988.png"/>
           <p:cNvPicPr>
             <a:picLocks noChangeAspect="1"/>
           </p:cNvPicPr>
@@ -4994,8 +5034,8 @@
         </p:blipFill>
         <p:spPr>
           <a:xfrm>
-            <a:off x="5394960" y="2148840"/>
-            <a:ext cx="2825314" cy="438912"/>
+            <a:off x="5394960" y="2194560"/>
+            <a:ext cx="4002528" cy="621792"/>
           </a:xfrm>
           <a:prstGeom prst="rect">
             <a:avLst/>
@@ -5004,13 +5044,13 @@
       </p:pic>
       <p:sp>
         <p:nvSpPr>
-          <p:cNvPr id="13" name="TextBox 12"/>
+          <p:cNvPr id="14" name="TextBox 13"/>
           <p:cNvSpPr txBox="1"/>
           <p:nvPr/>
         </p:nvSpPr>
         <p:spPr>
           <a:xfrm>
-            <a:off x="5394960" y="2834640"/>
+            <a:off x="5394960" y="2971800"/>
             <a:ext cx="5760720" cy="320040"/>
           </a:xfrm>
           <a:prstGeom prst="rect">
@@ -5025,14 +5065,14 @@
           <a:lstStyle/>
           <a:p>
             <a:pPr algn="l">
-              <a:defRPr sz="1400">
-                <a:solidFill>
-                  <a:srgbClr val="FFFFFF"/>
-                </a:solidFill>
-              </a:defRPr>
-            </a:pPr>
-            <a:r>
-              <a:rPr sz="1400">
+              <a:defRPr sz="1500">
+                <a:solidFill>
+                  <a:srgbClr val="FFFFFF"/>
+                </a:solidFill>
+              </a:defRPr>
+            </a:pPr>
+            <a:r>
+              <a:rPr sz="1500">
                 <a:solidFill>
                   <a:srgbClr val="FFFFFF"/>
                 </a:solidFill>
@@ -5044,7 +5084,7 @@
       </p:sp>
       <p:pic>
         <p:nvPicPr>
-          <p:cNvPr id="14" name="Picture 13" descr="eq_d3cc56a0e87a29528d48690a85598da7.png"/>
+          <p:cNvPr id="15" name="Picture 14" descr="eq_d3cc56a0e87a29528d48690a85598da7.png"/>
           <p:cNvPicPr>
             <a:picLocks noChangeAspect="1"/>
           </p:cNvPicPr>
@@ -5058,8 +5098,8 @@
         </p:blipFill>
         <p:spPr>
           <a:xfrm>
-            <a:off x="5394960" y="3246120"/>
-            <a:ext cx="1974511" cy="411480"/>
+            <a:off x="5394960" y="3383280"/>
+            <a:ext cx="2413292" cy="502920"/>
           </a:xfrm>
           <a:prstGeom prst="rect">
             <a:avLst/>
@@ -5068,7 +5108,7 @@
       </p:pic>
       <p:pic>
         <p:nvPicPr>
-          <p:cNvPr id="15" name="Picture 14" descr="eq_383431ee7cb363d006acacfdbffa99d2.png"/>
+          <p:cNvPr id="16" name="Picture 15" descr="eq_383431ee7cb363d006acacfdbffa99d2.png"/>
           <p:cNvPicPr>
             <a:picLocks noChangeAspect="1"/>
           </p:cNvPicPr>
@@ -5082,8 +5122,8 @@
         </p:blipFill>
         <p:spPr>
           <a:xfrm>
-            <a:off x="5394960" y="3794760"/>
-            <a:ext cx="674370" cy="320040"/>
+            <a:off x="5394960" y="3977639"/>
+            <a:ext cx="867047" cy="411480"/>
           </a:xfrm>
           <a:prstGeom prst="rect">
             <a:avLst/>
@@ -5092,14 +5132,14 @@
       </p:pic>
       <p:sp>
         <p:nvSpPr>
-          <p:cNvPr id="16" name="TextBox 15"/>
+          <p:cNvPr id="17" name="TextBox 16"/>
           <p:cNvSpPr txBox="1"/>
           <p:nvPr/>
         </p:nvSpPr>
         <p:spPr>
           <a:xfrm>
-            <a:off x="5394960" y="4434840"/>
-            <a:ext cx="5760720" cy="914400"/>
+            <a:off x="5394960" y="4526280"/>
+            <a:ext cx="5760720" cy="1097280"/>
           </a:xfrm>
           <a:prstGeom prst="rect">
             <a:avLst/>
@@ -5113,14 +5153,14 @@
           <a:lstStyle/>
           <a:p>
             <a:pPr algn="l">
-              <a:defRPr sz="1400">
-                <a:solidFill>
-                  <a:srgbClr val="E8A838"/>
-                </a:solidFill>
-              </a:defRPr>
-            </a:pPr>
-            <a:r>
-              <a:rPr sz="1400">
+              <a:defRPr sz="1500">
+                <a:solidFill>
+                  <a:srgbClr val="E8A838"/>
+                </a:solidFill>
+              </a:defRPr>
+            </a:pPr>
+            <a:r>
+              <a:rPr sz="1500">
                 <a:solidFill>
                   <a:srgbClr val="E8A838"/>
                 </a:solidFill>
@@ -5128,7 +5168,7 @@
               <a:t>La optimización se realiza mediante ajuste de mínimos cuadrados con bounds físicos (</a:t>
             </a:r>
             <a:r>
-              <a:rPr sz="1400" i="1">
+              <a:rPr sz="1500" i="1">
                 <a:solidFill>
                   <a:srgbClr val="E8A838"/>
                 </a:solidFill>
@@ -5136,7 +5176,7 @@
               <a:t>R</a:t>
             </a:r>
             <a:r>
-              <a:rPr sz="1400" i="1">
+              <a:rPr sz="1500" i="1">
                 <a:solidFill>
                   <a:srgbClr val="E8A838"/>
                 </a:solidFill>
@@ -5144,7 +5184,7 @@
               <a:t>s</a:t>
             </a:r>
             <a:r>
-              <a:rPr sz="1400">
+              <a:rPr sz="1500">
                 <a:solidFill>
                   <a:srgbClr val="E8A838"/>
                 </a:solidFill>
@@ -5152,7 +5192,7 @@
               <a:t> &gt; 0, </a:t>
             </a:r>
             <a:r>
-              <a:rPr sz="1400" i="1">
+              <a:rPr sz="1500" i="1">
                 <a:solidFill>
                   <a:srgbClr val="E8A838"/>
                 </a:solidFill>
@@ -5160,7 +5200,7 @@
               <a:t>n</a:t>
             </a:r>
             <a:r>
-              <a:rPr sz="1400" i="1">
+              <a:rPr sz="1500" i="1">
                 <a:solidFill>
                   <a:srgbClr val="E8A838"/>
                 </a:solidFill>
@@ -5168,7 +5208,7 @@
               <a:t>I</a:t>
             </a:r>
             <a:r>
-              <a:rPr sz="1400">
+              <a:rPr sz="1500">
                 <a:solidFill>
                   <a:srgbClr val="E8A838"/>
                 </a:solidFill>
@@ -5176,7 +5216,7 @@
               <a:t> ∈ </a:t>
             </a:r>
             <a:r>
-              <a:rPr sz="1400">
+              <a:rPr sz="1500">
                 <a:solidFill>
                   <a:srgbClr val="E8A838"/>
                 </a:solidFill>
@@ -5184,7 +5224,7 @@
               <a:t>1, 2</a:t>
             </a:r>
             <a:r>
-              <a:rPr sz="1400">
+              <a:rPr sz="1500">
                 <a:solidFill>
                   <a:srgbClr val="E8A838"/>
                 </a:solidFill>
@@ -5196,7 +5236,7 @@
       </p:sp>
       <p:sp>
         <p:nvSpPr>
-          <p:cNvPr id="17" name="TextBox 16"/>
+          <p:cNvPr id="18" name="TextBox 17"/>
           <p:cNvSpPr txBox="1"/>
           <p:nvPr/>
         </p:nvSpPr>
@@ -5469,7 +5509,7 @@
         <p:spPr>
           <a:xfrm>
             <a:off x="640080" y="1874519"/>
-            <a:ext cx="4260506" cy="347472"/>
+            <a:ext cx="5029200" cy="410163"/>
           </a:xfrm>
           <a:prstGeom prst="rect">
             <a:avLst/>
@@ -5484,7 +5524,7 @@
         </p:nvSpPr>
         <p:spPr>
           <a:xfrm>
-            <a:off x="548640" y="2468880"/>
+            <a:off x="548640" y="2514600"/>
             <a:ext cx="5181447" cy="274320"/>
           </a:xfrm>
           <a:prstGeom prst="rect">
@@ -5556,8 +5596,8 @@
         </p:blipFill>
         <p:spPr>
           <a:xfrm>
-            <a:off x="640080" y="2788920"/>
-            <a:ext cx="2956947" cy="384048"/>
+            <a:off x="640080" y="2834640"/>
+            <a:ext cx="4083403" cy="530352"/>
           </a:xfrm>
           <a:prstGeom prst="rect">
             <a:avLst/>
@@ -5572,7 +5612,7 @@
         </p:nvSpPr>
         <p:spPr>
           <a:xfrm>
-            <a:off x="548640" y="3474720"/>
+            <a:off x="548640" y="3520440"/>
             <a:ext cx="5181447" cy="274320"/>
           </a:xfrm>
           <a:prstGeom prst="rect">
@@ -5636,8 +5676,8 @@
         </p:blipFill>
         <p:spPr>
           <a:xfrm>
-            <a:off x="640080" y="3794760"/>
-            <a:ext cx="693420" cy="320040"/>
+            <a:off x="640080" y="3840480"/>
+            <a:ext cx="1089660" cy="502920"/>
           </a:xfrm>
           <a:prstGeom prst="rect">
             <a:avLst/>
@@ -5652,8 +5692,8 @@
         </p:nvSpPr>
         <p:spPr>
           <a:xfrm>
-            <a:off x="548640" y="4389120"/>
-            <a:ext cx="5181447" cy="1828800"/>
+            <a:off x="548640" y="4572000"/>
+            <a:ext cx="5181447" cy="1371600"/>
           </a:xfrm>
           <a:prstGeom prst="rect">
             <a:avLst/>
@@ -5964,7 +6004,7 @@
         <p:spPr>
           <a:xfrm>
             <a:off x="6461607" y="1874519"/>
-            <a:ext cx="1741270" cy="320040"/>
+            <a:ext cx="2736281" cy="502920"/>
           </a:xfrm>
           <a:prstGeom prst="rect">
             <a:avLst/>
@@ -5979,7 +6019,7 @@
         </p:nvSpPr>
         <p:spPr>
           <a:xfrm>
-            <a:off x="6370167" y="2468880"/>
+            <a:off x="6370167" y="2514600"/>
             <a:ext cx="5181447" cy="274320"/>
           </a:xfrm>
           <a:prstGeom prst="rect">
@@ -6051,8 +6091,8 @@
         </p:blipFill>
         <p:spPr>
           <a:xfrm>
-            <a:off x="6461607" y="2788920"/>
-            <a:ext cx="2671973" cy="329184"/>
+            <a:off x="6461607" y="2834640"/>
+            <a:ext cx="4082181" cy="502920"/>
           </a:xfrm>
           <a:prstGeom prst="rect">
             <a:avLst/>
@@ -6067,8 +6107,8 @@
         </p:nvSpPr>
         <p:spPr>
           <a:xfrm>
-            <a:off x="6370167" y="3474720"/>
-            <a:ext cx="5181447" cy="2743200"/>
+            <a:off x="6370167" y="3520440"/>
+            <a:ext cx="5181447" cy="2468880"/>
           </a:xfrm>
           <a:prstGeom prst="rect">
             <a:avLst/>
@@ -14636,8 +14676,8 @@
         </p:blipFill>
         <p:spPr>
           <a:xfrm>
-            <a:off x="914400" y="1508760"/>
-            <a:ext cx="6035040" cy="4526280"/>
+            <a:off x="1005840" y="1508760"/>
+            <a:ext cx="5852160" cy="4389120"/>
           </a:xfrm>
           <a:prstGeom prst="rect">
             <a:avLst/>

</xml_diff>

<commit_message>
Cambia scatter plot a aspect ratio 10:7.5 en Slide 14 y extiende la ecuacion del PR en Slide 15
</commit_message>
<xml_diff>
--- a/output/Presentacion_Final_ELI556_Atacama.pptx
+++ b/output/Presentacion_Final_ELI556_Atacama.pptx
@@ -6714,7 +6714,7 @@
         <p:spPr>
           <a:xfrm>
             <a:off x="365760" y="1097280"/>
-            <a:ext cx="5943600" cy="5029200"/>
+            <a:ext cx="5852160" cy="5029200"/>
           </a:xfrm>
           <a:prstGeom prst="rect">
             <a:avLst/>
@@ -6759,7 +6759,7 @@
         <p:spPr>
           <a:xfrm>
             <a:off x="457200" y="1188720"/>
-            <a:ext cx="5760720" cy="411480"/>
+            <a:ext cx="5669280" cy="411480"/>
           </a:xfrm>
           <a:prstGeom prst="rect">
             <a:avLst/>
@@ -6806,8 +6806,8 @@
         </p:blipFill>
         <p:spPr>
           <a:xfrm>
-            <a:off x="548640" y="1645920"/>
-            <a:ext cx="4114800" cy="4114800"/>
+            <a:off x="548640" y="1554480"/>
+            <a:ext cx="5486400" cy="4114800"/>
           </a:xfrm>
           <a:prstGeom prst="rect">
             <a:avLst/>
@@ -6822,8 +6822,8 @@
         </p:nvSpPr>
         <p:spPr>
           <a:xfrm>
-            <a:off x="6400800" y="1097280"/>
-            <a:ext cx="5394960" cy="5029200"/>
+            <a:off x="6766560" y="1097280"/>
+            <a:ext cx="4663440" cy="5029200"/>
           </a:xfrm>
           <a:prstGeom prst="rect">
             <a:avLst/>
@@ -6867,8 +6867,8 @@
         </p:nvSpPr>
         <p:spPr>
           <a:xfrm>
-            <a:off x="6492240" y="1188720"/>
-            <a:ext cx="5212080" cy="411480"/>
+            <a:off x="6858000" y="1188720"/>
+            <a:ext cx="4480560" cy="411480"/>
           </a:xfrm>
           <a:prstGeom prst="rect">
             <a:avLst/>
@@ -6907,8 +6907,8 @@
         </p:nvSpPr>
         <p:spPr>
           <a:xfrm>
-            <a:off x="6583680" y="1645920"/>
-            <a:ext cx="5029200" cy="3657600"/>
+            <a:off x="6949440" y="1645920"/>
+            <a:ext cx="4297680" cy="4114800"/>
           </a:xfrm>
           <a:prstGeom prst="rect">
             <a:avLst/>
@@ -7261,7 +7261,7 @@
       </p:sp>
       <p:pic>
         <p:nvPicPr>
-          <p:cNvPr id="6" name="Picture 5" descr="eq_a7cd84c1dfc4bbc488901a2df13705be.png"/>
+          <p:cNvPr id="6" name="Picture 5" descr="eq_a94e9ad4dd062e009503f40fd565ad11.png"/>
           <p:cNvPicPr>
             <a:picLocks noChangeAspect="1"/>
           </p:cNvPicPr>
@@ -7275,8 +7275,8 @@
         </p:blipFill>
         <p:spPr>
           <a:xfrm>
-            <a:off x="2011680" y="1965960"/>
-            <a:ext cx="1726410" cy="502920"/>
+            <a:off x="1737360" y="1874519"/>
+            <a:ext cx="2292484" cy="777240"/>
           </a:xfrm>
           <a:prstGeom prst="rect">
             <a:avLst/>
@@ -7411,7 +7411,7 @@
                   <a:srgbClr val="E8A838"/>
                 </a:solidFill>
               </a:rPr>
-              <a:t>P</a:t>
+              <a:t>V</a:t>
             </a:r>
             <a:r>
               <a:rPr sz="1400" i="1">
@@ -7419,7 +7419,7 @@
                   <a:srgbClr val="E8A838"/>
                 </a:solidFill>
               </a:rPr>
-              <a:t>mp,SDM</a:t>
+              <a:t>mp,t</a:t>
             </a:r>
             <a:r>
               <a:rPr sz="1400">
@@ -7427,7 +7427,23 @@
                   <a:srgbClr val="E8A838"/>
                 </a:solidFill>
               </a:rPr>
-              <a:t>: Potencia MPP simulada hora a hora con De Soto</a:t>
+              <a:t> / </a:t>
+            </a:r>
+            <a:r>
+              <a:rPr sz="1400" i="1">
+                <a:solidFill>
+                  <a:srgbClr val="E8A838"/>
+                </a:solidFill>
+              </a:rPr>
+              <a:t>I</a:t>
+            </a:r>
+            <a:r>
+              <a:rPr sz="1400" i="1">
+                <a:solidFill>
+                  <a:srgbClr val="E8A838"/>
+                </a:solidFill>
+              </a:rPr>
+              <a:t>mp,t</a:t>
             </a:r>
             <a:r>
               <a:rPr sz="1400">
@@ -7435,6 +7451,14 @@
                   <a:srgbClr val="E8A838"/>
                 </a:solidFill>
               </a:rPr>
+              <a:t>: Tensión y corriente MPP horarias del SDM</a:t>
+            </a:r>
+            <a:r>
+              <a:rPr sz="1400">
+                <a:solidFill>
+                  <a:srgbClr val="E8A838"/>
+                </a:solidFill>
+              </a:rPr>
               <a:t>[1]</a:t>
             </a:r>
             <a:r>
@@ -7443,7 +7467,7 @@
                   <a:srgbClr val="E8A838"/>
                 </a:solidFill>
               </a:rPr>
-              <a:t> (W).</a:t>
+              <a:t>.</a:t>
             </a:r>
           </a:p>
           <a:p>
@@ -7517,7 +7541,7 @@
                   <a:srgbClr val="E8A838"/>
                 </a:solidFill>
               </a:rPr>
-              <a:t>poa</a:t>
+              <a:t>poa,t</a:t>
             </a:r>
             <a:r>
               <a:rPr sz="1400">
@@ -7525,7 +7549,7 @@
                   <a:srgbClr val="E8A838"/>
                 </a:solidFill>
               </a:rPr>
-              <a:t>: Irradiancia calculada en el plano del panel (W/m²).</a:t>
+              <a:t>: Irradiancia temporal en el plano del panel (W/m²).</a:t>
             </a:r>
           </a:p>
           <a:p>
@@ -7542,7 +7566,31 @@
                   <a:srgbClr val="E8A838"/>
                 </a:solidFill>
               </a:rPr>
-              <a:t>• 1000: Irradiancia de referencia a STC (W/m²).</a:t>
+              <a:t>• </a:t>
+            </a:r>
+            <a:r>
+              <a:rPr sz="1400" i="1">
+                <a:solidFill>
+                  <a:srgbClr val="E8A838"/>
+                </a:solidFill>
+              </a:rPr>
+              <a:t>G</a:t>
+            </a:r>
+            <a:r>
+              <a:rPr sz="1400" i="1">
+                <a:solidFill>
+                  <a:srgbClr val="E8A838"/>
+                </a:solidFill>
+              </a:rPr>
+              <a:t>ref</a:t>
+            </a:r>
+            <a:r>
+              <a:rPr sz="1400">
+                <a:solidFill>
+                  <a:srgbClr val="E8A838"/>
+                </a:solidFill>
+              </a:rPr>
+              <a:t>: Irradiancia de referencia a STC (1000 W/m²).</a:t>
             </a:r>
           </a:p>
         </p:txBody>

</xml_diff>

<commit_message>
Usa division horizontal con barra inclinada en la ecuacion del PR de la Slide 15
</commit_message>
<xml_diff>
--- a/output/Presentacion_Final_ELI556_Atacama.pptx
+++ b/output/Presentacion_Final_ELI556_Atacama.pptx
@@ -7261,7 +7261,7 @@
       </p:sp>
       <p:pic>
         <p:nvPicPr>
-          <p:cNvPr id="6" name="Picture 5" descr="eq_a94e9ad4dd062e009503f40fd565ad11.png"/>
+          <p:cNvPr id="6" name="Picture 5" descr="eq_89f2913b946191ae2d2668e37f8cda9b.png"/>
           <p:cNvPicPr>
             <a:picLocks noChangeAspect="1"/>
           </p:cNvPicPr>
@@ -7275,8 +7275,8 @@
         </p:blipFill>
         <p:spPr>
           <a:xfrm>
-            <a:off x="1737360" y="1874519"/>
-            <a:ext cx="2292484" cy="777240"/>
+            <a:off x="822960" y="1920240"/>
+            <a:ext cx="6620222" cy="685800"/>
           </a:xfrm>
           <a:prstGeom prst="rect">
             <a:avLst/>

</xml_diff>

<commit_message>
Mueve el histograma de Slide 9 a la izquierda para cuadrarlo perfectamente
</commit_message>
<xml_diff>
--- a/output/Presentacion_Final_ELI556_Atacama.pptx
+++ b/output/Presentacion_Final_ELI556_Atacama.pptx
@@ -14724,8 +14724,8 @@
         </p:blipFill>
         <p:spPr>
           <a:xfrm>
-            <a:off x="1005840" y="1508760"/>
-            <a:ext cx="5852160" cy="4389120"/>
+            <a:off x="822960" y="1508760"/>
+            <a:ext cx="5669280" cy="4251960"/>
           </a:xfrm>
           <a:prstGeom prst="rect">
             <a:avLst/>

</xml_diff>

<commit_message>
Maximiza tamaño de curvas IV-PV en Slide 13 y alinea terminos a la derecha del igual en Slide 5
</commit_message>
<xml_diff>
--- a/output/Presentacion_Final_ELI556_Atacama.pptx
+++ b/output/Presentacion_Final_ELI556_Atacama.pptx
@@ -6596,8 +6596,8 @@
         </p:blipFill>
         <p:spPr>
           <a:xfrm>
-            <a:off x="1517904" y="1280160"/>
-            <a:ext cx="9144000" cy="3918857"/>
+            <a:off x="914400" y="1234440"/>
+            <a:ext cx="10360152" cy="4937760"/>
           </a:xfrm>
           <a:prstGeom prst="rect">
             <a:avLst/>
@@ -12278,7 +12278,7 @@
       </p:sp>
       <p:pic>
         <p:nvPicPr>
-          <p:cNvPr id="11" name="Picture 10" descr="eq_bb06151bcf09291bead73672e21c10fb.png"/>
+          <p:cNvPr id="11" name="Picture 10" descr="eq_2b23b4ade8ffd59ce03b1b191c8e84e1.png"/>
           <p:cNvPicPr>
             <a:picLocks noChangeAspect="1"/>
           </p:cNvPicPr>
@@ -12293,7 +12293,7 @@
         <p:spPr>
           <a:xfrm>
             <a:off x="5852160" y="1874519"/>
-            <a:ext cx="2459783" cy="1280160"/>
+            <a:ext cx="5303520" cy="595599"/>
           </a:xfrm>
           <a:prstGeom prst="rect">
             <a:avLst/>

</xml_diff>

<commit_message>
Corrige renderizado de ecuacion de absorcion en Slide 5 dividiendola en 3 lineas independientes
</commit_message>
<xml_diff>
--- a/output/Presentacion_Final_ELI556_Atacama.pptx
+++ b/output/Presentacion_Final_ELI556_Atacama.pptx
@@ -12278,7 +12278,7 @@
       </p:sp>
       <p:pic>
         <p:nvPicPr>
-          <p:cNvPr id="11" name="Picture 10" descr="eq_2b23b4ade8ffd59ce03b1b191c8e84e1.png"/>
+          <p:cNvPr id="11" name="Picture 10" descr="eq_506bad7002e524c24e9cb60bf8ff68ae.png"/>
           <p:cNvPicPr>
             <a:picLocks noChangeAspect="1"/>
           </p:cNvPicPr>
@@ -12293,16 +12293,64 @@
         <p:spPr>
           <a:xfrm>
             <a:off x="5852160" y="1874519"/>
-            <a:ext cx="5303520" cy="595599"/>
+            <a:ext cx="2251076" cy="384048"/>
           </a:xfrm>
           <a:prstGeom prst="rect">
             <a:avLst/>
           </a:prstGeom>
         </p:spPr>
       </p:pic>
-      <p:sp>
-        <p:nvSpPr>
-          <p:cNvPr id="12" name="TextBox 11"/>
+      <p:pic>
+        <p:nvPicPr>
+          <p:cNvPr id="12" name="Picture 11" descr="eq_c9e0e5966a79a53d7e6daf086af3f7eb.png"/>
+          <p:cNvPicPr>
+            <a:picLocks noChangeAspect="1"/>
+          </p:cNvPicPr>
+          <p:nvPr/>
+        </p:nvPicPr>
+        <p:blipFill>
+          <a:blip r:embed="rId4"/>
+          <a:stretch>
+            <a:fillRect/>
+          </a:stretch>
+        </p:blipFill>
+        <p:spPr>
+          <a:xfrm>
+            <a:off x="6720840" y="2286000"/>
+            <a:ext cx="2120992" cy="384048"/>
+          </a:xfrm>
+          <a:prstGeom prst="rect">
+            <a:avLst/>
+          </a:prstGeom>
+        </p:spPr>
+      </p:pic>
+      <p:pic>
+        <p:nvPicPr>
+          <p:cNvPr id="13" name="Picture 12" descr="eq_678fcbf570fad393118f2ab814b44019.png"/>
+          <p:cNvPicPr>
+            <a:picLocks noChangeAspect="1"/>
+          </p:cNvPicPr>
+          <p:nvPr/>
+        </p:nvPicPr>
+        <p:blipFill>
+          <a:blip r:embed="rId5"/>
+          <a:stretch>
+            <a:fillRect/>
+          </a:stretch>
+        </p:blipFill>
+        <p:spPr>
+          <a:xfrm>
+            <a:off x="6720840" y="2697480"/>
+            <a:ext cx="2363204" cy="384048"/>
+          </a:xfrm>
+          <a:prstGeom prst="rect">
+            <a:avLst/>
+          </a:prstGeom>
+        </p:spPr>
+      </p:pic>
+      <p:sp>
+        <p:nvSpPr>
+          <p:cNvPr id="14" name="TextBox 13"/>
           <p:cNvSpPr txBox="1"/>
           <p:nvPr/>
         </p:nvSpPr>
@@ -12521,7 +12569,7 @@
       </p:sp>
       <p:sp>
         <p:nvSpPr>
-          <p:cNvPr id="13" name="TextBox 12"/>
+          <p:cNvPr id="15" name="TextBox 14"/>
           <p:cNvSpPr txBox="1"/>
           <p:nvPr/>
         </p:nvSpPr>

</xml_diff>

<commit_message>
Corregir asimetria horizontal en diapositivas, eliminar solapamiento en Lamina 17, corregir opacidad de leyenda en scatter y aumentar tamano de etiquetas de ejes
</commit_message>
<xml_diff>
--- a/output/Presentacion_Final_ELI556_Atacama.pptx
+++ b/output/Presentacion_Final_ELI556_Atacama.pptx
@@ -3735,7 +3735,7 @@
         <p:spPr>
           <a:xfrm>
             <a:off x="5577840" y="3291840"/>
-            <a:ext cx="5760720" cy="2834640"/>
+            <a:ext cx="6248095" cy="2834640"/>
           </a:xfrm>
           <a:prstGeom prst="rect">
             <a:avLst/>
@@ -3780,7 +3780,7 @@
         <p:spPr>
           <a:xfrm>
             <a:off x="5669280" y="3383280"/>
-            <a:ext cx="5577840" cy="411480"/>
+            <a:ext cx="6065215" cy="411480"/>
           </a:xfrm>
           <a:prstGeom prst="rect">
             <a:avLst/>
@@ -3820,7 +3820,7 @@
         <p:spPr>
           <a:xfrm>
             <a:off x="5760720" y="3657600"/>
-            <a:ext cx="5394960" cy="2103120"/>
+            <a:ext cx="5882335" cy="2103120"/>
           </a:xfrm>
           <a:prstGeom prst="rect">
             <a:avLst/>
@@ -4878,7 +4878,7 @@
         <p:spPr>
           <a:xfrm>
             <a:off x="5212080" y="1097280"/>
-            <a:ext cx="6126480" cy="5029200"/>
+            <a:ext cx="6613855" cy="5029200"/>
           </a:xfrm>
           <a:prstGeom prst="rect">
             <a:avLst/>
@@ -4923,7 +4923,7 @@
         <p:spPr>
           <a:xfrm>
             <a:off x="5303520" y="1188720"/>
-            <a:ext cx="5943600" cy="411480"/>
+            <a:ext cx="6430975" cy="411480"/>
           </a:xfrm>
           <a:prstGeom prst="rect">
             <a:avLst/>
@@ -4963,7 +4963,7 @@
         <p:spPr>
           <a:xfrm>
             <a:off x="5394960" y="1554480"/>
-            <a:ext cx="5760720" cy="548640"/>
+            <a:ext cx="6248095" cy="548640"/>
           </a:xfrm>
           <a:prstGeom prst="rect">
             <a:avLst/>
@@ -5051,7 +5051,7 @@
         <p:spPr>
           <a:xfrm>
             <a:off x="5394960" y="2971800"/>
-            <a:ext cx="5760720" cy="320040"/>
+            <a:ext cx="6248095" cy="320040"/>
           </a:xfrm>
           <a:prstGeom prst="rect">
             <a:avLst/>
@@ -5139,7 +5139,7 @@
         <p:spPr>
           <a:xfrm>
             <a:off x="5394960" y="4526280"/>
-            <a:ext cx="5760720" cy="1097280"/>
+            <a:ext cx="6248095" cy="1097280"/>
           </a:xfrm>
           <a:prstGeom prst="rect">
             <a:avLst/>
@@ -5344,7 +5344,7 @@
         <p:spPr>
           <a:xfrm>
             <a:off x="365760" y="1097280"/>
-            <a:ext cx="5547207" cy="5029200"/>
+            <a:ext cx="5592927" cy="5029200"/>
           </a:xfrm>
           <a:prstGeom prst="rect">
             <a:avLst/>
@@ -5389,7 +5389,7 @@
         <p:spPr>
           <a:xfrm>
             <a:off x="457200" y="1188720"/>
-            <a:ext cx="5364327" cy="411480"/>
+            <a:ext cx="5410047" cy="411480"/>
           </a:xfrm>
           <a:prstGeom prst="rect">
             <a:avLst/>
@@ -5437,7 +5437,7 @@
         <p:spPr>
           <a:xfrm>
             <a:off x="548640" y="1554480"/>
-            <a:ext cx="5181447" cy="274320"/>
+            <a:ext cx="5227167" cy="274320"/>
           </a:xfrm>
           <a:prstGeom prst="rect">
             <a:avLst/>
@@ -5525,7 +5525,7 @@
         <p:spPr>
           <a:xfrm>
             <a:off x="548640" y="2514600"/>
-            <a:ext cx="5181447" cy="274320"/>
+            <a:ext cx="5227167" cy="274320"/>
           </a:xfrm>
           <a:prstGeom prst="rect">
             <a:avLst/>
@@ -5613,7 +5613,7 @@
         <p:spPr>
           <a:xfrm>
             <a:off x="548640" y="3520440"/>
-            <a:ext cx="5181447" cy="274320"/>
+            <a:ext cx="5227167" cy="274320"/>
           </a:xfrm>
           <a:prstGeom prst="rect">
             <a:avLst/>
@@ -5693,7 +5693,7 @@
         <p:spPr>
           <a:xfrm>
             <a:off x="548640" y="4572000"/>
-            <a:ext cx="5181447" cy="1371600"/>
+            <a:ext cx="5227167" cy="1371600"/>
           </a:xfrm>
           <a:prstGeom prst="rect">
             <a:avLst/>
@@ -5838,8 +5838,8 @@
         </p:nvSpPr>
         <p:spPr>
           <a:xfrm>
-            <a:off x="6187287" y="1097280"/>
-            <a:ext cx="5547207" cy="5029200"/>
+            <a:off x="6233007" y="1097280"/>
+            <a:ext cx="5592927" cy="5029200"/>
           </a:xfrm>
           <a:prstGeom prst="rect">
             <a:avLst/>
@@ -5883,8 +5883,8 @@
         </p:nvSpPr>
         <p:spPr>
           <a:xfrm>
-            <a:off x="6278727" y="1188720"/>
-            <a:ext cx="5364327" cy="411480"/>
+            <a:off x="6324447" y="1188720"/>
+            <a:ext cx="5410047" cy="411480"/>
           </a:xfrm>
           <a:prstGeom prst="rect">
             <a:avLst/>
@@ -5931,8 +5931,8 @@
         </p:nvSpPr>
         <p:spPr>
           <a:xfrm>
-            <a:off x="6370167" y="1554480"/>
-            <a:ext cx="5181447" cy="274320"/>
+            <a:off x="6415887" y="1554480"/>
+            <a:ext cx="5227167" cy="274320"/>
           </a:xfrm>
           <a:prstGeom prst="rect">
             <a:avLst/>
@@ -6003,7 +6003,7 @@
         </p:blipFill>
         <p:spPr>
           <a:xfrm>
-            <a:off x="6461607" y="1874519"/>
+            <a:off x="6507327" y="1874519"/>
             <a:ext cx="2736281" cy="502920"/>
           </a:xfrm>
           <a:prstGeom prst="rect">
@@ -6019,8 +6019,8 @@
         </p:nvSpPr>
         <p:spPr>
           <a:xfrm>
-            <a:off x="6370167" y="2514600"/>
-            <a:ext cx="5181447" cy="274320"/>
+            <a:off x="6415887" y="2514600"/>
+            <a:ext cx="5227167" cy="274320"/>
           </a:xfrm>
           <a:prstGeom prst="rect">
             <a:avLst/>
@@ -6091,7 +6091,7 @@
         </p:blipFill>
         <p:spPr>
           <a:xfrm>
-            <a:off x="6461607" y="2834640"/>
+            <a:off x="6507327" y="2834640"/>
             <a:ext cx="4082181" cy="502920"/>
           </a:xfrm>
           <a:prstGeom prst="rect">
@@ -6107,8 +6107,8 @@
         </p:nvSpPr>
         <p:spPr>
           <a:xfrm>
-            <a:off x="6370167" y="3520440"/>
-            <a:ext cx="5181447" cy="2468880"/>
+            <a:off x="6415887" y="3520440"/>
+            <a:ext cx="5227167" cy="2468880"/>
           </a:xfrm>
           <a:prstGeom prst="rect">
             <a:avLst/>
@@ -6714,7 +6714,7 @@
         <p:spPr>
           <a:xfrm>
             <a:off x="365760" y="1097280"/>
-            <a:ext cx="5852160" cy="5029200"/>
+            <a:ext cx="6035040" cy="5029200"/>
           </a:xfrm>
           <a:prstGeom prst="rect">
             <a:avLst/>
@@ -6759,7 +6759,7 @@
         <p:spPr>
           <a:xfrm>
             <a:off x="457200" y="1188720"/>
-            <a:ext cx="5669280" cy="411480"/>
+            <a:ext cx="5852160" cy="411480"/>
           </a:xfrm>
           <a:prstGeom prst="rect">
             <a:avLst/>
@@ -6806,7 +6806,7 @@
         </p:blipFill>
         <p:spPr>
           <a:xfrm>
-            <a:off x="548640" y="1554480"/>
+            <a:off x="640080" y="1554480"/>
             <a:ext cx="5486400" cy="4114800"/>
           </a:xfrm>
           <a:prstGeom prst="rect">
@@ -6822,8 +6822,8 @@
         </p:nvSpPr>
         <p:spPr>
           <a:xfrm>
-            <a:off x="6766560" y="1097280"/>
-            <a:ext cx="4663440" cy="5029200"/>
+            <a:off x="6675120" y="1097280"/>
+            <a:ext cx="5150815" cy="5029200"/>
           </a:xfrm>
           <a:prstGeom prst="rect">
             <a:avLst/>
@@ -6867,8 +6867,8 @@
         </p:nvSpPr>
         <p:spPr>
           <a:xfrm>
-            <a:off x="6858000" y="1188720"/>
-            <a:ext cx="4480560" cy="411480"/>
+            <a:off x="6766560" y="1188720"/>
+            <a:ext cx="4967935" cy="411480"/>
           </a:xfrm>
           <a:prstGeom prst="rect">
             <a:avLst/>
@@ -6907,8 +6907,8 @@
         </p:nvSpPr>
         <p:spPr>
           <a:xfrm>
-            <a:off x="6949440" y="1645920"/>
-            <a:ext cx="4297680" cy="4114800"/>
+            <a:off x="6858000" y="1645920"/>
+            <a:ext cx="4785055" cy="4114800"/>
           </a:xfrm>
           <a:prstGeom prst="rect">
             <a:avLst/>
@@ -7604,7 +7604,7 @@
         <p:spPr>
           <a:xfrm>
             <a:off x="5394960" y="3291840"/>
-            <a:ext cx="5943600" cy="2834640"/>
+            <a:ext cx="6430975" cy="2834640"/>
           </a:xfrm>
           <a:prstGeom prst="rect">
             <a:avLst/>
@@ -7649,7 +7649,7 @@
         <p:spPr>
           <a:xfrm>
             <a:off x="5486400" y="3383280"/>
-            <a:ext cx="5760720" cy="411480"/>
+            <a:ext cx="6248095" cy="411480"/>
           </a:xfrm>
           <a:prstGeom prst="rect">
             <a:avLst/>
@@ -7689,7 +7689,7 @@
         <p:spPr>
           <a:xfrm>
             <a:off x="5577840" y="3749039"/>
-            <a:ext cx="5577840" cy="2103120"/>
+            <a:ext cx="6065215" cy="2103120"/>
           </a:xfrm>
           <a:prstGeom prst="rect">
             <a:avLst/>
@@ -8163,7 +8163,7 @@
         <p:spPr>
           <a:xfrm>
             <a:off x="365760" y="1097280"/>
-            <a:ext cx="7315200" cy="5029200"/>
+            <a:ext cx="6949440" cy="5029200"/>
           </a:xfrm>
           <a:prstGeom prst="rect">
             <a:avLst/>
@@ -8208,7 +8208,7 @@
         <p:spPr>
           <a:xfrm>
             <a:off x="457200" y="1188720"/>
-            <a:ext cx="7132320" cy="411480"/>
+            <a:ext cx="6766560" cy="411480"/>
           </a:xfrm>
           <a:prstGeom prst="rect">
             <a:avLst/>
@@ -8255,7 +8255,7 @@
         </p:blipFill>
         <p:spPr>
           <a:xfrm>
-            <a:off x="548640" y="1645920"/>
+            <a:off x="731520" y="1645920"/>
             <a:ext cx="6217920" cy="3695556"/>
           </a:xfrm>
           <a:prstGeom prst="rect">
@@ -8272,7 +8272,7 @@
         <p:spPr>
           <a:xfrm>
             <a:off x="7589520" y="1097280"/>
-            <a:ext cx="4206240" cy="5029200"/>
+            <a:ext cx="4236415" cy="5029200"/>
           </a:xfrm>
           <a:prstGeom prst="rect">
             <a:avLst/>
@@ -8317,7 +8317,7 @@
         <p:spPr>
           <a:xfrm>
             <a:off x="7680960" y="1188720"/>
-            <a:ext cx="4023360" cy="411480"/>
+            <a:ext cx="4053535" cy="411480"/>
           </a:xfrm>
           <a:prstGeom prst="rect">
             <a:avLst/>
@@ -8357,7 +8357,7 @@
         <p:spPr>
           <a:xfrm>
             <a:off x="7772400" y="1645920"/>
-            <a:ext cx="3840480" cy="4114800"/>
+            <a:ext cx="3870655" cy="4114800"/>
           </a:xfrm>
           <a:prstGeom prst="rect">
             <a:avLst/>
@@ -8524,7 +8524,7 @@
         <p:spPr>
           <a:xfrm>
             <a:off x="365760" y="1097280"/>
-            <a:ext cx="5547207" cy="5029200"/>
+            <a:ext cx="5592927" cy="5029200"/>
           </a:xfrm>
           <a:prstGeom prst="rect">
             <a:avLst/>
@@ -8569,7 +8569,7 @@
         <p:spPr>
           <a:xfrm>
             <a:off x="457200" y="1188720"/>
-            <a:ext cx="5364327" cy="411480"/>
+            <a:ext cx="5410047" cy="411480"/>
           </a:xfrm>
           <a:prstGeom prst="rect">
             <a:avLst/>
@@ -8609,7 +8609,7 @@
         <p:spPr>
           <a:xfrm>
             <a:off x="548640" y="1645920"/>
-            <a:ext cx="5181447" cy="4114800"/>
+            <a:ext cx="5227167" cy="4114800"/>
           </a:xfrm>
           <a:prstGeom prst="rect">
             <a:avLst/>
@@ -8742,8 +8742,8 @@
         </p:nvSpPr>
         <p:spPr>
           <a:xfrm>
-            <a:off x="6187287" y="1097280"/>
-            <a:ext cx="5547207" cy="5029200"/>
+            <a:off x="6233007" y="1097280"/>
+            <a:ext cx="5592927" cy="5029200"/>
           </a:xfrm>
           <a:prstGeom prst="rect">
             <a:avLst/>
@@ -8787,8 +8787,8 @@
         </p:nvSpPr>
         <p:spPr>
           <a:xfrm>
-            <a:off x="6278727" y="1188720"/>
-            <a:ext cx="5364327" cy="411480"/>
+            <a:off x="6324447" y="1188720"/>
+            <a:ext cx="5410047" cy="411480"/>
           </a:xfrm>
           <a:prstGeom prst="rect">
             <a:avLst/>
@@ -8827,8 +8827,8 @@
         </p:nvSpPr>
         <p:spPr>
           <a:xfrm>
-            <a:off x="6370167" y="1645920"/>
-            <a:ext cx="5181447" cy="4114800"/>
+            <a:off x="6415887" y="1645920"/>
+            <a:ext cx="5227167" cy="4114800"/>
           </a:xfrm>
           <a:prstGeom prst="rect">
             <a:avLst/>
@@ -9047,7 +9047,7 @@
         <p:spPr>
           <a:xfrm>
             <a:off x="365760" y="1097280"/>
-            <a:ext cx="5547207" cy="5029200"/>
+            <a:ext cx="5592927" cy="5029200"/>
           </a:xfrm>
           <a:prstGeom prst="rect">
             <a:avLst/>
@@ -9092,7 +9092,7 @@
         <p:spPr>
           <a:xfrm>
             <a:off x="457200" y="1188720"/>
-            <a:ext cx="5364327" cy="411480"/>
+            <a:ext cx="5410047" cy="411480"/>
           </a:xfrm>
           <a:prstGeom prst="rect">
             <a:avLst/>
@@ -9132,7 +9132,7 @@
         <p:spPr>
           <a:xfrm>
             <a:off x="548640" y="1645920"/>
-            <a:ext cx="5181447" cy="4114800"/>
+            <a:ext cx="5227167" cy="4114800"/>
           </a:xfrm>
           <a:prstGeom prst="rect">
             <a:avLst/>
@@ -9265,8 +9265,8 @@
         </p:nvSpPr>
         <p:spPr>
           <a:xfrm>
-            <a:off x="6187287" y="1097280"/>
-            <a:ext cx="5547207" cy="5029200"/>
+            <a:off x="6233007" y="1097280"/>
+            <a:ext cx="5592927" cy="5029200"/>
           </a:xfrm>
           <a:prstGeom prst="rect">
             <a:avLst/>
@@ -9310,8 +9310,8 @@
         </p:nvSpPr>
         <p:spPr>
           <a:xfrm>
-            <a:off x="6278727" y="1188720"/>
-            <a:ext cx="5364327" cy="411480"/>
+            <a:off x="6324447" y="1188720"/>
+            <a:ext cx="5410047" cy="411480"/>
           </a:xfrm>
           <a:prstGeom prst="rect">
             <a:avLst/>
@@ -9350,8 +9350,8 @@
         </p:nvSpPr>
         <p:spPr>
           <a:xfrm>
-            <a:off x="6370167" y="1645920"/>
-            <a:ext cx="5181447" cy="4114800"/>
+            <a:off x="6415887" y="1645920"/>
+            <a:ext cx="5227167" cy="4114800"/>
           </a:xfrm>
           <a:prstGeom prst="rect">
             <a:avLst/>
@@ -9586,7 +9586,7 @@
         <p:spPr>
           <a:xfrm>
             <a:off x="365760" y="1097280"/>
-            <a:ext cx="5547207" cy="5029200"/>
+            <a:ext cx="5592927" cy="5029200"/>
           </a:xfrm>
           <a:prstGeom prst="rect">
             <a:avLst/>
@@ -9631,7 +9631,7 @@
         <p:spPr>
           <a:xfrm>
             <a:off x="457200" y="1188720"/>
-            <a:ext cx="5364327" cy="411480"/>
+            <a:ext cx="5410047" cy="411480"/>
           </a:xfrm>
           <a:prstGeom prst="rect">
             <a:avLst/>
@@ -9671,7 +9671,7 @@
         <p:spPr>
           <a:xfrm>
             <a:off x="548640" y="1645920"/>
-            <a:ext cx="5181447" cy="3657600"/>
+            <a:ext cx="5227167" cy="3657600"/>
           </a:xfrm>
           <a:prstGeom prst="rect">
             <a:avLst/>
@@ -9788,8 +9788,8 @@
         </p:nvSpPr>
         <p:spPr>
           <a:xfrm>
-            <a:off x="6187287" y="1097280"/>
-            <a:ext cx="5547207" cy="5029200"/>
+            <a:off x="6233007" y="1097280"/>
+            <a:ext cx="5592927" cy="5029200"/>
           </a:xfrm>
           <a:prstGeom prst="rect">
             <a:avLst/>
@@ -9833,8 +9833,8 @@
         </p:nvSpPr>
         <p:spPr>
           <a:xfrm>
-            <a:off x="6278727" y="1188720"/>
-            <a:ext cx="5364327" cy="411480"/>
+            <a:off x="6324447" y="1188720"/>
+            <a:ext cx="5410047" cy="411480"/>
           </a:xfrm>
           <a:prstGeom prst="rect">
             <a:avLst/>
@@ -9873,8 +9873,8 @@
         </p:nvSpPr>
         <p:spPr>
           <a:xfrm>
-            <a:off x="6370167" y="1645920"/>
-            <a:ext cx="5181447" cy="3657600"/>
+            <a:off x="6415887" y="1645920"/>
+            <a:ext cx="5227167" cy="3657600"/>
           </a:xfrm>
           <a:prstGeom prst="rect">
             <a:avLst/>
@@ -12160,7 +12160,7 @@
         <p:spPr>
           <a:xfrm>
             <a:off x="5669280" y="1097280"/>
-            <a:ext cx="5669280" cy="5029200"/>
+            <a:ext cx="6156655" cy="5029200"/>
           </a:xfrm>
           <a:prstGeom prst="rect">
             <a:avLst/>
@@ -12205,7 +12205,7 @@
         <p:spPr>
           <a:xfrm>
             <a:off x="5760720" y="1188720"/>
-            <a:ext cx="5486400" cy="411480"/>
+            <a:ext cx="5973775" cy="411480"/>
           </a:xfrm>
           <a:prstGeom prst="rect">
             <a:avLst/>
@@ -12245,7 +12245,7 @@
         <p:spPr>
           <a:xfrm>
             <a:off x="5852160" y="1554480"/>
-            <a:ext cx="5303520" cy="320040"/>
+            <a:ext cx="5790895" cy="320040"/>
           </a:xfrm>
           <a:prstGeom prst="rect">
             <a:avLst/>
@@ -12357,7 +12357,7 @@
         <p:spPr>
           <a:xfrm>
             <a:off x="5852160" y="3337560"/>
-            <a:ext cx="5303520" cy="2377440"/>
+            <a:ext cx="5790895" cy="2377440"/>
           </a:xfrm>
           <a:prstGeom prst="rect">
             <a:avLst/>
@@ -12677,7 +12677,7 @@
         <p:spPr>
           <a:xfrm>
             <a:off x="365760" y="1097280"/>
-            <a:ext cx="5547207" cy="5029200"/>
+            <a:ext cx="5592927" cy="5029200"/>
           </a:xfrm>
           <a:prstGeom prst="rect">
             <a:avLst/>
@@ -12722,7 +12722,7 @@
         <p:spPr>
           <a:xfrm>
             <a:off x="457200" y="1188720"/>
-            <a:ext cx="5364327" cy="411480"/>
+            <a:ext cx="5410047" cy="411480"/>
           </a:xfrm>
           <a:prstGeom prst="rect">
             <a:avLst/>
@@ -12770,7 +12770,7 @@
         <p:spPr>
           <a:xfrm>
             <a:off x="548640" y="1554480"/>
-            <a:ext cx="5181447" cy="320040"/>
+            <a:ext cx="5227167" cy="320040"/>
           </a:xfrm>
           <a:prstGeom prst="rect">
             <a:avLst/>
@@ -12882,7 +12882,7 @@
         <p:spPr>
           <a:xfrm>
             <a:off x="548640" y="3931920"/>
-            <a:ext cx="5181447" cy="1828800"/>
+            <a:ext cx="5227167" cy="1828800"/>
           </a:xfrm>
           <a:prstGeom prst="rect">
             <a:avLst/>
@@ -13019,8 +13019,8 @@
         </p:nvSpPr>
         <p:spPr>
           <a:xfrm>
-            <a:off x="6187287" y="1097280"/>
-            <a:ext cx="5547207" cy="5029200"/>
+            <a:off x="6233007" y="1097280"/>
+            <a:ext cx="5592927" cy="5029200"/>
           </a:xfrm>
           <a:prstGeom prst="rect">
             <a:avLst/>
@@ -13064,8 +13064,8 @@
         </p:nvSpPr>
         <p:spPr>
           <a:xfrm>
-            <a:off x="6278727" y="1188720"/>
-            <a:ext cx="5364327" cy="411480"/>
+            <a:off x="6324447" y="1188720"/>
+            <a:ext cx="5410047" cy="411480"/>
           </a:xfrm>
           <a:prstGeom prst="rect">
             <a:avLst/>
@@ -13112,8 +13112,8 @@
         </p:nvSpPr>
         <p:spPr>
           <a:xfrm>
-            <a:off x="6370167" y="1508760"/>
-            <a:ext cx="5181447" cy="502920"/>
+            <a:off x="6415887" y="1508760"/>
+            <a:ext cx="5227167" cy="502920"/>
           </a:xfrm>
           <a:prstGeom prst="rect">
             <a:avLst/>
@@ -13160,7 +13160,7 @@
         </p:blipFill>
         <p:spPr>
           <a:xfrm>
-            <a:off x="6461607" y="2148840"/>
+            <a:off x="6507327" y="2148840"/>
             <a:ext cx="5029200" cy="333513"/>
           </a:xfrm>
           <a:prstGeom prst="rect">
@@ -13184,7 +13184,7 @@
         </p:blipFill>
         <p:spPr>
           <a:xfrm>
-            <a:off x="6461607" y="2834640"/>
+            <a:off x="6507327" y="2834640"/>
             <a:ext cx="3687419" cy="438912"/>
           </a:xfrm>
           <a:prstGeom prst="rect">
@@ -13200,8 +13200,8 @@
         </p:nvSpPr>
         <p:spPr>
           <a:xfrm>
-            <a:off x="6370167" y="3749039"/>
-            <a:ext cx="5181447" cy="2286000"/>
+            <a:off x="6415887" y="3749039"/>
+            <a:ext cx="5227167" cy="2286000"/>
           </a:xfrm>
           <a:prstGeom prst="rect">
             <a:avLst/>
@@ -14248,7 +14248,7 @@
         <p:spPr>
           <a:xfrm>
             <a:off x="5212080" y="3291840"/>
-            <a:ext cx="6126480" cy="2834640"/>
+            <a:ext cx="6613855" cy="2834640"/>
           </a:xfrm>
           <a:prstGeom prst="rect">
             <a:avLst/>
@@ -14293,7 +14293,7 @@
         <p:spPr>
           <a:xfrm>
             <a:off x="5303520" y="3383280"/>
-            <a:ext cx="5943600" cy="411480"/>
+            <a:ext cx="6430975" cy="411480"/>
           </a:xfrm>
           <a:prstGeom prst="rect">
             <a:avLst/>
@@ -14333,7 +14333,7 @@
         <p:spPr>
           <a:xfrm>
             <a:off x="5394960" y="3749039"/>
-            <a:ext cx="5760720" cy="2103120"/>
+            <a:ext cx="6248095" cy="2103120"/>
           </a:xfrm>
           <a:prstGeom prst="rect">
             <a:avLst/>
@@ -14680,7 +14680,7 @@
         <p:spPr>
           <a:xfrm>
             <a:off x="365760" y="1097280"/>
-            <a:ext cx="6400800" cy="5029200"/>
+            <a:ext cx="6309360" cy="5029200"/>
           </a:xfrm>
           <a:prstGeom prst="rect">
             <a:avLst/>
@@ -14725,7 +14725,7 @@
         <p:spPr>
           <a:xfrm>
             <a:off x="457200" y="1188720"/>
-            <a:ext cx="6217920" cy="411480"/>
+            <a:ext cx="6126480" cy="411480"/>
           </a:xfrm>
           <a:prstGeom prst="rect">
             <a:avLst/>
@@ -14772,7 +14772,7 @@
         </p:blipFill>
         <p:spPr>
           <a:xfrm>
-            <a:off x="822960" y="1508760"/>
+            <a:off x="685800" y="1508760"/>
             <a:ext cx="5669280" cy="4251960"/>
           </a:xfrm>
           <a:prstGeom prst="rect">
@@ -14788,8 +14788,8 @@
         </p:nvSpPr>
         <p:spPr>
           <a:xfrm>
-            <a:off x="6858000" y="1097280"/>
-            <a:ext cx="4937760" cy="5029200"/>
+            <a:off x="6949440" y="1097280"/>
+            <a:ext cx="4876495" cy="5029200"/>
           </a:xfrm>
           <a:prstGeom prst="rect">
             <a:avLst/>
@@ -14833,8 +14833,8 @@
         </p:nvSpPr>
         <p:spPr>
           <a:xfrm>
-            <a:off x="6949440" y="1188720"/>
-            <a:ext cx="4754880" cy="411480"/>
+            <a:off x="7040880" y="1188720"/>
+            <a:ext cx="4693615" cy="411480"/>
           </a:xfrm>
           <a:prstGeom prst="rect">
             <a:avLst/>
@@ -14873,8 +14873,8 @@
         </p:nvSpPr>
         <p:spPr>
           <a:xfrm>
-            <a:off x="7040880" y="1645920"/>
-            <a:ext cx="4572000" cy="3657600"/>
+            <a:off x="7132320" y="1645920"/>
+            <a:ext cx="4510735" cy="3657600"/>
           </a:xfrm>
           <a:prstGeom prst="rect">
             <a:avLst/>

</xml_diff>

<commit_message>
docs: reference annexes and academic papers in presentation body slides
</commit_message>
<xml_diff>
--- a/output/Presentacion_Final_ELI556_Atacama.pptx
+++ b/output/Presentacion_Final_ELI556_Atacama.pptx
@@ -3486,14 +3486,14 @@
           <a:lstStyle/>
           <a:p>
             <a:pPr algn="l">
-              <a:defRPr sz="1700">
-                <a:solidFill>
-                  <a:srgbClr val="FFFFFF"/>
-                </a:solidFill>
-              </a:defRPr>
-            </a:pPr>
-            <a:r>
-              <a:rPr sz="1700">
+              <a:defRPr sz="1600">
+                <a:solidFill>
+                  <a:srgbClr val="FFFFFF"/>
+                </a:solidFill>
+              </a:defRPr>
+            </a:pPr>
+            <a:r>
+              <a:rPr sz="1600">
                 <a:solidFill>
                   <a:srgbClr val="FFFFFF"/>
                 </a:solidFill>
@@ -3501,7 +3501,7 @@
               <a:t>• </a:t>
             </a:r>
             <a:r>
-              <a:rPr sz="1700" b="1">
+              <a:rPr sz="1600" b="1">
                 <a:solidFill>
                   <a:srgbClr val="FFFFFF"/>
                 </a:solidFill>
@@ -3509,33 +3509,49 @@
               <a:t>Formulación Matemática:</a:t>
             </a:r>
             <a:r>
-              <a:rPr sz="1700">
-                <a:solidFill>
-                  <a:srgbClr val="FFFFFF"/>
-                </a:solidFill>
-              </a:rPr>
-              <a:t> Las ecuaciones de cortocircuito, circuito abierto, máxima potencia y derivada analítica en MPP ($dP/dV = 0$) forman un sistema no lineal trascendental de 5 incógnitas.</a:t>
-            </a:r>
-          </a:p>
-          <a:p>
-            <a:pPr algn="l">
-              <a:defRPr sz="1700">
-                <a:solidFill>
-                  <a:srgbClr val="FFFFFF"/>
-                </a:solidFill>
-              </a:defRPr>
-            </a:pPr>
-          </a:p>
-          <a:p>
-            <a:pPr algn="l">
-              <a:defRPr sz="1700">
-                <a:solidFill>
-                  <a:srgbClr val="FFFFFF"/>
-                </a:solidFill>
-              </a:defRPr>
-            </a:pPr>
-            <a:r>
-              <a:rPr sz="1700">
+              <a:rPr sz="1600">
+                <a:solidFill>
+                  <a:srgbClr val="FFFFFF"/>
+                </a:solidFill>
+              </a:rPr>
+              <a:t> Ecuaciones del modelo SDM de 5 parámetros planteadas en STC para cortocircuito, circuito abierto y máxima potencia </a:t>
+            </a:r>
+            <a:r>
+              <a:rPr sz="1600">
+                <a:solidFill>
+                  <a:srgbClr val="FFFFFF"/>
+                </a:solidFill>
+              </a:rPr>
+              <a:t>De Soto et al., 2006</a:t>
+            </a:r>
+            <a:r>
+              <a:rPr sz="1600">
+                <a:solidFill>
+                  <a:srgbClr val="FFFFFF"/>
+                </a:solidFill>
+              </a:rPr>
+              <a:t>. *(Ecuación en Anexo V, Lámina 23)*</a:t>
+            </a:r>
+          </a:p>
+          <a:p>
+            <a:pPr algn="l">
+              <a:defRPr sz="1600">
+                <a:solidFill>
+                  <a:srgbClr val="FFFFFF"/>
+                </a:solidFill>
+              </a:defRPr>
+            </a:pPr>
+          </a:p>
+          <a:p>
+            <a:pPr algn="l">
+              <a:defRPr sz="1600">
+                <a:solidFill>
+                  <a:srgbClr val="FFFFFF"/>
+                </a:solidFill>
+              </a:defRPr>
+            </a:pPr>
+            <a:r>
+              <a:rPr sz="1600">
                 <a:solidFill>
                   <a:srgbClr val="FFFFFF"/>
                 </a:solidFill>
@@ -3543,41 +3559,41 @@
               <a:t>• </a:t>
             </a:r>
             <a:r>
-              <a:rPr sz="1700" b="1">
-                <a:solidFill>
-                  <a:srgbClr val="FFFFFF"/>
-                </a:solidFill>
-              </a:rPr>
-              <a:t>Implementación de Mínimos Cuadrados:</a:t>
-            </a:r>
-            <a:r>
-              <a:rPr sz="1700">
-                <a:solidFill>
-                  <a:srgbClr val="FFFFFF"/>
-                </a:solidFill>
-              </a:rPr>
-              <a:t> Ajuste del sistema a través del algoritmo de optimización numérica `scipy.optimize.minimize`.</a:t>
-            </a:r>
-          </a:p>
-          <a:p>
-            <a:pPr algn="l">
-              <a:defRPr sz="1700">
-                <a:solidFill>
-                  <a:srgbClr val="FFFFFF"/>
-                </a:solidFill>
-              </a:defRPr>
-            </a:pPr>
-          </a:p>
-          <a:p>
-            <a:pPr algn="l">
-              <a:defRPr sz="1700">
-                <a:solidFill>
-                  <a:srgbClr val="FFFFFF"/>
-                </a:solidFill>
-              </a:defRPr>
-            </a:pPr>
-            <a:r>
-              <a:rPr sz="1700">
+              <a:rPr sz="1600" b="1">
+                <a:solidFill>
+                  <a:srgbClr val="FFFFFF"/>
+                </a:solidFill>
+              </a:rPr>
+              <a:t>Optimización de Mínimos Cuadrados:</a:t>
+            </a:r>
+            <a:r>
+              <a:rPr sz="1600">
+                <a:solidFill>
+                  <a:srgbClr val="FFFFFF"/>
+                </a:solidFill>
+              </a:rPr>
+              <a:t> Resolución simultánea del sistema no lineal trascendental mediante scipy en Python para obtener los valores óptimos nominales.</a:t>
+            </a:r>
+          </a:p>
+          <a:p>
+            <a:pPr algn="l">
+              <a:defRPr sz="1600">
+                <a:solidFill>
+                  <a:srgbClr val="FFFFFF"/>
+                </a:solidFill>
+              </a:defRPr>
+            </a:pPr>
+          </a:p>
+          <a:p>
+            <a:pPr algn="l">
+              <a:defRPr sz="1600">
+                <a:solidFill>
+                  <a:srgbClr val="FFFFFF"/>
+                </a:solidFill>
+              </a:defRPr>
+            </a:pPr>
+            <a:r>
+              <a:rPr sz="1600">
                 <a:solidFill>
                   <a:srgbClr val="FFFFFF"/>
                 </a:solidFill>
@@ -3585,7 +3601,7 @@
               <a:t>• </a:t>
             </a:r>
             <a:r>
-              <a:rPr sz="1700" b="1">
+              <a:rPr sz="1600" b="1">
                 <a:solidFill>
                   <a:srgbClr val="FFFFFF"/>
                 </a:solidFill>
@@ -3593,23 +3609,23 @@
               <a:t>Consistencia Física (Bounds):</a:t>
             </a:r>
             <a:r>
-              <a:rPr sz="1700">
-                <a:solidFill>
-                  <a:srgbClr val="FFFFFF"/>
-                </a:solidFill>
-              </a:rPr>
-              <a:t> Se restringió estrictamente que la resistencia serie fuera mayor a cero ($R</a:t>
-            </a:r>
-            <a:r>
-              <a:rPr sz="1700" i="1">
-                <a:solidFill>
-                  <a:srgbClr val="FFFFFF"/>
-                </a:solidFill>
-              </a:rPr>
-              <a:t>{s,ref} &gt; 0$) y el factor de idealidad estuviese acotado ($n</a:t>
-            </a:r>
-            <a:r>
-              <a:rPr sz="1700">
+              <a:rPr sz="1600">
+                <a:solidFill>
+                  <a:srgbClr val="FFFFFF"/>
+                </a:solidFill>
+              </a:rPr>
+              <a:t> Restricciones explícitas de resistencia serie mayor a cero ($R</a:t>
+            </a:r>
+            <a:r>
+              <a:rPr sz="1600" i="1">
+                <a:solidFill>
+                  <a:srgbClr val="FFFFFF"/>
+                </a:solidFill>
+              </a:rPr>
+              <a:t>{s,ref} &gt; 0$) y factor de idealidad $n</a:t>
+            </a:r>
+            <a:r>
+              <a:rPr sz="1600">
                 <a:solidFill>
                   <a:srgbClr val="FFFFFF"/>
                 </a:solidFill>
@@ -3617,7 +3633,7 @@
               <a:t>I \in </a:t>
             </a:r>
             <a:r>
-              <a:rPr sz="1700">
+              <a:rPr sz="1600">
                 <a:solidFill>
                   <a:srgbClr val="FFFFFF"/>
                 </a:solidFill>
@@ -3625,12 +3641,12 @@
               <a:t>1, 2</a:t>
             </a:r>
             <a:r>
-              <a:rPr sz="1700">
-                <a:solidFill>
-                  <a:srgbClr val="FFFFFF"/>
-                </a:solidFill>
-              </a:rPr>
-              <a:t>$) para evitar soluciones irreales.</a:t>
+              <a:rPr sz="1600">
+                <a:solidFill>
+                  <a:srgbClr val="FFFFFF"/>
+                </a:solidFill>
+              </a:rPr>
+              <a:t>$ para garantizar sentido físico.</a:t>
             </a:r>
           </a:p>
         </p:txBody>
@@ -3763,7 +3779,7 @@
                   <a:srgbClr val="FFFFFF"/>
                 </a:solidFill>
               </a:rPr>
-              <a:t>Silicio Monocristalino (m-Si):</a:t>
+              <a:t>m-Si (Silicio Monocristalino) [De Soto et al., 2006]:</a:t>
             </a:r>
           </a:p>
           <a:p>
@@ -3796,7 +3812,7 @@
                   <a:srgbClr val="FFFFFF"/>
                 </a:solidFill>
               </a:rPr>
-              <a:t>{0,ref}$ = $4.13 	imes 10^{-9}$ A  |  $R</a:t>
+              <a:t>{0,ref}$ = $4.13 \times 10^{-9}$ A  |  $R</a:t>
             </a:r>
             <a:r>
               <a:rPr sz="1600" i="1">
@@ -3846,7 +3862,7 @@
                   <a:srgbClr val="FFFFFF"/>
                 </a:solidFill>
               </a:rPr>
-              <a:t>Heterounión (HIT):</a:t>
+              <a:t>HIT (Heterounión) [De Soto et al., 2006]:</a:t>
             </a:r>
           </a:p>
           <a:p>
@@ -3879,7 +3895,7 @@
                   <a:srgbClr val="FFFFFF"/>
                 </a:solidFill>
               </a:rPr>
-              <a:t>{0,ref}$ = $4.68 	imes 10^{-10}$ A  |  $R</a:t>
+              <a:t>{0,ref}$ = $4.68 \times 10^{-10}$ A  |  $R</a:t>
             </a:r>
             <a:r>
               <a:rPr sz="1600" i="1">
@@ -3937,7 +3953,7 @@
                   <a:srgbClr val="FFFFFF"/>
                 </a:solidFill>
               </a:rPr>
-              <a:t> La corriente de saturación inversa de HIT es un orden de magnitud menor, demostrando su superioridad frente a la recombinación térmica.</a:t>
+              <a:t> La corriente de saturación inversa ($I_0$) de HIT es un orden de magnitud inferior, demostrando su menor recombinación intrínseca por temperatura.</a:t>
             </a:r>
           </a:p>
         </p:txBody>
@@ -4151,14 +4167,14 @@
           <a:lstStyle/>
           <a:p>
             <a:pPr algn="l">
-              <a:defRPr sz="1700">
-                <a:solidFill>
-                  <a:srgbClr val="FFFFFF"/>
-                </a:solidFill>
-              </a:defRPr>
-            </a:pPr>
-            <a:r>
-              <a:rPr sz="1700">
+              <a:defRPr sz="1600">
+                <a:solidFill>
+                  <a:srgbClr val="FFFFFF"/>
+                </a:solidFill>
+              </a:defRPr>
+            </a:pPr>
+            <a:r>
+              <a:rPr sz="1600">
                 <a:solidFill>
                   <a:srgbClr val="FFFFFF"/>
                 </a:solidFill>
@@ -4166,41 +4182,81 @@
               <a:t>• </a:t>
             </a:r>
             <a:r>
-              <a:rPr sz="1700" b="1">
-                <a:solidFill>
-                  <a:srgbClr val="FFFFFF"/>
-                </a:solidFill>
-              </a:rPr>
-              <a:t>Cálculo Temporal:</a:t>
-            </a:r>
-            <a:r>
-              <a:rPr sz="1700">
-                <a:solidFill>
-                  <a:srgbClr val="FFFFFF"/>
-                </a:solidFill>
-              </a:rPr>
-              <a:t> Para cada paso de tiempo de los 8,760 intervalos del año 2026, los 5 parámetros fueron escalados a la irradiancia incidente absorbida ($S$) y temperatura de celda ($T_c$) locales.</a:t>
-            </a:r>
-          </a:p>
-          <a:p>
-            <a:pPr algn="l">
-              <a:defRPr sz="1700">
-                <a:solidFill>
-                  <a:srgbClr val="FFFFFF"/>
-                </a:solidFill>
-              </a:defRPr>
-            </a:pPr>
-          </a:p>
-          <a:p>
-            <a:pPr algn="l">
-              <a:defRPr sz="1700">
-                <a:solidFill>
-                  <a:srgbClr val="FFFFFF"/>
-                </a:solidFill>
-              </a:defRPr>
-            </a:pPr>
-            <a:r>
-              <a:rPr sz="1700">
+              <a:rPr sz="1600" b="1">
+                <a:solidFill>
+                  <a:srgbClr val="FFFFFF"/>
+                </a:solidFill>
+              </a:rPr>
+              <a:t>Traslado de De Soto:</a:t>
+            </a:r>
+            <a:r>
+              <a:rPr sz="1600">
+                <a:solidFill>
+                  <a:srgbClr val="FFFFFF"/>
+                </a:solidFill>
+              </a:rPr>
+              <a:t> Para cada intervalo de la simulación anual 2026, los 5 parámetros se escalaron a la irradiancia efectiva ($S$) y temperatura de celda (</a:t>
+            </a:r>
+            <a:r>
+              <a:rPr sz="1600" i="1">
+                <a:solidFill>
+                  <a:srgbClr val="FFFFFF"/>
+                </a:solidFill>
+              </a:rPr>
+              <a:t>T</a:t>
+            </a:r>
+            <a:r>
+              <a:rPr sz="1600" i="1">
+                <a:solidFill>
+                  <a:srgbClr val="FFFFFF"/>
+                </a:solidFill>
+              </a:rPr>
+              <a:t>c</a:t>
+            </a:r>
+            <a:r>
+              <a:rPr sz="1600">
+                <a:solidFill>
+                  <a:srgbClr val="FFFFFF"/>
+                </a:solidFill>
+              </a:rPr>
+              <a:t>) locales </a:t>
+            </a:r>
+            <a:r>
+              <a:rPr sz="1600">
+                <a:solidFill>
+                  <a:srgbClr val="FFFFFF"/>
+                </a:solidFill>
+              </a:rPr>
+              <a:t>De Soto et al., 2006</a:t>
+            </a:r>
+            <a:r>
+              <a:rPr sz="1600">
+                <a:solidFill>
+                  <a:srgbClr val="FFFFFF"/>
+                </a:solidFill>
+              </a:rPr>
+              <a:t>. *(Ecuaciones en Anexo VI, Lámina 24)*</a:t>
+            </a:r>
+          </a:p>
+          <a:p>
+            <a:pPr algn="l">
+              <a:defRPr sz="1600">
+                <a:solidFill>
+                  <a:srgbClr val="FFFFFF"/>
+                </a:solidFill>
+              </a:defRPr>
+            </a:pPr>
+          </a:p>
+          <a:p>
+            <a:pPr algn="l">
+              <a:defRPr sz="1600">
+                <a:solidFill>
+                  <a:srgbClr val="FFFFFF"/>
+                </a:solidFill>
+              </a:defRPr>
+            </a:pPr>
+            <a:r>
+              <a:rPr sz="1600">
                 <a:solidFill>
                   <a:srgbClr val="FFFFFF"/>
                 </a:solidFill>
@@ -4208,57 +4264,81 @@
               <a:t>• </a:t>
             </a:r>
             <a:r>
-              <a:rPr sz="1700" b="1">
-                <a:solidFill>
-                  <a:srgbClr val="FFFFFF"/>
-                </a:solidFill>
-              </a:rPr>
-              <a:t>Traslado de De Soto:</a:t>
-            </a:r>
-            <a:r>
-              <a:rPr sz="1700">
-                <a:solidFill>
-                  <a:srgbClr val="FFFFFF"/>
-                </a:solidFill>
-              </a:rPr>
-              <a:t> Variación térmica del factor de idealidad ($a$), bandgap del silicio ($E</a:t>
-            </a:r>
-            <a:r>
-              <a:rPr sz="1700" i="1">
-                <a:solidFill>
-                  <a:srgbClr val="FFFFFF"/>
-                </a:solidFill>
-              </a:rPr>
-              <a:t>g$), corrientes de saturación ($I</a:t>
-            </a:r>
-            <a:r>
-              <a:rPr sz="1700">
-                <a:solidFill>
-                  <a:srgbClr val="FFFFFF"/>
-                </a:solidFill>
-              </a:rPr>
-              <a:t>0$) y fotogenerada ($I_L$).</a:t>
-            </a:r>
-          </a:p>
-          <a:p>
-            <a:pPr algn="l">
-              <a:defRPr sz="1700">
-                <a:solidFill>
-                  <a:srgbClr val="FFFFFF"/>
-                </a:solidFill>
-              </a:defRPr>
-            </a:pPr>
-          </a:p>
-          <a:p>
-            <a:pPr algn="l">
-              <a:defRPr sz="1700">
-                <a:solidFill>
-                  <a:srgbClr val="FFFFFF"/>
-                </a:solidFill>
-              </a:defRPr>
-            </a:pPr>
-            <a:r>
-              <a:rPr sz="1700">
+              <a:rPr sz="1600" b="1">
+                <a:solidFill>
+                  <a:srgbClr val="FFFFFF"/>
+                </a:solidFill>
+              </a:rPr>
+              <a:t>Dependencia del Bandgap:</a:t>
+            </a:r>
+            <a:r>
+              <a:rPr sz="1600">
+                <a:solidFill>
+                  <a:srgbClr val="FFFFFF"/>
+                </a:solidFill>
+              </a:rPr>
+              <a:t> Variación térmica no lineal del bandgap de silicio (</a:t>
+            </a:r>
+            <a:r>
+              <a:rPr sz="1600" i="1">
+                <a:solidFill>
+                  <a:srgbClr val="FFFFFF"/>
+                </a:solidFill>
+              </a:rPr>
+              <a:t>E</a:t>
+            </a:r>
+            <a:r>
+              <a:rPr sz="1600" i="1">
+                <a:solidFill>
+                  <a:srgbClr val="FFFFFF"/>
+                </a:solidFill>
+              </a:rPr>
+              <a:t>g</a:t>
+            </a:r>
+            <a:r>
+              <a:rPr sz="1600">
+                <a:solidFill>
+                  <a:srgbClr val="FFFFFF"/>
+                </a:solidFill>
+              </a:rPr>
+              <a:t>) y factor de idealidad térmico (</a:t>
+            </a:r>
+            <a:r>
+              <a:rPr sz="1600" i="1">
+                <a:solidFill>
+                  <a:srgbClr val="FFFFFF"/>
+                </a:solidFill>
+              </a:rPr>
+              <a:t>a</a:t>
+            </a:r>
+            <a:r>
+              <a:rPr sz="1600">
+                <a:solidFill>
+                  <a:srgbClr val="FFFFFF"/>
+                </a:solidFill>
+              </a:rPr>
+              <a:t>).</a:t>
+            </a:r>
+          </a:p>
+          <a:p>
+            <a:pPr algn="l">
+              <a:defRPr sz="1600">
+                <a:solidFill>
+                  <a:srgbClr val="FFFFFF"/>
+                </a:solidFill>
+              </a:defRPr>
+            </a:pPr>
+          </a:p>
+          <a:p>
+            <a:pPr algn="l">
+              <a:defRPr sz="1600">
+                <a:solidFill>
+                  <a:srgbClr val="FFFFFF"/>
+                </a:solidFill>
+              </a:defRPr>
+            </a:pPr>
+            <a:r>
+              <a:rPr sz="1600">
                 <a:solidFill>
                   <a:srgbClr val="FFFFFF"/>
                 </a:solidFill>
@@ -4266,20 +4346,36 @@
               <a:t>• </a:t>
             </a:r>
             <a:r>
-              <a:rPr sz="1700" b="1">
-                <a:solidFill>
-                  <a:srgbClr val="FFFFFF"/>
-                </a:solidFill>
-              </a:rPr>
-              <a:t>Resistencia Paralelo:</a:t>
-            </a:r>
-            <a:r>
-              <a:rPr sz="1700">
-                <a:solidFill>
-                  <a:srgbClr val="FFFFFF"/>
-                </a:solidFill>
-              </a:rPr>
-              <a:t> Modelada inversamente proporcional a la irradiancia. Resistencia serie constante.</a:t>
+              <a:rPr sz="1600" b="1">
+                <a:solidFill>
+                  <a:srgbClr val="FFFFFF"/>
+                </a:solidFill>
+              </a:rPr>
+              <a:t>Resistencias Shunt y Serie:</a:t>
+            </a:r>
+            <a:r>
+              <a:rPr sz="1600">
+                <a:solidFill>
+                  <a:srgbClr val="FFFFFF"/>
+                </a:solidFill>
+              </a:rPr>
+              <a:t> Resistencia paralelo inversamente proporcional a la irradiancia. Resistencia serie asumida constante según validaciones NIST </a:t>
+            </a:r>
+            <a:r>
+              <a:rPr sz="1600">
+                <a:solidFill>
+                  <a:srgbClr val="FFFFFF"/>
+                </a:solidFill>
+              </a:rPr>
+              <a:t>De Soto et al., 2006</a:t>
+            </a:r>
+            <a:r>
+              <a:rPr sz="1600">
+                <a:solidFill>
+                  <a:srgbClr val="FFFFFF"/>
+                </a:solidFill>
+              </a:rPr>
+              <a:t>.</a:t>
             </a:r>
           </a:p>
         </p:txBody>
@@ -4392,14 +4488,14 @@
           <a:lstStyle/>
           <a:p>
             <a:pPr algn="l">
-              <a:defRPr sz="1700">
-                <a:solidFill>
-                  <a:srgbClr val="FFFFFF"/>
-                </a:solidFill>
-              </a:defRPr>
-            </a:pPr>
-            <a:r>
-              <a:rPr sz="1700">
+              <a:defRPr sz="1600">
+                <a:solidFill>
+                  <a:srgbClr val="FFFFFF"/>
+                </a:solidFill>
+              </a:defRPr>
+            </a:pPr>
+            <a:r>
+              <a:rPr sz="1600">
                 <a:solidFill>
                   <a:srgbClr val="FFFFFF"/>
                 </a:solidFill>
@@ -4407,41 +4503,57 @@
               <a:t>• </a:t>
             </a:r>
             <a:r>
-              <a:rPr sz="1700" b="1">
-                <a:solidFill>
-                  <a:srgbClr val="FFFFFF"/>
-                </a:solidFill>
-              </a:rPr>
-              <a:t>Resolución Trascendental:</a:t>
-            </a:r>
-            <a:r>
-              <a:rPr sz="1700">
-                <a:solidFill>
-                  <a:srgbClr val="FFFFFF"/>
-                </a:solidFill>
-              </a:rPr>
-              <a:t> Dado que la corriente ($I$) depende implícitamente del voltaje y de sí misma, se empleó un algoritmo de resolución numérica robusto (`calcparams_desoto` de pvlib).</a:t>
-            </a:r>
-          </a:p>
-          <a:p>
-            <a:pPr algn="l">
-              <a:defRPr sz="1700">
-                <a:solidFill>
-                  <a:srgbClr val="FFFFFF"/>
-                </a:solidFill>
-              </a:defRPr>
-            </a:pPr>
-          </a:p>
-          <a:p>
-            <a:pPr algn="l">
-              <a:defRPr sz="1700">
-                <a:solidFill>
-                  <a:srgbClr val="FFFFFF"/>
-                </a:solidFill>
-              </a:defRPr>
-            </a:pPr>
-            <a:r>
-              <a:rPr sz="1700">
+              <a:rPr sz="1600" b="1">
+                <a:solidFill>
+                  <a:srgbClr val="FFFFFF"/>
+                </a:solidFill>
+              </a:rPr>
+              <a:t>Resolución Numérica:</a:t>
+            </a:r>
+            <a:r>
+              <a:rPr sz="1600">
+                <a:solidFill>
+                  <a:srgbClr val="FFFFFF"/>
+                </a:solidFill>
+              </a:rPr>
+              <a:t> Empleo del algoritmo implícito `calcparams_desoto` de pvlib </a:t>
+            </a:r>
+            <a:r>
+              <a:rPr sz="1600">
+                <a:solidFill>
+                  <a:srgbClr val="FFFFFF"/>
+                </a:solidFill>
+              </a:rPr>
+              <a:t>Holmgren et al., 2018</a:t>
+            </a:r>
+            <a:r>
+              <a:rPr sz="1600">
+                <a:solidFill>
+                  <a:srgbClr val="FFFFFF"/>
+                </a:solidFill>
+              </a:rPr>
+              <a:t> para obtener los parámetros en cada minuto.</a:t>
+            </a:r>
+          </a:p>
+          <a:p>
+            <a:pPr algn="l">
+              <a:defRPr sz="1600">
+                <a:solidFill>
+                  <a:srgbClr val="FFFFFF"/>
+                </a:solidFill>
+              </a:defRPr>
+            </a:pPr>
+          </a:p>
+          <a:p>
+            <a:pPr algn="l">
+              <a:defRPr sz="1600">
+                <a:solidFill>
+                  <a:srgbClr val="FFFFFF"/>
+                </a:solidFill>
+              </a:defRPr>
+            </a:pPr>
+            <a:r>
+              <a:rPr sz="1600">
                 <a:solidFill>
                   <a:srgbClr val="FFFFFF"/>
                 </a:solidFill>
@@ -4449,41 +4561,41 @@
               <a:t>• </a:t>
             </a:r>
             <a:r>
-              <a:rPr sz="1700" b="1">
-                <a:solidFill>
-                  <a:srgbClr val="FFFFFF"/>
-                </a:solidFill>
-              </a:rPr>
-              <a:t>Búsqueda del MPP Minutal:</a:t>
-            </a:r>
-            <a:r>
-              <a:rPr sz="1700">
-                <a:solidFill>
-                  <a:srgbClr val="FFFFFF"/>
-                </a:solidFill>
-              </a:rPr>
-              <a:t> Se resolvió numéricamente la curva para encontrar el Punto de Máxima Potencia ($P_{mp,SDM}$) para cada registro del año.</a:t>
-            </a:r>
-          </a:p>
-          <a:p>
-            <a:pPr algn="l">
-              <a:defRPr sz="1700">
-                <a:solidFill>
-                  <a:srgbClr val="FFFFFF"/>
-                </a:solidFill>
-              </a:defRPr>
-            </a:pPr>
-          </a:p>
-          <a:p>
-            <a:pPr algn="l">
-              <a:defRPr sz="1700">
-                <a:solidFill>
-                  <a:srgbClr val="FFFFFF"/>
-                </a:solidFill>
-              </a:defRPr>
-            </a:pPr>
-            <a:r>
-              <a:rPr sz="1700">
+              <a:rPr sz="1600" b="1">
+                <a:solidFill>
+                  <a:srgbClr val="FFFFFF"/>
+                </a:solidFill>
+              </a:rPr>
+              <a:t>Búsqueda del MPP:</a:t>
+            </a:r>
+            <a:r>
+              <a:rPr sz="1600">
+                <a:solidFill>
+                  <a:srgbClr val="FFFFFF"/>
+                </a:solidFill>
+              </a:rPr>
+              <a:t> Se resolvió la ecuación trascendental del diodo simple utilizando la función W de Lambert para ubicar el Punto de Máxima Potencia ($P_{mp,SDM}$).</a:t>
+            </a:r>
+          </a:p>
+          <a:p>
+            <a:pPr algn="l">
+              <a:defRPr sz="1600">
+                <a:solidFill>
+                  <a:srgbClr val="FFFFFF"/>
+                </a:solidFill>
+              </a:defRPr>
+            </a:pPr>
+          </a:p>
+          <a:p>
+            <a:pPr algn="l">
+              <a:defRPr sz="1600">
+                <a:solidFill>
+                  <a:srgbClr val="FFFFFF"/>
+                </a:solidFill>
+              </a:defRPr>
+            </a:pPr>
+            <a:r>
+              <a:rPr sz="1600">
                 <a:solidFill>
                   <a:srgbClr val="FFFFFF"/>
                 </a:solidFill>
@@ -4491,20 +4603,20 @@
               <a:t>• </a:t>
             </a:r>
             <a:r>
-              <a:rPr sz="1700" b="1">
-                <a:solidFill>
-                  <a:srgbClr val="FFFFFF"/>
-                </a:solidFill>
-              </a:rPr>
-              <a:t>Cómputo de Generación:</a:t>
-            </a:r>
-            <a:r>
-              <a:rPr sz="1700">
-                <a:solidFill>
-                  <a:srgbClr val="FFFFFF"/>
-                </a:solidFill>
-              </a:rPr>
-              <a:t> Integración de la potencia generada minutalmente para obtener la energía total anual producida por cada tecnología.</a:t>
+              <a:rPr sz="1600" b="1">
+                <a:solidFill>
+                  <a:srgbClr val="FFFFFF"/>
+                </a:solidFill>
+              </a:rPr>
+              <a:t>Cómputo de Energía:</a:t>
+            </a:r>
+            <a:r>
+              <a:rPr sz="1600">
+                <a:solidFill>
+                  <a:srgbClr val="FFFFFF"/>
+                </a:solidFill>
+              </a:rPr>
+              <a:t> Integración temporal de la potencia útil minutal para consolidar la energía anual generada por cada panel.</a:t>
             </a:r>
           </a:p>
         </p:txBody>
@@ -4827,14 +4939,14 @@
           <a:lstStyle/>
           <a:p>
             <a:pPr algn="l">
-              <a:defRPr sz="1700">
-                <a:solidFill>
-                  <a:srgbClr val="FFFFFF"/>
-                </a:solidFill>
-              </a:defRPr>
-            </a:pPr>
-            <a:r>
-              <a:rPr sz="1700">
+              <a:defRPr sz="1600">
+                <a:solidFill>
+                  <a:srgbClr val="FFFFFF"/>
+                </a:solidFill>
+              </a:defRPr>
+            </a:pPr>
+            <a:r>
+              <a:rPr sz="1600">
                 <a:solidFill>
                   <a:srgbClr val="FFFFFF"/>
                 </a:solidFill>
@@ -4842,7 +4954,7 @@
               <a:t>• </a:t>
             </a:r>
             <a:r>
-              <a:rPr sz="1700" b="1">
+              <a:rPr sz="1600" b="1">
                 <a:solidFill>
                   <a:srgbClr val="FFFFFF"/>
                 </a:solidFill>
@@ -4850,33 +4962,33 @@
               <a:t>Estrés Térmico Evidenciado:</a:t>
             </a:r>
             <a:r>
-              <a:rPr sz="1700">
-                <a:solidFill>
-                  <a:srgbClr val="FFFFFF"/>
-                </a:solidFill>
-              </a:rPr>
-              <a:t> El histograma térmico revela que la mayor parte de las horas de sol el panel opera entre 38°C y 50°C, con picos extremos de 65°C a 70°C.</a:t>
-            </a:r>
-          </a:p>
-          <a:p>
-            <a:pPr algn="l">
-              <a:defRPr sz="1700">
-                <a:solidFill>
-                  <a:srgbClr val="FFFFFF"/>
-                </a:solidFill>
-              </a:defRPr>
-            </a:pPr>
-          </a:p>
-          <a:p>
-            <a:pPr algn="l">
-              <a:defRPr sz="1700">
-                <a:solidFill>
-                  <a:srgbClr val="FFFFFF"/>
-                </a:solidFill>
-              </a:defRPr>
-            </a:pPr>
-            <a:r>
-              <a:rPr sz="1700">
+              <a:rPr sz="1600">
+                <a:solidFill>
+                  <a:srgbClr val="FFFFFF"/>
+                </a:solidFill>
+              </a:rPr>
+              <a:t> La simulación térmica minutal revela temperaturas de celda operativas recurrentes entre 38°C y 50°C, con picos de calor extremo de 65°C a 70°C a mediodía.</a:t>
+            </a:r>
+          </a:p>
+          <a:p>
+            <a:pPr algn="l">
+              <a:defRPr sz="1600">
+                <a:solidFill>
+                  <a:srgbClr val="FFFFFF"/>
+                </a:solidFill>
+              </a:defRPr>
+            </a:pPr>
+          </a:p>
+          <a:p>
+            <a:pPr algn="l">
+              <a:defRPr sz="1600">
+                <a:solidFill>
+                  <a:srgbClr val="FFFFFF"/>
+                </a:solidFill>
+              </a:defRPr>
+            </a:pPr>
+            <a:r>
+              <a:rPr sz="1600">
                 <a:solidFill>
                   <a:srgbClr val="FFFFFF"/>
                 </a:solidFill>
@@ -4884,41 +4996,57 @@
               <a:t>• </a:t>
             </a:r>
             <a:r>
-              <a:rPr sz="1700" b="1">
-                <a:solidFill>
-                  <a:srgbClr val="FFFFFF"/>
-                </a:solidFill>
-              </a:rPr>
-              <a:t>Impacto del Viento Bajo (1 m/s):</a:t>
-            </a:r>
-            <a:r>
-              <a:rPr sz="1700">
-                <a:solidFill>
-                  <a:srgbClr val="FFFFFF"/>
-                </a:solidFill>
-              </a:rPr>
-              <a:t> La baja velocidad del viento en la modelación reduce el enfriamiento convectivo natural, maximizando el calentamiento térmico de la celda.</a:t>
-            </a:r>
-          </a:p>
-          <a:p>
-            <a:pPr algn="l">
-              <a:defRPr sz="1700">
-                <a:solidFill>
-                  <a:srgbClr val="FFFFFF"/>
-                </a:solidFill>
-              </a:defRPr>
-            </a:pPr>
-          </a:p>
-          <a:p>
-            <a:pPr algn="l">
-              <a:defRPr sz="1700">
-                <a:solidFill>
-                  <a:srgbClr val="FFFFFF"/>
-                </a:solidFill>
-              </a:defRPr>
-            </a:pPr>
-            <a:r>
-              <a:rPr sz="1700">
+              <a:rPr sz="1600" b="1">
+                <a:solidFill>
+                  <a:srgbClr val="FFFFFF"/>
+                </a:solidFill>
+              </a:rPr>
+              <a:t>Enfriamiento Convectivo Limitado:</a:t>
+            </a:r>
+            <a:r>
+              <a:rPr sz="1600">
+                <a:solidFill>
+                  <a:srgbClr val="FFFFFF"/>
+                </a:solidFill>
+              </a:rPr>
+              <a:t> Al asumir velocidad de viento conservadora de 1 m/s en SAPM </a:t>
+            </a:r>
+            <a:r>
+              <a:rPr sz="1600">
+                <a:solidFill>
+                  <a:srgbClr val="FFFFFF"/>
+                </a:solidFill>
+              </a:rPr>
+              <a:t>King et al., 2004</a:t>
+            </a:r>
+            <a:r>
+              <a:rPr sz="1600">
+                <a:solidFill>
+                  <a:srgbClr val="FFFFFF"/>
+                </a:solidFill>
+              </a:rPr>
+              <a:t>, se restringe la disipación térmica, modelando el peor escenario físico real.</a:t>
+            </a:r>
+          </a:p>
+          <a:p>
+            <a:pPr algn="l">
+              <a:defRPr sz="1600">
+                <a:solidFill>
+                  <a:srgbClr val="FFFFFF"/>
+                </a:solidFill>
+              </a:defRPr>
+            </a:pPr>
+          </a:p>
+          <a:p>
+            <a:pPr algn="l">
+              <a:defRPr sz="1600">
+                <a:solidFill>
+                  <a:srgbClr val="FFFFFF"/>
+                </a:solidFill>
+              </a:defRPr>
+            </a:pPr>
+            <a:r>
+              <a:rPr sz="1600">
                 <a:solidFill>
                   <a:srgbClr val="FFFFFF"/>
                 </a:solidFill>
@@ -4926,31 +5054,31 @@
               <a:t>• </a:t>
             </a:r>
             <a:r>
-              <a:rPr sz="1700" b="1">
-                <a:solidFill>
-                  <a:srgbClr val="FFFFFF"/>
-                </a:solidFill>
-              </a:rPr>
-              <a:t>Consecuencia Física:</a:t>
-            </a:r>
-            <a:r>
-              <a:rPr sz="1700">
-                <a:solidFill>
-                  <a:srgbClr val="FFFFFF"/>
-                </a:solidFill>
-              </a:rPr>
-              <a:t> Las altas temperaturas aumentan la corriente de saturación inversa ($I</a:t>
-            </a:r>
-            <a:r>
-              <a:rPr sz="1700" i="1">
-                <a:solidFill>
-                  <a:srgbClr val="FFFFFF"/>
-                </a:solidFill>
-              </a:rPr>
-              <a:t>0$), degradando severamente el voltaje en circuito abierto ($V</a:t>
-            </a:r>
-            <a:r>
-              <a:rPr sz="1700">
+              <a:rPr sz="1600" b="1">
+                <a:solidFill>
+                  <a:srgbClr val="FFFFFF"/>
+                </a:solidFill>
+              </a:rPr>
+              <a:t>Consecuencia en Voltaje [De Soto et al., 2006]:</a:t>
+            </a:r>
+            <a:r>
+              <a:rPr sz="1600">
+                <a:solidFill>
+                  <a:srgbClr val="FFFFFF"/>
+                </a:solidFill>
+              </a:rPr>
+              <a:t> El calentamiento incrementa la corriente de saturación inversa ($I</a:t>
+            </a:r>
+            <a:r>
+              <a:rPr sz="1600" i="1">
+                <a:solidFill>
+                  <a:srgbClr val="FFFFFF"/>
+                </a:solidFill>
+              </a:rPr>
+              <a:t>0$), deprimiendo fuertemente la tensión de circuito abierto ($V</a:t>
+            </a:r>
+            <a:r>
+              <a:rPr sz="1600">
                 <a:solidFill>
                   <a:srgbClr val="FFFFFF"/>
                 </a:solidFill>
@@ -5278,14 +5406,14 @@
           <a:lstStyle/>
           <a:p>
             <a:pPr algn="l">
-              <a:defRPr sz="1700">
-                <a:solidFill>
-                  <a:srgbClr val="FFFFFF"/>
-                </a:solidFill>
-              </a:defRPr>
-            </a:pPr>
-            <a:r>
-              <a:rPr sz="1700">
+              <a:defRPr sz="1600">
+                <a:solidFill>
+                  <a:srgbClr val="FFFFFF"/>
+                </a:solidFill>
+              </a:defRPr>
+            </a:pPr>
+            <a:r>
+              <a:rPr sz="1600">
                 <a:solidFill>
                   <a:srgbClr val="FFFFFF"/>
                 </a:solidFill>
@@ -5293,41 +5421,41 @@
               <a:t>• </a:t>
             </a:r>
             <a:r>
-              <a:rPr sz="1700" b="1">
-                <a:solidFill>
-                  <a:srgbClr val="FFFFFF"/>
-                </a:solidFill>
-              </a:rPr>
-              <a:t>Alta Precisión:</a:t>
-            </a:r>
-            <a:r>
-              <a:rPr sz="1700">
-                <a:solidFill>
-                  <a:srgbClr val="FFFFFF"/>
-                </a:solidFill>
-              </a:rPr>
-              <a:t> El coeficiente de determinación $R^2 &gt; 0.99$ en la validación experimental cruzada demuestra la alta fidelidad del modelo.</a:t>
-            </a:r>
-          </a:p>
-          <a:p>
-            <a:pPr algn="l">
-              <a:defRPr sz="1700">
-                <a:solidFill>
-                  <a:srgbClr val="FFFFFF"/>
-                </a:solidFill>
-              </a:defRPr>
-            </a:pPr>
-          </a:p>
-          <a:p>
-            <a:pPr algn="l">
-              <a:defRPr sz="1700">
-                <a:solidFill>
-                  <a:srgbClr val="FFFFFF"/>
-                </a:solidFill>
-              </a:defRPr>
-            </a:pPr>
-            <a:r>
-              <a:rPr sz="1700">
+              <a:rPr sz="1600" b="1">
+                <a:solidFill>
+                  <a:srgbClr val="FFFFFF"/>
+                </a:solidFill>
+              </a:rPr>
+              <a:t>Fidelidad del Ajuste [De Soto et al., 2006]:</a:t>
+            </a:r>
+            <a:r>
+              <a:rPr sz="1600">
+                <a:solidFill>
+                  <a:srgbClr val="FFFFFF"/>
+                </a:solidFill>
+              </a:rPr>
+              <a:t> Coeficiente de determinación $R^2 &gt; 0.99$ en validación cruzada frente a datos medidos, confirmando la precisión del modelo en todo el espectro de irradiancia.</a:t>
+            </a:r>
+          </a:p>
+          <a:p>
+            <a:pPr algn="l">
+              <a:defRPr sz="1600">
+                <a:solidFill>
+                  <a:srgbClr val="FFFFFF"/>
+                </a:solidFill>
+              </a:defRPr>
+            </a:pPr>
+          </a:p>
+          <a:p>
+            <a:pPr algn="l">
+              <a:defRPr sz="1600">
+                <a:solidFill>
+                  <a:srgbClr val="FFFFFF"/>
+                </a:solidFill>
+              </a:defRPr>
+            </a:pPr>
+            <a:r>
+              <a:rPr sz="1600">
                 <a:solidFill>
                   <a:srgbClr val="FFFFFF"/>
                 </a:solidFill>
@@ -5335,41 +5463,41 @@
               <a:t>• </a:t>
             </a:r>
             <a:r>
-              <a:rPr sz="1700" b="1">
-                <a:solidFill>
-                  <a:srgbClr val="FFFFFF"/>
-                </a:solidFill>
-              </a:rPr>
-              <a:t>RMSE Reducido:</a:t>
-            </a:r>
-            <a:r>
-              <a:rPr sz="1700">
-                <a:solidFill>
-                  <a:srgbClr val="FFFFFF"/>
-                </a:solidFill>
-              </a:rPr>
-              <a:t> Error cuadrático medio de la potencia ($RMSE$) inferior a 5W bajo condiciones nominales.</a:t>
-            </a:r>
-          </a:p>
-          <a:p>
-            <a:pPr algn="l">
-              <a:defRPr sz="1700">
-                <a:solidFill>
-                  <a:srgbClr val="FFFFFF"/>
-                </a:solidFill>
-              </a:defRPr>
-            </a:pPr>
-          </a:p>
-          <a:p>
-            <a:pPr algn="l">
-              <a:defRPr sz="1700">
-                <a:solidFill>
-                  <a:srgbClr val="FFFFFF"/>
-                </a:solidFill>
-              </a:defRPr>
-            </a:pPr>
-            <a:r>
-              <a:rPr sz="1700">
+              <a:rPr sz="1600" b="1">
+                <a:solidFill>
+                  <a:srgbClr val="FFFFFF"/>
+                </a:solidFill>
+              </a:rPr>
+              <a:t>Desviación Minutal (RMSE):</a:t>
+            </a:r>
+            <a:r>
+              <a:rPr sz="1600">
+                <a:solidFill>
+                  <a:srgbClr val="FFFFFF"/>
+                </a:solidFill>
+              </a:rPr>
+              <a:t> Error cuadrático medio ($RMSE$) inferior a 5W en condiciones típicas diurnas.</a:t>
+            </a:r>
+          </a:p>
+          <a:p>
+            <a:pPr algn="l">
+              <a:defRPr sz="1600">
+                <a:solidFill>
+                  <a:srgbClr val="FFFFFF"/>
+                </a:solidFill>
+              </a:defRPr>
+            </a:pPr>
+          </a:p>
+          <a:p>
+            <a:pPr algn="l">
+              <a:defRPr sz="1600">
+                <a:solidFill>
+                  <a:srgbClr val="FFFFFF"/>
+                </a:solidFill>
+              </a:defRPr>
+            </a:pPr>
+            <a:r>
+              <a:rPr sz="1600">
                 <a:solidFill>
                   <a:srgbClr val="FFFFFF"/>
                 </a:solidFill>
@@ -5377,41 +5505,41 @@
               <a:t>• </a:t>
             </a:r>
             <a:r>
-              <a:rPr sz="1700" b="1">
-                <a:solidFill>
-                  <a:srgbClr val="FFFFFF"/>
-                </a:solidFill>
-              </a:rPr>
-              <a:t>Puntos de Desviación:</a:t>
-            </a:r>
-            <a:r>
-              <a:rPr sz="1700">
-                <a:solidFill>
-                  <a:srgbClr val="FFFFFF"/>
-                </a:solidFill>
-              </a:rPr>
-              <a:t> El error máximo se concentra en la zona del codo de la curva característica I-V a irradiancias muy bajas.</a:t>
-            </a:r>
-          </a:p>
-          <a:p>
-            <a:pPr algn="l">
-              <a:defRPr sz="1700">
-                <a:solidFill>
-                  <a:srgbClr val="FFFFFF"/>
-                </a:solidFill>
-              </a:defRPr>
-            </a:pPr>
-          </a:p>
-          <a:p>
-            <a:pPr algn="l">
-              <a:defRPr sz="1700">
-                <a:solidFill>
-                  <a:srgbClr val="FFFFFF"/>
-                </a:solidFill>
-              </a:defRPr>
-            </a:pPr>
-            <a:r>
-              <a:rPr sz="1700">
+              <a:rPr sz="1600" b="1">
+                <a:solidFill>
+                  <a:srgbClr val="FFFFFF"/>
+                </a:solidFill>
+              </a:rPr>
+              <a:t>Zonas de Discrepancia:</a:t>
+            </a:r>
+            <a:r>
+              <a:rPr sz="1600">
+                <a:solidFill>
+                  <a:srgbClr val="FFFFFF"/>
+                </a:solidFill>
+              </a:rPr>
+              <a:t> Leve dispersión en irradiancias extremadamente bajas (amanecer/atardecer) por la idealización empírica de la resistencia shunt.</a:t>
+            </a:r>
+          </a:p>
+          <a:p>
+            <a:pPr algn="l">
+              <a:defRPr sz="1600">
+                <a:solidFill>
+                  <a:srgbClr val="FFFFFF"/>
+                </a:solidFill>
+              </a:defRPr>
+            </a:pPr>
+          </a:p>
+          <a:p>
+            <a:pPr algn="l">
+              <a:defRPr sz="1600">
+                <a:solidFill>
+                  <a:srgbClr val="FFFFFF"/>
+                </a:solidFill>
+              </a:defRPr>
+            </a:pPr>
+            <a:r>
+              <a:rPr sz="1600">
                 <a:solidFill>
                   <a:srgbClr val="FFFFFF"/>
                 </a:solidFill>
@@ -5419,20 +5547,20 @@
               <a:t>• </a:t>
             </a:r>
             <a:r>
-              <a:rPr sz="1700" b="1">
-                <a:solidFill>
-                  <a:srgbClr val="FFFFFF"/>
-                </a:solidFill>
-              </a:rPr>
-              <a:t>Fidelidad Térmica:</a:t>
-            </a:r>
-            <a:r>
-              <a:rPr sz="1700">
-                <a:solidFill>
-                  <a:srgbClr val="FFFFFF"/>
-                </a:solidFill>
-              </a:rPr>
-              <a:t> Valida la capacidad de las ecuaciones físicas de trasladar el voltaje y potencia a condiciones reales.</a:t>
+              <a:rPr sz="1600" b="1">
+                <a:solidFill>
+                  <a:srgbClr val="FFFFFF"/>
+                </a:solidFill>
+              </a:rPr>
+              <a:t>Conclusión de Validación:</a:t>
+            </a:r>
+            <a:r>
+              <a:rPr sz="1600">
+                <a:solidFill>
+                  <a:srgbClr val="FFFFFF"/>
+                </a:solidFill>
+              </a:rPr>
+              <a:t> Excelente consistencia de las ecuaciones físicas del circuito de un diodo para predecir potencia bajo el sol extremo.</a:t>
             </a:r>
           </a:p>
         </p:txBody>
@@ -5666,7 +5794,7 @@
                   <a:srgbClr val="FFFFFF"/>
                 </a:solidFill>
               </a:rPr>
-              <a:t>Alta Correlación Paramétrica:</a:t>
+              <a:t>Alta Correlación Paramétrica [De Soto et al., 2006]:</a:t>
             </a:r>
           </a:p>
           <a:p>
@@ -5683,7 +5811,7 @@
                   <a:srgbClr val="FFFFFF"/>
                 </a:solidFill>
               </a:rPr>
-              <a:t>  Tanto la resistencia serie (</a:t>
+              <a:t>  La resistencia serie (</a:t>
             </a:r>
             <a:r>
               <a:rPr sz="1400" i="1">
@@ -5707,7 +5835,7 @@
                   <a:srgbClr val="FFFFFF"/>
                 </a:solidFill>
               </a:rPr>
-              <a:t>) como el factor de idealidad del diodo (</a:t>
+              <a:t>) y el factor de idealidad del diodo (</a:t>
             </a:r>
             <a:r>
               <a:rPr sz="1400" i="1">
@@ -5723,7 +5851,7 @@
                   <a:srgbClr val="FFFFFF"/>
                 </a:solidFill>
               </a:rPr>
-              <a:t>) controlan la curvatura de la curva </a:t>
+              <a:t>) influyen de manera similar en la redondez de la curva </a:t>
             </a:r>
             <a:r>
               <a:rPr sz="1400" i="1">
@@ -5755,7 +5883,7 @@
                   <a:srgbClr val="FFFFFF"/>
                 </a:solidFill>
               </a:rPr>
-              <a:t> en la región cercana al Punto de Máxima Potencia (MPP).</a:t>
+              <a:t> cerca del MPP.</a:t>
             </a:r>
           </a:p>
           <a:p>
@@ -5789,7 +5917,7 @@
                   <a:srgbClr val="FFFFFF"/>
                 </a:solidFill>
               </a:rPr>
-              <a:t>Problema Mal Condicionado:</a:t>
+              <a:t>Problema Matemático Mal Condicionado:</a:t>
             </a:r>
           </a:p>
           <a:p>
@@ -5846,7 +5974,75 @@
                   <a:srgbClr val="FFFFFF"/>
                 </a:solidFill>
               </a:rPr>
-              <a:t>) pueden reproducir curvas </a:t>
+              <a:t>) pueden resultar en un ajuste idéntico de curvas con un error residual mínimo similar, perdiendo significado físico real.</a:t>
+            </a:r>
+          </a:p>
+          <a:p>
+            <a:pPr algn="l">
+              <a:defRPr sz="1400">
+                <a:solidFill>
+                  <a:srgbClr val="FFFFFF"/>
+                </a:solidFill>
+              </a:defRPr>
+            </a:pPr>
+          </a:p>
+          <a:p>
+            <a:pPr algn="l">
+              <a:defRPr sz="1400">
+                <a:solidFill>
+                  <a:srgbClr val="FFFFFF"/>
+                </a:solidFill>
+              </a:defRPr>
+            </a:pPr>
+            <a:r>
+              <a:rPr sz="1400">
+                <a:solidFill>
+                  <a:srgbClr val="FFFFFF"/>
+                </a:solidFill>
+              </a:rPr>
+              <a:t>• </a:t>
+            </a:r>
+            <a:r>
+              <a:rPr sz="1400" b="1">
+                <a:solidFill>
+                  <a:srgbClr val="FFFFFF"/>
+                </a:solidFill>
+              </a:rPr>
+              <a:t>Mitigación y Solución [De Soto et al., 2006]:</a:t>
+            </a:r>
+          </a:p>
+          <a:p>
+            <a:pPr algn="l">
+              <a:defRPr sz="1400">
+                <a:solidFill>
+                  <a:srgbClr val="FFFFFF"/>
+                </a:solidFill>
+              </a:defRPr>
+            </a:pPr>
+            <a:r>
+              <a:rPr sz="1400">
+                <a:solidFill>
+                  <a:srgbClr val="FFFFFF"/>
+                </a:solidFill>
+              </a:rPr>
+              <a:t>  Se fijaron límites estrictos en el optimizador multivariable:</a:t>
+            </a:r>
+          </a:p>
+          <a:p>
+            <a:pPr algn="l">
+              <a:defRPr sz="1400">
+                <a:solidFill>
+                  <a:srgbClr val="FFFFFF"/>
+                </a:solidFill>
+              </a:defRPr>
+            </a:pPr>
+            <a:r>
+              <a:rPr sz="1400">
+                <a:solidFill>
+                  <a:srgbClr val="FFFFFF"/>
+                </a:solidFill>
+              </a:rPr>
+              <a:t>  </a:t>
             </a:r>
             <a:r>
               <a:rPr sz="1400" i="1">
@@ -5854,7 +6050,15 @@
                   <a:srgbClr val="FFFFFF"/>
                 </a:solidFill>
               </a:rPr>
-              <a:t>I</a:t>
+              <a:t>R</a:t>
+            </a:r>
+            <a:r>
+              <a:rPr sz="1400" i="1">
+                <a:solidFill>
+                  <a:srgbClr val="FFFFFF"/>
+                </a:solidFill>
+              </a:rPr>
+              <a:t>s</a:t>
             </a:r>
             <a:r>
               <a:rPr sz="1400">
@@ -5862,7 +6066,7 @@
                   <a:srgbClr val="FFFFFF"/>
                 </a:solidFill>
               </a:rPr>
-              <a:t>-</a:t>
+              <a:t> &gt; 0  |  </a:t>
             </a:r>
             <a:r>
               <a:rPr sz="1400" i="1">
@@ -5870,7 +6074,7 @@
                   <a:srgbClr val="FFFFFF"/>
                 </a:solidFill>
               </a:rPr>
-              <a:t>V</a:t>
+              <a:t>n</a:t>
             </a:r>
             <a:r>
               <a:rPr sz="1400">
@@ -5878,7 +6082,15 @@
                   <a:srgbClr val="FFFFFF"/>
                 </a:solidFill>
               </a:rPr>
-              <a:t> con errores de ajuste idénticos, lo que dificulta la identificación unívoca.</a:t>
+              <a:t> ∈ </a:t>
+            </a:r>
+            <a:r>
+              <a:rPr sz="1400">
+                <a:solidFill>
+                  <a:srgbClr val="FFFFFF"/>
+                </a:solidFill>
+              </a:rPr>
+              <a:t>1.0, 2.0</a:t>
             </a:r>
           </a:p>
           <a:p>
@@ -5889,129 +6101,13 @@
                 </a:solidFill>
               </a:defRPr>
             </a:pPr>
-          </a:p>
-          <a:p>
-            <a:pPr algn="l">
-              <a:defRPr sz="1400">
-                <a:solidFill>
-                  <a:srgbClr val="FFFFFF"/>
-                </a:solidFill>
-              </a:defRPr>
-            </a:pPr>
             <a:r>
               <a:rPr sz="1400">
                 <a:solidFill>
                   <a:srgbClr val="FFFFFF"/>
                 </a:solidFill>
               </a:rPr>
-              <a:t>• </a:t>
-            </a:r>
-            <a:r>
-              <a:rPr sz="1400" b="1">
-                <a:solidFill>
-                  <a:srgbClr val="FFFFFF"/>
-                </a:solidFill>
-              </a:rPr>
-              <a:t>Mitigación y Solución:</a:t>
-            </a:r>
-          </a:p>
-          <a:p>
-            <a:pPr algn="l">
-              <a:defRPr sz="1400">
-                <a:solidFill>
-                  <a:srgbClr val="FFFFFF"/>
-                </a:solidFill>
-              </a:defRPr>
-            </a:pPr>
-            <a:r>
-              <a:rPr sz="1400">
-                <a:solidFill>
-                  <a:srgbClr val="FFFFFF"/>
-                </a:solidFill>
-              </a:rPr>
-              <a:t>  Se implementaron restricciones físicas estrictas en la optimización por mínimos cuadrados:</a:t>
-            </a:r>
-          </a:p>
-          <a:p>
-            <a:pPr algn="l">
-              <a:defRPr sz="1400">
-                <a:solidFill>
-                  <a:srgbClr val="FFFFFF"/>
-                </a:solidFill>
-              </a:defRPr>
-            </a:pPr>
-            <a:r>
-              <a:rPr sz="1400">
-                <a:solidFill>
-                  <a:srgbClr val="FFFFFF"/>
-                </a:solidFill>
-              </a:rPr>
-              <a:t>  </a:t>
-            </a:r>
-            <a:r>
-              <a:rPr sz="1400" i="1">
-                <a:solidFill>
-                  <a:srgbClr val="FFFFFF"/>
-                </a:solidFill>
-              </a:rPr>
-              <a:t>R</a:t>
-            </a:r>
-            <a:r>
-              <a:rPr sz="1400" i="1">
-                <a:solidFill>
-                  <a:srgbClr val="FFFFFF"/>
-                </a:solidFill>
-              </a:rPr>
-              <a:t>s</a:t>
-            </a:r>
-            <a:r>
-              <a:rPr sz="1400">
-                <a:solidFill>
-                  <a:srgbClr val="FFFFFF"/>
-                </a:solidFill>
-              </a:rPr>
-              <a:t> &gt; 0  |  </a:t>
-            </a:r>
-            <a:r>
-              <a:rPr sz="1400" i="1">
-                <a:solidFill>
-                  <a:srgbClr val="FFFFFF"/>
-                </a:solidFill>
-              </a:rPr>
-              <a:t>n</a:t>
-            </a:r>
-            <a:r>
-              <a:rPr sz="1400">
-                <a:solidFill>
-                  <a:srgbClr val="FFFFFF"/>
-                </a:solidFill>
-              </a:rPr>
-              <a:t> ∈ </a:t>
-            </a:r>
-            <a:r>
-              <a:rPr sz="1400">
-                <a:solidFill>
-                  <a:srgbClr val="FFFFFF"/>
-                </a:solidFill>
-              </a:rPr>
-              <a:t>1.0, 2.0</a:t>
-            </a:r>
-          </a:p>
-          <a:p>
-            <a:pPr algn="l">
-              <a:defRPr sz="1400">
-                <a:solidFill>
-                  <a:srgbClr val="FFFFFF"/>
-                </a:solidFill>
-              </a:defRPr>
-            </a:pPr>
-            <a:r>
-              <a:rPr sz="1400">
-                <a:solidFill>
-                  <a:srgbClr val="FFFFFF"/>
-                </a:solidFill>
-              </a:rPr>
-              <a:t>  Esto asegura consistencia física y convergencia estable.</a:t>
+              <a:t>  Esto evita la convergencia a soluciones matemáticamente correctas pero físicamente imposibles.</a:t>
             </a:r>
           </a:p>
         </p:txBody>
@@ -6773,14 +6869,14 @@
           <a:lstStyle/>
           <a:p>
             <a:pPr algn="l">
-              <a:defRPr sz="1700">
-                <a:solidFill>
-                  <a:srgbClr val="FFFFFF"/>
-                </a:solidFill>
-              </a:defRPr>
-            </a:pPr>
-            <a:r>
-              <a:rPr sz="1700">
+              <a:defRPr sz="1600">
+                <a:solidFill>
+                  <a:srgbClr val="FFFFFF"/>
+                </a:solidFill>
+              </a:defRPr>
+            </a:pPr>
+            <a:r>
+              <a:rPr sz="1600">
                 <a:solidFill>
                   <a:srgbClr val="FFFFFF"/>
                 </a:solidFill>
@@ -6788,41 +6884,41 @@
               <a:t>• </a:t>
             </a:r>
             <a:r>
-              <a:rPr sz="1700" b="1">
-                <a:solidFill>
-                  <a:srgbClr val="FFFFFF"/>
-                </a:solidFill>
-              </a:rPr>
-              <a:t>Heterounión (HIT - Naranja):</a:t>
-            </a:r>
-            <a:r>
-              <a:rPr sz="1700">
-                <a:solidFill>
-                  <a:srgbClr val="FFFFFF"/>
-                </a:solidFill>
-              </a:rPr>
-              <a:t> Pendiente suave y controlada. Su bajo coeficiente térmico de potencia (-0.26 %/°C) mantiene una alta eficiencia de conversión incluso a temperaturas de 65°C.</a:t>
-            </a:r>
-          </a:p>
-          <a:p>
-            <a:pPr algn="l">
-              <a:defRPr sz="1700">
-                <a:solidFill>
-                  <a:srgbClr val="FFFFFF"/>
-                </a:solidFill>
-              </a:defRPr>
-            </a:pPr>
-          </a:p>
-          <a:p>
-            <a:pPr algn="l">
-              <a:defRPr sz="1700">
-                <a:solidFill>
-                  <a:srgbClr val="FFFFFF"/>
-                </a:solidFill>
-              </a:defRPr>
-            </a:pPr>
-            <a:r>
-              <a:rPr sz="1700">
+              <a:rPr sz="1600" b="1">
+                <a:solidFill>
+                  <a:srgbClr val="FFFFFF"/>
+                </a:solidFill>
+              </a:rPr>
+              <a:t>Heterounión (HIT - Naranja) [De Soto et al., 2006]:</a:t>
+            </a:r>
+            <a:r>
+              <a:rPr sz="1600">
+                <a:solidFill>
+                  <a:srgbClr val="FFFFFF"/>
+                </a:solidFill>
+              </a:rPr>
+              <a:t> Coeficiente de temperatura de potencia muy bajo (-0.26 %/°C), preservando una alta eficiencia de conversión a 65°C.</a:t>
+            </a:r>
+          </a:p>
+          <a:p>
+            <a:pPr algn="l">
+              <a:defRPr sz="1600">
+                <a:solidFill>
+                  <a:srgbClr val="FFFFFF"/>
+                </a:solidFill>
+              </a:defRPr>
+            </a:pPr>
+          </a:p>
+          <a:p>
+            <a:pPr algn="l">
+              <a:defRPr sz="1600">
+                <a:solidFill>
+                  <a:srgbClr val="FFFFFF"/>
+                </a:solidFill>
+              </a:defRPr>
+            </a:pPr>
+            <a:r>
+              <a:rPr sz="1600">
                 <a:solidFill>
                   <a:srgbClr val="FFFFFF"/>
                 </a:solidFill>
@@ -6830,41 +6926,41 @@
               <a:t>• </a:t>
             </a:r>
             <a:r>
-              <a:rPr sz="1700" b="1">
-                <a:solidFill>
-                  <a:srgbClr val="FFFFFF"/>
-                </a:solidFill>
-              </a:rPr>
-              <a:t>Silicio Monocristalino (m-Si - Azul):</a:t>
-            </a:r>
-            <a:r>
-              <a:rPr sz="1700">
-                <a:solidFill>
-                  <a:srgbClr val="FFFFFF"/>
-                </a:solidFill>
-              </a:rPr>
-              <a:t> Caída térmica severa. Su alto coeficiente térmico (-0.40 %/°C) penaliza drásticamente el voltaje durante las horas pico de irradiancia desértica.</a:t>
-            </a:r>
-          </a:p>
-          <a:p>
-            <a:pPr algn="l">
-              <a:defRPr sz="1700">
-                <a:solidFill>
-                  <a:srgbClr val="FFFFFF"/>
-                </a:solidFill>
-              </a:defRPr>
-            </a:pPr>
-          </a:p>
-          <a:p>
-            <a:pPr algn="l">
-              <a:defRPr sz="1700">
-                <a:solidFill>
-                  <a:srgbClr val="FFFFFF"/>
-                </a:solidFill>
-              </a:defRPr>
-            </a:pPr>
-            <a:r>
-              <a:rPr sz="1700">
+              <a:rPr sz="1600" b="1">
+                <a:solidFill>
+                  <a:srgbClr val="FFFFFF"/>
+                </a:solidFill>
+              </a:rPr>
+              <a:t>Silicio Monocristalino (m-Si - Azul) [De Soto et al., 2006]:</a:t>
+            </a:r>
+            <a:r>
+              <a:rPr sz="1600">
+                <a:solidFill>
+                  <a:srgbClr val="FFFFFF"/>
+                </a:solidFill>
+              </a:rPr>
+              <a:t> Descenso térmico pronunciado (-0.40 %/°C) que penaliza la potencia generada durante el mediodía solar.</a:t>
+            </a:r>
+          </a:p>
+          <a:p>
+            <a:pPr algn="l">
+              <a:defRPr sz="1600">
+                <a:solidFill>
+                  <a:srgbClr val="FFFFFF"/>
+                </a:solidFill>
+              </a:defRPr>
+            </a:pPr>
+          </a:p>
+          <a:p>
+            <a:pPr algn="l">
+              <a:defRPr sz="1600">
+                <a:solidFill>
+                  <a:srgbClr val="FFFFFF"/>
+                </a:solidFill>
+              </a:defRPr>
+            </a:pPr>
+            <a:r>
+              <a:rPr sz="1600">
                 <a:solidFill>
                   <a:srgbClr val="FFFFFF"/>
                 </a:solidFill>
@@ -6872,20 +6968,20 @@
               <a:t>• </a:t>
             </a:r>
             <a:r>
-              <a:rPr sz="1700" b="1">
-                <a:solidFill>
-                  <a:srgbClr val="FFFFFF"/>
-                </a:solidFill>
-              </a:rPr>
-              <a:t>Impacto en PR:</a:t>
-            </a:r>
-            <a:r>
-              <a:rPr sz="1700">
-                <a:solidFill>
-                  <a:srgbClr val="FFFFFF"/>
-                </a:solidFill>
-              </a:rPr>
-              <a:t> Esta diferencia de comportamiento explica la brecha mensual y anual de rendimiento entre ambas tecnologías.</a:t>
+              <a:rPr sz="1600" b="1">
+                <a:solidFill>
+                  <a:srgbClr val="FFFFFF"/>
+                </a:solidFill>
+              </a:rPr>
+              <a:t>Consecuencia en PR Anual:</a:t>
+            </a:r>
+            <a:r>
+              <a:rPr sz="1600">
+                <a:solidFill>
+                  <a:srgbClr val="FFFFFF"/>
+                </a:solidFill>
+              </a:rPr>
+              <a:t> Explica mecánicamente la diferencia del Performance Ratio entre tecnologías. *(Ecuación de PR en Anexo VII, Lámina 25)*</a:t>
             </a:r>
           </a:p>
         </p:txBody>
@@ -7119,7 +7215,7 @@
                   <a:srgbClr val="E8A838"/>
                 </a:solidFill>
               </a:rPr>
-              <a:t>Performance Ratio Anual m-Si:</a:t>
+              <a:t>PR Anual Silicio Monocristalino (m-Si):</a:t>
             </a:r>
             <a:r>
               <a:rPr sz="1800" b="1">
@@ -7161,7 +7257,7 @@
                   <a:srgbClr val="E8A838"/>
                 </a:solidFill>
               </a:rPr>
-              <a:t>Performance Ratio Anual HIT:</a:t>
+              <a:t>PR Anual Heterounión (HIT):</a:t>
             </a:r>
             <a:r>
               <a:rPr sz="1800" b="1">
@@ -7203,7 +7299,7 @@
                   <a:srgbClr val="E8A838"/>
                 </a:solidFill>
               </a:rPr>
-              <a:t>Diferencia Neta en PR:</a:t>
+              <a:t>Ganancia Neta en PR Anual:</a:t>
             </a:r>
             <a:r>
               <a:rPr sz="1800" b="1">
@@ -7261,7 +7357,7 @@
                   <a:srgbClr val="E8A838"/>
                 </a:solidFill>
               </a:rPr>
-              <a:t>Conclusión Técnica:</a:t>
+              <a:t>Veredicto Técnico [De Soto et al., 2006]:</a:t>
             </a:r>
             <a:r>
               <a:rPr sz="1800" b="1">
@@ -7269,7 +7365,7 @@
                   <a:srgbClr val="E8A838"/>
                 </a:solidFill>
               </a:rPr>
-              <a:t> La tecnología HIT es categóricamente superior en el desierto debido a que su estructura física de capas delgadas amortigua la pérdida de tensión ($V_{oc}$) debida a la excitación térmica de portadores.</a:t>
+              <a:t> HIT demuestra superioridad física indiscutible en Atacama. Su celda híbrida intrínsecamente resiste el calor amortiguando la caída de la tensión en circuito abierto ($V_{oc}$).</a:t>
             </a:r>
           </a:p>
         </p:txBody>
@@ -16450,7 +16546,7 @@
                   <a:srgbClr val="FFFFFF"/>
                 </a:solidFill>
               </a:rPr>
-              <a:t>Modelo de un Diodo Simple (SDM):</a:t>
+              <a:t>Modelo de un Diodo Simple (SDM) [De Soto et al., 2006]:</a:t>
             </a:r>
           </a:p>
           <a:p>
@@ -16467,7 +16563,7 @@
                   <a:srgbClr val="FFFFFF"/>
                 </a:solidFill>
               </a:rPr>
-              <a:t>  Estructura circuital clásica que describe eléctricamente la celda. Incorpora las pérdidas óhmicas resistivas en serie (</a:t>
+              <a:t>  Estructura circuital clásica que describe eléctricamente la celda. Incorpora las pérdidas óhmicas en serie (</a:t>
             </a:r>
             <a:r>
               <a:rPr sz="1400" i="1">
@@ -16515,7 +16611,7 @@
                   <a:srgbClr val="FFFFFF"/>
                 </a:solidFill>
               </a:rPr>
-              <a:t>) en el semiconductor.</a:t>
+              <a:t>). *(Ecuación en Anexo IV, Lámina 22)*</a:t>
             </a:r>
           </a:p>
           <a:p>
@@ -16549,7 +16645,7 @@
                   <a:srgbClr val="FFFFFF"/>
                 </a:solidFill>
               </a:rPr>
-              <a:t>Modelo Térmico de Sandia (SAPM):</a:t>
+              <a:t>Modelo Térmico de Sandia (SAPM) [King et al., 2004]:</a:t>
             </a:r>
           </a:p>
           <a:p>
@@ -16590,7 +16686,7 @@
                   <a:srgbClr val="FFFFFF"/>
                 </a:solidFill>
               </a:rPr>
-              <a:t>) a partir de la irradiancia incidente y la velocidad del viento, considerando los coeficientes empíricos del encapsulado.</a:t>
+              <a:t>) a partir de la irradiancia incidente y el viento. *(Ecuación en Anexo III, Lámina 21)*</a:t>
             </a:r>
           </a:p>
           <a:p>
@@ -16624,7 +16720,7 @@
                   <a:srgbClr val="FFFFFF"/>
                 </a:solidFill>
               </a:rPr>
-              <a:t>Modelo de Transposición de Perez (1990):</a:t>
+              <a:t>Modelo de Transposición de Perez (1990) [Perez et al., 1990]:</a:t>
             </a:r>
           </a:p>
           <a:p>
@@ -16641,7 +16737,7 @@
                   <a:srgbClr val="FFFFFF"/>
                 </a:solidFill>
               </a:rPr>
-              <a:t>  Traducción geométrica de irradiancia sobre plano inclinado, modelando componentes de cielo difuso anisotrópico.</a:t>
+              <a:t>  Traducción geométrica de irradiancia sobre plano inclinado, modelando el cielo difuso anisotrópico. *(Ecuación en Anexo I, Lámina 19)*</a:t>
             </a:r>
           </a:p>
           <a:p>
@@ -16675,7 +16771,7 @@
                   <a:srgbClr val="FFFFFF"/>
                 </a:solidFill>
               </a:rPr>
-              <a:t>Algoritmo de Parámetros de De Soto (2006):</a:t>
+              <a:t>Algoritmo de Parámetros de De Soto (2006) [De Soto et al., 2006]:</a:t>
             </a:r>
           </a:p>
           <a:p>
@@ -16692,7 +16788,7 @@
                   <a:srgbClr val="FFFFFF"/>
                 </a:solidFill>
               </a:rPr>
-              <a:t>  Fórmulas para trasladar los parámetros desde STC a condiciones operacionales basándose en la energía de bandgap del silicio.</a:t>
+              <a:t>  Fórmulas para trasladar los parámetros desde STC a condiciones operacionales basándose en la energía de bandgap. *(Ecuaciones en Anexos V y VI, Láminas 23 y 24)*</a:t>
             </a:r>
           </a:p>
         </p:txBody>
@@ -17035,7 +17131,7 @@
                   <a:srgbClr val="FFFFFF"/>
                 </a:solidFill>
               </a:rPr>
-              <a:t>Etapa 1: Ingesta de Datos (NREL Cocoa):</a:t>
+              <a:t>Etapa 1: Ingesta de Datos (NREL Cocoa) [Marion et al., 2014]:</a:t>
             </a:r>
           </a:p>
           <a:p>
@@ -17052,7 +17148,7 @@
                   <a:srgbClr val="FFFFFF"/>
                 </a:solidFill>
               </a:rPr>
-              <a:t>  Extracción selectiva de variables de recurso solar y métricas eléctricas minutales a partir del dataset experimental.</a:t>
+              <a:t>  Extracción selectiva de variables de recurso solar y métricas de curvas I-V completas a partir del dataset experimental.</a:t>
             </a:r>
           </a:p>
           <a:p>
@@ -17103,7 +17199,7 @@
                   <a:srgbClr val="FFFFFF"/>
                 </a:solidFill>
               </a:rPr>
-              <a:t>  Traslación espacial, proyección al año calendarizado 2026 y desfase estacional estricto de +6 meses.</a:t>
+              <a:t>  Traslación espacial, proyección a 2026 y desfase estacional de +6 meses para alinear el clima del Hemisferio Sur.</a:t>
             </a:r>
           </a:p>
           <a:p>
@@ -17154,7 +17250,39 @@
                   <a:srgbClr val="FFFFFF"/>
                 </a:solidFill>
               </a:rPr>
-              <a:t>  Cálculo térmico (Sandia) y ajuste por mínimos cuadrados acotados para obtener los 5 parámetros De Soto en STC.</a:t>
+              <a:t>  Cálculo térmico de Sandia </a:t>
+            </a:r>
+            <a:r>
+              <a:rPr sz="1300">
+                <a:solidFill>
+                  <a:srgbClr val="FFFFFF"/>
+                </a:solidFill>
+              </a:rPr>
+              <a:t>King et al., 2004</a:t>
+            </a:r>
+            <a:r>
+              <a:rPr sz="1300">
+                <a:solidFill>
+                  <a:srgbClr val="FFFFFF"/>
+                </a:solidFill>
+              </a:rPr>
+              <a:t> y ajuste de mínimos cuadrados para obtener los 5 parámetros de De Soto </a:t>
+            </a:r>
+            <a:r>
+              <a:rPr sz="1300">
+                <a:solidFill>
+                  <a:srgbClr val="FFFFFF"/>
+                </a:solidFill>
+              </a:rPr>
+              <a:t>De Soto et al., 2006</a:t>
+            </a:r>
+            <a:r>
+              <a:rPr sz="1300">
+                <a:solidFill>
+                  <a:srgbClr val="FFFFFF"/>
+                </a:solidFill>
+              </a:rPr>
+              <a:t> en STC.</a:t>
             </a:r>
           </a:p>
           <a:p>
@@ -17205,7 +17333,23 @@
                   <a:srgbClr val="FFFFFF"/>
                 </a:solidFill>
               </a:rPr>
-              <a:t>  Escalamiento dinámico de parámetros y resolución implícita del circuito fotovoltaico minutal para calcular energía.</a:t>
+              <a:t>  Escalamiento dinámico de parámetros (Modelo De Soto) y resolución implícita de I-V mediante pvlib </a:t>
+            </a:r>
+            <a:r>
+              <a:rPr sz="1300">
+                <a:solidFill>
+                  <a:srgbClr val="FFFFFF"/>
+                </a:solidFill>
+              </a:rPr>
+              <a:t>Holmgren et al., 2018</a:t>
+            </a:r>
+            <a:r>
+              <a:rPr sz="1300">
+                <a:solidFill>
+                  <a:srgbClr val="FFFFFF"/>
+                </a:solidFill>
+              </a:rPr>
+              <a:t>.</a:t>
             </a:r>
           </a:p>
           <a:p>
@@ -17239,7 +17383,7 @@
                   <a:srgbClr val="FFFFFF"/>
                 </a:solidFill>
               </a:rPr>
-              <a:t>Etapa 5: Evaluación de Indicadores (Performance Ratio):</a:t>
+              <a:t>Etapa 5: Evaluación de Performance Ratio (PR):</a:t>
             </a:r>
           </a:p>
           <a:p>
@@ -17272,7 +17416,7 @@
                   <a:srgbClr val="FFFFFF"/>
                 </a:solidFill>
               </a:rPr>
-              <a:t> para recomendación final.</a:t>
+              <a:t> utilizando el estándar IEC 61724-1. *(Fórmulas y glosario en Anexo VII, Lámina 25)*</a:t>
             </a:r>
           </a:p>
         </p:txBody>
@@ -17623,7 +17767,23 @@
                   <a:srgbClr val="FFFFFF"/>
                 </a:solidFill>
               </a:rPr>
-              <a:t> Dataset Cocoa (NREL). Contiene mediciones experimentales minuto a minuto de curvas I-V completas tomadas en Florida.</a:t>
+              <a:t> Dataset experimental Cocoa (NREL) </a:t>
+            </a:r>
+            <a:r>
+              <a:rPr sz="1700">
+                <a:solidFill>
+                  <a:srgbClr val="FFFFFF"/>
+                </a:solidFill>
+              </a:rPr>
+              <a:t>Marion et al., 2014</a:t>
+            </a:r>
+            <a:r>
+              <a:rPr sz="1700">
+                <a:solidFill>
+                  <a:srgbClr val="FFFFFF"/>
+                </a:solidFill>
+              </a:rPr>
+              <a:t>. Contiene curvas I-V completas y mediciones meteorológicas minuto a minuto.</a:t>
             </a:r>
           </a:p>
           <a:p>
@@ -17665,7 +17825,7 @@
                   <a:srgbClr val="FFFFFF"/>
                 </a:solidFill>
               </a:rPr>
-              <a:t> Los archivos CSV unitarios superan los 100MB por tecnología, con millones de registros de longitudes variables.</a:t>
+              <a:t> Los archivos CSV unitarios superan los 100MB por tecnología, acumulando millones de registros de longitudes variables.</a:t>
             </a:r>
           </a:p>
           <a:p>
@@ -17707,7 +17867,7 @@
                   <a:srgbClr val="FFFFFF"/>
                 </a:solidFill>
               </a:rPr>
-              <a:t> Lectores convencionales (Pandas `read_csv`) agotan la RAM y fallan debido a caracteres atípicos en los metadatos.</a:t>
+              <a:t> Lectores convencionales (e.g., Pandas `read_csv`) agotan la memoria RAM y fallan debido a caracteres atípicos en la metadata.</a:t>
             </a:r>
           </a:p>
         </p:txBody>
@@ -17882,7 +18042,7 @@
                   <a:srgbClr val="FFFFFF"/>
                 </a:solidFill>
               </a:rPr>
-              <a:t>Extracción Selectiva:</a:t>
+              <a:t>Extracción Selectiva [Marion et al., 2014]:</a:t>
             </a:r>
             <a:r>
               <a:rPr sz="1700">
@@ -17890,7 +18050,7 @@
                   <a:srgbClr val="FFFFFF"/>
                 </a:solidFill>
               </a:rPr>
-              <a:t> Se ignoraron las series de curvas I-V masivas en la carga inicial y se extrajeron únicamente los metadatos y puntos clave de operación (</a:t>
+              <a:t> Se ignoraron las series de curvas I-V completas en la carga inicial y se extrajeron únicamente los metadatos y puntos clave de operación (</a:t>
             </a:r>
             <a:r>
               <a:rPr sz="1700" i="1">
@@ -18052,7 +18212,7 @@
                   <a:srgbClr val="FFFFFF"/>
                 </a:solidFill>
               </a:rPr>
-              <a:t> Se descartaron registros nocturnos ($G &lt; 10$ W/m²) o con datos incompletos, acelerando la simulación anual un 95%.</a:t>
+              <a:t> Se descartaron registros nocturnos ($G &lt; 10$ W/m²) o incompletos, acelerando la simulación anual del recurso solar un 95%.</a:t>
             </a:r>
           </a:p>
         </p:txBody>
@@ -18412,7 +18572,23 @@
                   <a:srgbClr val="FFFFFF"/>
                 </a:solidFill>
               </a:rPr>
-              <a:t>  Los datos crudos de NREL Cocoa son medidos en Florida (Hemisferio Norte). Si se simulan directamente en Atacama (Hemisferio Sur), el verano solar coincidiría con el invierno térmico real, lo que es físicamente incorrecto.</a:t>
+              <a:t>  Los datos experimentales de NREL Cocoa </a:t>
+            </a:r>
+            <a:r>
+              <a:rPr sz="1400">
+                <a:solidFill>
+                  <a:srgbClr val="FFFFFF"/>
+                </a:solidFill>
+              </a:rPr>
+              <a:t>Marion et al., 2014</a:t>
+            </a:r>
+            <a:r>
+              <a:rPr sz="1400">
+                <a:solidFill>
+                  <a:srgbClr val="FFFFFF"/>
+                </a:solidFill>
+              </a:rPr>
+              <a:t> se midieron en el Hemisferio Norte. Simularlos directamente en el Hemisferio Sur crearía un desfase físico absurdo entre solsticios e inviernos térmicos.</a:t>
             </a:r>
           </a:p>
           <a:p>
@@ -18463,7 +18639,7 @@
                   <a:srgbClr val="FFFFFF"/>
                 </a:solidFill>
               </a:rPr>
-              <a:t>  Se aplicó un desplazamiento estacional de +6 meses (+182 días). De esta forma, el verano térmico medido en Florida se alinea correctamente con el verano astronómico del Hemisferio Sur.</a:t>
+              <a:t>  Se implementó un desplazamiento estacional exacto de +6 meses (+182 días). Así, el perfil de calor de Florida coincide coherentemente con el verano del Hemisferio Sur.</a:t>
             </a:r>
           </a:p>
           <a:p>
@@ -18497,7 +18673,7 @@
                   <a:srgbClr val="FFFFFF"/>
                 </a:solidFill>
               </a:rPr>
-              <a:t>Traducción Espacial y Proyección 2026:</a:t>
+              <a:t>Traducción Espacial a Atacama:</a:t>
             </a:r>
           </a:p>
           <a:p>
@@ -18514,7 +18690,39 @@
                   <a:srgbClr val="FFFFFF"/>
                 </a:solidFill>
               </a:rPr>
-              <a:t>  Todos los timestamps se remapearon al año 2026. Se modificaron las coordenadas a San Pedro de Atacama (Latitud −22.91° S, Longitud −68.20° W, Altitud 2400 m).</a:t>
+              <a:t>  Timestamp remapeado a 2026 con coordenadas de San Pedro de Atacama (Latitud −22.91° S, Longitud −68.20° W, Altitud 2400m) para calcular la inclinación óptima anual de </a:t>
+            </a:r>
+            <a:r>
+              <a:rPr sz="1400" b="1">
+                <a:solidFill>
+                  <a:srgbClr val="FFFFFF"/>
+                </a:solidFill>
+              </a:rPr>
+              <a:t>22.91° Norte</a:t>
+            </a:r>
+            <a:r>
+              <a:rPr sz="1400">
+                <a:solidFill>
+                  <a:srgbClr val="FFFFFF"/>
+                </a:solidFill>
+              </a:rPr>
+              <a:t> </a:t>
+            </a:r>
+            <a:r>
+              <a:rPr sz="1400">
+                <a:solidFill>
+                  <a:srgbClr val="FFFFFF"/>
+                </a:solidFill>
+              </a:rPr>
+              <a:t>Holmgren et al., 2018</a:t>
+            </a:r>
+            <a:r>
+              <a:rPr sz="1400">
+                <a:solidFill>
+                  <a:srgbClr val="FFFFFF"/>
+                </a:solidFill>
+              </a:rPr>
+              <a:t>.</a:t>
             </a:r>
           </a:p>
           <a:p>
@@ -18548,7 +18756,7 @@
                   <a:srgbClr val="FFFFFF"/>
                 </a:solidFill>
               </a:rPr>
-              <a:t>Alineación Solar Óptima:</a:t>
+              <a:t>Alineación de Coordenadas:</a:t>
             </a:r>
           </a:p>
           <a:p>
@@ -18565,39 +18773,7 @@
                   <a:srgbClr val="FFFFFF"/>
                 </a:solidFill>
               </a:rPr>
-              <a:t>  Inclinación del módulo (Tilt) fijada a </a:t>
-            </a:r>
-            <a:r>
-              <a:rPr sz="1400" b="1">
-                <a:solidFill>
-                  <a:srgbClr val="FFFFFF"/>
-                </a:solidFill>
-              </a:rPr>
-              <a:t>22.91°</a:t>
-            </a:r>
-            <a:r>
-              <a:rPr sz="1400">
-                <a:solidFill>
-                  <a:srgbClr val="FFFFFF"/>
-                </a:solidFill>
-              </a:rPr>
-              <a:t> (óptimo anual) y orientación (Azimut) a </a:t>
-            </a:r>
-            <a:r>
-              <a:rPr sz="1400" b="1">
-                <a:solidFill>
-                  <a:srgbClr val="FFFFFF"/>
-                </a:solidFill>
-              </a:rPr>
-              <a:t>0° Norte</a:t>
-            </a:r>
-            <a:r>
-              <a:rPr sz="1400">
-                <a:solidFill>
-                  <a:srgbClr val="FFFFFF"/>
-                </a:solidFill>
-              </a:rPr>
-              <a:t>.</a:t>
+              <a:t>  Ajuste del ángulo cenital y azimutal en pvlib para simular una captación fotovoltaica impecable sin sombras locales.</a:t>
             </a:r>
           </a:p>
         </p:txBody>
@@ -18811,14 +18987,14 @@
           <a:lstStyle/>
           <a:p>
             <a:pPr algn="l">
-              <a:defRPr sz="1700">
-                <a:solidFill>
-                  <a:srgbClr val="FFFFFF"/>
-                </a:solidFill>
-              </a:defRPr>
-            </a:pPr>
-            <a:r>
-              <a:rPr sz="1700">
+              <a:defRPr sz="1600">
+                <a:solidFill>
+                  <a:srgbClr val="FFFFFF"/>
+                </a:solidFill>
+              </a:defRPr>
+            </a:pPr>
+            <a:r>
+              <a:rPr sz="1600">
                 <a:solidFill>
                   <a:srgbClr val="FFFFFF"/>
                 </a:solidFill>
@@ -18826,7 +19002,7 @@
               <a:t>• </a:t>
             </a:r>
             <a:r>
-              <a:rPr sz="1700" b="1">
+              <a:rPr sz="1600" b="1">
                 <a:solidFill>
                   <a:srgbClr val="FFFFFF"/>
                 </a:solidFill>
@@ -18834,33 +19010,49 @@
               <a:t>Modelo de Perez:</a:t>
             </a:r>
             <a:r>
-              <a:rPr sz="1700">
-                <a:solidFill>
-                  <a:srgbClr val="FFFFFF"/>
-                </a:solidFill>
-              </a:rPr>
-              <a:t> Ejecución del algoritmo en `pvlib` para calcular la irradiancia total en el Plano del Arreglo ($G_{poa}$).</a:t>
-            </a:r>
-          </a:p>
-          <a:p>
-            <a:pPr algn="l">
-              <a:defRPr sz="1700">
-                <a:solidFill>
-                  <a:srgbClr val="FFFFFF"/>
-                </a:solidFill>
-              </a:defRPr>
-            </a:pPr>
-          </a:p>
-          <a:p>
-            <a:pPr algn="l">
-              <a:defRPr sz="1700">
-                <a:solidFill>
-                  <a:srgbClr val="FFFFFF"/>
-                </a:solidFill>
-              </a:defRPr>
-            </a:pPr>
-            <a:r>
-              <a:rPr sz="1700">
+              <a:rPr sz="1600">
+                <a:solidFill>
+                  <a:srgbClr val="FFFFFF"/>
+                </a:solidFill>
+              </a:rPr>
+              <a:t> Ejecución del algoritmo </a:t>
+            </a:r>
+            <a:r>
+              <a:rPr sz="1600">
+                <a:solidFill>
+                  <a:srgbClr val="FFFFFF"/>
+                </a:solidFill>
+              </a:rPr>
+              <a:t>Perez et al., 1990</a:t>
+            </a:r>
+            <a:r>
+              <a:rPr sz="1600">
+                <a:solidFill>
+                  <a:srgbClr val="FFFFFF"/>
+                </a:solidFill>
+              </a:rPr>
+              <a:t> en pvlib para calcular la irradiancia total en el Plano del Arreglo ($G_{poa}$). *(Ecuación en Anexo I, Lámina 19)*</a:t>
+            </a:r>
+          </a:p>
+          <a:p>
+            <a:pPr algn="l">
+              <a:defRPr sz="1600">
+                <a:solidFill>
+                  <a:srgbClr val="FFFFFF"/>
+                </a:solidFill>
+              </a:defRPr>
+            </a:pPr>
+          </a:p>
+          <a:p>
+            <a:pPr algn="l">
+              <a:defRPr sz="1600">
+                <a:solidFill>
+                  <a:srgbClr val="FFFFFF"/>
+                </a:solidFill>
+              </a:defRPr>
+            </a:pPr>
+            <a:r>
+              <a:rPr sz="1600">
                 <a:solidFill>
                   <a:srgbClr val="FFFFFF"/>
                 </a:solidFill>
@@ -18868,7 +19060,7 @@
               <a:t>• </a:t>
             </a:r>
             <a:r>
-              <a:rPr sz="1700" b="1">
+              <a:rPr sz="1600" b="1">
                 <a:solidFill>
                   <a:srgbClr val="FFFFFF"/>
                 </a:solidFill>
@@ -18876,33 +19068,49 @@
               <a:t>Modificador IAM:</a:t>
             </a:r>
             <a:r>
-              <a:rPr sz="1700">
-                <a:solidFill>
-                  <a:srgbClr val="FFFFFF"/>
-                </a:solidFill>
-              </a:rPr>
-              <a:t> Simulación física de pérdidas por reflexión en el cristal de los paneles. Se utilizaron coeficientes de transmitancia basados en el espesor del vidrio (2mm) y su índice de refracción (1.526).</a:t>
-            </a:r>
-          </a:p>
-          <a:p>
-            <a:pPr algn="l">
-              <a:defRPr sz="1700">
-                <a:solidFill>
-                  <a:srgbClr val="FFFFFF"/>
-                </a:solidFill>
-              </a:defRPr>
-            </a:pPr>
-          </a:p>
-          <a:p>
-            <a:pPr algn="l">
-              <a:defRPr sz="1700">
-                <a:solidFill>
-                  <a:srgbClr val="FFFFFF"/>
-                </a:solidFill>
-              </a:defRPr>
-            </a:pPr>
-            <a:r>
-              <a:rPr sz="1700">
+              <a:rPr sz="1600">
+                <a:solidFill>
+                  <a:srgbClr val="FFFFFF"/>
+                </a:solidFill>
+              </a:rPr>
+              <a:t> Pérdidas por reflexión en el cristal basadas en la Ley de Snell y Bouguer </a:t>
+            </a:r>
+            <a:r>
+              <a:rPr sz="1600">
+                <a:solidFill>
+                  <a:srgbClr val="FFFFFF"/>
+                </a:solidFill>
+              </a:rPr>
+              <a:t>King et al., 2004</a:t>
+            </a:r>
+            <a:r>
+              <a:rPr sz="1600">
+                <a:solidFill>
+                  <a:srgbClr val="FFFFFF"/>
+                </a:solidFill>
+              </a:rPr>
+              <a:t> (espesor 2mm, índice refracción 1.526). *(Fórmulas en Anexo II, Lámina 20)*</a:t>
+            </a:r>
+          </a:p>
+          <a:p>
+            <a:pPr algn="l">
+              <a:defRPr sz="1600">
+                <a:solidFill>
+                  <a:srgbClr val="FFFFFF"/>
+                </a:solidFill>
+              </a:defRPr>
+            </a:pPr>
+          </a:p>
+          <a:p>
+            <a:pPr algn="l">
+              <a:defRPr sz="1600">
+                <a:solidFill>
+                  <a:srgbClr val="FFFFFF"/>
+                </a:solidFill>
+              </a:defRPr>
+            </a:pPr>
+            <a:r>
+              <a:rPr sz="1600">
                 <a:solidFill>
                   <a:srgbClr val="FFFFFF"/>
                 </a:solidFill>
@@ -18910,7 +19118,7 @@
               <a:t>• </a:t>
             </a:r>
             <a:r>
-              <a:rPr sz="1700" b="1">
+              <a:rPr sz="1600" b="1">
                 <a:solidFill>
                   <a:srgbClr val="FFFFFF"/>
                 </a:solidFill>
@@ -18918,12 +19126,28 @@
               <a:t>Modificador Espectral (AM):</a:t>
             </a:r>
             <a:r>
-              <a:rPr sz="1700">
-                <a:solidFill>
-                  <a:srgbClr val="FFFFFF"/>
-                </a:solidFill>
-              </a:rPr>
-              <a:t> Estimación de la masa de aire absoluta en función de la altura del sol, aplicando una corrección de cuarto orden.</a:t>
+              <a:rPr sz="1600">
+                <a:solidFill>
+                  <a:srgbClr val="FFFFFF"/>
+                </a:solidFill>
+              </a:rPr>
+              <a:t> Corrección empírica de masa de aire de cuarto orden </a:t>
+            </a:r>
+            <a:r>
+              <a:rPr sz="1600">
+                <a:solidFill>
+                  <a:srgbClr val="FFFFFF"/>
+                </a:solidFill>
+              </a:rPr>
+              <a:t>King et al., 2004</a:t>
+            </a:r>
+            <a:r>
+              <a:rPr sz="1600">
+                <a:solidFill>
+                  <a:srgbClr val="FFFFFF"/>
+                </a:solidFill>
+              </a:rPr>
+              <a:t> según la elevación del sol. *(Fórmula en Anexo II, Lámina 20)*</a:t>
             </a:r>
           </a:p>
         </p:txBody>
@@ -19036,14 +19260,14 @@
           <a:lstStyle/>
           <a:p>
             <a:pPr algn="l">
-              <a:defRPr sz="1700">
-                <a:solidFill>
-                  <a:srgbClr val="FFFFFF"/>
-                </a:solidFill>
-              </a:defRPr>
-            </a:pPr>
-            <a:r>
-              <a:rPr sz="1700">
+              <a:defRPr sz="1600">
+                <a:solidFill>
+                  <a:srgbClr val="FFFFFF"/>
+                </a:solidFill>
+              </a:defRPr>
+            </a:pPr>
+            <a:r>
+              <a:rPr sz="1600">
                 <a:solidFill>
                   <a:srgbClr val="FFFFFF"/>
                 </a:solidFill>
@@ -19051,7 +19275,7 @@
               <a:t>• </a:t>
             </a:r>
             <a:r>
-              <a:rPr sz="1700" b="1">
+              <a:rPr sz="1600" b="1">
                 <a:solidFill>
                   <a:srgbClr val="FFFFFF"/>
                 </a:solidFill>
@@ -19059,33 +19283,73 @@
               <a:t>Modelación Tc:</a:t>
             </a:r>
             <a:r>
-              <a:rPr sz="1700">
-                <a:solidFill>
-                  <a:srgbClr val="FFFFFF"/>
-                </a:solidFill>
-              </a:rPr>
-              <a:t> Estimación dinámica minutal de la temperatura de celda utilizando los parámetros empíricos de encapsulado.</a:t>
-            </a:r>
-          </a:p>
-          <a:p>
-            <a:pPr algn="l">
-              <a:defRPr sz="1700">
-                <a:solidFill>
-                  <a:srgbClr val="FFFFFF"/>
-                </a:solidFill>
-              </a:defRPr>
-            </a:pPr>
-          </a:p>
-          <a:p>
-            <a:pPr algn="l">
-              <a:defRPr sz="1700">
-                <a:solidFill>
-                  <a:srgbClr val="FFFFFF"/>
-                </a:solidFill>
-              </a:defRPr>
-            </a:pPr>
-            <a:r>
-              <a:rPr sz="1700">
+              <a:rPr sz="1600">
+                <a:solidFill>
+                  <a:srgbClr val="FFFFFF"/>
+                </a:solidFill>
+              </a:rPr>
+              <a:t> Estimación dinámica de la temperatura de celda (</a:t>
+            </a:r>
+            <a:r>
+              <a:rPr sz="1600" i="1">
+                <a:solidFill>
+                  <a:srgbClr val="FFFFFF"/>
+                </a:solidFill>
+              </a:rPr>
+              <a:t>T</a:t>
+            </a:r>
+            <a:r>
+              <a:rPr sz="1600" i="1">
+                <a:solidFill>
+                  <a:srgbClr val="FFFFFF"/>
+                </a:solidFill>
+              </a:rPr>
+              <a:t>c</a:t>
+            </a:r>
+            <a:r>
+              <a:rPr sz="1600">
+                <a:solidFill>
+                  <a:srgbClr val="FFFFFF"/>
+                </a:solidFill>
+              </a:rPr>
+              <a:t>) usando coeficientes empíricos de encapsulado del modelo de Sandia </a:t>
+            </a:r>
+            <a:r>
+              <a:rPr sz="1600">
+                <a:solidFill>
+                  <a:srgbClr val="FFFFFF"/>
+                </a:solidFill>
+              </a:rPr>
+              <a:t>King et al., 2004</a:t>
+            </a:r>
+            <a:r>
+              <a:rPr sz="1600">
+                <a:solidFill>
+                  <a:srgbClr val="FFFFFF"/>
+                </a:solidFill>
+              </a:rPr>
+              <a:t>. *(Fórmula en Anexo III, Lámina 21)*</a:t>
+            </a:r>
+          </a:p>
+          <a:p>
+            <a:pPr algn="l">
+              <a:defRPr sz="1600">
+                <a:solidFill>
+                  <a:srgbClr val="FFFFFF"/>
+                </a:solidFill>
+              </a:defRPr>
+            </a:pPr>
+          </a:p>
+          <a:p>
+            <a:pPr algn="l">
+              <a:defRPr sz="1600">
+                <a:solidFill>
+                  <a:srgbClr val="FFFFFF"/>
+                </a:solidFill>
+              </a:defRPr>
+            </a:pPr>
+            <a:r>
+              <a:rPr sz="1600">
                 <a:solidFill>
                   <a:srgbClr val="FFFFFF"/>
                 </a:solidFill>
@@ -19093,7 +19357,7 @@
               <a:t>• </a:t>
             </a:r>
             <a:r>
-              <a:rPr sz="1700" b="1">
+              <a:rPr sz="1600" b="1">
                 <a:solidFill>
                   <a:srgbClr val="FFFFFF"/>
                 </a:solidFill>
@@ -19103,14 +19367,14 @@
           </a:p>
           <a:p>
             <a:pPr algn="l">
-              <a:defRPr sz="1700">
-                <a:solidFill>
-                  <a:srgbClr val="FFFFFF"/>
-                </a:solidFill>
-              </a:defRPr>
-            </a:pPr>
-            <a:r>
-              <a:rPr sz="1700">
+              <a:defRPr sz="1600">
+                <a:solidFill>
+                  <a:srgbClr val="FFFFFF"/>
+                </a:solidFill>
+              </a:defRPr>
+            </a:pPr>
+            <a:r>
+              <a:rPr sz="1600">
                 <a:solidFill>
                   <a:srgbClr val="FFFFFF"/>
                 </a:solidFill>
@@ -19118,7 +19382,7 @@
               <a:t>  1. </a:t>
             </a:r>
             <a:r>
-              <a:rPr sz="1700" b="1">
+              <a:rPr sz="1600" b="1">
                 <a:solidFill>
                   <a:srgbClr val="FFFFFF"/>
                 </a:solidFill>
@@ -19126,15 +19390,15 @@
               <a:t>Velocidad del Viento:</a:t>
             </a:r>
             <a:r>
-              <a:rPr sz="1700">
-                <a:solidFill>
-                  <a:srgbClr val="FFFFFF"/>
-                </a:solidFill>
-              </a:rPr>
-              <a:t> Asumida constante en </a:t>
-            </a:r>
-            <a:r>
-              <a:rPr sz="1700" b="1">
+              <a:rPr sz="1600">
+                <a:solidFill>
+                  <a:srgbClr val="FFFFFF"/>
+                </a:solidFill>
+              </a:rPr>
+              <a:t> Fijada constante en </a:t>
+            </a:r>
+            <a:r>
+              <a:rPr sz="1600" b="1">
                 <a:solidFill>
                   <a:srgbClr val="FFFFFF"/>
                 </a:solidFill>
@@ -19142,24 +19406,24 @@
               <a:t>1 m/s</a:t>
             </a:r>
             <a:r>
-              <a:rPr sz="1700">
-                <a:solidFill>
-                  <a:srgbClr val="FFFFFF"/>
-                </a:solidFill>
-              </a:rPr>
-              <a:t> (valor conservador para desierto que minimiza pérdidas por convección artificial).</a:t>
-            </a:r>
-          </a:p>
-          <a:p>
-            <a:pPr algn="l">
-              <a:defRPr sz="1700">
-                <a:solidFill>
-                  <a:srgbClr val="FFFFFF"/>
-                </a:solidFill>
-              </a:defRPr>
-            </a:pPr>
-            <a:r>
-              <a:rPr sz="1700">
+              <a:rPr sz="1600">
+                <a:solidFill>
+                  <a:srgbClr val="FFFFFF"/>
+                </a:solidFill>
+              </a:rPr>
+              <a:t> (valor conservador de diseño que minimiza pérdidas por convección artificial).</a:t>
+            </a:r>
+          </a:p>
+          <a:p>
+            <a:pPr algn="l">
+              <a:defRPr sz="1600">
+                <a:solidFill>
+                  <a:srgbClr val="FFFFFF"/>
+                </a:solidFill>
+              </a:defRPr>
+            </a:pPr>
+            <a:r>
+              <a:rPr sz="1600">
                 <a:solidFill>
                   <a:srgbClr val="FFFFFF"/>
                 </a:solidFill>
@@ -19167,7 +19431,7 @@
               <a:t>  2. </a:t>
             </a:r>
             <a:r>
-              <a:rPr sz="1700" b="1">
+              <a:rPr sz="1600" b="1">
                 <a:solidFill>
                   <a:srgbClr val="FFFFFF"/>
                 </a:solidFill>
@@ -19175,7 +19439,7 @@
               <a:t>Reflectancia del Suelo (Albedo):</a:t>
             </a:r>
             <a:r>
-              <a:rPr sz="1700">
+              <a:rPr sz="1600">
                 <a:solidFill>
                   <a:srgbClr val="FFFFFF"/>
                 </a:solidFill>
@@ -19183,7 +19447,7 @@
               <a:t> Fijada en </a:t>
             </a:r>
             <a:r>
-              <a:rPr sz="1700" b="1">
+              <a:rPr sz="1600" b="1">
                 <a:solidFill>
                   <a:srgbClr val="FFFFFF"/>
                 </a:solidFill>
@@ -19191,12 +19455,12 @@
               <a:t>0.20</a:t>
             </a:r>
             <a:r>
-              <a:rPr sz="1700">
-                <a:solidFill>
-                  <a:srgbClr val="FFFFFF"/>
-                </a:solidFill>
-              </a:rPr>
-              <a:t> (suelo arenoso/árido del desierto de Atacama).</a:t>
+              <a:rPr sz="1600">
+                <a:solidFill>
+                  <a:srgbClr val="FFFFFF"/>
+                </a:solidFill>
+              </a:rPr>
+              <a:t> (suelo arenoso/árido típico del desierto de Atacama).</a:t>
             </a:r>
           </a:p>
         </p:txBody>
@@ -19438,7 +19702,7 @@
                   <a:srgbClr val="FFFFFF"/>
                 </a:solidFill>
               </a:rPr>
-              <a:t> La base experimental Cocoa usa códigos del NREL (`mSi0166`, `HIT05667`) que no corresponden a marcas comerciales registradas en las librerías estándar.</a:t>
+              <a:t> La base experimental Cocoa usa códigos internos del NREL (`mSi0166`, `HIT05667`) que no figuran directamente en datasheets comerciales estándar.</a:t>
             </a:r>
           </a:p>
           <a:p>
@@ -19472,7 +19736,7 @@
                   <a:srgbClr val="FFFFFF"/>
                 </a:solidFill>
               </a:rPr>
-              <a:t>Solución: Extracción Directa:</a:t>
+              <a:t>Solución: Extracción en STC:</a:t>
             </a:r>
             <a:r>
               <a:rPr sz="1700">
@@ -19480,7 +19744,23 @@
                   <a:srgbClr val="FFFFFF"/>
                 </a:solidFill>
               </a:rPr>
-              <a:t> En lugar de buscar datasheets aproximados, se diseñó un algoritmo para encontrar las propiedades nominales directamente en las curvas medidas del CSV.</a:t>
+              <a:t> Se diseñó un algoritmo para caracterizar las propiedades nominales directamente desde la base de datos experimental minutal </a:t>
+            </a:r>
+            <a:r>
+              <a:rPr sz="1700">
+                <a:solidFill>
+                  <a:srgbClr val="FFFFFF"/>
+                </a:solidFill>
+              </a:rPr>
+              <a:t>De Soto et al., 2006</a:t>
+            </a:r>
+            <a:r>
+              <a:rPr sz="1700">
+                <a:solidFill>
+                  <a:srgbClr val="FFFFFF"/>
+                </a:solidFill>
+              </a:rPr>
+              <a:t>.</a:t>
             </a:r>
           </a:p>
           <a:p>
@@ -19514,7 +19794,7 @@
                   <a:srgbClr val="FFFFFF"/>
                 </a:solidFill>
               </a:rPr>
-              <a:t>Búsqueda SRC:</a:t>
+              <a:t>Condiciones de Referencia (SRC):</a:t>
             </a:r>
             <a:r>
               <a:rPr sz="1700">
@@ -19522,7 +19802,7 @@
                   <a:srgbClr val="FFFFFF"/>
                 </a:solidFill>
               </a:rPr>
-              <a:t> Se filtraron los instantes experimentales bajo condiciones estándar (STC: Irradiancia $G _x0007_pprox 1000$ W/m² y temperatura de celda $T_c _x0007_pprox 25^\circ	ext{C}$).</a:t>
+              <a:t> Se filtraron mediciones instantáneas bajo condiciones estándar ($G \approx 1000$ W/m² y temperatura de celda $T_c \approx 25^\circ\text{C}$).</a:t>
             </a:r>
           </a:p>
         </p:txBody>
@@ -19635,14 +19915,14 @@
           <a:lstStyle/>
           <a:p>
             <a:pPr algn="l">
-              <a:defRPr sz="1700">
-                <a:solidFill>
-                  <a:srgbClr val="FFFFFF"/>
-                </a:solidFill>
-              </a:defRPr>
-            </a:pPr>
-            <a:r>
-              <a:rPr sz="1700">
+              <a:defRPr sz="1600">
+                <a:solidFill>
+                  <a:srgbClr val="FFFFFF"/>
+                </a:solidFill>
+              </a:defRPr>
+            </a:pPr>
+            <a:r>
+              <a:rPr sz="1600">
                 <a:solidFill>
                   <a:srgbClr val="FFFFFF"/>
                 </a:solidFill>
@@ -19650,50 +19930,50 @@
               <a:t>• </a:t>
             </a:r>
             <a:r>
-              <a:rPr sz="1700" b="1">
-                <a:solidFill>
-                  <a:srgbClr val="FFFFFF"/>
-                </a:solidFill>
-              </a:rPr>
-              <a:t>Coeficientes de Temperatura ($_x0007_lpha_{Isc}$ y $_x0008_eta_{Voc}$):</a:t>
-            </a:r>
-          </a:p>
-          <a:p>
-            <a:pPr algn="l">
-              <a:defRPr sz="1700">
-                <a:solidFill>
-                  <a:srgbClr val="FFFFFF"/>
-                </a:solidFill>
-              </a:defRPr>
-            </a:pPr>
-            <a:r>
-              <a:rPr sz="1700">
-                <a:solidFill>
-                  <a:srgbClr val="FFFFFF"/>
-                </a:solidFill>
-              </a:rPr>
-              <a:t>  Se calcularon directamente de las mediciones aplicando regresiones lineales en condiciones de alta radiación ($G &gt; 800$ W/m²).</a:t>
-            </a:r>
-          </a:p>
-          <a:p>
-            <a:pPr algn="l">
-              <a:defRPr sz="1700">
-                <a:solidFill>
-                  <a:srgbClr val="FFFFFF"/>
-                </a:solidFill>
-              </a:defRPr>
-            </a:pPr>
-          </a:p>
-          <a:p>
-            <a:pPr algn="l">
-              <a:defRPr sz="1700">
-                <a:solidFill>
-                  <a:srgbClr val="FFFFFF"/>
-                </a:solidFill>
-              </a:defRPr>
-            </a:pPr>
-            <a:r>
-              <a:rPr sz="1700">
+              <a:rPr sz="1600" b="1">
+                <a:solidFill>
+                  <a:srgbClr val="FFFFFF"/>
+                </a:solidFill>
+              </a:rPr>
+              <a:t>Coeficientes Térmicos ($_x0007_lpha_{Isc}$ y $_x0008_eta_{Voc}$):</a:t>
+            </a:r>
+          </a:p>
+          <a:p>
+            <a:pPr algn="l">
+              <a:defRPr sz="1600">
+                <a:solidFill>
+                  <a:srgbClr val="FFFFFF"/>
+                </a:solidFill>
+              </a:defRPr>
+            </a:pPr>
+            <a:r>
+              <a:rPr sz="1600">
+                <a:solidFill>
+                  <a:srgbClr val="FFFFFF"/>
+                </a:solidFill>
+              </a:rPr>
+              <a:t>  Calculados directamente de los datos usando regresiones lineales en periodos estables y de alta radiación ($G &gt; 800$ W/m²).</a:t>
+            </a:r>
+          </a:p>
+          <a:p>
+            <a:pPr algn="l">
+              <a:defRPr sz="1600">
+                <a:solidFill>
+                  <a:srgbClr val="FFFFFF"/>
+                </a:solidFill>
+              </a:defRPr>
+            </a:pPr>
+          </a:p>
+          <a:p>
+            <a:pPr algn="l">
+              <a:defRPr sz="1600">
+                <a:solidFill>
+                  <a:srgbClr val="FFFFFF"/>
+                </a:solidFill>
+              </a:defRPr>
+            </a:pPr>
+            <a:r>
+              <a:rPr sz="1600">
                 <a:solidFill>
                   <a:srgbClr val="FFFFFF"/>
                 </a:solidFill>
@@ -19701,29 +19981,29 @@
               <a:t>• </a:t>
             </a:r>
             <a:r>
-              <a:rPr sz="1700" b="1">
-                <a:solidFill>
-                  <a:srgbClr val="FFFFFF"/>
-                </a:solidFill>
-              </a:rPr>
-              <a:t>Normalización por Irradiancia:</a:t>
-            </a:r>
-          </a:p>
-          <a:p>
-            <a:pPr algn="l">
-              <a:defRPr sz="1700">
-                <a:solidFill>
-                  <a:srgbClr val="FFFFFF"/>
-                </a:solidFill>
-              </a:defRPr>
-            </a:pPr>
-            <a:r>
-              <a:rPr sz="1700">
-                <a:solidFill>
-                  <a:srgbClr val="FFFFFF"/>
-                </a:solidFill>
-              </a:rPr>
-              <a:t>  Para la corriente de cortocircuito, se normalizó el valor frente a la irradiancia instantánea para desacoplar el efecto solar y aislar la ganancia térmica pura.</a:t>
+              <a:rPr sz="1600" b="1">
+                <a:solidFill>
+                  <a:srgbClr val="FFFFFF"/>
+                </a:solidFill>
+              </a:rPr>
+              <a:t>Normalización y Consistencia [De Soto et al., 2006]:</a:t>
+            </a:r>
+          </a:p>
+          <a:p>
+            <a:pPr algn="l">
+              <a:defRPr sz="1600">
+                <a:solidFill>
+                  <a:srgbClr val="FFFFFF"/>
+                </a:solidFill>
+              </a:defRPr>
+            </a:pPr>
+            <a:r>
+              <a:rPr sz="1600">
+                <a:solidFill>
+                  <a:srgbClr val="FFFFFF"/>
+                </a:solidFill>
+              </a:rPr>
+              <a:t>  La corriente de cortocircuito se normalizó por irradiancia efectiva para aislar el coeficiente de ganancia térmica pura y asegurar consistencia paramétrica.</a:t>
             </a:r>
           </a:p>
         </p:txBody>

</xml_diff>